<commit_message>
Align interim presentation materials with thesis findings and final controller plans
</commit_message>
<xml_diff>
--- a/docs/presentation/中間発表_主要事項.pptx
+++ b/docs/presentation/中間発表_主要事項.pptx
@@ -2,20 +2,20 @@
 <file path=ppt/presentation.xml><?xml version="1.0" encoding="utf-8"?>
 <p:presentation xmlns:p="http://schemas.openxmlformats.org/presentationml/2006/main">
   <p:sldMasterIdLst>
-    <p:sldMasterId xmlns:r="http://schemas.openxmlformats.org/officeDocument/2006/relationships" id="2147483648" r:id="Rf1e13a78212740b4"/>
+    <p:sldMasterId xmlns:r="http://schemas.openxmlformats.org/officeDocument/2006/relationships" id="2147483648" r:id="R0f78d91987ab4744"/>
   </p:sldMasterIdLst>
   <p:notesMasterIdLst>
-    <p:notesMasterId xmlns:r="http://schemas.openxmlformats.org/officeDocument/2006/relationships" r:id="R7b9040cbcd3c4674"/>
+    <p:notesMasterId xmlns:r="http://schemas.openxmlformats.org/officeDocument/2006/relationships" r:id="R67701b03eedd4467"/>
   </p:notesMasterIdLst>
   <p:sldIdLst>
-    <p:sldId xmlns:r="http://schemas.openxmlformats.org/officeDocument/2006/relationships" id="256" r:id="R263cd7840cef488b"/>
-    <p:sldId xmlns:r="http://schemas.openxmlformats.org/officeDocument/2006/relationships" id="257" r:id="R49d91104d95347bc"/>
-    <p:sldId xmlns:r="http://schemas.openxmlformats.org/officeDocument/2006/relationships" id="258" r:id="R755236e0a0eb42a5"/>
-    <p:sldId xmlns:r="http://schemas.openxmlformats.org/officeDocument/2006/relationships" id="259" r:id="Rf38aea831c534c81"/>
-    <p:sldId xmlns:r="http://schemas.openxmlformats.org/officeDocument/2006/relationships" id="260" r:id="R20b32a9d07d5470c"/>
-    <p:sldId xmlns:r="http://schemas.openxmlformats.org/officeDocument/2006/relationships" id="261" r:id="R192e1485f17b4a8c"/>
-    <p:sldId xmlns:r="http://schemas.openxmlformats.org/officeDocument/2006/relationships" id="262" r:id="Reac398f0950e4593"/>
-    <p:sldId xmlns:r="http://schemas.openxmlformats.org/officeDocument/2006/relationships" id="263" r:id="Rafd94b476a8e441b"/>
+    <p:sldId xmlns:r="http://schemas.openxmlformats.org/officeDocument/2006/relationships" id="256" r:id="R020f4b782dd04e1a"/>
+    <p:sldId xmlns:r="http://schemas.openxmlformats.org/officeDocument/2006/relationships" id="257" r:id="R0627dc9ff8ae4302"/>
+    <p:sldId xmlns:r="http://schemas.openxmlformats.org/officeDocument/2006/relationships" id="258" r:id="Ra5a425279f104e87"/>
+    <p:sldId xmlns:r="http://schemas.openxmlformats.org/officeDocument/2006/relationships" id="259" r:id="R595ca7e1e5084d8d"/>
+    <p:sldId xmlns:r="http://schemas.openxmlformats.org/officeDocument/2006/relationships" id="260" r:id="Re3db1ff116264378"/>
+    <p:sldId xmlns:r="http://schemas.openxmlformats.org/officeDocument/2006/relationships" id="261" r:id="Rb0fb2395a48b4620"/>
+    <p:sldId xmlns:r="http://schemas.openxmlformats.org/officeDocument/2006/relationships" id="262" r:id="Rbf49a971e98b4c90"/>
+    <p:sldId xmlns:r="http://schemas.openxmlformats.org/officeDocument/2006/relationships" id="263" r:id="Rfb1e42385d6e4eba"/>
   </p:sldIdLst>
   <p:sldSz cx="12192000" cy="6858000"/>
   <p:notesSz cx="6858000" cy="9144000"/>
@@ -464,7 +464,7 @@
           </a:p>
           <a:p xmlns:a="http://schemas.openxmlformats.org/drawingml/2006/main">
             <a:r>
-              <a:t>根拠：docs/thesis/本文.md 第6〜10章、第13章。実験記録 E6。製品 https://github.com/SoshiroFujimori/wally-game-console/tree/261832d48832dd6e26c4971ab8893ce61200688b 。</a:t>
+              <a:t>根拠：docs/thesis/本文.md 第6〜11章、第13章、第16章。実験記録 E6、E7。製品 https://github.com/SoshiroFujimori/wally-game-console/tree/261832d48832dd6e26c4971ab8893ce61200688b 。</a:t>
             </a:r>
           </a:p>
         </p:txBody>
@@ -534,7 +534,7 @@
           <a:lstStyle xmlns:a="http://schemas.openxmlformats.org/drawingml/2006/main"/>
           <a:p xmlns:a="http://schemas.openxmlformats.org/drawingml/2006/main">
             <a:r>
-              <a:t>想定時間：40秒</a:t>
+              <a:t>想定時間：35秒</a:t>
             </a:r>
           </a:p>
           <a:p xmlns:a="http://schemas.openxmlformats.org/drawingml/2006/main">
@@ -549,7 +549,7 @@
           </a:p>
           <a:p xmlns:a="http://schemas.openxmlformats.org/drawingml/2006/main">
             <a:r>
-              <a:t>根拠：docs/thesis/本文.md 第6〜10章、第13章。実験記録 E6。製品 https://github.com/SoshiroFujimori/wally-game-console/tree/261832d48832dd6e26c4971ab8893ce61200688b 。</a:t>
+              <a:t>根拠：docs/thesis/本文.md 第6〜11章、第13章、第16章。実験記録 E6、E7。製品 https://github.com/SoshiroFujimori/wally-game-console/tree/261832d48832dd6e26c4971ab8893ce61200688b 。</a:t>
             </a:r>
           </a:p>
         </p:txBody>
@@ -634,7 +634,7 @@
           </a:p>
           <a:p xmlns:a="http://schemas.openxmlformats.org/drawingml/2006/main">
             <a:r>
-              <a:t>根拠：docs/thesis/本文.md 第6〜10章、第13章。実験記録 E6。製品 https://github.com/SoshiroFujimori/wally-game-console/tree/261832d48832dd6e26c4971ab8893ce61200688b 。</a:t>
+              <a:t>根拠：docs/thesis/本文.md 第6〜11章、第13章、第16章。実験記録 E6、E7。製品 https://github.com/SoshiroFujimori/wally-game-console/tree/261832d48832dd6e26c4971ab8893ce61200688b 。</a:t>
             </a:r>
           </a:p>
         </p:txBody>
@@ -704,7 +704,7 @@
           <a:lstStyle xmlns:a="http://schemas.openxmlformats.org/drawingml/2006/main"/>
           <a:p xmlns:a="http://schemas.openxmlformats.org/drawingml/2006/main">
             <a:r>
-              <a:t>想定時間：40秒</a:t>
+              <a:t>想定時間：50秒</a:t>
             </a:r>
           </a:p>
           <a:p xmlns:a="http://schemas.openxmlformats.org/drawingml/2006/main">
@@ -714,12 +714,12 @@
           </a:p>
           <a:p xmlns:a="http://schemas.openxmlformats.org/drawingml/2006/main">
             <a:r>
-              <a:t>CPUはSDカードから読み込んだゲームプログラムを実行します。ゲームの一回の処理では、ボールなどの位置を更新し、その位置と色を描画命令にします。CPUは命令列をメモリに用意してから接続回路へ送ります。RasterIXは命令に従って画素の色を計算し、画像をメモリへ保存します。表示回路がその画像を読むと、画面にボールが見えます。この処理を繰り返すことで、動いて見えます。</a:t>
-            </a:r>
-          </a:p>
-          <a:p xmlns:a="http://schemas.openxmlformats.org/drawingml/2006/main">
-            <a:r>
-              <a:t>根拠：docs/thesis/本文.md 第6〜10章、第13章。実験記録 E6。製品 https://github.com/SoshiroFujimori/wally-game-console/tree/261832d48832dd6e26c4971ab8893ce61200688b 。</a:t>
+              <a:t>CPUはSDカードから読み込んだゲームを実行します。一回の処理でボールの位置を更新し、位置や色を描画命令にしてメモリへ置きます。接続回路から命令を受けたRasterIXが画像を作り、表示回路が読み出します。これを繰り返すと動いて見えます。計測ではCPUの命令準備が大きな負担でした。そこで、同じ設定の図形をまとめ、変わった部分だけを描き直すようにしました。</a:t>
+            </a:r>
+          </a:p>
+          <a:p xmlns:a="http://schemas.openxmlformats.org/drawingml/2006/main">
+            <a:r>
+              <a:t>根拠：docs/thesis/本文.md 第6〜11章、第13章、第16章。実験記録 E6、E7。製品 https://github.com/SoshiroFujimori/wally-game-console/tree/261832d48832dd6e26c4971ab8893ce61200688b 。</a:t>
             </a:r>
           </a:p>
         </p:txBody>
@@ -789,7 +789,7 @@
           <a:lstStyle xmlns:a="http://schemas.openxmlformats.org/drawingml/2006/main"/>
           <a:p xmlns:a="http://schemas.openxmlformats.org/drawingml/2006/main">
             <a:r>
-              <a:t>想定時間：50秒</a:t>
+              <a:t>想定時間：45秒</a:t>
             </a:r>
           </a:p>
           <a:p xmlns:a="http://schemas.openxmlformats.org/drawingml/2006/main">
@@ -874,7 +874,7 @@
           <a:lstStyle xmlns:a="http://schemas.openxmlformats.org/drawingml/2006/main"/>
           <a:p xmlns:a="http://schemas.openxmlformats.org/drawingml/2006/main">
             <a:r>
-              <a:t>想定時間：45秒</a:t>
+              <a:t>想定時間：40秒</a:t>
             </a:r>
           </a:p>
           <a:p xmlns:a="http://schemas.openxmlformats.org/drawingml/2006/main">
@@ -889,7 +889,7 @@
           </a:p>
           <a:p xmlns:a="http://schemas.openxmlformats.org/drawingml/2006/main">
             <a:r>
-              <a:t>根拠：docs/thesis/本文.md 第6〜10章、第13章。実験記録 E6。製品 https://github.com/SoshiroFujimori/wally-game-console/tree/261832d48832dd6e26c4971ab8893ce61200688b 。</a:t>
+              <a:t>根拠：docs/thesis/本文.md 第6〜11章、第13章、第16章。実験記録 E6、E7。製品 https://github.com/SoshiroFujimori/wally-game-console/tree/261832d48832dd6e26c4971ab8893ce61200688b 。</a:t>
             </a:r>
           </a:p>
         </p:txBody>
@@ -959,7 +959,7 @@
           <a:lstStyle xmlns:a="http://schemas.openxmlformats.org/drawingml/2006/main"/>
           <a:p xmlns:a="http://schemas.openxmlformats.org/drawingml/2006/main">
             <a:r>
-              <a:t>想定時間：55秒</a:t>
+              <a:t>想定時間：40秒</a:t>
             </a:r>
           </a:p>
           <a:p xmlns:a="http://schemas.openxmlformats.org/drawingml/2006/main">
@@ -969,7 +969,7 @@
           </a:p>
           <a:p xmlns:a="http://schemas.openxmlformats.org/drawingml/2006/main">
             <a:r>
-              <a:t>実機では640×480画素のブロック崩しを動かしました。ここに示したのは、実機映像の一場面です。通常版で5分間の自動プレイが継続し、別途保存した30秒の映像でもボールの移動を確認しました。接続を比較した三方式では、選んだ27画面の全画素が正解画像と一致しました。ただし、すべての途中画像を比べたわけではありません。また、大きいテクスチャと映像機器での認識には未解決の条件があります。専用のゲームコントローラーは、まだ検証していません。</a:t>
+              <a:t>640×480画素で、通常版の5分間の自動プレイと、別に30秒の実機映像を確認しました。接続を比較した三方式では、選んだ27条件の最終画像が全画素で期待画像と一致しました。すべての途中画像まで確認したわけではありません。大きなテクスチャの描画と映像認識には未解決の条件が残っています。専用コントローラーは今回の成果に含めず、最終発表に向けて接続と操作を検証します。</a:t>
             </a:r>
           </a:p>
           <a:p xmlns:a="http://schemas.openxmlformats.org/drawingml/2006/main">
@@ -1044,7 +1044,7 @@
           <a:lstStyle xmlns:a="http://schemas.openxmlformats.org/drawingml/2006/main"/>
           <a:p xmlns:a="http://schemas.openxmlformats.org/drawingml/2006/main">
             <a:r>
-              <a:t>想定時間：25秒</a:t>
+              <a:t>想定時間：45秒</a:t>
             </a:r>
           </a:p>
           <a:p xmlns:a="http://schemas.openxmlformats.org/drawingml/2006/main">
@@ -1054,12 +1054,12 @@
           </a:p>
           <a:p xmlns:a="http://schemas.openxmlformats.org/drawingml/2006/main">
             <a:r>
-              <a:t>WallyをFPGAボードに実装し、描画回路、メモリ、表示をつなぐことで、二次元ゲームを動かしました。動いたという報告に加え、命令の渡し方を比較し、採用した接続の根拠を示しました。設計とソース、試験条件を公開し、Wallyへ周辺機能を追加したい学習者が、同じ構成を検討するときの参照例とします。今後は残る不具合の検証と、専用コントローラーの接続を進めます。</a:t>
-            </a:r>
-          </a:p>
-          <a:p xmlns:a="http://schemas.openxmlformats.org/drawingml/2006/main">
-            <a:r>
-              <a:t>根拠：docs/thesis/本文.md 第6〜10章、第13章。実験記録 E6。製品 https://github.com/SoshiroFujimori/wally-game-console/tree/261832d48832dd6e26c4971ab8893ce61200688b 。</a:t>
+              <a:t>Wallyへ描画・表示機能を追加し、二次元ゲームを動かす接続設計を示しました。命令を専用回路で転送する方式と、描画用メモリを増やす方式も実機で比較しました。試した条件では、前者はコピー処理を含めると速くならず、後者の改善も小さい結果でした。設計と試験条件を公開し、学習者が同様の拡張を検討するための参照例とします。最終発表では、専用コントローラーを接続し、ボタンによるゲーム操作を検証します。</a:t>
+            </a:r>
+          </a:p>
+          <a:p xmlns:a="http://schemas.openxmlformats.org/drawingml/2006/main">
+            <a:r>
+              <a:t>根拠：docs/thesis/本文.md 第6〜11章、第13章、第16章。実験記録 E6、E7。製品 https://github.com/SoshiroFujimori/wally-game-console/tree/261832d48832dd6e26c4971ab8893ce61200688b 。</a:t>
             </a:r>
           </a:p>
         </p:txBody>
@@ -1106,7 +1106,7 @@
           <p:cNvPr id="3" name="Title">
             <a:extLst xmlns:a="http://schemas.openxmlformats.org/drawingml/2006/main">
               <a:ext uri="{FF2B5EF4-FFF2-40B4-BE49-F238E27FC236}">
-                <a16:creationId xmlns:a16="http://schemas.microsoft.com/office/drawing/2014/main" id="{1E09A3AA-BBD7-4758-A46A-DEC7D4C10378}"/>
+                <a16:creationId xmlns:a16="http://schemas.microsoft.com/office/drawing/2014/main" id="{B4C62657-22C4-4594-BEF0-8453C76EA30F}"/>
               </a:ext>
             </a:extLst>
           </p:cNvPr>
@@ -1263,7 +1263,7 @@
           <p:cNvPr id="2" name="Subtitle">
             <a:extLst xmlns:a="http://schemas.openxmlformats.org/drawingml/2006/main">
               <a:ext uri="{FF2B5EF4-FFF2-40B4-BE49-F238E27FC236}">
-                <a16:creationId xmlns:a16="http://schemas.microsoft.com/office/drawing/2014/main" id="{DB934987-FC46-435D-87FE-4ECB100FC118}"/>
+                <a16:creationId xmlns:a16="http://schemas.microsoft.com/office/drawing/2014/main" id="{DE774234-3A9B-444D-91A5-FC5C6B6289ED}"/>
               </a:ext>
             </a:extLst>
           </p:cNvPr>
@@ -1437,7 +1437,7 @@
           <p:cNvPr id="2" name="Section title">
             <a:extLst xmlns:a="http://schemas.openxmlformats.org/drawingml/2006/main">
               <a:ext uri="{FF2B5EF4-FFF2-40B4-BE49-F238E27FC236}">
-                <a16:creationId xmlns:a16="http://schemas.microsoft.com/office/drawing/2014/main" id="{3B52F47C-9667-4B50-A049-F6438F70D000}"/>
+                <a16:creationId xmlns:a16="http://schemas.microsoft.com/office/drawing/2014/main" id="{AB6749E0-95DA-4EC3-877D-432CC94BCB62}"/>
               </a:ext>
             </a:extLst>
           </p:cNvPr>
@@ -1611,7 +1611,7 @@
           <p:cNvPr id="3" name="Title">
             <a:extLst xmlns:a="http://schemas.openxmlformats.org/drawingml/2006/main">
               <a:ext uri="{FF2B5EF4-FFF2-40B4-BE49-F238E27FC236}">
-                <a16:creationId xmlns:a16="http://schemas.microsoft.com/office/drawing/2014/main" id="{A5650D46-E0A1-4D83-ACB5-6E00B937B7B4}"/>
+                <a16:creationId xmlns:a16="http://schemas.microsoft.com/office/drawing/2014/main" id="{9399E3C0-3116-49BE-B28C-D8B17C174AF9}"/>
               </a:ext>
             </a:extLst>
           </p:cNvPr>
@@ -1768,7 +1768,7 @@
           <p:cNvPr id="2" name="Body">
             <a:extLst xmlns:a="http://schemas.openxmlformats.org/drawingml/2006/main">
               <a:ext uri="{FF2B5EF4-FFF2-40B4-BE49-F238E27FC236}">
-                <a16:creationId xmlns:a16="http://schemas.microsoft.com/office/drawing/2014/main" id="{34198E15-7006-49B2-A775-4447B0D35BB6}"/>
+                <a16:creationId xmlns:a16="http://schemas.microsoft.com/office/drawing/2014/main" id="{16D73D6E-5551-46AE-8583-2D6A93A261ED}"/>
               </a:ext>
             </a:extLst>
           </p:cNvPr>
@@ -1942,7 +1942,7 @@
           <p:cNvPr id="4" name="Title">
             <a:extLst xmlns:a="http://schemas.openxmlformats.org/drawingml/2006/main">
               <a:ext uri="{FF2B5EF4-FFF2-40B4-BE49-F238E27FC236}">
-                <a16:creationId xmlns:a16="http://schemas.microsoft.com/office/drawing/2014/main" id="{936DFDBD-0635-4686-9D52-D9E25C4F6902}"/>
+                <a16:creationId xmlns:a16="http://schemas.microsoft.com/office/drawing/2014/main" id="{26CFC281-07C0-445A-9916-147D6CD3C3D0}"/>
               </a:ext>
             </a:extLst>
           </p:cNvPr>
@@ -2099,7 +2099,7 @@
           <p:cNvPr id="2" name="Left column">
             <a:extLst xmlns:a="http://schemas.openxmlformats.org/drawingml/2006/main">
               <a:ext uri="{FF2B5EF4-FFF2-40B4-BE49-F238E27FC236}">
-                <a16:creationId xmlns:a16="http://schemas.microsoft.com/office/drawing/2014/main" id="{6E36D116-6D09-4C81-A5DA-BE4AA761689C}"/>
+                <a16:creationId xmlns:a16="http://schemas.microsoft.com/office/drawing/2014/main" id="{C28266EF-2A34-4BFC-BD3E-D7C8CE43CCCC}"/>
               </a:ext>
             </a:extLst>
           </p:cNvPr>
@@ -2256,7 +2256,7 @@
           <p:cNvPr id="3" name="Right column">
             <a:extLst xmlns:a="http://schemas.openxmlformats.org/drawingml/2006/main">
               <a:ext uri="{FF2B5EF4-FFF2-40B4-BE49-F238E27FC236}">
-                <a16:creationId xmlns:a16="http://schemas.microsoft.com/office/drawing/2014/main" id="{8E618FCA-41D1-4C7A-8D2F-30D67A177570}"/>
+                <a16:creationId xmlns:a16="http://schemas.microsoft.com/office/drawing/2014/main" id="{82B16F02-8AD4-4C53-A6D1-60B90DF4D735}"/>
               </a:ext>
             </a:extLst>
           </p:cNvPr>
@@ -2430,7 +2430,7 @@
           <p:cNvPr id="3" name="Title">
             <a:extLst xmlns:a="http://schemas.openxmlformats.org/drawingml/2006/main">
               <a:ext uri="{FF2B5EF4-FFF2-40B4-BE49-F238E27FC236}">
-                <a16:creationId xmlns:a16="http://schemas.microsoft.com/office/drawing/2014/main" id="{3549E315-C5F5-49D2-A920-9027CF54200B}"/>
+                <a16:creationId xmlns:a16="http://schemas.microsoft.com/office/drawing/2014/main" id="{0B65F3A4-EA9E-42D0-AF75-9701D10EBFEA}"/>
               </a:ext>
             </a:extLst>
           </p:cNvPr>
@@ -2587,7 +2587,7 @@
           <p:cNvPr id="2" name="Left column">
             <a:extLst xmlns:a="http://schemas.openxmlformats.org/drawingml/2006/main">
               <a:ext uri="{FF2B5EF4-FFF2-40B4-BE49-F238E27FC236}">
-                <a16:creationId xmlns:a16="http://schemas.microsoft.com/office/drawing/2014/main" id="{8AC8A0D9-C168-48B5-95C3-D78A4C9B21C4}"/>
+                <a16:creationId xmlns:a16="http://schemas.microsoft.com/office/drawing/2014/main" id="{5E451818-910F-4335-863B-C19DBD1F80C7}"/>
               </a:ext>
             </a:extLst>
           </p:cNvPr>
@@ -2782,12 +2782,12 @@
   </p:cSld>
   <p:clrMap bg1="lt1" tx1="dk1" bg2="lt2" tx2="dk2" accent1="accent1" accent2="accent2" accent3="accent3" accent4="accent4" accent5="accent5" accent6="accent6" hlink="hlink" folHlink="folHlink"/>
   <p:sldLayoutIdLst>
-    <p:sldLayoutId xmlns:r="http://schemas.openxmlformats.org/officeDocument/2006/relationships" id="2147483649" r:id="R5e00b7651940438f"/>
-    <p:sldLayoutId xmlns:r="http://schemas.openxmlformats.org/officeDocument/2006/relationships" id="2147483650" r:id="R20c35189b1e141cb"/>
-    <p:sldLayoutId xmlns:r="http://schemas.openxmlformats.org/officeDocument/2006/relationships" id="2147483651" r:id="R159d58a94f0f4fcd"/>
-    <p:sldLayoutId xmlns:r="http://schemas.openxmlformats.org/officeDocument/2006/relationships" id="2147483652" r:id="R0c1ca3fb18ef446a"/>
-    <p:sldLayoutId xmlns:r="http://schemas.openxmlformats.org/officeDocument/2006/relationships" id="2147483653" r:id="Rafaf3415f9e94277"/>
-    <p:sldLayoutId xmlns:r="http://schemas.openxmlformats.org/officeDocument/2006/relationships" id="2147483654" r:id="Rbb4337d8e5344ec7"/>
+    <p:sldLayoutId xmlns:r="http://schemas.openxmlformats.org/officeDocument/2006/relationships" id="2147483649" r:id="R816e691821794932"/>
+    <p:sldLayoutId xmlns:r="http://schemas.openxmlformats.org/officeDocument/2006/relationships" id="2147483650" r:id="Re16e8c83ecad4c3f"/>
+    <p:sldLayoutId xmlns:r="http://schemas.openxmlformats.org/officeDocument/2006/relationships" id="2147483651" r:id="R22aa12cb15a24406"/>
+    <p:sldLayoutId xmlns:r="http://schemas.openxmlformats.org/officeDocument/2006/relationships" id="2147483652" r:id="Rbb0be728faf24d05"/>
+    <p:sldLayoutId xmlns:r="http://schemas.openxmlformats.org/officeDocument/2006/relationships" id="2147483653" r:id="Rdd135fd5973e4ade"/>
+    <p:sldLayoutId xmlns:r="http://schemas.openxmlformats.org/officeDocument/2006/relationships" id="2147483654" r:id="R2ce53f2a01564967"/>
   </p:sldLayoutIdLst>
   <p:txStyles>
     <p:titleStyle>
@@ -3338,7 +3338,7 @@
           <p:cNvPr id="6" name="text-1">
             <a:extLst xmlns:a="http://schemas.openxmlformats.org/drawingml/2006/main">
               <a:ext uri="{FF2B5EF4-FFF2-40B4-BE49-F238E27FC236}">
-                <a16:creationId xmlns:a16="http://schemas.microsoft.com/office/drawing/2014/main" id="{BBDD8E20-0C0E-46B7-B107-AB1311E3E11E}"/>
+                <a16:creationId xmlns:a16="http://schemas.microsoft.com/office/drawing/2014/main" id="{3B53737B-9B56-49BC-959F-7D7FEC493565}"/>
               </a:ext>
             </a:extLst>
           </p:cNvPr>
@@ -3404,7 +3404,7 @@
           <p:cNvPr id="2" name="text-2">
             <a:extLst xmlns:a="http://schemas.openxmlformats.org/drawingml/2006/main">
               <a:ext uri="{FF2B5EF4-FFF2-40B4-BE49-F238E27FC236}">
-                <a16:creationId xmlns:a16="http://schemas.microsoft.com/office/drawing/2014/main" id="{E33C9205-1446-4584-862B-C7EE35709D42}"/>
+                <a16:creationId xmlns:a16="http://schemas.microsoft.com/office/drawing/2014/main" id="{F477BF8E-16E1-4598-BC94-D5939BC1F334}"/>
               </a:ext>
             </a:extLst>
           </p:cNvPr>
@@ -3470,7 +3470,7 @@
           <p:cNvPr id="3" name="text-3">
             <a:extLst xmlns:a="http://schemas.openxmlformats.org/drawingml/2006/main">
               <a:ext uri="{FF2B5EF4-FFF2-40B4-BE49-F238E27FC236}">
-                <a16:creationId xmlns:a16="http://schemas.microsoft.com/office/drawing/2014/main" id="{D27714FF-566C-4D8B-93DD-D5C2A5E51E4B}"/>
+                <a16:creationId xmlns:a16="http://schemas.microsoft.com/office/drawing/2014/main" id="{3451ADF5-5011-4DB5-AEB9-66F67470427D}"/>
               </a:ext>
             </a:extLst>
           </p:cNvPr>
@@ -3559,7 +3559,7 @@
           <p:cNvPr id="4" name="text-4">
             <a:extLst xmlns:a="http://schemas.openxmlformats.org/drawingml/2006/main">
               <a:ext uri="{FF2B5EF4-FFF2-40B4-BE49-F238E27FC236}">
-                <a16:creationId xmlns:a16="http://schemas.microsoft.com/office/drawing/2014/main" id="{F9BA049F-D906-4F80-96C9-7D356CC9F2C6}"/>
+                <a16:creationId xmlns:a16="http://schemas.microsoft.com/office/drawing/2014/main" id="{555120D7-A3FC-4BD3-B99B-03C5D1E35703}"/>
               </a:ext>
             </a:extLst>
           </p:cNvPr>
@@ -3625,7 +3625,7 @@
           <p:cNvPr id="5" name="text-5">
             <a:extLst xmlns:a="http://schemas.openxmlformats.org/drawingml/2006/main">
               <a:ext uri="{FF2B5EF4-FFF2-40B4-BE49-F238E27FC236}">
-                <a16:creationId xmlns:a16="http://schemas.microsoft.com/office/drawing/2014/main" id="{015EAC8A-6F00-4DE3-BC90-7A0C602C384D}"/>
+                <a16:creationId xmlns:a16="http://schemas.microsoft.com/office/drawing/2014/main" id="{721FCF5E-B5C1-4CE5-BC0C-19AFBF25FFE4}"/>
               </a:ext>
             </a:extLst>
           </p:cNvPr>
@@ -3689,7 +3689,7 @@
     </p:spTree>
     <p:extLst>
       <p:ext uri="{BB962C8B-B14F-4D97-AF65-F5344CB8AC3E}">
-        <p14:creationId xmlns:p14="http://schemas.microsoft.com/office/powerpoint/2010/main" val="1457739082"/>
+        <p14:creationId xmlns:p14="http://schemas.microsoft.com/office/powerpoint/2010/main" val="1789090923"/>
       </p:ext>
     </p:extLst>
   </p:cSld>
@@ -3720,7 +3720,7 @@
           <p:cNvPr id="28" name="text-6">
             <a:extLst xmlns:a="http://schemas.openxmlformats.org/drawingml/2006/main">
               <a:ext uri="{FF2B5EF4-FFF2-40B4-BE49-F238E27FC236}">
-                <a16:creationId xmlns:a16="http://schemas.microsoft.com/office/drawing/2014/main" id="{6FBA1C34-C8A0-45DD-A465-F1FDB20A8A79}"/>
+                <a16:creationId xmlns:a16="http://schemas.microsoft.com/office/drawing/2014/main" id="{59893F04-BEB1-4DF0-A2D4-5525F93CD33D}"/>
               </a:ext>
             </a:extLst>
           </p:cNvPr>
@@ -3786,7 +3786,7 @@
           <p:cNvPr id="2" name="text-7">
             <a:extLst xmlns:a="http://schemas.openxmlformats.org/drawingml/2006/main">
               <a:ext uri="{FF2B5EF4-FFF2-40B4-BE49-F238E27FC236}">
-                <a16:creationId xmlns:a16="http://schemas.microsoft.com/office/drawing/2014/main" id="{0870896A-C2FA-40F1-A44D-9A7E359A1DAF}"/>
+                <a16:creationId xmlns:a16="http://schemas.microsoft.com/office/drawing/2014/main" id="{0481EEEC-4FAB-46A9-BAE7-516FB4F503C6}"/>
               </a:ext>
             </a:extLst>
           </p:cNvPr>
@@ -3852,7 +3852,7 @@
           <p:cNvPr id="3" name="circuit-8">
             <a:extLst xmlns:a="http://schemas.openxmlformats.org/drawingml/2006/main">
               <a:ext uri="{FF2B5EF4-FFF2-40B4-BE49-F238E27FC236}">
-                <a16:creationId xmlns:a16="http://schemas.microsoft.com/office/drawing/2014/main" id="{CED436F3-1DED-4F5E-9B2C-672BA31FC467}"/>
+                <a16:creationId xmlns:a16="http://schemas.microsoft.com/office/drawing/2014/main" id="{19CB58CB-3699-4B8C-B6D8-E58BD2FBF8FC}"/>
               </a:ext>
             </a:extLst>
           </p:cNvPr>
@@ -3884,7 +3884,7 @@
           <p:cNvPr id="4" name="text-9">
             <a:extLst xmlns:a="http://schemas.openxmlformats.org/drawingml/2006/main">
               <a:ext uri="{FF2B5EF4-FFF2-40B4-BE49-F238E27FC236}">
-                <a16:creationId xmlns:a16="http://schemas.microsoft.com/office/drawing/2014/main" id="{4C449D34-330E-41A7-AE66-C826FBA4EFFB}"/>
+                <a16:creationId xmlns:a16="http://schemas.microsoft.com/office/drawing/2014/main" id="{C8D4E9C4-3B31-4496-85B8-E65FEE34D11D}"/>
               </a:ext>
             </a:extLst>
           </p:cNvPr>
@@ -3950,7 +3950,7 @@
           <p:cNvPr id="5" name="circuit-10">
             <a:extLst xmlns:a="http://schemas.openxmlformats.org/drawingml/2006/main">
               <a:ext uri="{FF2B5EF4-FFF2-40B4-BE49-F238E27FC236}">
-                <a16:creationId xmlns:a16="http://schemas.microsoft.com/office/drawing/2014/main" id="{5E17A505-D5B7-4A2B-8A0A-CD6FD59E5CF3}"/>
+                <a16:creationId xmlns:a16="http://schemas.microsoft.com/office/drawing/2014/main" id="{19982CAF-B93F-4C1B-9DD4-CC338ED61A12}"/>
               </a:ext>
             </a:extLst>
           </p:cNvPr>
@@ -3982,7 +3982,7 @@
           <p:cNvPr id="6" name="text-11">
             <a:extLst xmlns:a="http://schemas.openxmlformats.org/drawingml/2006/main">
               <a:ext uri="{FF2B5EF4-FFF2-40B4-BE49-F238E27FC236}">
-                <a16:creationId xmlns:a16="http://schemas.microsoft.com/office/drawing/2014/main" id="{756203E2-4893-4B9E-9A22-2F72CFA3D30B}"/>
+                <a16:creationId xmlns:a16="http://schemas.microsoft.com/office/drawing/2014/main" id="{AD8981ED-D48F-4446-B890-D6538EAFADC9}"/>
               </a:ext>
             </a:extLst>
           </p:cNvPr>
@@ -4048,7 +4048,7 @@
           <p:cNvPr id="7" name="wire-12">
             <a:extLst xmlns:a="http://schemas.openxmlformats.org/drawingml/2006/main">
               <a:ext uri="{FF2B5EF4-FFF2-40B4-BE49-F238E27FC236}">
-                <a16:creationId xmlns:a16="http://schemas.microsoft.com/office/drawing/2014/main" id="{081C60E1-B51C-45D7-9CC1-942473273061}"/>
+                <a16:creationId xmlns:a16="http://schemas.microsoft.com/office/drawing/2014/main" id="{34668B9E-1A4C-4746-BFF0-E4B1D093D9C1}"/>
               </a:ext>
             </a:extLst>
           </p:cNvPr>
@@ -4087,7 +4087,7 @@
           <p:cNvPr id="8" name="circuit-13">
             <a:extLst xmlns:a="http://schemas.openxmlformats.org/drawingml/2006/main">
               <a:ext uri="{FF2B5EF4-FFF2-40B4-BE49-F238E27FC236}">
-                <a16:creationId xmlns:a16="http://schemas.microsoft.com/office/drawing/2014/main" id="{28BAB3DC-AF62-4E51-A1CC-985876E85FCA}"/>
+                <a16:creationId xmlns:a16="http://schemas.microsoft.com/office/drawing/2014/main" id="{CD5075E7-D07A-4506-BFB1-004D6C8C9FA9}"/>
               </a:ext>
             </a:extLst>
           </p:cNvPr>
@@ -4119,7 +4119,7 @@
           <p:cNvPr id="9" name="text-14">
             <a:extLst xmlns:a="http://schemas.openxmlformats.org/drawingml/2006/main">
               <a:ext uri="{FF2B5EF4-FFF2-40B4-BE49-F238E27FC236}">
-                <a16:creationId xmlns:a16="http://schemas.microsoft.com/office/drawing/2014/main" id="{1761364E-74EF-48D2-89A4-AE003A5B245D}"/>
+                <a16:creationId xmlns:a16="http://schemas.microsoft.com/office/drawing/2014/main" id="{3F9F91B9-3B5D-4A9F-A190-525E2453CE26}"/>
               </a:ext>
             </a:extLst>
           </p:cNvPr>
@@ -4185,7 +4185,7 @@
           <p:cNvPr id="10" name="wire-15">
             <a:extLst xmlns:a="http://schemas.openxmlformats.org/drawingml/2006/main">
               <a:ext uri="{FF2B5EF4-FFF2-40B4-BE49-F238E27FC236}">
-                <a16:creationId xmlns:a16="http://schemas.microsoft.com/office/drawing/2014/main" id="{E1B0448A-3A94-4D2A-BAFB-CC4AA102BF2E}"/>
+                <a16:creationId xmlns:a16="http://schemas.microsoft.com/office/drawing/2014/main" id="{4A81F6E9-54CD-4436-993C-D967FD2B7336}"/>
               </a:ext>
             </a:extLst>
           </p:cNvPr>
@@ -4224,7 +4224,7 @@
           <p:cNvPr id="11" name="circuit-16">
             <a:extLst xmlns:a="http://schemas.openxmlformats.org/drawingml/2006/main">
               <a:ext uri="{FF2B5EF4-FFF2-40B4-BE49-F238E27FC236}">
-                <a16:creationId xmlns:a16="http://schemas.microsoft.com/office/drawing/2014/main" id="{C30D773B-01EA-45C2-9C95-8E0C0F9B611D}"/>
+                <a16:creationId xmlns:a16="http://schemas.microsoft.com/office/drawing/2014/main" id="{D1B61E4B-7E55-4A60-9A47-0711AA2888EF}"/>
               </a:ext>
             </a:extLst>
           </p:cNvPr>
@@ -4256,7 +4256,7 @@
           <p:cNvPr id="12" name="text-17">
             <a:extLst xmlns:a="http://schemas.openxmlformats.org/drawingml/2006/main">
               <a:ext uri="{FF2B5EF4-FFF2-40B4-BE49-F238E27FC236}">
-                <a16:creationId xmlns:a16="http://schemas.microsoft.com/office/drawing/2014/main" id="{B41F6F4B-5305-4EA2-98E5-347520B22A84}"/>
+                <a16:creationId xmlns:a16="http://schemas.microsoft.com/office/drawing/2014/main" id="{6F665B3D-5AFA-46F4-8831-92D74AABA530}"/>
               </a:ext>
             </a:extLst>
           </p:cNvPr>
@@ -4322,7 +4322,7 @@
           <p:cNvPr id="13" name="wire-18">
             <a:extLst xmlns:a="http://schemas.openxmlformats.org/drawingml/2006/main">
               <a:ext uri="{FF2B5EF4-FFF2-40B4-BE49-F238E27FC236}">
-                <a16:creationId xmlns:a16="http://schemas.microsoft.com/office/drawing/2014/main" id="{42139D83-C327-42EC-8817-85FDB33C0346}"/>
+                <a16:creationId xmlns:a16="http://schemas.microsoft.com/office/drawing/2014/main" id="{0FE6B6FE-BDB4-4C96-8064-748BE3423561}"/>
               </a:ext>
             </a:extLst>
           </p:cNvPr>
@@ -4361,7 +4361,7 @@
           <p:cNvPr id="14" name="circuit-19">
             <a:extLst xmlns:a="http://schemas.openxmlformats.org/drawingml/2006/main">
               <a:ext uri="{FF2B5EF4-FFF2-40B4-BE49-F238E27FC236}">
-                <a16:creationId xmlns:a16="http://schemas.microsoft.com/office/drawing/2014/main" id="{10C61005-4B6C-41EA-8934-4FB34A3DFA0D}"/>
+                <a16:creationId xmlns:a16="http://schemas.microsoft.com/office/drawing/2014/main" id="{4ED8C7BB-2649-4A86-99DA-7F3BB0AECDC6}"/>
               </a:ext>
             </a:extLst>
           </p:cNvPr>
@@ -4393,7 +4393,7 @@
           <p:cNvPr id="15" name="text-20">
             <a:extLst xmlns:a="http://schemas.openxmlformats.org/drawingml/2006/main">
               <a:ext uri="{FF2B5EF4-FFF2-40B4-BE49-F238E27FC236}">
-                <a16:creationId xmlns:a16="http://schemas.microsoft.com/office/drawing/2014/main" id="{A7573F92-2DF0-4552-8276-2083825B07D9}"/>
+                <a16:creationId xmlns:a16="http://schemas.microsoft.com/office/drawing/2014/main" id="{84D9EFD0-C0D7-4EA8-ACED-3EC8D6BD7DDA}"/>
               </a:ext>
             </a:extLst>
           </p:cNvPr>
@@ -4459,7 +4459,7 @@
           <p:cNvPr id="16" name="and-gate-21">
             <a:extLst xmlns:a="http://schemas.openxmlformats.org/drawingml/2006/main">
               <a:ext uri="{FF2B5EF4-FFF2-40B4-BE49-F238E27FC236}">
-                <a16:creationId xmlns:a16="http://schemas.microsoft.com/office/drawing/2014/main" id="{31C29F03-F791-4B48-AFE3-B84B3E8148F6}"/>
+                <a16:creationId xmlns:a16="http://schemas.microsoft.com/office/drawing/2014/main" id="{F6A9D9EE-6847-4DC2-974A-060F3C0FF73D}"/>
               </a:ext>
             </a:extLst>
           </p:cNvPr>
@@ -4509,7 +4509,7 @@
           <p:cNvPr id="17" name="wire-22">
             <a:extLst xmlns:a="http://schemas.openxmlformats.org/drawingml/2006/main">
               <a:ext uri="{FF2B5EF4-FFF2-40B4-BE49-F238E27FC236}">
-                <a16:creationId xmlns:a16="http://schemas.microsoft.com/office/drawing/2014/main" id="{E6871896-403C-4A7D-9665-36B4DC68CA8E}"/>
+                <a16:creationId xmlns:a16="http://schemas.microsoft.com/office/drawing/2014/main" id="{897CD172-30CE-45A7-845F-27093E936404}"/>
               </a:ext>
             </a:extLst>
           </p:cNvPr>
@@ -4548,7 +4548,7 @@
           <p:cNvPr id="18" name="wire-23">
             <a:extLst xmlns:a="http://schemas.openxmlformats.org/drawingml/2006/main">
               <a:ext uri="{FF2B5EF4-FFF2-40B4-BE49-F238E27FC236}">
-                <a16:creationId xmlns:a16="http://schemas.microsoft.com/office/drawing/2014/main" id="{4A797759-8845-49A6-9235-4C14286946F8}"/>
+                <a16:creationId xmlns:a16="http://schemas.microsoft.com/office/drawing/2014/main" id="{5388F295-91D4-4507-B009-660142958717}"/>
               </a:ext>
             </a:extLst>
           </p:cNvPr>
@@ -4587,7 +4587,7 @@
           <p:cNvPr id="19" name="wire-24">
             <a:extLst xmlns:a="http://schemas.openxmlformats.org/drawingml/2006/main">
               <a:ext uri="{FF2B5EF4-FFF2-40B4-BE49-F238E27FC236}">
-                <a16:creationId xmlns:a16="http://schemas.microsoft.com/office/drawing/2014/main" id="{772585BE-216B-431D-8AD2-0AC0190E454F}"/>
+                <a16:creationId xmlns:a16="http://schemas.microsoft.com/office/drawing/2014/main" id="{3F0B3275-3A1A-4C33-AD2C-23270C718A08}"/>
               </a:ext>
             </a:extLst>
           </p:cNvPr>
@@ -4626,7 +4626,7 @@
           <p:cNvPr id="20" name="and-gate-25">
             <a:extLst xmlns:a="http://schemas.openxmlformats.org/drawingml/2006/main">
               <a:ext uri="{FF2B5EF4-FFF2-40B4-BE49-F238E27FC236}">
-                <a16:creationId xmlns:a16="http://schemas.microsoft.com/office/drawing/2014/main" id="{A16C93C5-4E7D-44FE-AE37-3E5AC1CCFF29}"/>
+                <a16:creationId xmlns:a16="http://schemas.microsoft.com/office/drawing/2014/main" id="{52201803-95A0-4D80-9DB5-91CC2F33AF8C}"/>
               </a:ext>
             </a:extLst>
           </p:cNvPr>
@@ -4676,7 +4676,7 @@
           <p:cNvPr id="21" name="wire-26">
             <a:extLst xmlns:a="http://schemas.openxmlformats.org/drawingml/2006/main">
               <a:ext uri="{FF2B5EF4-FFF2-40B4-BE49-F238E27FC236}">
-                <a16:creationId xmlns:a16="http://schemas.microsoft.com/office/drawing/2014/main" id="{937A4BFC-893C-49CD-A1E7-9DA997CF7D8B}"/>
+                <a16:creationId xmlns:a16="http://schemas.microsoft.com/office/drawing/2014/main" id="{B797C2C2-3451-49A9-A5A5-A4043589116C}"/>
               </a:ext>
             </a:extLst>
           </p:cNvPr>
@@ -4715,7 +4715,7 @@
           <p:cNvPr id="22" name="wire-27">
             <a:extLst xmlns:a="http://schemas.openxmlformats.org/drawingml/2006/main">
               <a:ext uri="{FF2B5EF4-FFF2-40B4-BE49-F238E27FC236}">
-                <a16:creationId xmlns:a16="http://schemas.microsoft.com/office/drawing/2014/main" id="{BD7352A6-3F8E-4B0E-AA68-67DE612C23C2}"/>
+                <a16:creationId xmlns:a16="http://schemas.microsoft.com/office/drawing/2014/main" id="{DD612E14-A908-4685-94F4-25E45C34AC21}"/>
               </a:ext>
             </a:extLst>
           </p:cNvPr>
@@ -4754,7 +4754,7 @@
           <p:cNvPr id="23" name="wire-28">
             <a:extLst xmlns:a="http://schemas.openxmlformats.org/drawingml/2006/main">
               <a:ext uri="{FF2B5EF4-FFF2-40B4-BE49-F238E27FC236}">
-                <a16:creationId xmlns:a16="http://schemas.microsoft.com/office/drawing/2014/main" id="{0CF66122-B6DE-40E1-8558-E2C2810F54EE}"/>
+                <a16:creationId xmlns:a16="http://schemas.microsoft.com/office/drawing/2014/main" id="{EFD76EAD-5AE4-481F-B5FD-28AF94DC5C95}"/>
               </a:ext>
             </a:extLst>
           </p:cNvPr>
@@ -4793,7 +4793,7 @@
           <p:cNvPr id="24" name="logic-29">
             <a:extLst xmlns:a="http://schemas.openxmlformats.org/drawingml/2006/main">
               <a:ext uri="{FF2B5EF4-FFF2-40B4-BE49-F238E27FC236}">
-                <a16:creationId xmlns:a16="http://schemas.microsoft.com/office/drawing/2014/main" id="{8CAC69DF-635D-4B68-9FE7-220A2A7EC5B4}"/>
+                <a16:creationId xmlns:a16="http://schemas.microsoft.com/office/drawing/2014/main" id="{DA49DA04-46B7-4C77-B48C-01CF74AA64E0}"/>
               </a:ext>
             </a:extLst>
           </p:cNvPr>
@@ -4838,7 +4838,7 @@
           <p:cNvPr id="25" name="wire-30">
             <a:extLst xmlns:a="http://schemas.openxmlformats.org/drawingml/2006/main">
               <a:ext uri="{FF2B5EF4-FFF2-40B4-BE49-F238E27FC236}">
-                <a16:creationId xmlns:a16="http://schemas.microsoft.com/office/drawing/2014/main" id="{E0E5E8C5-80A1-4DF5-A13F-B927324B7827}"/>
+                <a16:creationId xmlns:a16="http://schemas.microsoft.com/office/drawing/2014/main" id="{860A11BC-1CE0-4BA0-9590-5506B55CA34A}"/>
               </a:ext>
             </a:extLst>
           </p:cNvPr>
@@ -4877,7 +4877,7 @@
           <p:cNvPr id="26" name="wire-31">
             <a:extLst xmlns:a="http://schemas.openxmlformats.org/drawingml/2006/main">
               <a:ext uri="{FF2B5EF4-FFF2-40B4-BE49-F238E27FC236}">
-                <a16:creationId xmlns:a16="http://schemas.microsoft.com/office/drawing/2014/main" id="{E8AE1C7C-6929-4DAA-AC27-AF5BF07B3C21}"/>
+                <a16:creationId xmlns:a16="http://schemas.microsoft.com/office/drawing/2014/main" id="{8A9FCD2F-87D3-4B24-8C80-B042834F2F00}"/>
               </a:ext>
             </a:extLst>
           </p:cNvPr>
@@ -4916,7 +4916,7 @@
           <p:cNvPr id="27" name="text-32">
             <a:extLst xmlns:a="http://schemas.openxmlformats.org/drawingml/2006/main">
               <a:ext uri="{FF2B5EF4-FFF2-40B4-BE49-F238E27FC236}">
-                <a16:creationId xmlns:a16="http://schemas.microsoft.com/office/drawing/2014/main" id="{82081E19-3232-4962-95FA-FE4055D8ABC0}"/>
+                <a16:creationId xmlns:a16="http://schemas.microsoft.com/office/drawing/2014/main" id="{1127BD84-AA22-43F1-AD15-47B65A49EB62}"/>
               </a:ext>
             </a:extLst>
           </p:cNvPr>
@@ -4980,7 +4980,7 @@
     </p:spTree>
     <p:extLst>
       <p:ext uri="{BB962C8B-B14F-4D97-AF65-F5344CB8AC3E}">
-        <p14:creationId xmlns:p14="http://schemas.microsoft.com/office/powerpoint/2010/main" val="580490197"/>
+        <p14:creationId xmlns:p14="http://schemas.microsoft.com/office/powerpoint/2010/main" val="2068751094"/>
       </p:ext>
     </p:extLst>
   </p:cSld>
@@ -5011,7 +5011,7 @@
           <p:cNvPr id="47" name="text-33">
             <a:extLst xmlns:a="http://schemas.openxmlformats.org/drawingml/2006/main">
               <a:ext uri="{FF2B5EF4-FFF2-40B4-BE49-F238E27FC236}">
-                <a16:creationId xmlns:a16="http://schemas.microsoft.com/office/drawing/2014/main" id="{B17702DB-D69C-45AE-AFF7-54CB2E0859E8}"/>
+                <a16:creationId xmlns:a16="http://schemas.microsoft.com/office/drawing/2014/main" id="{EF3A2FEB-7689-4707-9414-6B44E6BF10EB}"/>
               </a:ext>
             </a:extLst>
           </p:cNvPr>
@@ -5077,7 +5077,7 @@
           <p:cNvPr id="2" name="text-34">
             <a:extLst xmlns:a="http://schemas.openxmlformats.org/drawingml/2006/main">
               <a:ext uri="{FF2B5EF4-FFF2-40B4-BE49-F238E27FC236}">
-                <a16:creationId xmlns:a16="http://schemas.microsoft.com/office/drawing/2014/main" id="{2B0EAA29-53B9-417D-AEA6-8641ECC1ECA5}"/>
+                <a16:creationId xmlns:a16="http://schemas.microsoft.com/office/drawing/2014/main" id="{14D40230-DFE5-420C-9BB9-F1ED0FDD2467}"/>
               </a:ext>
             </a:extLst>
           </p:cNvPr>
@@ -5143,7 +5143,7 @@
           <p:cNvPr id="3" name="circuit-35">
             <a:extLst xmlns:a="http://schemas.openxmlformats.org/drawingml/2006/main">
               <a:ext uri="{FF2B5EF4-FFF2-40B4-BE49-F238E27FC236}">
-                <a16:creationId xmlns:a16="http://schemas.microsoft.com/office/drawing/2014/main" id="{3D0CA728-C5AA-4A49-AF8E-AC27329DB5F3}"/>
+                <a16:creationId xmlns:a16="http://schemas.microsoft.com/office/drawing/2014/main" id="{81509C60-7078-4DE6-8111-6C23DDA2FBAB}"/>
               </a:ext>
             </a:extLst>
           </p:cNvPr>
@@ -5175,7 +5175,7 @@
           <p:cNvPr id="4" name="circuit-36">
             <a:extLst xmlns:a="http://schemas.openxmlformats.org/drawingml/2006/main">
               <a:ext uri="{FF2B5EF4-FFF2-40B4-BE49-F238E27FC236}">
-                <a16:creationId xmlns:a16="http://schemas.microsoft.com/office/drawing/2014/main" id="{ECA0F695-B5D8-4134-B73D-B96002500C91}"/>
+                <a16:creationId xmlns:a16="http://schemas.microsoft.com/office/drawing/2014/main" id="{6BF73041-F4A5-4B2E-8F3C-3C02508315BC}"/>
               </a:ext>
             </a:extLst>
           </p:cNvPr>
@@ -5207,7 +5207,7 @@
           <p:cNvPr id="5" name="text-37">
             <a:extLst xmlns:a="http://schemas.openxmlformats.org/drawingml/2006/main">
               <a:ext uri="{FF2B5EF4-FFF2-40B4-BE49-F238E27FC236}">
-                <a16:creationId xmlns:a16="http://schemas.microsoft.com/office/drawing/2014/main" id="{BF0F3927-A1D1-45DE-9B6E-39EE55D7ECA5}"/>
+                <a16:creationId xmlns:a16="http://schemas.microsoft.com/office/drawing/2014/main" id="{9841C403-4D62-4259-A628-EFA9C9BFBD46}"/>
               </a:ext>
             </a:extLst>
           </p:cNvPr>
@@ -5273,7 +5273,7 @@
           <p:cNvPr id="6" name="circuit-38">
             <a:extLst xmlns:a="http://schemas.openxmlformats.org/drawingml/2006/main">
               <a:ext uri="{FF2B5EF4-FFF2-40B4-BE49-F238E27FC236}">
-                <a16:creationId xmlns:a16="http://schemas.microsoft.com/office/drawing/2014/main" id="{C7D6EB08-6A6F-44EB-847B-4C6E896C1A1D}"/>
+                <a16:creationId xmlns:a16="http://schemas.microsoft.com/office/drawing/2014/main" id="{C924D272-8E77-4167-870B-D17A3955CA10}"/>
               </a:ext>
             </a:extLst>
           </p:cNvPr>
@@ -5305,7 +5305,7 @@
           <p:cNvPr id="7" name="text-39">
             <a:extLst xmlns:a="http://schemas.openxmlformats.org/drawingml/2006/main">
               <a:ext uri="{FF2B5EF4-FFF2-40B4-BE49-F238E27FC236}">
-                <a16:creationId xmlns:a16="http://schemas.microsoft.com/office/drawing/2014/main" id="{E03A6243-F491-44CB-8098-09C13132D1FB}"/>
+                <a16:creationId xmlns:a16="http://schemas.microsoft.com/office/drawing/2014/main" id="{ECB9D904-4ACB-481D-92EF-8319414AEB63}"/>
               </a:ext>
             </a:extLst>
           </p:cNvPr>
@@ -5371,7 +5371,7 @@
           <p:cNvPr id="8" name="circuit-40">
             <a:extLst xmlns:a="http://schemas.openxmlformats.org/drawingml/2006/main">
               <a:ext uri="{FF2B5EF4-FFF2-40B4-BE49-F238E27FC236}">
-                <a16:creationId xmlns:a16="http://schemas.microsoft.com/office/drawing/2014/main" id="{418F370A-E36B-45BE-B267-0504C4B9B14F}"/>
+                <a16:creationId xmlns:a16="http://schemas.microsoft.com/office/drawing/2014/main" id="{DF95BA53-9BEF-4244-AA6F-A575C47ABA5A}"/>
               </a:ext>
             </a:extLst>
           </p:cNvPr>
@@ -5403,7 +5403,7 @@
           <p:cNvPr id="9" name="text-41">
             <a:extLst xmlns:a="http://schemas.openxmlformats.org/drawingml/2006/main">
               <a:ext uri="{FF2B5EF4-FFF2-40B4-BE49-F238E27FC236}">
-                <a16:creationId xmlns:a16="http://schemas.microsoft.com/office/drawing/2014/main" id="{00325098-5961-420E-8724-397131DC6AEB}"/>
+                <a16:creationId xmlns:a16="http://schemas.microsoft.com/office/drawing/2014/main" id="{0A8FBAB8-503D-47BC-A875-AF86AF14117D}"/>
               </a:ext>
             </a:extLst>
           </p:cNvPr>
@@ -5469,7 +5469,7 @@
           <p:cNvPr id="10" name="circuit-42">
             <a:extLst xmlns:a="http://schemas.openxmlformats.org/drawingml/2006/main">
               <a:ext uri="{FF2B5EF4-FFF2-40B4-BE49-F238E27FC236}">
-                <a16:creationId xmlns:a16="http://schemas.microsoft.com/office/drawing/2014/main" id="{5046ACA9-1F24-4E52-80B4-3E98840D0320}"/>
+                <a16:creationId xmlns:a16="http://schemas.microsoft.com/office/drawing/2014/main" id="{F51D2C75-80CE-4413-BA20-BD66D1841A27}"/>
               </a:ext>
             </a:extLst>
           </p:cNvPr>
@@ -5501,7 +5501,7 @@
           <p:cNvPr id="11" name="text-43">
             <a:extLst xmlns:a="http://schemas.openxmlformats.org/drawingml/2006/main">
               <a:ext uri="{FF2B5EF4-FFF2-40B4-BE49-F238E27FC236}">
-                <a16:creationId xmlns:a16="http://schemas.microsoft.com/office/drawing/2014/main" id="{520804C9-FE6F-4944-BE07-288470FA1FAE}"/>
+                <a16:creationId xmlns:a16="http://schemas.microsoft.com/office/drawing/2014/main" id="{5093F561-DADF-4EED-8B71-BDDBFA284A9E}"/>
               </a:ext>
             </a:extLst>
           </p:cNvPr>
@@ -5567,7 +5567,7 @@
           <p:cNvPr id="12" name="circuit-44">
             <a:extLst xmlns:a="http://schemas.openxmlformats.org/drawingml/2006/main">
               <a:ext uri="{FF2B5EF4-FFF2-40B4-BE49-F238E27FC236}">
-                <a16:creationId xmlns:a16="http://schemas.microsoft.com/office/drawing/2014/main" id="{D11D5E59-3AA7-42E0-99A3-FA2039A1F6F4}"/>
+                <a16:creationId xmlns:a16="http://schemas.microsoft.com/office/drawing/2014/main" id="{66C9E6B6-7C3B-4098-BF86-69470A4BDE77}"/>
               </a:ext>
             </a:extLst>
           </p:cNvPr>
@@ -5599,7 +5599,7 @@
           <p:cNvPr id="13" name="text-45">
             <a:extLst xmlns:a="http://schemas.openxmlformats.org/drawingml/2006/main">
               <a:ext uri="{FF2B5EF4-FFF2-40B4-BE49-F238E27FC236}">
-                <a16:creationId xmlns:a16="http://schemas.microsoft.com/office/drawing/2014/main" id="{5015B512-6226-415B-ABAE-C972B68E6DF0}"/>
+                <a16:creationId xmlns:a16="http://schemas.microsoft.com/office/drawing/2014/main" id="{3238DF3E-61D3-43C2-BB13-6FEFD3003929}"/>
               </a:ext>
             </a:extLst>
           </p:cNvPr>
@@ -5665,7 +5665,7 @@
           <p:cNvPr id="14" name="wire-46">
             <a:extLst xmlns:a="http://schemas.openxmlformats.org/drawingml/2006/main">
               <a:ext uri="{FF2B5EF4-FFF2-40B4-BE49-F238E27FC236}">
-                <a16:creationId xmlns:a16="http://schemas.microsoft.com/office/drawing/2014/main" id="{43F3EFF0-FDCC-4C54-B749-21CE7096A879}"/>
+                <a16:creationId xmlns:a16="http://schemas.microsoft.com/office/drawing/2014/main" id="{AFD0873E-C1F3-4C3B-B528-F3D2811D6D8D}"/>
               </a:ext>
             </a:extLst>
           </p:cNvPr>
@@ -5704,7 +5704,7 @@
           <p:cNvPr id="15" name="circuit-47">
             <a:extLst xmlns:a="http://schemas.openxmlformats.org/drawingml/2006/main">
               <a:ext uri="{FF2B5EF4-FFF2-40B4-BE49-F238E27FC236}">
-                <a16:creationId xmlns:a16="http://schemas.microsoft.com/office/drawing/2014/main" id="{E57C49DA-8F38-4567-BDFA-5968FE0A1333}"/>
+                <a16:creationId xmlns:a16="http://schemas.microsoft.com/office/drawing/2014/main" id="{33C87545-FF41-43A6-8514-39E408404125}"/>
               </a:ext>
             </a:extLst>
           </p:cNvPr>
@@ -5736,7 +5736,7 @@
           <p:cNvPr id="16" name="text-48">
             <a:extLst xmlns:a="http://schemas.openxmlformats.org/drawingml/2006/main">
               <a:ext uri="{FF2B5EF4-FFF2-40B4-BE49-F238E27FC236}">
-                <a16:creationId xmlns:a16="http://schemas.microsoft.com/office/drawing/2014/main" id="{1C5ABD16-20B6-4DB2-8214-18070B913C5F}"/>
+                <a16:creationId xmlns:a16="http://schemas.microsoft.com/office/drawing/2014/main" id="{1FC04B89-D019-4118-80B5-A9D7E91E4ED7}"/>
               </a:ext>
             </a:extLst>
           </p:cNvPr>
@@ -5802,7 +5802,7 @@
           <p:cNvPr id="17" name="wire-49">
             <a:extLst xmlns:a="http://schemas.openxmlformats.org/drawingml/2006/main">
               <a:ext uri="{FF2B5EF4-FFF2-40B4-BE49-F238E27FC236}">
-                <a16:creationId xmlns:a16="http://schemas.microsoft.com/office/drawing/2014/main" id="{04683435-49DC-47CB-865E-F6674E8CEC13}"/>
+                <a16:creationId xmlns:a16="http://schemas.microsoft.com/office/drawing/2014/main" id="{CD58AA67-4DC0-4996-A9D1-55EAD51BC7BA}"/>
               </a:ext>
             </a:extLst>
           </p:cNvPr>
@@ -5841,7 +5841,7 @@
           <p:cNvPr id="18" name="circuit-50">
             <a:extLst xmlns:a="http://schemas.openxmlformats.org/drawingml/2006/main">
               <a:ext uri="{FF2B5EF4-FFF2-40B4-BE49-F238E27FC236}">
-                <a16:creationId xmlns:a16="http://schemas.microsoft.com/office/drawing/2014/main" id="{785DD9B7-C472-4812-BF54-6887B33BC3C7}"/>
+                <a16:creationId xmlns:a16="http://schemas.microsoft.com/office/drawing/2014/main" id="{C539C608-CD8E-4631-B00A-AB6411AB1994}"/>
               </a:ext>
             </a:extLst>
           </p:cNvPr>
@@ -5873,7 +5873,7 @@
           <p:cNvPr id="19" name="text-51">
             <a:extLst xmlns:a="http://schemas.openxmlformats.org/drawingml/2006/main">
               <a:ext uri="{FF2B5EF4-FFF2-40B4-BE49-F238E27FC236}">
-                <a16:creationId xmlns:a16="http://schemas.microsoft.com/office/drawing/2014/main" id="{D9EFB498-9827-4741-BF9E-05A19C6F4DB5}"/>
+                <a16:creationId xmlns:a16="http://schemas.microsoft.com/office/drawing/2014/main" id="{69F06A67-A2F0-459B-B053-8E1096269F80}"/>
               </a:ext>
             </a:extLst>
           </p:cNvPr>
@@ -5939,7 +5939,7 @@
           <p:cNvPr id="20" name="wire-52">
             <a:extLst xmlns:a="http://schemas.openxmlformats.org/drawingml/2006/main">
               <a:ext uri="{FF2B5EF4-FFF2-40B4-BE49-F238E27FC236}">
-                <a16:creationId xmlns:a16="http://schemas.microsoft.com/office/drawing/2014/main" id="{78AA3CCD-6E2C-4766-88BA-29EABD5B48E5}"/>
+                <a16:creationId xmlns:a16="http://schemas.microsoft.com/office/drawing/2014/main" id="{20887AEB-06F6-4621-A1F9-4A260E745386}"/>
               </a:ext>
             </a:extLst>
           </p:cNvPr>
@@ -5978,7 +5978,7 @@
           <p:cNvPr id="21" name="logic-53">
             <a:extLst xmlns:a="http://schemas.openxmlformats.org/drawingml/2006/main">
               <a:ext uri="{FF2B5EF4-FFF2-40B4-BE49-F238E27FC236}">
-                <a16:creationId xmlns:a16="http://schemas.microsoft.com/office/drawing/2014/main" id="{D41C46B5-C5B5-4DA8-B94D-EA3BA62FBA38}"/>
+                <a16:creationId xmlns:a16="http://schemas.microsoft.com/office/drawing/2014/main" id="{5428709B-E16E-4753-AF5F-F66FF8F3F0C7}"/>
               </a:ext>
             </a:extLst>
           </p:cNvPr>
@@ -6023,7 +6023,7 @@
           <p:cNvPr id="22" name="circuit-54">
             <a:extLst xmlns:a="http://schemas.openxmlformats.org/drawingml/2006/main">
               <a:ext uri="{FF2B5EF4-FFF2-40B4-BE49-F238E27FC236}">
-                <a16:creationId xmlns:a16="http://schemas.microsoft.com/office/drawing/2014/main" id="{25C93872-CCDF-4940-BD0B-2CC632AE0AA0}"/>
+                <a16:creationId xmlns:a16="http://schemas.microsoft.com/office/drawing/2014/main" id="{96A09CD1-3722-494B-85E9-2247E064A17C}"/>
               </a:ext>
             </a:extLst>
           </p:cNvPr>
@@ -6055,7 +6055,7 @@
           <p:cNvPr id="23" name="text-55">
             <a:extLst xmlns:a="http://schemas.openxmlformats.org/drawingml/2006/main">
               <a:ext uri="{FF2B5EF4-FFF2-40B4-BE49-F238E27FC236}">
-                <a16:creationId xmlns:a16="http://schemas.microsoft.com/office/drawing/2014/main" id="{2385397B-99FF-45F9-8DE8-A628DE9DF46B}"/>
+                <a16:creationId xmlns:a16="http://schemas.microsoft.com/office/drawing/2014/main" id="{3BCE5604-085D-4409-9B6D-A67B769CB48C}"/>
               </a:ext>
             </a:extLst>
           </p:cNvPr>
@@ -6121,7 +6121,7 @@
           <p:cNvPr id="24" name="wire-56">
             <a:extLst xmlns:a="http://schemas.openxmlformats.org/drawingml/2006/main">
               <a:ext uri="{FF2B5EF4-FFF2-40B4-BE49-F238E27FC236}">
-                <a16:creationId xmlns:a16="http://schemas.microsoft.com/office/drawing/2014/main" id="{A7FCBE3B-A168-4664-B755-E77EB11C048E}"/>
+                <a16:creationId xmlns:a16="http://schemas.microsoft.com/office/drawing/2014/main" id="{BFFD0E4E-F170-408F-ADDD-15EAD0B22902}"/>
               </a:ext>
             </a:extLst>
           </p:cNvPr>
@@ -6160,7 +6160,7 @@
           <p:cNvPr id="25" name="wire-57">
             <a:extLst xmlns:a="http://schemas.openxmlformats.org/drawingml/2006/main">
               <a:ext uri="{FF2B5EF4-FFF2-40B4-BE49-F238E27FC236}">
-                <a16:creationId xmlns:a16="http://schemas.microsoft.com/office/drawing/2014/main" id="{780E1788-AA53-4EFB-8989-75B86A6E0C25}"/>
+                <a16:creationId xmlns:a16="http://schemas.microsoft.com/office/drawing/2014/main" id="{ACA6E9C7-CA2F-478C-9A54-80A127B763A5}"/>
               </a:ext>
             </a:extLst>
           </p:cNvPr>
@@ -6199,7 +6199,7 @@
           <p:cNvPr id="26" name="circuit-58">
             <a:extLst xmlns:a="http://schemas.openxmlformats.org/drawingml/2006/main">
               <a:ext uri="{FF2B5EF4-FFF2-40B4-BE49-F238E27FC236}">
-                <a16:creationId xmlns:a16="http://schemas.microsoft.com/office/drawing/2014/main" id="{0587471F-98C5-4DE4-B89E-F69624936F1B}"/>
+                <a16:creationId xmlns:a16="http://schemas.microsoft.com/office/drawing/2014/main" id="{C47F49CC-1234-4E5E-B584-254123E89ABE}"/>
               </a:ext>
             </a:extLst>
           </p:cNvPr>
@@ -6231,7 +6231,7 @@
           <p:cNvPr id="27" name="text-59">
             <a:extLst xmlns:a="http://schemas.openxmlformats.org/drawingml/2006/main">
               <a:ext uri="{FF2B5EF4-FFF2-40B4-BE49-F238E27FC236}">
-                <a16:creationId xmlns:a16="http://schemas.microsoft.com/office/drawing/2014/main" id="{522C3C29-3886-4490-BADC-51EA0F3BAF2E}"/>
+                <a16:creationId xmlns:a16="http://schemas.microsoft.com/office/drawing/2014/main" id="{B7BD1F35-A5B2-48A2-B548-8D8465D05438}"/>
               </a:ext>
             </a:extLst>
           </p:cNvPr>
@@ -6320,7 +6320,7 @@
           <p:cNvPr id="28" name="wire-60">
             <a:extLst xmlns:a="http://schemas.openxmlformats.org/drawingml/2006/main">
               <a:ext uri="{FF2B5EF4-FFF2-40B4-BE49-F238E27FC236}">
-                <a16:creationId xmlns:a16="http://schemas.microsoft.com/office/drawing/2014/main" id="{B4E7433A-5E94-4623-8B61-746DE7690714}"/>
+                <a16:creationId xmlns:a16="http://schemas.microsoft.com/office/drawing/2014/main" id="{FC41B873-5A89-4ACE-9A5C-A6FAEF2341C2}"/>
               </a:ext>
             </a:extLst>
           </p:cNvPr>
@@ -6359,7 +6359,7 @@
           <p:cNvPr id="29" name="circuit-61">
             <a:extLst xmlns:a="http://schemas.openxmlformats.org/drawingml/2006/main">
               <a:ext uri="{FF2B5EF4-FFF2-40B4-BE49-F238E27FC236}">
-                <a16:creationId xmlns:a16="http://schemas.microsoft.com/office/drawing/2014/main" id="{48AB9A6D-1B3E-4E7B-B465-E4EE3FCA2D84}"/>
+                <a16:creationId xmlns:a16="http://schemas.microsoft.com/office/drawing/2014/main" id="{CF7A1E86-C775-45B1-8C53-8A823D050397}"/>
               </a:ext>
             </a:extLst>
           </p:cNvPr>
@@ -6391,7 +6391,7 @@
           <p:cNvPr id="30" name="text-62">
             <a:extLst xmlns:a="http://schemas.openxmlformats.org/drawingml/2006/main">
               <a:ext uri="{FF2B5EF4-FFF2-40B4-BE49-F238E27FC236}">
-                <a16:creationId xmlns:a16="http://schemas.microsoft.com/office/drawing/2014/main" id="{3BDCFB0C-FF2E-4106-86DB-161C2E4E2095}"/>
+                <a16:creationId xmlns:a16="http://schemas.microsoft.com/office/drawing/2014/main" id="{797F5DB3-406D-40A9-981E-3ABDDA17287C}"/>
               </a:ext>
             </a:extLst>
           </p:cNvPr>
@@ -6457,7 +6457,7 @@
           <p:cNvPr id="31" name="wire-63">
             <a:extLst xmlns:a="http://schemas.openxmlformats.org/drawingml/2006/main">
               <a:ext uri="{FF2B5EF4-FFF2-40B4-BE49-F238E27FC236}">
-                <a16:creationId xmlns:a16="http://schemas.microsoft.com/office/drawing/2014/main" id="{8AAFE06C-16C1-4F94-A78B-0BECE6D1E58C}"/>
+                <a16:creationId xmlns:a16="http://schemas.microsoft.com/office/drawing/2014/main" id="{CBD8D724-C277-495A-A91B-09BB0A4B3112}"/>
               </a:ext>
             </a:extLst>
           </p:cNvPr>
@@ -6496,7 +6496,7 @@
           <p:cNvPr id="32" name="logic-64">
             <a:extLst xmlns:a="http://schemas.openxmlformats.org/drawingml/2006/main">
               <a:ext uri="{FF2B5EF4-FFF2-40B4-BE49-F238E27FC236}">
-                <a16:creationId xmlns:a16="http://schemas.microsoft.com/office/drawing/2014/main" id="{32C1BDD6-E347-4BF9-B196-E4230EA008BC}"/>
+                <a16:creationId xmlns:a16="http://schemas.microsoft.com/office/drawing/2014/main" id="{2034F2CF-A733-4BF4-9174-270C86CA5E7D}"/>
               </a:ext>
             </a:extLst>
           </p:cNvPr>
@@ -6541,7 +6541,7 @@
           <p:cNvPr id="33" name="circuit-65">
             <a:extLst xmlns:a="http://schemas.openxmlformats.org/drawingml/2006/main">
               <a:ext uri="{FF2B5EF4-FFF2-40B4-BE49-F238E27FC236}">
-                <a16:creationId xmlns:a16="http://schemas.microsoft.com/office/drawing/2014/main" id="{6329EAAD-2951-4BFD-BF9B-E77419BEE081}"/>
+                <a16:creationId xmlns:a16="http://schemas.microsoft.com/office/drawing/2014/main" id="{5F48AFC3-B7EA-4A17-9D87-493B3CD2AAC4}"/>
               </a:ext>
             </a:extLst>
           </p:cNvPr>
@@ -6573,7 +6573,7 @@
           <p:cNvPr id="34" name="text-66">
             <a:extLst xmlns:a="http://schemas.openxmlformats.org/drawingml/2006/main">
               <a:ext uri="{FF2B5EF4-FFF2-40B4-BE49-F238E27FC236}">
-                <a16:creationId xmlns:a16="http://schemas.microsoft.com/office/drawing/2014/main" id="{FF414F51-8474-4267-98A7-A2C27406D0E9}"/>
+                <a16:creationId xmlns:a16="http://schemas.microsoft.com/office/drawing/2014/main" id="{82B2E5FE-C16D-4963-AC62-1D599C530D42}"/>
               </a:ext>
             </a:extLst>
           </p:cNvPr>
@@ -6662,7 +6662,7 @@
           <p:cNvPr id="35" name="wire-67">
             <a:extLst xmlns:a="http://schemas.openxmlformats.org/drawingml/2006/main">
               <a:ext uri="{FF2B5EF4-FFF2-40B4-BE49-F238E27FC236}">
-                <a16:creationId xmlns:a16="http://schemas.microsoft.com/office/drawing/2014/main" id="{BFCB5087-1D80-4B86-80D7-2A0D93BD987E}"/>
+                <a16:creationId xmlns:a16="http://schemas.microsoft.com/office/drawing/2014/main" id="{70DB5D4B-0854-4AA3-A924-A28D817E918E}"/>
               </a:ext>
             </a:extLst>
           </p:cNvPr>
@@ -6701,7 +6701,7 @@
           <p:cNvPr id="36" name="logic-68">
             <a:extLst xmlns:a="http://schemas.openxmlformats.org/drawingml/2006/main">
               <a:ext uri="{FF2B5EF4-FFF2-40B4-BE49-F238E27FC236}">
-                <a16:creationId xmlns:a16="http://schemas.microsoft.com/office/drawing/2014/main" id="{1415AE55-0850-4BE5-B0E1-4F0228BB60E2}"/>
+                <a16:creationId xmlns:a16="http://schemas.microsoft.com/office/drawing/2014/main" id="{1BA635AE-34DB-4096-9052-D06397797ACB}"/>
               </a:ext>
             </a:extLst>
           </p:cNvPr>
@@ -6746,7 +6746,7 @@
           <p:cNvPr id="37" name="wire-69">
             <a:extLst xmlns:a="http://schemas.openxmlformats.org/drawingml/2006/main">
               <a:ext uri="{FF2B5EF4-FFF2-40B4-BE49-F238E27FC236}">
-                <a16:creationId xmlns:a16="http://schemas.microsoft.com/office/drawing/2014/main" id="{CFA0BA97-74F2-445D-9304-9D1F84A31907}"/>
+                <a16:creationId xmlns:a16="http://schemas.microsoft.com/office/drawing/2014/main" id="{77277122-AA44-46B6-93C2-4EE435A4BDE8}"/>
               </a:ext>
             </a:extLst>
           </p:cNvPr>
@@ -6785,7 +6785,7 @@
           <p:cNvPr id="38" name="wire-70">
             <a:extLst xmlns:a="http://schemas.openxmlformats.org/drawingml/2006/main">
               <a:ext uri="{FF2B5EF4-FFF2-40B4-BE49-F238E27FC236}">
-                <a16:creationId xmlns:a16="http://schemas.microsoft.com/office/drawing/2014/main" id="{575461BF-78C2-48B7-ADF3-8255279D2385}"/>
+                <a16:creationId xmlns:a16="http://schemas.microsoft.com/office/drawing/2014/main" id="{FE4D91FF-7AD7-4AE4-9DC6-B845A73ACAD1}"/>
               </a:ext>
             </a:extLst>
           </p:cNvPr>
@@ -6824,7 +6824,7 @@
           <p:cNvPr id="39" name="wire-71">
             <a:extLst xmlns:a="http://schemas.openxmlformats.org/drawingml/2006/main">
               <a:ext uri="{FF2B5EF4-FFF2-40B4-BE49-F238E27FC236}">
-                <a16:creationId xmlns:a16="http://schemas.microsoft.com/office/drawing/2014/main" id="{6B02F194-867F-4396-B437-F82224ECE996}"/>
+                <a16:creationId xmlns:a16="http://schemas.microsoft.com/office/drawing/2014/main" id="{717A87F1-89F1-4416-AFCD-C9B7BF9DB20E}"/>
               </a:ext>
             </a:extLst>
           </p:cNvPr>
@@ -6863,7 +6863,7 @@
           <p:cNvPr id="40" name="wire-72">
             <a:extLst xmlns:a="http://schemas.openxmlformats.org/drawingml/2006/main">
               <a:ext uri="{FF2B5EF4-FFF2-40B4-BE49-F238E27FC236}">
-                <a16:creationId xmlns:a16="http://schemas.microsoft.com/office/drawing/2014/main" id="{9DCA05C3-BFF4-4DBA-98E5-011BFF5EED3F}"/>
+                <a16:creationId xmlns:a16="http://schemas.microsoft.com/office/drawing/2014/main" id="{0B03AA88-E546-40A6-A03A-BAE9CAB453D9}"/>
               </a:ext>
             </a:extLst>
           </p:cNvPr>
@@ -6902,7 +6902,7 @@
           <p:cNvPr id="41" name="logic-73">
             <a:extLst xmlns:a="http://schemas.openxmlformats.org/drawingml/2006/main">
               <a:ext uri="{FF2B5EF4-FFF2-40B4-BE49-F238E27FC236}">
-                <a16:creationId xmlns:a16="http://schemas.microsoft.com/office/drawing/2014/main" id="{76BD342E-E0C1-48A0-A465-2BCF147116D9}"/>
+                <a16:creationId xmlns:a16="http://schemas.microsoft.com/office/drawing/2014/main" id="{F43C9107-B8B0-4E1F-AE01-BE99930BB792}"/>
               </a:ext>
             </a:extLst>
           </p:cNvPr>
@@ -6947,7 +6947,7 @@
           <p:cNvPr id="42" name="text-74">
             <a:extLst xmlns:a="http://schemas.openxmlformats.org/drawingml/2006/main">
               <a:ext uri="{FF2B5EF4-FFF2-40B4-BE49-F238E27FC236}">
-                <a16:creationId xmlns:a16="http://schemas.microsoft.com/office/drawing/2014/main" id="{1E42A30F-6D68-4A5A-9A20-B3B67CF68771}"/>
+                <a16:creationId xmlns:a16="http://schemas.microsoft.com/office/drawing/2014/main" id="{29001FFD-A6B9-485C-8506-71A51653B050}"/>
               </a:ext>
             </a:extLst>
           </p:cNvPr>
@@ -7013,7 +7013,7 @@
           <p:cNvPr id="43" name="wire-75">
             <a:extLst xmlns:a="http://schemas.openxmlformats.org/drawingml/2006/main">
               <a:ext uri="{FF2B5EF4-FFF2-40B4-BE49-F238E27FC236}">
-                <a16:creationId xmlns:a16="http://schemas.microsoft.com/office/drawing/2014/main" id="{06C37ED9-4C23-4927-97FB-D27104078884}"/>
+                <a16:creationId xmlns:a16="http://schemas.microsoft.com/office/drawing/2014/main" id="{02DC308F-1460-4334-A561-BA42CB36522F}"/>
               </a:ext>
             </a:extLst>
           </p:cNvPr>
@@ -7052,7 +7052,7 @@
           <p:cNvPr id="44" name="logic-76">
             <a:extLst xmlns:a="http://schemas.openxmlformats.org/drawingml/2006/main">
               <a:ext uri="{FF2B5EF4-FFF2-40B4-BE49-F238E27FC236}">
-                <a16:creationId xmlns:a16="http://schemas.microsoft.com/office/drawing/2014/main" id="{209EB2E7-C453-40E6-8732-6702CABBCEF8}"/>
+                <a16:creationId xmlns:a16="http://schemas.microsoft.com/office/drawing/2014/main" id="{C8C9AB22-1B16-4FE6-9C6C-B1D69F6E8B9F}"/>
               </a:ext>
             </a:extLst>
           </p:cNvPr>
@@ -7097,7 +7097,7 @@
           <p:cNvPr id="45" name="text-77">
             <a:extLst xmlns:a="http://schemas.openxmlformats.org/drawingml/2006/main">
               <a:ext uri="{FF2B5EF4-FFF2-40B4-BE49-F238E27FC236}">
-                <a16:creationId xmlns:a16="http://schemas.microsoft.com/office/drawing/2014/main" id="{84AB9170-EA51-4A61-95A2-92B979FF784E}"/>
+                <a16:creationId xmlns:a16="http://schemas.microsoft.com/office/drawing/2014/main" id="{E4F136EB-C842-4211-B774-F3E8992A7C7D}"/>
               </a:ext>
             </a:extLst>
           </p:cNvPr>
@@ -7163,7 +7163,7 @@
           <p:cNvPr id="46" name="text-78">
             <a:extLst xmlns:a="http://schemas.openxmlformats.org/drawingml/2006/main">
               <a:ext uri="{FF2B5EF4-FFF2-40B4-BE49-F238E27FC236}">
-                <a16:creationId xmlns:a16="http://schemas.microsoft.com/office/drawing/2014/main" id="{FB2BAF9A-2CCB-410F-AB0C-B83E81F1E617}"/>
+                <a16:creationId xmlns:a16="http://schemas.microsoft.com/office/drawing/2014/main" id="{936B64A4-8488-4FFD-9E60-8CE3F4BACA27}"/>
               </a:ext>
             </a:extLst>
           </p:cNvPr>
@@ -7227,7 +7227,7 @@
     </p:spTree>
     <p:extLst>
       <p:ext uri="{BB962C8B-B14F-4D97-AF65-F5344CB8AC3E}">
-        <p14:creationId xmlns:p14="http://schemas.microsoft.com/office/powerpoint/2010/main" val="1305173874"/>
+        <p14:creationId xmlns:p14="http://schemas.microsoft.com/office/powerpoint/2010/main" val="1815262970"/>
       </p:ext>
     </p:extLst>
   </p:cSld>
@@ -7255,10 +7255,10 @@
       </p:grpSpPr>
       <p:sp>
         <p:nvSpPr>
-          <p:cNvPr id="25" name="text-79">
-            <a:extLst xmlns:a="http://schemas.openxmlformats.org/drawingml/2006/main">
-              <a:ext uri="{FF2B5EF4-FFF2-40B4-BE49-F238E27FC236}">
-                <a16:creationId xmlns:a16="http://schemas.microsoft.com/office/drawing/2014/main" id="{176B8BF6-9F2B-45AB-B195-F45D589E402E}"/>
+          <p:cNvPr id="26" name="text-79">
+            <a:extLst xmlns:a="http://schemas.openxmlformats.org/drawingml/2006/main">
+              <a:ext uri="{FF2B5EF4-FFF2-40B4-BE49-F238E27FC236}">
+                <a16:creationId xmlns:a16="http://schemas.microsoft.com/office/drawing/2014/main" id="{5E5071CC-3C9F-496A-BAB1-C178C124BB55}"/>
               </a:ext>
             </a:extLst>
           </p:cNvPr>
@@ -7324,7 +7324,7 @@
           <p:cNvPr id="2" name="text-80">
             <a:extLst xmlns:a="http://schemas.openxmlformats.org/drawingml/2006/main">
               <a:ext uri="{FF2B5EF4-FFF2-40B4-BE49-F238E27FC236}">
-                <a16:creationId xmlns:a16="http://schemas.microsoft.com/office/drawing/2014/main" id="{1A70094A-41F3-4257-902F-32198AA861CF}"/>
+                <a16:creationId xmlns:a16="http://schemas.microsoft.com/office/drawing/2014/main" id="{378C1FAD-693E-4ED2-BA47-0877AAE5793C}"/>
               </a:ext>
             </a:extLst>
           </p:cNvPr>
@@ -7390,7 +7390,7 @@
           <p:cNvPr id="3" name="circuit-81">
             <a:extLst xmlns:a="http://schemas.openxmlformats.org/drawingml/2006/main">
               <a:ext uri="{FF2B5EF4-FFF2-40B4-BE49-F238E27FC236}">
-                <a16:creationId xmlns:a16="http://schemas.microsoft.com/office/drawing/2014/main" id="{39DD6F4B-1CF3-4761-9A49-8D48EA505242}"/>
+                <a16:creationId xmlns:a16="http://schemas.microsoft.com/office/drawing/2014/main" id="{EE50C894-8895-4B03-94BA-A4D12C9DC4E5}"/>
               </a:ext>
             </a:extLst>
           </p:cNvPr>
@@ -7422,7 +7422,7 @@
           <p:cNvPr id="4" name="text-82">
             <a:extLst xmlns:a="http://schemas.openxmlformats.org/drawingml/2006/main">
               <a:ext uri="{FF2B5EF4-FFF2-40B4-BE49-F238E27FC236}">
-                <a16:creationId xmlns:a16="http://schemas.microsoft.com/office/drawing/2014/main" id="{4D3CD7C7-90DA-42B0-A145-2F0664957B54}"/>
+                <a16:creationId xmlns:a16="http://schemas.microsoft.com/office/drawing/2014/main" id="{18CB5927-CB33-4788-B639-9200AD5F4F64}"/>
               </a:ext>
             </a:extLst>
           </p:cNvPr>
@@ -7488,7 +7488,7 @@
           <p:cNvPr id="5" name="circuit-83">
             <a:extLst xmlns:a="http://schemas.openxmlformats.org/drawingml/2006/main">
               <a:ext uri="{FF2B5EF4-FFF2-40B4-BE49-F238E27FC236}">
-                <a16:creationId xmlns:a16="http://schemas.microsoft.com/office/drawing/2014/main" id="{3735FAAF-76D8-4472-801C-6EEE4955735E}"/>
+                <a16:creationId xmlns:a16="http://schemas.microsoft.com/office/drawing/2014/main" id="{2984D5CF-633B-4221-AABD-B8BAC590EE3A}"/>
               </a:ext>
             </a:extLst>
           </p:cNvPr>
@@ -7520,7 +7520,7 @@
           <p:cNvPr id="6" name="text-84">
             <a:extLst xmlns:a="http://schemas.openxmlformats.org/drawingml/2006/main">
               <a:ext uri="{FF2B5EF4-FFF2-40B4-BE49-F238E27FC236}">
-                <a16:creationId xmlns:a16="http://schemas.microsoft.com/office/drawing/2014/main" id="{9F1C2E9A-727B-4C59-8C4A-C12FD8B77071}"/>
+                <a16:creationId xmlns:a16="http://schemas.microsoft.com/office/drawing/2014/main" id="{2D5F3999-7048-460A-A141-758A8911F0D9}"/>
               </a:ext>
             </a:extLst>
           </p:cNvPr>
@@ -7586,7 +7586,7 @@
           <p:cNvPr id="7" name="circuit-85">
             <a:extLst xmlns:a="http://schemas.openxmlformats.org/drawingml/2006/main">
               <a:ext uri="{FF2B5EF4-FFF2-40B4-BE49-F238E27FC236}">
-                <a16:creationId xmlns:a16="http://schemas.microsoft.com/office/drawing/2014/main" id="{93F8F352-C5A9-4313-8A1E-8BF30602B027}"/>
+                <a16:creationId xmlns:a16="http://schemas.microsoft.com/office/drawing/2014/main" id="{0A0799C3-FFFA-4894-92FC-894598F867E3}"/>
               </a:ext>
             </a:extLst>
           </p:cNvPr>
@@ -7618,7 +7618,7 @@
           <p:cNvPr id="8" name="text-86">
             <a:extLst xmlns:a="http://schemas.openxmlformats.org/drawingml/2006/main">
               <a:ext uri="{FF2B5EF4-FFF2-40B4-BE49-F238E27FC236}">
-                <a16:creationId xmlns:a16="http://schemas.microsoft.com/office/drawing/2014/main" id="{93A2430B-1A83-4B34-87B6-B58701EA2D69}"/>
+                <a16:creationId xmlns:a16="http://schemas.microsoft.com/office/drawing/2014/main" id="{B2B1D937-F6C0-4A2B-9E3F-E77D401365F4}"/>
               </a:ext>
             </a:extLst>
           </p:cNvPr>
@@ -7684,7 +7684,7 @@
           <p:cNvPr id="9" name="circuit-87">
             <a:extLst xmlns:a="http://schemas.openxmlformats.org/drawingml/2006/main">
               <a:ext uri="{FF2B5EF4-FFF2-40B4-BE49-F238E27FC236}">
-                <a16:creationId xmlns:a16="http://schemas.microsoft.com/office/drawing/2014/main" id="{6C83094E-DA5F-404A-BECC-79F13D6ADE4D}"/>
+                <a16:creationId xmlns:a16="http://schemas.microsoft.com/office/drawing/2014/main" id="{D89AB0C2-3648-4193-912D-8194B61B839A}"/>
               </a:ext>
             </a:extLst>
           </p:cNvPr>
@@ -7716,7 +7716,7 @@
           <p:cNvPr id="10" name="text-88">
             <a:extLst xmlns:a="http://schemas.openxmlformats.org/drawingml/2006/main">
               <a:ext uri="{FF2B5EF4-FFF2-40B4-BE49-F238E27FC236}">
-                <a16:creationId xmlns:a16="http://schemas.microsoft.com/office/drawing/2014/main" id="{0B2FE83A-3BF3-4AF4-8508-36ADD882F76E}"/>
+                <a16:creationId xmlns:a16="http://schemas.microsoft.com/office/drawing/2014/main" id="{E6233557-BCC5-41B2-8A99-03D36B24E789}"/>
               </a:ext>
             </a:extLst>
           </p:cNvPr>
@@ -7782,7 +7782,7 @@
           <p:cNvPr id="11" name="wire-89">
             <a:extLst xmlns:a="http://schemas.openxmlformats.org/drawingml/2006/main">
               <a:ext uri="{FF2B5EF4-FFF2-40B4-BE49-F238E27FC236}">
-                <a16:creationId xmlns:a16="http://schemas.microsoft.com/office/drawing/2014/main" id="{3958F3E0-78EF-4C28-BE00-140802224EB1}"/>
+                <a16:creationId xmlns:a16="http://schemas.microsoft.com/office/drawing/2014/main" id="{2974A33F-9E07-4939-8CB2-4A3C8E13678A}"/>
               </a:ext>
             </a:extLst>
           </p:cNvPr>
@@ -7821,7 +7821,7 @@
           <p:cNvPr id="12" name="logic-90">
             <a:extLst xmlns:a="http://schemas.openxmlformats.org/drawingml/2006/main">
               <a:ext uri="{FF2B5EF4-FFF2-40B4-BE49-F238E27FC236}">
-                <a16:creationId xmlns:a16="http://schemas.microsoft.com/office/drawing/2014/main" id="{511CB18F-7BFA-4626-A1C2-C53275D64D7A}"/>
+                <a16:creationId xmlns:a16="http://schemas.microsoft.com/office/drawing/2014/main" id="{D84BBE1F-B1B1-4D77-8825-2A0E853C0C8A}"/>
               </a:ext>
             </a:extLst>
           </p:cNvPr>
@@ -7866,7 +7866,7 @@
           <p:cNvPr id="13" name="wire-91">
             <a:extLst xmlns:a="http://schemas.openxmlformats.org/drawingml/2006/main">
               <a:ext uri="{FF2B5EF4-FFF2-40B4-BE49-F238E27FC236}">
-                <a16:creationId xmlns:a16="http://schemas.microsoft.com/office/drawing/2014/main" id="{019201D1-B54D-4A4B-9220-92C8B67F9985}"/>
+                <a16:creationId xmlns:a16="http://schemas.microsoft.com/office/drawing/2014/main" id="{870CFA7F-B35A-488B-BDB2-A123305BFDFD}"/>
               </a:ext>
             </a:extLst>
           </p:cNvPr>
@@ -7905,7 +7905,7 @@
           <p:cNvPr id="14" name="logic-92">
             <a:extLst xmlns:a="http://schemas.openxmlformats.org/drawingml/2006/main">
               <a:ext uri="{FF2B5EF4-FFF2-40B4-BE49-F238E27FC236}">
-                <a16:creationId xmlns:a16="http://schemas.microsoft.com/office/drawing/2014/main" id="{83A8DB64-5C2D-4D53-BE66-EB3A6B17EEA9}"/>
+                <a16:creationId xmlns:a16="http://schemas.microsoft.com/office/drawing/2014/main" id="{5CD782A3-4F49-4D49-9DB3-87A752F3269C}"/>
               </a:ext>
             </a:extLst>
           </p:cNvPr>
@@ -7950,7 +7950,7 @@
           <p:cNvPr id="15" name="wire-93">
             <a:extLst xmlns:a="http://schemas.openxmlformats.org/drawingml/2006/main">
               <a:ext uri="{FF2B5EF4-FFF2-40B4-BE49-F238E27FC236}">
-                <a16:creationId xmlns:a16="http://schemas.microsoft.com/office/drawing/2014/main" id="{3A29B038-2A6A-4D19-8B47-2730A3E90532}"/>
+                <a16:creationId xmlns:a16="http://schemas.microsoft.com/office/drawing/2014/main" id="{A77654F6-6E9A-423A-AE7F-D74A13E4FDC1}"/>
               </a:ext>
             </a:extLst>
           </p:cNvPr>
@@ -7989,7 +7989,7 @@
           <p:cNvPr id="16" name="logic-94">
             <a:extLst xmlns:a="http://schemas.openxmlformats.org/drawingml/2006/main">
               <a:ext uri="{FF2B5EF4-FFF2-40B4-BE49-F238E27FC236}">
-                <a16:creationId xmlns:a16="http://schemas.microsoft.com/office/drawing/2014/main" id="{56EE2A59-44E4-4067-B788-E3FED6A6F5DC}"/>
+                <a16:creationId xmlns:a16="http://schemas.microsoft.com/office/drawing/2014/main" id="{584A59F3-DB02-492E-AF9E-29A998C30EB4}"/>
               </a:ext>
             </a:extLst>
           </p:cNvPr>
@@ -8034,7 +8034,7 @@
           <p:cNvPr id="17" name="text-95">
             <a:extLst xmlns:a="http://schemas.openxmlformats.org/drawingml/2006/main">
               <a:ext uri="{FF2B5EF4-FFF2-40B4-BE49-F238E27FC236}">
-                <a16:creationId xmlns:a16="http://schemas.microsoft.com/office/drawing/2014/main" id="{1F3734B8-C0CD-4623-9F7E-FA7BC26BAECA}"/>
+                <a16:creationId xmlns:a16="http://schemas.microsoft.com/office/drawing/2014/main" id="{C0C27C63-22AA-4360-9D6C-9062B10B49FC}"/>
               </a:ext>
             </a:extLst>
           </p:cNvPr>
@@ -8123,7 +8123,7 @@
           <p:cNvPr id="18" name="text-96">
             <a:extLst xmlns:a="http://schemas.openxmlformats.org/drawingml/2006/main">
               <a:ext uri="{FF2B5EF4-FFF2-40B4-BE49-F238E27FC236}">
-                <a16:creationId xmlns:a16="http://schemas.microsoft.com/office/drawing/2014/main" id="{7D59C48A-5229-4A88-A3BC-1E401687809A}"/>
+                <a16:creationId xmlns:a16="http://schemas.microsoft.com/office/drawing/2014/main" id="{7134E0A0-A2CE-48BF-A9FA-6CBC20C3215C}"/>
               </a:ext>
             </a:extLst>
           </p:cNvPr>
@@ -8235,7 +8235,7 @@
           <p:cNvPr id="19" name="text-97">
             <a:extLst xmlns:a="http://schemas.openxmlformats.org/drawingml/2006/main">
               <a:ext uri="{FF2B5EF4-FFF2-40B4-BE49-F238E27FC236}">
-                <a16:creationId xmlns:a16="http://schemas.microsoft.com/office/drawing/2014/main" id="{C6840D2F-61F1-494D-8756-3169E4FF32D0}"/>
+                <a16:creationId xmlns:a16="http://schemas.microsoft.com/office/drawing/2014/main" id="{0EA3CC78-3A05-4276-9CC5-A1DEA1883006}"/>
               </a:ext>
             </a:extLst>
           </p:cNvPr>
@@ -8324,7 +8324,7 @@
           <p:cNvPr id="20" name="circuit-98">
             <a:extLst xmlns:a="http://schemas.openxmlformats.org/drawingml/2006/main">
               <a:ext uri="{FF2B5EF4-FFF2-40B4-BE49-F238E27FC236}">
-                <a16:creationId xmlns:a16="http://schemas.microsoft.com/office/drawing/2014/main" id="{D96357D1-F8F9-47ED-A2F7-FB4136FD02B7}"/>
+                <a16:creationId xmlns:a16="http://schemas.microsoft.com/office/drawing/2014/main" id="{DB407B34-2BDE-42E3-90C6-65504065EDFC}"/>
               </a:ext>
             </a:extLst>
           </p:cNvPr>
@@ -8356,7 +8356,7 @@
           <p:cNvPr id="21" name="circuit-99">
             <a:extLst xmlns:a="http://schemas.openxmlformats.org/drawingml/2006/main">
               <a:ext uri="{FF2B5EF4-FFF2-40B4-BE49-F238E27FC236}">
-                <a16:creationId xmlns:a16="http://schemas.microsoft.com/office/drawing/2014/main" id="{E7343203-E50A-464A-9508-03B14B1C46BD}"/>
+                <a16:creationId xmlns:a16="http://schemas.microsoft.com/office/drawing/2014/main" id="{372136B0-56C4-4104-875A-8F1288A616BE}"/>
               </a:ext>
             </a:extLst>
           </p:cNvPr>
@@ -8388,7 +8388,7 @@
           <p:cNvPr id="22" name="wire-100">
             <a:extLst xmlns:a="http://schemas.openxmlformats.org/drawingml/2006/main">
               <a:ext uri="{FF2B5EF4-FFF2-40B4-BE49-F238E27FC236}">
-                <a16:creationId xmlns:a16="http://schemas.microsoft.com/office/drawing/2014/main" id="{44C4E5BE-7C64-40DC-AD08-2344618D2FFC}"/>
+                <a16:creationId xmlns:a16="http://schemas.microsoft.com/office/drawing/2014/main" id="{F74A872A-64FE-4612-9A0C-8BFC65EE15A3}"/>
               </a:ext>
             </a:extLst>
           </p:cNvPr>
@@ -8427,7 +8427,7 @@
           <p:cNvPr id="23" name="wire-101">
             <a:extLst xmlns:a="http://schemas.openxmlformats.org/drawingml/2006/main">
               <a:ext uri="{FF2B5EF4-FFF2-40B4-BE49-F238E27FC236}">
-                <a16:creationId xmlns:a16="http://schemas.microsoft.com/office/drawing/2014/main" id="{2B9E60B4-F0D3-4364-B15D-9E5A3F4F4B39}"/>
+                <a16:creationId xmlns:a16="http://schemas.microsoft.com/office/drawing/2014/main" id="{168454AA-98E7-4D1A-A29D-6C14BD372971}"/>
               </a:ext>
             </a:extLst>
           </p:cNvPr>
@@ -8466,19 +8466,19 @@
           <p:cNvPr id="24" name="text-102">
             <a:extLst xmlns:a="http://schemas.openxmlformats.org/drawingml/2006/main">
               <a:ext uri="{FF2B5EF4-FFF2-40B4-BE49-F238E27FC236}">
-                <a16:creationId xmlns:a16="http://schemas.microsoft.com/office/drawing/2014/main" id="{B6C654C0-F1F9-4146-BE3D-7C22955D1830}"/>
-              </a:ext>
-            </a:extLst>
-          </p:cNvPr>
-          <p:cNvSpPr>
-            <a:spLocks xmlns:a="http://schemas.openxmlformats.org/drawingml/2006/main" noGrp="1"/>
-          </p:cNvSpPr>
-          <p:nvPr/>
-        </p:nvSpPr>
-        <p:spPr>
-          <a:xfrm xmlns:a="http://schemas.openxmlformats.org/drawingml/2006/main">
-            <a:off x="3000375" y="5276850"/>
-            <a:ext cx="6572250" cy="619125"/>
+                <a16:creationId xmlns:a16="http://schemas.microsoft.com/office/drawing/2014/main" id="{50ACC1E6-BCA2-4DF0-A52E-A45D82B97E48}"/>
+              </a:ext>
+            </a:extLst>
+          </p:cNvPr>
+          <p:cNvSpPr>
+            <a:spLocks xmlns:a="http://schemas.openxmlformats.org/drawingml/2006/main" noGrp="1"/>
+          </p:cNvSpPr>
+          <p:nvPr/>
+        </p:nvSpPr>
+        <p:spPr>
+          <a:xfrm xmlns:a="http://schemas.openxmlformats.org/drawingml/2006/main">
+            <a:off x="3000375" y="4857750"/>
+            <a:ext cx="6572250" cy="476250"/>
           </a:xfrm>
           <a:prstGeom xmlns:a="http://schemas.openxmlformats.org/drawingml/2006/main" prst="rect">
             <a:avLst/>
@@ -8492,7 +8492,7 @@
           <a:bodyPr xmlns:a="http://schemas.openxmlformats.org/drawingml/2006/main" wrap="square" lIns="0" tIns="0" rIns="0" bIns="0" anchor="ctr"/>
           <a:lstStyle xmlns:a="http://schemas.openxmlformats.org/drawingml/2006/main">
             <a:defPPr algn="ctr">
-              <a:defRPr sz="2625" b="1">
+              <a:defRPr sz="2400" b="1">
                 <a:solidFill>
                   <a:srgbClr val="231F20"/>
                 </a:solidFill>
@@ -8504,7 +8504,7 @@
           </a:lstStyle>
           <a:p xmlns:a="http://schemas.openxmlformats.org/drawingml/2006/main">
             <a:pPr algn="ctr">
-              <a:defRPr sz="2625" b="1">
+              <a:defRPr sz="2400" b="1">
                 <a:solidFill>
                   <a:srgbClr val="231F20"/>
                 </a:solidFill>
@@ -8514,7 +8514,7 @@
               </a:defRPr>
             </a:pPr>
             <a:r>
-              <a:rPr sz="2625" b="1">
+              <a:rPr sz="2400" b="1">
                 <a:solidFill>
                   <a:srgbClr val="231F20"/>
                 </a:solidFill>
@@ -8523,6 +8523,72 @@
                 <a:cs typeface="Meiryo"/>
               </a:rPr>
               <a:t>一画面分の処理を繰り返す</a:t>
+            </a:r>
+          </a:p>
+        </p:txBody>
+      </p:sp>
+      <p:sp>
+        <p:nvSpPr>
+          <p:cNvPr id="25" name="text-103">
+            <a:extLst xmlns:a="http://schemas.openxmlformats.org/drawingml/2006/main">
+              <a:ext uri="{FF2B5EF4-FFF2-40B4-BE49-F238E27FC236}">
+                <a16:creationId xmlns:a16="http://schemas.microsoft.com/office/drawing/2014/main" id="{F344C147-27D7-4159-B44E-166BCCF6D947}"/>
+              </a:ext>
+            </a:extLst>
+          </p:cNvPr>
+          <p:cNvSpPr>
+            <a:spLocks xmlns:a="http://schemas.openxmlformats.org/drawingml/2006/main" noGrp="1"/>
+          </p:cNvSpPr>
+          <p:nvPr/>
+        </p:nvSpPr>
+        <p:spPr>
+          <a:xfrm xmlns:a="http://schemas.openxmlformats.org/drawingml/2006/main">
+            <a:off x="762000" y="5619750"/>
+            <a:ext cx="10668000" cy="523875"/>
+          </a:xfrm>
+          <a:prstGeom xmlns:a="http://schemas.openxmlformats.org/drawingml/2006/main" prst="rect">
+            <a:avLst/>
+          </a:prstGeom>
+          <a:noFill xmlns:a="http://schemas.openxmlformats.org/drawingml/2006/main"/>
+          <a:ln xmlns:a="http://schemas.openxmlformats.org/drawingml/2006/main" w="0">
+            <a:noFill/>
+          </a:ln>
+        </p:spPr>
+        <p:txBody>
+          <a:bodyPr xmlns:a="http://schemas.openxmlformats.org/drawingml/2006/main" wrap="square" lIns="0" tIns="0" rIns="0" bIns="0" anchor="ctr"/>
+          <a:lstStyle xmlns:a="http://schemas.openxmlformats.org/drawingml/2006/main">
+            <a:defPPr algn="ctr">
+              <a:defRPr sz="2250" b="0">
+                <a:solidFill>
+                  <a:srgbClr val="231F20"/>
+                </a:solidFill>
+                <a:latin typeface="Meiryo"/>
+                <a:ea typeface="Meiryo"/>
+                <a:cs typeface="Meiryo"/>
+              </a:defRPr>
+            </a:defPPr>
+          </a:lstStyle>
+          <a:p xmlns:a="http://schemas.openxmlformats.org/drawingml/2006/main">
+            <a:pPr algn="ctr">
+              <a:defRPr sz="2250" b="0">
+                <a:solidFill>
+                  <a:srgbClr val="231F20"/>
+                </a:solidFill>
+                <a:latin typeface="Meiryo"/>
+                <a:ea typeface="Meiryo"/>
+                <a:cs typeface="Meiryo"/>
+              </a:defRPr>
+            </a:pPr>
+            <a:r>
+              <a:rPr sz="2250" b="0">
+                <a:solidFill>
+                  <a:srgbClr val="231F20"/>
+                </a:solidFill>
+                <a:latin typeface="Meiryo"/>
+                <a:ea typeface="Meiryo"/>
+                <a:cs typeface="Meiryo"/>
+              </a:rPr>
+              <a:t>同じ設定の図形をまとめ、変わった部分だけ描き直す</a:t>
             </a:r>
           </a:p>
         </p:txBody>
@@ -8530,7 +8596,7 @@
     </p:spTree>
     <p:extLst>
       <p:ext uri="{BB962C8B-B14F-4D97-AF65-F5344CB8AC3E}">
-        <p14:creationId xmlns:p14="http://schemas.microsoft.com/office/powerpoint/2010/main" val="1932500792"/>
+        <p14:creationId xmlns:p14="http://schemas.microsoft.com/office/powerpoint/2010/main" val="29969453"/>
       </p:ext>
     </p:extLst>
   </p:cSld>
@@ -8558,10 +8624,10 @@
       </p:grpSpPr>
       <p:sp>
         <p:nvSpPr>
-          <p:cNvPr id="25" name="text-103">
-            <a:extLst xmlns:a="http://schemas.openxmlformats.org/drawingml/2006/main">
-              <a:ext uri="{FF2B5EF4-FFF2-40B4-BE49-F238E27FC236}">
-                <a16:creationId xmlns:a16="http://schemas.microsoft.com/office/drawing/2014/main" id="{64B53D4A-C8B3-49E4-BD64-DA49B197D7C3}"/>
+          <p:cNvPr id="25" name="text-104">
+            <a:extLst xmlns:a="http://schemas.openxmlformats.org/drawingml/2006/main">
+              <a:ext uri="{FF2B5EF4-FFF2-40B4-BE49-F238E27FC236}">
+                <a16:creationId xmlns:a16="http://schemas.microsoft.com/office/drawing/2014/main" id="{476E555F-0BEA-489C-A962-CAA8078AAAD8}"/>
               </a:ext>
             </a:extLst>
           </p:cNvPr>
@@ -8624,10 +8690,10 @@
       </p:sp>
       <p:sp>
         <p:nvSpPr>
-          <p:cNvPr id="2" name="text-104">
-            <a:extLst xmlns:a="http://schemas.openxmlformats.org/drawingml/2006/main">
-              <a:ext uri="{FF2B5EF4-FFF2-40B4-BE49-F238E27FC236}">
-                <a16:creationId xmlns:a16="http://schemas.microsoft.com/office/drawing/2014/main" id="{4BA752F1-B483-4896-A97B-20E4CCA63253}"/>
+          <p:cNvPr id="2" name="text-105">
+            <a:extLst xmlns:a="http://schemas.openxmlformats.org/drawingml/2006/main">
+              <a:ext uri="{FF2B5EF4-FFF2-40B4-BE49-F238E27FC236}">
+                <a16:creationId xmlns:a16="http://schemas.microsoft.com/office/drawing/2014/main" id="{1AEDB49A-7F71-4EE5-B7E6-A297E71DE80E}"/>
               </a:ext>
             </a:extLst>
           </p:cNvPr>
@@ -8690,10 +8756,10 @@
       </p:sp>
       <p:sp>
         <p:nvSpPr>
-          <p:cNvPr id="3" name="circuit-105">
-            <a:extLst xmlns:a="http://schemas.openxmlformats.org/drawingml/2006/main">
-              <a:ext uri="{FF2B5EF4-FFF2-40B4-BE49-F238E27FC236}">
-                <a16:creationId xmlns:a16="http://schemas.microsoft.com/office/drawing/2014/main" id="{54B44810-01BA-44DD-BFAB-24B9B722408C}"/>
+          <p:cNvPr id="3" name="circuit-106">
+            <a:extLst xmlns:a="http://schemas.openxmlformats.org/drawingml/2006/main">
+              <a:ext uri="{FF2B5EF4-FFF2-40B4-BE49-F238E27FC236}">
+                <a16:creationId xmlns:a16="http://schemas.microsoft.com/office/drawing/2014/main" id="{0B532AC3-CE17-42A9-A147-95308DE11325}"/>
               </a:ext>
             </a:extLst>
           </p:cNvPr>
@@ -8722,10 +8788,10 @@
       </p:sp>
       <p:sp>
         <p:nvSpPr>
-          <p:cNvPr id="4" name="text-106">
-            <a:extLst xmlns:a="http://schemas.openxmlformats.org/drawingml/2006/main">
-              <a:ext uri="{FF2B5EF4-FFF2-40B4-BE49-F238E27FC236}">
-                <a16:creationId xmlns:a16="http://schemas.microsoft.com/office/drawing/2014/main" id="{9BC477AD-6474-45E1-AA7E-EE4DA44FF24E}"/>
+          <p:cNvPr id="4" name="text-107">
+            <a:extLst xmlns:a="http://schemas.openxmlformats.org/drawingml/2006/main">
+              <a:ext uri="{FF2B5EF4-FFF2-40B4-BE49-F238E27FC236}">
+                <a16:creationId xmlns:a16="http://schemas.microsoft.com/office/drawing/2014/main" id="{B34A5BF8-AAF7-4A76-9E61-1DBC24D0264E}"/>
               </a:ext>
             </a:extLst>
           </p:cNvPr>
@@ -8811,10 +8877,10 @@
       </p:sp>
       <p:sp>
         <p:nvSpPr>
-          <p:cNvPr id="5" name="circuit-107">
-            <a:extLst xmlns:a="http://schemas.openxmlformats.org/drawingml/2006/main">
-              <a:ext uri="{FF2B5EF4-FFF2-40B4-BE49-F238E27FC236}">
-                <a16:creationId xmlns:a16="http://schemas.microsoft.com/office/drawing/2014/main" id="{1615FEDE-6994-4F12-9525-793BF403A479}"/>
+          <p:cNvPr id="5" name="circuit-108">
+            <a:extLst xmlns:a="http://schemas.openxmlformats.org/drawingml/2006/main">
+              <a:ext uri="{FF2B5EF4-FFF2-40B4-BE49-F238E27FC236}">
+                <a16:creationId xmlns:a16="http://schemas.microsoft.com/office/drawing/2014/main" id="{B7B18C24-702E-4410-8536-452AA5A3E772}"/>
               </a:ext>
             </a:extLst>
           </p:cNvPr>
@@ -8843,10 +8909,10 @@
       </p:sp>
       <p:sp>
         <p:nvSpPr>
-          <p:cNvPr id="6" name="text-108">
-            <a:extLst xmlns:a="http://schemas.openxmlformats.org/drawingml/2006/main">
-              <a:ext uri="{FF2B5EF4-FFF2-40B4-BE49-F238E27FC236}">
-                <a16:creationId xmlns:a16="http://schemas.microsoft.com/office/drawing/2014/main" id="{D9020E23-84DA-4B69-BDDC-22EC82EEBD61}"/>
+          <p:cNvPr id="6" name="text-109">
+            <a:extLst xmlns:a="http://schemas.openxmlformats.org/drawingml/2006/main">
+              <a:ext uri="{FF2B5EF4-FFF2-40B4-BE49-F238E27FC236}">
+                <a16:creationId xmlns:a16="http://schemas.microsoft.com/office/drawing/2014/main" id="{A0401B4B-6898-461A-933E-8F627354167A}"/>
               </a:ext>
             </a:extLst>
           </p:cNvPr>
@@ -8932,10 +8998,10 @@
       </p:sp>
       <p:sp>
         <p:nvSpPr>
-          <p:cNvPr id="7" name="circuit-109">
-            <a:extLst xmlns:a="http://schemas.openxmlformats.org/drawingml/2006/main">
-              <a:ext uri="{FF2B5EF4-FFF2-40B4-BE49-F238E27FC236}">
-                <a16:creationId xmlns:a16="http://schemas.microsoft.com/office/drawing/2014/main" id="{220EEFEF-D74B-448B-8CAB-3C03841FE362}"/>
+          <p:cNvPr id="7" name="circuit-110">
+            <a:extLst xmlns:a="http://schemas.openxmlformats.org/drawingml/2006/main">
+              <a:ext uri="{FF2B5EF4-FFF2-40B4-BE49-F238E27FC236}">
+                <a16:creationId xmlns:a16="http://schemas.microsoft.com/office/drawing/2014/main" id="{3698B3B7-84A8-4A34-8B2F-B790E6CF9D0C}"/>
               </a:ext>
             </a:extLst>
           </p:cNvPr>
@@ -8964,10 +9030,10 @@
       </p:sp>
       <p:sp>
         <p:nvSpPr>
-          <p:cNvPr id="8" name="text-110">
-            <a:extLst xmlns:a="http://schemas.openxmlformats.org/drawingml/2006/main">
-              <a:ext uri="{FF2B5EF4-FFF2-40B4-BE49-F238E27FC236}">
-                <a16:creationId xmlns:a16="http://schemas.microsoft.com/office/drawing/2014/main" id="{328AF419-8309-4C19-B2A5-2CA2676A8A3A}"/>
+          <p:cNvPr id="8" name="text-111">
+            <a:extLst xmlns:a="http://schemas.openxmlformats.org/drawingml/2006/main">
+              <a:ext uri="{FF2B5EF4-FFF2-40B4-BE49-F238E27FC236}">
+                <a16:creationId xmlns:a16="http://schemas.microsoft.com/office/drawing/2014/main" id="{8C672DB1-F1F5-419D-BB90-6BB29489DBA1}"/>
               </a:ext>
             </a:extLst>
           </p:cNvPr>
@@ -9053,10 +9119,10 @@
       </p:sp>
       <p:sp>
         <p:nvSpPr>
-          <p:cNvPr id="9" name="wire-111">
-            <a:extLst xmlns:a="http://schemas.openxmlformats.org/drawingml/2006/main">
-              <a:ext uri="{FF2B5EF4-FFF2-40B4-BE49-F238E27FC236}">
-                <a16:creationId xmlns:a16="http://schemas.microsoft.com/office/drawing/2014/main" id="{5358196E-5002-4D17-BBC9-6754D1343320}"/>
+          <p:cNvPr id="9" name="wire-112">
+            <a:extLst xmlns:a="http://schemas.openxmlformats.org/drawingml/2006/main">
+              <a:ext uri="{FF2B5EF4-FFF2-40B4-BE49-F238E27FC236}">
+                <a16:creationId xmlns:a16="http://schemas.microsoft.com/office/drawing/2014/main" id="{02DF3075-9355-4FB7-B17D-655352612D80}"/>
               </a:ext>
             </a:extLst>
           </p:cNvPr>
@@ -9092,10 +9158,10 @@
       </p:sp>
       <p:sp>
         <p:nvSpPr>
-          <p:cNvPr id="10" name="logic-112">
-            <a:extLst xmlns:a="http://schemas.openxmlformats.org/drawingml/2006/main">
-              <a:ext uri="{FF2B5EF4-FFF2-40B4-BE49-F238E27FC236}">
-                <a16:creationId xmlns:a16="http://schemas.microsoft.com/office/drawing/2014/main" id="{E936325C-9229-4A30-BEC8-BB8A7EB737E8}"/>
+          <p:cNvPr id="10" name="logic-113">
+            <a:extLst xmlns:a="http://schemas.openxmlformats.org/drawingml/2006/main">
+              <a:ext uri="{FF2B5EF4-FFF2-40B4-BE49-F238E27FC236}">
+                <a16:creationId xmlns:a16="http://schemas.microsoft.com/office/drawing/2014/main" id="{DB2C5989-AC1D-46C9-BFAC-1298650BCE6E}"/>
               </a:ext>
             </a:extLst>
           </p:cNvPr>
@@ -9137,10 +9203,10 @@
       </p:sp>
       <p:sp>
         <p:nvSpPr>
-          <p:cNvPr id="11" name="wire-113">
-            <a:extLst xmlns:a="http://schemas.openxmlformats.org/drawingml/2006/main">
-              <a:ext uri="{FF2B5EF4-FFF2-40B4-BE49-F238E27FC236}">
-                <a16:creationId xmlns:a16="http://schemas.microsoft.com/office/drawing/2014/main" id="{B882EE42-3827-47A9-BC07-901A3713B741}"/>
+          <p:cNvPr id="11" name="wire-114">
+            <a:extLst xmlns:a="http://schemas.openxmlformats.org/drawingml/2006/main">
+              <a:ext uri="{FF2B5EF4-FFF2-40B4-BE49-F238E27FC236}">
+                <a16:creationId xmlns:a16="http://schemas.microsoft.com/office/drawing/2014/main" id="{1E665D3A-2C95-4FFA-9FF8-FBFE7E07CB5B}"/>
               </a:ext>
             </a:extLst>
           </p:cNvPr>
@@ -9176,10 +9242,10 @@
       </p:sp>
       <p:sp>
         <p:nvSpPr>
-          <p:cNvPr id="12" name="logic-114">
-            <a:extLst xmlns:a="http://schemas.openxmlformats.org/drawingml/2006/main">
-              <a:ext uri="{FF2B5EF4-FFF2-40B4-BE49-F238E27FC236}">
-                <a16:creationId xmlns:a16="http://schemas.microsoft.com/office/drawing/2014/main" id="{783F4E23-6395-45CB-B7B8-EF221A7D778D}"/>
+          <p:cNvPr id="12" name="logic-115">
+            <a:extLst xmlns:a="http://schemas.openxmlformats.org/drawingml/2006/main">
+              <a:ext uri="{FF2B5EF4-FFF2-40B4-BE49-F238E27FC236}">
+                <a16:creationId xmlns:a16="http://schemas.microsoft.com/office/drawing/2014/main" id="{70BC985A-7D9C-47C8-89CD-541CDF41A725}"/>
               </a:ext>
             </a:extLst>
           </p:cNvPr>
@@ -9221,10 +9287,10 @@
       </p:sp>
       <p:sp>
         <p:nvSpPr>
-          <p:cNvPr id="13" name="text-115">
-            <a:extLst xmlns:a="http://schemas.openxmlformats.org/drawingml/2006/main">
-              <a:ext uri="{FF2B5EF4-FFF2-40B4-BE49-F238E27FC236}">
-                <a16:creationId xmlns:a16="http://schemas.microsoft.com/office/drawing/2014/main" id="{886F5FA2-F679-43C5-8DFB-64EF01952815}"/>
+          <p:cNvPr id="13" name="text-116">
+            <a:extLst xmlns:a="http://schemas.openxmlformats.org/drawingml/2006/main">
+              <a:ext uri="{FF2B5EF4-FFF2-40B4-BE49-F238E27FC236}">
+                <a16:creationId xmlns:a16="http://schemas.microsoft.com/office/drawing/2014/main" id="{139A4F99-336D-4EB1-A79F-EB14ED662599}"/>
               </a:ext>
             </a:extLst>
           </p:cNvPr>
@@ -9287,10 +9353,10 @@
       </p:sp>
       <p:sp>
         <p:nvSpPr>
-          <p:cNvPr id="14" name="text-116">
-            <a:extLst xmlns:a="http://schemas.openxmlformats.org/drawingml/2006/main">
-              <a:ext uri="{FF2B5EF4-FFF2-40B4-BE49-F238E27FC236}">
-                <a16:creationId xmlns:a16="http://schemas.microsoft.com/office/drawing/2014/main" id="{7A5FAC2A-BDC9-419D-AFE7-FC42AE1D0424}"/>
+          <p:cNvPr id="14" name="text-117">
+            <a:extLst xmlns:a="http://schemas.openxmlformats.org/drawingml/2006/main">
+              <a:ext uri="{FF2B5EF4-FFF2-40B4-BE49-F238E27FC236}">
+                <a16:creationId xmlns:a16="http://schemas.microsoft.com/office/drawing/2014/main" id="{A07574CF-9321-49A7-976A-2EB5582219DE}"/>
               </a:ext>
             </a:extLst>
           </p:cNvPr>
@@ -9353,10 +9419,10 @@
       </p:sp>
       <p:sp>
         <p:nvSpPr>
-          <p:cNvPr id="15" name="text-117">
-            <a:extLst xmlns:a="http://schemas.openxmlformats.org/drawingml/2006/main">
-              <a:ext uri="{FF2B5EF4-FFF2-40B4-BE49-F238E27FC236}">
-                <a16:creationId xmlns:a16="http://schemas.microsoft.com/office/drawing/2014/main" id="{1C8351F4-2D85-479A-8074-AA69F3BB96A5}"/>
+          <p:cNvPr id="15" name="text-118">
+            <a:extLst xmlns:a="http://schemas.openxmlformats.org/drawingml/2006/main">
+              <a:ext uri="{FF2B5EF4-FFF2-40B4-BE49-F238E27FC236}">
+                <a16:creationId xmlns:a16="http://schemas.microsoft.com/office/drawing/2014/main" id="{79B3EADF-D90A-4AA8-9C3C-FC75B07B7B11}"/>
               </a:ext>
             </a:extLst>
           </p:cNvPr>
@@ -9419,10 +9485,10 @@
       </p:sp>
       <p:sp>
         <p:nvSpPr>
-          <p:cNvPr id="16" name="circuit-118">
-            <a:extLst xmlns:a="http://schemas.openxmlformats.org/drawingml/2006/main">
-              <a:ext uri="{FF2B5EF4-FFF2-40B4-BE49-F238E27FC236}">
-                <a16:creationId xmlns:a16="http://schemas.microsoft.com/office/drawing/2014/main" id="{4593BDBE-E5D0-42C0-8D12-B8CC343AF700}"/>
+          <p:cNvPr id="16" name="circuit-119">
+            <a:extLst xmlns:a="http://schemas.openxmlformats.org/drawingml/2006/main">
+              <a:ext uri="{FF2B5EF4-FFF2-40B4-BE49-F238E27FC236}">
+                <a16:creationId xmlns:a16="http://schemas.microsoft.com/office/drawing/2014/main" id="{9D091537-FE85-433A-9E76-A41DAC4E8AA7}"/>
               </a:ext>
             </a:extLst>
           </p:cNvPr>
@@ -9451,10 +9517,10 @@
       </p:sp>
       <p:sp>
         <p:nvSpPr>
-          <p:cNvPr id="17" name="text-119">
-            <a:extLst xmlns:a="http://schemas.openxmlformats.org/drawingml/2006/main">
-              <a:ext uri="{FF2B5EF4-FFF2-40B4-BE49-F238E27FC236}">
-                <a16:creationId xmlns:a16="http://schemas.microsoft.com/office/drawing/2014/main" id="{76E1910A-944F-4579-A365-0FBF0337B8E0}"/>
+          <p:cNvPr id="17" name="text-120">
+            <a:extLst xmlns:a="http://schemas.openxmlformats.org/drawingml/2006/main">
+              <a:ext uri="{FF2B5EF4-FFF2-40B4-BE49-F238E27FC236}">
+                <a16:creationId xmlns:a16="http://schemas.microsoft.com/office/drawing/2014/main" id="{013D2C10-CA38-4480-B532-220039EC32DC}"/>
               </a:ext>
             </a:extLst>
           </p:cNvPr>
@@ -9517,10 +9583,10 @@
       </p:sp>
       <p:sp>
         <p:nvSpPr>
-          <p:cNvPr id="18" name="text-120">
-            <a:extLst xmlns:a="http://schemas.openxmlformats.org/drawingml/2006/main">
-              <a:ext uri="{FF2B5EF4-FFF2-40B4-BE49-F238E27FC236}">
-                <a16:creationId xmlns:a16="http://schemas.microsoft.com/office/drawing/2014/main" id="{AC3ABE6E-E25B-4A6C-B567-D7C085744C9D}"/>
+          <p:cNvPr id="18" name="text-121">
+            <a:extLst xmlns:a="http://schemas.openxmlformats.org/drawingml/2006/main">
+              <a:ext uri="{FF2B5EF4-FFF2-40B4-BE49-F238E27FC236}">
+                <a16:creationId xmlns:a16="http://schemas.microsoft.com/office/drawing/2014/main" id="{7F6A4D07-D058-461B-9BA4-E713CBE69DCE}"/>
               </a:ext>
             </a:extLst>
           </p:cNvPr>
@@ -9583,10 +9649,10 @@
       </p:sp>
       <p:sp>
         <p:nvSpPr>
-          <p:cNvPr id="19" name="circuit-121">
-            <a:extLst xmlns:a="http://schemas.openxmlformats.org/drawingml/2006/main">
-              <a:ext uri="{FF2B5EF4-FFF2-40B4-BE49-F238E27FC236}">
-                <a16:creationId xmlns:a16="http://schemas.microsoft.com/office/drawing/2014/main" id="{DDE88C74-BD66-482B-8E82-0A3E16241149}"/>
+          <p:cNvPr id="19" name="circuit-122">
+            <a:extLst xmlns:a="http://schemas.openxmlformats.org/drawingml/2006/main">
+              <a:ext uri="{FF2B5EF4-FFF2-40B4-BE49-F238E27FC236}">
+                <a16:creationId xmlns:a16="http://schemas.microsoft.com/office/drawing/2014/main" id="{B78D1FA6-8AB5-4A89-A5FF-C1CD01EA4406}"/>
               </a:ext>
             </a:extLst>
           </p:cNvPr>
@@ -9615,10 +9681,10 @@
       </p:sp>
       <p:sp>
         <p:nvSpPr>
-          <p:cNvPr id="20" name="text-122">
-            <a:extLst xmlns:a="http://schemas.openxmlformats.org/drawingml/2006/main">
-              <a:ext uri="{FF2B5EF4-FFF2-40B4-BE49-F238E27FC236}">
-                <a16:creationId xmlns:a16="http://schemas.microsoft.com/office/drawing/2014/main" id="{481A5D8A-5C40-4E66-8506-3214CE7F26FF}"/>
+          <p:cNvPr id="20" name="text-123">
+            <a:extLst xmlns:a="http://schemas.openxmlformats.org/drawingml/2006/main">
+              <a:ext uri="{FF2B5EF4-FFF2-40B4-BE49-F238E27FC236}">
+                <a16:creationId xmlns:a16="http://schemas.microsoft.com/office/drawing/2014/main" id="{314ADDAB-33DF-44ED-BBEC-675FD6E82C7C}"/>
               </a:ext>
             </a:extLst>
           </p:cNvPr>
@@ -9681,10 +9747,10 @@
       </p:sp>
       <p:sp>
         <p:nvSpPr>
-          <p:cNvPr id="21" name="text-123">
-            <a:extLst xmlns:a="http://schemas.openxmlformats.org/drawingml/2006/main">
-              <a:ext uri="{FF2B5EF4-FFF2-40B4-BE49-F238E27FC236}">
-                <a16:creationId xmlns:a16="http://schemas.microsoft.com/office/drawing/2014/main" id="{06538455-2B13-4917-BAFC-180E0914D6E6}"/>
+          <p:cNvPr id="21" name="text-124">
+            <a:extLst xmlns:a="http://schemas.openxmlformats.org/drawingml/2006/main">
+              <a:ext uri="{FF2B5EF4-FFF2-40B4-BE49-F238E27FC236}">
+                <a16:creationId xmlns:a16="http://schemas.microsoft.com/office/drawing/2014/main" id="{30D461AD-5C54-472C-9931-F51F94DD6425}"/>
               </a:ext>
             </a:extLst>
           </p:cNvPr>
@@ -9747,10 +9813,10 @@
       </p:sp>
       <p:sp>
         <p:nvSpPr>
-          <p:cNvPr id="22" name="circuit-124">
-            <a:extLst xmlns:a="http://schemas.openxmlformats.org/drawingml/2006/main">
-              <a:ext uri="{FF2B5EF4-FFF2-40B4-BE49-F238E27FC236}">
-                <a16:creationId xmlns:a16="http://schemas.microsoft.com/office/drawing/2014/main" id="{1FCD91DB-2A18-402F-95D4-BA1BAA0FF5A5}"/>
+          <p:cNvPr id="22" name="circuit-125">
+            <a:extLst xmlns:a="http://schemas.openxmlformats.org/drawingml/2006/main">
+              <a:ext uri="{FF2B5EF4-FFF2-40B4-BE49-F238E27FC236}">
+                <a16:creationId xmlns:a16="http://schemas.microsoft.com/office/drawing/2014/main" id="{C7177026-80A1-440E-9B76-ED85C0D095A4}"/>
               </a:ext>
             </a:extLst>
           </p:cNvPr>
@@ -9779,10 +9845,10 @@
       </p:sp>
       <p:sp>
         <p:nvSpPr>
-          <p:cNvPr id="23" name="text-125">
-            <a:extLst xmlns:a="http://schemas.openxmlformats.org/drawingml/2006/main">
-              <a:ext uri="{FF2B5EF4-FFF2-40B4-BE49-F238E27FC236}">
-                <a16:creationId xmlns:a16="http://schemas.microsoft.com/office/drawing/2014/main" id="{0AFF9AFC-2D99-4770-A0AD-E4FF4E852106}"/>
+          <p:cNvPr id="23" name="text-126">
+            <a:extLst xmlns:a="http://schemas.openxmlformats.org/drawingml/2006/main">
+              <a:ext uri="{FF2B5EF4-FFF2-40B4-BE49-F238E27FC236}">
+                <a16:creationId xmlns:a16="http://schemas.microsoft.com/office/drawing/2014/main" id="{64EE03B6-CD1B-44FD-94CD-5BBC3112A7CF}"/>
               </a:ext>
             </a:extLst>
           </p:cNvPr>
@@ -9845,10 +9911,10 @@
       </p:sp>
       <p:sp>
         <p:nvSpPr>
-          <p:cNvPr id="24" name="text-126">
-            <a:extLst xmlns:a="http://schemas.openxmlformats.org/drawingml/2006/main">
-              <a:ext uri="{FF2B5EF4-FFF2-40B4-BE49-F238E27FC236}">
-                <a16:creationId xmlns:a16="http://schemas.microsoft.com/office/drawing/2014/main" id="{FC2EB2D8-1A33-4297-9BCD-219D844FBA5D}"/>
+          <p:cNvPr id="24" name="text-127">
+            <a:extLst xmlns:a="http://schemas.openxmlformats.org/drawingml/2006/main">
+              <a:ext uri="{FF2B5EF4-FFF2-40B4-BE49-F238E27FC236}">
+                <a16:creationId xmlns:a16="http://schemas.microsoft.com/office/drawing/2014/main" id="{2A465313-E59B-44D7-B886-561C793B837C}"/>
               </a:ext>
             </a:extLst>
           </p:cNvPr>
@@ -9912,7 +9978,7 @@
     </p:spTree>
     <p:extLst>
       <p:ext uri="{BB962C8B-B14F-4D97-AF65-F5344CB8AC3E}">
-        <p14:creationId xmlns:p14="http://schemas.microsoft.com/office/powerpoint/2010/main" val="113074800"/>
+        <p14:creationId xmlns:p14="http://schemas.microsoft.com/office/powerpoint/2010/main" val="1464704116"/>
       </p:ext>
     </p:extLst>
   </p:cSld>
@@ -9940,10 +10006,10 @@
       </p:grpSpPr>
       <p:sp>
         <p:nvSpPr>
-          <p:cNvPr id="18" name="text-127">
-            <a:extLst xmlns:a="http://schemas.openxmlformats.org/drawingml/2006/main">
-              <a:ext uri="{FF2B5EF4-FFF2-40B4-BE49-F238E27FC236}">
-                <a16:creationId xmlns:a16="http://schemas.microsoft.com/office/drawing/2014/main" id="{2B264C6E-14CE-43D0-AA88-9A21A31B85B4}"/>
+          <p:cNvPr id="18" name="text-128">
+            <a:extLst xmlns:a="http://schemas.openxmlformats.org/drawingml/2006/main">
+              <a:ext uri="{FF2B5EF4-FFF2-40B4-BE49-F238E27FC236}">
+                <a16:creationId xmlns:a16="http://schemas.microsoft.com/office/drawing/2014/main" id="{53EB9674-7924-47C9-8896-0759E9AC0A06}"/>
               </a:ext>
             </a:extLst>
           </p:cNvPr>
@@ -10006,10 +10072,10 @@
       </p:sp>
       <p:sp>
         <p:nvSpPr>
-          <p:cNvPr id="2" name="text-128">
-            <a:extLst xmlns:a="http://schemas.openxmlformats.org/drawingml/2006/main">
-              <a:ext uri="{FF2B5EF4-FFF2-40B4-BE49-F238E27FC236}">
-                <a16:creationId xmlns:a16="http://schemas.microsoft.com/office/drawing/2014/main" id="{AF8C3280-0ED1-440D-A1AB-AC48C6AF535D}"/>
+          <p:cNvPr id="2" name="text-129">
+            <a:extLst xmlns:a="http://schemas.openxmlformats.org/drawingml/2006/main">
+              <a:ext uri="{FF2B5EF4-FFF2-40B4-BE49-F238E27FC236}">
+                <a16:creationId xmlns:a16="http://schemas.microsoft.com/office/drawing/2014/main" id="{6D9339F9-1ADE-404F-98C7-4EF87212FA9E}"/>
               </a:ext>
             </a:extLst>
           </p:cNvPr>
@@ -10072,10 +10138,10 @@
       </p:sp>
       <p:sp>
         <p:nvSpPr>
-          <p:cNvPr id="3" name="text-129">
-            <a:extLst xmlns:a="http://schemas.openxmlformats.org/drawingml/2006/main">
-              <a:ext uri="{FF2B5EF4-FFF2-40B4-BE49-F238E27FC236}">
-                <a16:creationId xmlns:a16="http://schemas.microsoft.com/office/drawing/2014/main" id="{76BE27FE-20A6-4557-B7AD-3C21D0DE134F}"/>
+          <p:cNvPr id="3" name="text-130">
+            <a:extLst xmlns:a="http://schemas.openxmlformats.org/drawingml/2006/main">
+              <a:ext uri="{FF2B5EF4-FFF2-40B4-BE49-F238E27FC236}">
+                <a16:creationId xmlns:a16="http://schemas.microsoft.com/office/drawing/2014/main" id="{9576D761-B315-48C2-B00C-618905F2BB0A}"/>
               </a:ext>
             </a:extLst>
           </p:cNvPr>
@@ -10138,10 +10204,10 @@
       </p:sp>
       <p:sp>
         <p:nvSpPr>
-          <p:cNvPr id="4" name="text-130">
-            <a:extLst xmlns:a="http://schemas.openxmlformats.org/drawingml/2006/main">
-              <a:ext uri="{FF2B5EF4-FFF2-40B4-BE49-F238E27FC236}">
-                <a16:creationId xmlns:a16="http://schemas.microsoft.com/office/drawing/2014/main" id="{16660255-B47D-4368-B6B8-AE6617363E99}"/>
+          <p:cNvPr id="4" name="text-131">
+            <a:extLst xmlns:a="http://schemas.openxmlformats.org/drawingml/2006/main">
+              <a:ext uri="{FF2B5EF4-FFF2-40B4-BE49-F238E27FC236}">
+                <a16:creationId xmlns:a16="http://schemas.microsoft.com/office/drawing/2014/main" id="{65B86BCF-8A27-4187-8D38-B4FAAF33DC08}"/>
               </a:ext>
             </a:extLst>
           </p:cNvPr>
@@ -10204,10 +10270,10 @@
       </p:sp>
       <p:sp>
         <p:nvSpPr>
-          <p:cNvPr id="5" name="circuit-131">
-            <a:extLst xmlns:a="http://schemas.openxmlformats.org/drawingml/2006/main">
-              <a:ext uri="{FF2B5EF4-FFF2-40B4-BE49-F238E27FC236}">
-                <a16:creationId xmlns:a16="http://schemas.microsoft.com/office/drawing/2014/main" id="{3AC916AB-7FA8-4271-9583-F8AC428393D4}"/>
+          <p:cNvPr id="5" name="circuit-132">
+            <a:extLst xmlns:a="http://schemas.openxmlformats.org/drawingml/2006/main">
+              <a:ext uri="{FF2B5EF4-FFF2-40B4-BE49-F238E27FC236}">
+                <a16:creationId xmlns:a16="http://schemas.microsoft.com/office/drawing/2014/main" id="{9E02BF4F-74F2-416D-8AF6-7DA84A10BDDC}"/>
               </a:ext>
             </a:extLst>
           </p:cNvPr>
@@ -10236,10 +10302,10 @@
       </p:sp>
       <p:sp>
         <p:nvSpPr>
-          <p:cNvPr id="6" name="text-132">
-            <a:extLst xmlns:a="http://schemas.openxmlformats.org/drawingml/2006/main">
-              <a:ext uri="{FF2B5EF4-FFF2-40B4-BE49-F238E27FC236}">
-                <a16:creationId xmlns:a16="http://schemas.microsoft.com/office/drawing/2014/main" id="{60E3379C-0A8B-4E96-95DE-335D66E4CEC2}"/>
+          <p:cNvPr id="6" name="text-133">
+            <a:extLst xmlns:a="http://schemas.openxmlformats.org/drawingml/2006/main">
+              <a:ext uri="{FF2B5EF4-FFF2-40B4-BE49-F238E27FC236}">
+                <a16:creationId xmlns:a16="http://schemas.microsoft.com/office/drawing/2014/main" id="{DAADE196-7872-4824-A14F-B0EB6E821C80}"/>
               </a:ext>
             </a:extLst>
           </p:cNvPr>
@@ -10302,10 +10368,10 @@
       </p:sp>
       <p:sp>
         <p:nvSpPr>
-          <p:cNvPr id="7" name="circuit-133">
-            <a:extLst xmlns:a="http://schemas.openxmlformats.org/drawingml/2006/main">
-              <a:ext uri="{FF2B5EF4-FFF2-40B4-BE49-F238E27FC236}">
-                <a16:creationId xmlns:a16="http://schemas.microsoft.com/office/drawing/2014/main" id="{A47BB1A0-40E3-491C-9DB9-16C7516938F5}"/>
+          <p:cNvPr id="7" name="circuit-134">
+            <a:extLst xmlns:a="http://schemas.openxmlformats.org/drawingml/2006/main">
+              <a:ext uri="{FF2B5EF4-FFF2-40B4-BE49-F238E27FC236}">
+                <a16:creationId xmlns:a16="http://schemas.microsoft.com/office/drawing/2014/main" id="{09B5032D-2CC3-4F00-B752-4E021294844E}"/>
               </a:ext>
             </a:extLst>
           </p:cNvPr>
@@ -10334,10 +10400,10 @@
       </p:sp>
       <p:sp>
         <p:nvSpPr>
-          <p:cNvPr id="8" name="text-134">
-            <a:extLst xmlns:a="http://schemas.openxmlformats.org/drawingml/2006/main">
-              <a:ext uri="{FF2B5EF4-FFF2-40B4-BE49-F238E27FC236}">
-                <a16:creationId xmlns:a16="http://schemas.microsoft.com/office/drawing/2014/main" id="{F4639679-0264-4CCE-81AC-2342CE9A93B0}"/>
+          <p:cNvPr id="8" name="text-135">
+            <a:extLst xmlns:a="http://schemas.openxmlformats.org/drawingml/2006/main">
+              <a:ext uri="{FF2B5EF4-FFF2-40B4-BE49-F238E27FC236}">
+                <a16:creationId xmlns:a16="http://schemas.microsoft.com/office/drawing/2014/main" id="{ACE97902-C858-4DC4-BB48-9018B286DBE7}"/>
               </a:ext>
             </a:extLst>
           </p:cNvPr>
@@ -10400,10 +10466,10 @@
       </p:sp>
       <p:sp>
         <p:nvSpPr>
-          <p:cNvPr id="9" name="circuit-135">
-            <a:extLst xmlns:a="http://schemas.openxmlformats.org/drawingml/2006/main">
-              <a:ext uri="{FF2B5EF4-FFF2-40B4-BE49-F238E27FC236}">
-                <a16:creationId xmlns:a16="http://schemas.microsoft.com/office/drawing/2014/main" id="{30ED2AF8-EE98-4EEF-BDFA-891C05E7CFBB}"/>
+          <p:cNvPr id="9" name="circuit-136">
+            <a:extLst xmlns:a="http://schemas.openxmlformats.org/drawingml/2006/main">
+              <a:ext uri="{FF2B5EF4-FFF2-40B4-BE49-F238E27FC236}">
+                <a16:creationId xmlns:a16="http://schemas.microsoft.com/office/drawing/2014/main" id="{4978ED78-C59A-4A1B-BB40-741DBD95C691}"/>
               </a:ext>
             </a:extLst>
           </p:cNvPr>
@@ -10432,10 +10498,10 @@
       </p:sp>
       <p:sp>
         <p:nvSpPr>
-          <p:cNvPr id="10" name="text-136">
-            <a:extLst xmlns:a="http://schemas.openxmlformats.org/drawingml/2006/main">
-              <a:ext uri="{FF2B5EF4-FFF2-40B4-BE49-F238E27FC236}">
-                <a16:creationId xmlns:a16="http://schemas.microsoft.com/office/drawing/2014/main" id="{7C8E7E10-7E16-4AB6-9486-E099EF3C4557}"/>
+          <p:cNvPr id="10" name="text-137">
+            <a:extLst xmlns:a="http://schemas.openxmlformats.org/drawingml/2006/main">
+              <a:ext uri="{FF2B5EF4-FFF2-40B4-BE49-F238E27FC236}">
+                <a16:creationId xmlns:a16="http://schemas.microsoft.com/office/drawing/2014/main" id="{0E69CBF7-B367-4CD9-A7D3-7145429CE5A1}"/>
               </a:ext>
             </a:extLst>
           </p:cNvPr>
@@ -10498,10 +10564,10 @@
       </p:sp>
       <p:sp>
         <p:nvSpPr>
-          <p:cNvPr id="11" name="circuit-137">
-            <a:extLst xmlns:a="http://schemas.openxmlformats.org/drawingml/2006/main">
-              <a:ext uri="{FF2B5EF4-FFF2-40B4-BE49-F238E27FC236}">
-                <a16:creationId xmlns:a16="http://schemas.microsoft.com/office/drawing/2014/main" id="{465B40A1-E320-4F9E-818D-9886D02749CA}"/>
+          <p:cNvPr id="11" name="circuit-138">
+            <a:extLst xmlns:a="http://schemas.openxmlformats.org/drawingml/2006/main">
+              <a:ext uri="{FF2B5EF4-FFF2-40B4-BE49-F238E27FC236}">
+                <a16:creationId xmlns:a16="http://schemas.microsoft.com/office/drawing/2014/main" id="{35518EFC-7351-4021-9B93-6C0F611B659C}"/>
               </a:ext>
             </a:extLst>
           </p:cNvPr>
@@ -10530,10 +10596,10 @@
       </p:sp>
       <p:sp>
         <p:nvSpPr>
-          <p:cNvPr id="12" name="text-138">
-            <a:extLst xmlns:a="http://schemas.openxmlformats.org/drawingml/2006/main">
-              <a:ext uri="{FF2B5EF4-FFF2-40B4-BE49-F238E27FC236}">
-                <a16:creationId xmlns:a16="http://schemas.microsoft.com/office/drawing/2014/main" id="{7167AC86-EB22-4051-9458-89B9D3E83472}"/>
+          <p:cNvPr id="12" name="text-139">
+            <a:extLst xmlns:a="http://schemas.openxmlformats.org/drawingml/2006/main">
+              <a:ext uri="{FF2B5EF4-FFF2-40B4-BE49-F238E27FC236}">
+                <a16:creationId xmlns:a16="http://schemas.microsoft.com/office/drawing/2014/main" id="{04A8987C-F8F7-44B6-B705-875D074156C5}"/>
               </a:ext>
             </a:extLst>
           </p:cNvPr>
@@ -10596,10 +10662,10 @@
       </p:sp>
       <p:sp>
         <p:nvSpPr>
-          <p:cNvPr id="13" name="wire-139">
-            <a:extLst xmlns:a="http://schemas.openxmlformats.org/drawingml/2006/main">
-              <a:ext uri="{FF2B5EF4-FFF2-40B4-BE49-F238E27FC236}">
-                <a16:creationId xmlns:a16="http://schemas.microsoft.com/office/drawing/2014/main" id="{27B1D47B-1BD3-4ECE-A903-BE913C11F4D6}"/>
+          <p:cNvPr id="13" name="wire-140">
+            <a:extLst xmlns:a="http://schemas.openxmlformats.org/drawingml/2006/main">
+              <a:ext uri="{FF2B5EF4-FFF2-40B4-BE49-F238E27FC236}">
+                <a16:creationId xmlns:a16="http://schemas.microsoft.com/office/drawing/2014/main" id="{E9FA8D79-7EA7-4109-9C2F-0B62FE9DC064}"/>
               </a:ext>
             </a:extLst>
           </p:cNvPr>
@@ -10635,10 +10701,10 @@
       </p:sp>
       <p:sp>
         <p:nvSpPr>
-          <p:cNvPr id="14" name="logic-140">
-            <a:extLst xmlns:a="http://schemas.openxmlformats.org/drawingml/2006/main">
-              <a:ext uri="{FF2B5EF4-FFF2-40B4-BE49-F238E27FC236}">
-                <a16:creationId xmlns:a16="http://schemas.microsoft.com/office/drawing/2014/main" id="{C2DF47B6-49E3-458E-9203-0EE57056A358}"/>
+          <p:cNvPr id="14" name="logic-141">
+            <a:extLst xmlns:a="http://schemas.openxmlformats.org/drawingml/2006/main">
+              <a:ext uri="{FF2B5EF4-FFF2-40B4-BE49-F238E27FC236}">
+                <a16:creationId xmlns:a16="http://schemas.microsoft.com/office/drawing/2014/main" id="{FCAD6AED-57C6-4F44-BCC2-641A877BCF4A}"/>
               </a:ext>
             </a:extLst>
           </p:cNvPr>
@@ -10680,10 +10746,10 @@
       </p:sp>
       <p:sp>
         <p:nvSpPr>
-          <p:cNvPr id="15" name="text-141">
-            <a:extLst xmlns:a="http://schemas.openxmlformats.org/drawingml/2006/main">
-              <a:ext uri="{FF2B5EF4-FFF2-40B4-BE49-F238E27FC236}">
-                <a16:creationId xmlns:a16="http://schemas.microsoft.com/office/drawing/2014/main" id="{1C9B722F-9825-4BFA-8DE4-6E67306DD4E8}"/>
+          <p:cNvPr id="15" name="text-142">
+            <a:extLst xmlns:a="http://schemas.openxmlformats.org/drawingml/2006/main">
+              <a:ext uri="{FF2B5EF4-FFF2-40B4-BE49-F238E27FC236}">
+                <a16:creationId xmlns:a16="http://schemas.microsoft.com/office/drawing/2014/main" id="{87C3AFEC-0A5D-4F09-89EC-12A2C031B843}"/>
               </a:ext>
             </a:extLst>
           </p:cNvPr>
@@ -10769,10 +10835,10 @@
       </p:sp>
       <p:sp>
         <p:nvSpPr>
-          <p:cNvPr id="16" name="text-142">
-            <a:extLst xmlns:a="http://schemas.openxmlformats.org/drawingml/2006/main">
-              <a:ext uri="{FF2B5EF4-FFF2-40B4-BE49-F238E27FC236}">
-                <a16:creationId xmlns:a16="http://schemas.microsoft.com/office/drawing/2014/main" id="{8E91415B-EB85-44E0-9A38-339522005093}"/>
+          <p:cNvPr id="16" name="text-143">
+            <a:extLst xmlns:a="http://schemas.openxmlformats.org/drawingml/2006/main">
+              <a:ext uri="{FF2B5EF4-FFF2-40B4-BE49-F238E27FC236}">
+                <a16:creationId xmlns:a16="http://schemas.microsoft.com/office/drawing/2014/main" id="{5D882871-2B15-461A-8ABB-35A9B7E5392D}"/>
               </a:ext>
             </a:extLst>
           </p:cNvPr>
@@ -10858,10 +10924,10 @@
       </p:sp>
       <p:sp>
         <p:nvSpPr>
-          <p:cNvPr id="17" name="text-143">
-            <a:extLst xmlns:a="http://schemas.openxmlformats.org/drawingml/2006/main">
-              <a:ext uri="{FF2B5EF4-FFF2-40B4-BE49-F238E27FC236}">
-                <a16:creationId xmlns:a16="http://schemas.microsoft.com/office/drawing/2014/main" id="{D55B682B-2F5D-4B15-A5F4-2C906BB5FDBD}"/>
+          <p:cNvPr id="17" name="text-144">
+            <a:extLst xmlns:a="http://schemas.openxmlformats.org/drawingml/2006/main">
+              <a:ext uri="{FF2B5EF4-FFF2-40B4-BE49-F238E27FC236}">
+                <a16:creationId xmlns:a16="http://schemas.microsoft.com/office/drawing/2014/main" id="{E035ECBC-0006-4E77-8ED1-3CD3DC57EAF2}"/>
               </a:ext>
             </a:extLst>
           </p:cNvPr>
@@ -10925,7 +10991,7 @@
     </p:spTree>
     <p:extLst>
       <p:ext uri="{BB962C8B-B14F-4D97-AF65-F5344CB8AC3E}">
-        <p14:creationId xmlns:p14="http://schemas.microsoft.com/office/powerpoint/2010/main" val="983790237"/>
+        <p14:creationId xmlns:p14="http://schemas.microsoft.com/office/powerpoint/2010/main" val="242002097"/>
       </p:ext>
     </p:extLst>
   </p:cSld>
@@ -10953,10 +11019,10 @@
       </p:grpSpPr>
       <p:sp>
         <p:nvSpPr>
-          <p:cNvPr id="8" name="text-144">
-            <a:extLst xmlns:a="http://schemas.openxmlformats.org/drawingml/2006/main">
-              <a:ext uri="{FF2B5EF4-FFF2-40B4-BE49-F238E27FC236}">
-                <a16:creationId xmlns:a16="http://schemas.microsoft.com/office/drawing/2014/main" id="{512D92DA-54A7-489D-BBEF-EAC77FBD3B26}"/>
+          <p:cNvPr id="8" name="text-145">
+            <a:extLst xmlns:a="http://schemas.openxmlformats.org/drawingml/2006/main">
+              <a:ext uri="{FF2B5EF4-FFF2-40B4-BE49-F238E27FC236}">
+                <a16:creationId xmlns:a16="http://schemas.microsoft.com/office/drawing/2014/main" id="{25132563-2EF5-408C-9019-90F97990A184}"/>
               </a:ext>
             </a:extLst>
           </p:cNvPr>
@@ -11019,10 +11085,10 @@
       </p:sp>
       <p:sp>
         <p:nvSpPr>
-          <p:cNvPr id="2" name="text-145">
-            <a:extLst xmlns:a="http://schemas.openxmlformats.org/drawingml/2006/main">
-              <a:ext uri="{FF2B5EF4-FFF2-40B4-BE49-F238E27FC236}">
-                <a16:creationId xmlns:a16="http://schemas.microsoft.com/office/drawing/2014/main" id="{73596BF5-B0D2-45B3-B89E-E3B05F53EE2E}"/>
+          <p:cNvPr id="2" name="text-146">
+            <a:extLst xmlns:a="http://schemas.openxmlformats.org/drawingml/2006/main">
+              <a:ext uri="{FF2B5EF4-FFF2-40B4-BE49-F238E27FC236}">
+                <a16:creationId xmlns:a16="http://schemas.microsoft.com/office/drawing/2014/main" id="{25C6EB79-990A-4539-AE18-4858FC88DFB3}"/>
               </a:ext>
             </a:extLst>
           </p:cNvPr>
@@ -11088,7 +11154,7 @@
           <p:cNvPr id="3" name="">
             <a:extLst xmlns:a="http://schemas.openxmlformats.org/drawingml/2006/main">
               <a:ext uri="{FF2B5EF4-FFF2-40B4-BE49-F238E27FC236}">
-                <a16:creationId xmlns:a16="http://schemas.microsoft.com/office/drawing/2014/main" id="{B2647DC9-79BF-45C2-A4A4-DFF6CC196031}"/>
+                <a16:creationId xmlns:a16="http://schemas.microsoft.com/office/drawing/2014/main" id="{AB02E750-0328-43A1-8439-094721D2BCE5}"/>
               </a:ext>
             </a:extLst>
           </p:cNvPr>
@@ -11098,7 +11164,7 @@
           <p:nvPr/>
         </p:nvPicPr>
         <p:blipFill>
-          <a:blip xmlns:r="http://schemas.openxmlformats.org/officeDocument/2006/relationships" xmlns:a="http://schemas.openxmlformats.org/drawingml/2006/main" r:embed="R53ff83d16a15471f"/>
+          <a:blip xmlns:r="http://schemas.openxmlformats.org/officeDocument/2006/relationships" xmlns:a="http://schemas.openxmlformats.org/drawingml/2006/main" r:embed="R8d83fa87adb74853"/>
           <a:stretch xmlns:a="http://schemas.openxmlformats.org/drawingml/2006/main"/>
         </p:blipFill>
         <p:spPr>
@@ -11113,10 +11179,10 @@
       </p:pic>
       <p:sp>
         <p:nvSpPr>
-          <p:cNvPr id="4" name="text-146">
-            <a:extLst xmlns:a="http://schemas.openxmlformats.org/drawingml/2006/main">
-              <a:ext uri="{FF2B5EF4-FFF2-40B4-BE49-F238E27FC236}">
-                <a16:creationId xmlns:a16="http://schemas.microsoft.com/office/drawing/2014/main" id="{3D1A6C4F-0129-427A-A8BD-0C7B897778F8}"/>
+          <p:cNvPr id="4" name="text-147">
+            <a:extLst xmlns:a="http://schemas.openxmlformats.org/drawingml/2006/main">
+              <a:ext uri="{FF2B5EF4-FFF2-40B4-BE49-F238E27FC236}">
+                <a16:creationId xmlns:a16="http://schemas.microsoft.com/office/drawing/2014/main" id="{0F54C650-7DD8-40A7-A4A4-264E452E937D}"/>
               </a:ext>
             </a:extLst>
           </p:cNvPr>
@@ -11202,10 +11268,10 @@
       </p:sp>
       <p:sp>
         <p:nvSpPr>
-          <p:cNvPr id="5" name="text-147">
-            <a:extLst xmlns:a="http://schemas.openxmlformats.org/drawingml/2006/main">
-              <a:ext uri="{FF2B5EF4-FFF2-40B4-BE49-F238E27FC236}">
-                <a16:creationId xmlns:a16="http://schemas.microsoft.com/office/drawing/2014/main" id="{8544C9F9-886D-410A-BCD1-ECA565F254D5}"/>
+          <p:cNvPr id="5" name="text-148">
+            <a:extLst xmlns:a="http://schemas.openxmlformats.org/drawingml/2006/main">
+              <a:ext uri="{FF2B5EF4-FFF2-40B4-BE49-F238E27FC236}">
+                <a16:creationId xmlns:a16="http://schemas.microsoft.com/office/drawing/2014/main" id="{8919EB1B-4B7C-4719-A699-840B76F36281}"/>
               </a:ext>
             </a:extLst>
           </p:cNvPr>
@@ -11291,22 +11357,111 @@
       </p:sp>
       <p:sp>
         <p:nvSpPr>
-          <p:cNvPr id="6" name="text-148">
-            <a:extLst xmlns:a="http://schemas.openxmlformats.org/drawingml/2006/main">
-              <a:ext uri="{FF2B5EF4-FFF2-40B4-BE49-F238E27FC236}">
-                <a16:creationId xmlns:a16="http://schemas.microsoft.com/office/drawing/2014/main" id="{EAABCC15-D665-49A1-9337-68BFA8755B5C}"/>
-              </a:ext>
-            </a:extLst>
-          </p:cNvPr>
-          <p:cNvSpPr>
-            <a:spLocks xmlns:a="http://schemas.openxmlformats.org/drawingml/2006/main" noGrp="1"/>
-          </p:cNvSpPr>
-          <p:nvPr/>
-        </p:nvSpPr>
-        <p:spPr>
-          <a:xfrm xmlns:a="http://schemas.openxmlformats.org/drawingml/2006/main">
-            <a:off x="7277100" y="4991100"/>
-            <a:ext cx="4238625" cy="666750"/>
+          <p:cNvPr id="6" name="text-149">
+            <a:extLst xmlns:a="http://schemas.openxmlformats.org/drawingml/2006/main">
+              <a:ext uri="{FF2B5EF4-FFF2-40B4-BE49-F238E27FC236}">
+                <a16:creationId xmlns:a16="http://schemas.microsoft.com/office/drawing/2014/main" id="{7F464D15-F10B-4422-95B5-5E74385CED7E}"/>
+              </a:ext>
+            </a:extLst>
+          </p:cNvPr>
+          <p:cNvSpPr>
+            <a:spLocks xmlns:a="http://schemas.openxmlformats.org/drawingml/2006/main" noGrp="1"/>
+          </p:cNvSpPr>
+          <p:nvPr/>
+        </p:nvSpPr>
+        <p:spPr>
+          <a:xfrm xmlns:a="http://schemas.openxmlformats.org/drawingml/2006/main">
+            <a:off x="7277100" y="4857750"/>
+            <a:ext cx="4238625" cy="857250"/>
+          </a:xfrm>
+          <a:prstGeom xmlns:a="http://schemas.openxmlformats.org/drawingml/2006/main" prst="rect">
+            <a:avLst/>
+          </a:prstGeom>
+          <a:noFill xmlns:a="http://schemas.openxmlformats.org/drawingml/2006/main"/>
+          <a:ln xmlns:a="http://schemas.openxmlformats.org/drawingml/2006/main" w="0">
+            <a:noFill/>
+          </a:ln>
+        </p:spPr>
+        <p:txBody>
+          <a:bodyPr xmlns:a="http://schemas.openxmlformats.org/drawingml/2006/main" wrap="square" lIns="0" tIns="0" rIns="0" bIns="0" anchor="ctr"/>
+          <a:lstStyle xmlns:a="http://schemas.openxmlformats.org/drawingml/2006/main">
+            <a:defPPr algn="l">
+              <a:defRPr sz="1950" b="0">
+                <a:solidFill>
+                  <a:srgbClr val="231F20"/>
+                </a:solidFill>
+                <a:latin typeface="Meiryo"/>
+                <a:ea typeface="Meiryo"/>
+                <a:cs typeface="Meiryo"/>
+              </a:defRPr>
+            </a:defPPr>
+          </a:lstStyle>
+          <a:p xmlns:a="http://schemas.openxmlformats.org/drawingml/2006/main">
+            <a:pPr algn="l">
+              <a:defRPr sz="1950" b="0">
+                <a:solidFill>
+                  <a:srgbClr val="231F20"/>
+                </a:solidFill>
+                <a:latin typeface="Meiryo"/>
+                <a:ea typeface="Meiryo"/>
+                <a:cs typeface="Meiryo"/>
+              </a:defRPr>
+            </a:pPr>
+            <a:r>
+              <a:rPr sz="1950" b="0">
+                <a:solidFill>
+                  <a:srgbClr val="231F20"/>
+                </a:solidFill>
+                <a:latin typeface="Meiryo"/>
+                <a:ea typeface="Meiryo"/>
+                <a:cs typeface="Meiryo"/>
+              </a:rPr>
+              <a:t>専用コントローラーは</a:t>
+            </a:r>
+          </a:p>
+          <a:p xmlns:a="http://schemas.openxmlformats.org/drawingml/2006/main">
+            <a:pPr algn="l">
+              <a:defRPr sz="1950" b="0">
+                <a:solidFill>
+                  <a:srgbClr val="231F20"/>
+                </a:solidFill>
+                <a:latin typeface="Meiryo"/>
+                <a:ea typeface="Meiryo"/>
+                <a:cs typeface="Meiryo"/>
+              </a:defRPr>
+            </a:pPr>
+            <a:r>
+              <a:rPr sz="1950" b="0">
+                <a:solidFill>
+                  <a:srgbClr val="231F20"/>
+                </a:solidFill>
+                <a:latin typeface="Meiryo"/>
+                <a:ea typeface="Meiryo"/>
+                <a:cs typeface="Meiryo"/>
+              </a:rPr>
+              <a:t>最終発表に向けて接続・検証</a:t>
+            </a:r>
+          </a:p>
+        </p:txBody>
+      </p:sp>
+      <p:sp>
+        <p:nvSpPr>
+          <p:cNvPr id="7" name="text-150">
+            <a:extLst xmlns:a="http://schemas.openxmlformats.org/drawingml/2006/main">
+              <a:ext uri="{FF2B5EF4-FFF2-40B4-BE49-F238E27FC236}">
+                <a16:creationId xmlns:a16="http://schemas.microsoft.com/office/drawing/2014/main" id="{031564CA-CCAC-47B3-8B30-5007414359AF}"/>
+              </a:ext>
+            </a:extLst>
+          </p:cNvPr>
+          <p:cNvSpPr>
+            <a:spLocks xmlns:a="http://schemas.openxmlformats.org/drawingml/2006/main" noGrp="1"/>
+          </p:cNvSpPr>
+          <p:nvPr/>
+        </p:nvSpPr>
+        <p:spPr>
+          <a:xfrm xmlns:a="http://schemas.openxmlformats.org/drawingml/2006/main">
+            <a:off x="685800" y="5962650"/>
+            <a:ext cx="10858500" cy="381000"/>
           </a:xfrm>
           <a:prstGeom xmlns:a="http://schemas.openxmlformats.org/drawingml/2006/main" prst="rect">
             <a:avLst/>
@@ -11350,72 +11505,6 @@
                 <a:ea typeface="Meiryo"/>
                 <a:cs typeface="Meiryo"/>
               </a:rPr>
-              <a:t>専用コントローラーは未検証</a:t>
-            </a:r>
-          </a:p>
-        </p:txBody>
-      </p:sp>
-      <p:sp>
-        <p:nvSpPr>
-          <p:cNvPr id="7" name="text-149">
-            <a:extLst xmlns:a="http://schemas.openxmlformats.org/drawingml/2006/main">
-              <a:ext uri="{FF2B5EF4-FFF2-40B4-BE49-F238E27FC236}">
-                <a16:creationId xmlns:a16="http://schemas.microsoft.com/office/drawing/2014/main" id="{47DE5E71-094F-4103-B4AB-7CF104259CB9}"/>
-              </a:ext>
-            </a:extLst>
-          </p:cNvPr>
-          <p:cNvSpPr>
-            <a:spLocks xmlns:a="http://schemas.openxmlformats.org/drawingml/2006/main" noGrp="1"/>
-          </p:cNvSpPr>
-          <p:nvPr/>
-        </p:nvSpPr>
-        <p:spPr>
-          <a:xfrm xmlns:a="http://schemas.openxmlformats.org/drawingml/2006/main">
-            <a:off x="685800" y="5962650"/>
-            <a:ext cx="10858500" cy="381000"/>
-          </a:xfrm>
-          <a:prstGeom xmlns:a="http://schemas.openxmlformats.org/drawingml/2006/main" prst="rect">
-            <a:avLst/>
-          </a:prstGeom>
-          <a:noFill xmlns:a="http://schemas.openxmlformats.org/drawingml/2006/main"/>
-          <a:ln xmlns:a="http://schemas.openxmlformats.org/drawingml/2006/main" w="0">
-            <a:noFill/>
-          </a:ln>
-        </p:spPr>
-        <p:txBody>
-          <a:bodyPr xmlns:a="http://schemas.openxmlformats.org/drawingml/2006/main" wrap="square" lIns="0" tIns="0" rIns="0" bIns="0" anchor="ctr"/>
-          <a:lstStyle xmlns:a="http://schemas.openxmlformats.org/drawingml/2006/main">
-            <a:defPPr algn="l">
-              <a:defRPr sz="1875" b="0">
-                <a:solidFill>
-                  <a:srgbClr val="231F20"/>
-                </a:solidFill>
-                <a:latin typeface="Meiryo"/>
-                <a:ea typeface="Meiryo"/>
-                <a:cs typeface="Meiryo"/>
-              </a:defRPr>
-            </a:defPPr>
-          </a:lstStyle>
-          <a:p xmlns:a="http://schemas.openxmlformats.org/drawingml/2006/main">
-            <a:pPr algn="l">
-              <a:defRPr sz="1875" b="0">
-                <a:solidFill>
-                  <a:srgbClr val="231F20"/>
-                </a:solidFill>
-                <a:latin typeface="Meiryo"/>
-                <a:ea typeface="Meiryo"/>
-                <a:cs typeface="Meiryo"/>
-              </a:defRPr>
-            </a:pPr>
-            <a:r>
-              <a:rPr sz="1875" b="0">
-                <a:solidFill>
-                  <a:srgbClr val="231F20"/>
-                </a:solidFill>
-                <a:latin typeface="Meiryo"/>
-                <a:ea typeface="Meiryo"/>
-                <a:cs typeface="Meiryo"/>
-              </a:rPr>
               <a:t>大きいテクスチャと、映像認識には未解決の条件がある</a:t>
             </a:r>
           </a:p>
@@ -11424,7 +11513,7 @@
     </p:spTree>
     <p:extLst>
       <p:ext uri="{BB962C8B-B14F-4D97-AF65-F5344CB8AC3E}">
-        <p14:creationId xmlns:p14="http://schemas.microsoft.com/office/powerpoint/2010/main" val="671413031"/>
+        <p14:creationId xmlns:p14="http://schemas.microsoft.com/office/powerpoint/2010/main" val="2091064138"/>
       </p:ext>
     </p:extLst>
   </p:cSld>
@@ -11452,10 +11541,10 @@
       </p:grpSpPr>
       <p:sp>
         <p:nvSpPr>
-          <p:cNvPr id="6" name="text-150">
-            <a:extLst xmlns:a="http://schemas.openxmlformats.org/drawingml/2006/main">
-              <a:ext uri="{FF2B5EF4-FFF2-40B4-BE49-F238E27FC236}">
-                <a16:creationId xmlns:a16="http://schemas.microsoft.com/office/drawing/2014/main" id="{E841561C-DF42-44B6-8C5D-AA5637FC847B}"/>
+          <p:cNvPr id="7" name="text-151">
+            <a:extLst xmlns:a="http://schemas.openxmlformats.org/drawingml/2006/main">
+              <a:ext uri="{FF2B5EF4-FFF2-40B4-BE49-F238E27FC236}">
+                <a16:creationId xmlns:a16="http://schemas.microsoft.com/office/drawing/2014/main" id="{A26B0A78-5355-4B2D-99F0-835C968BF305}"/>
               </a:ext>
             </a:extLst>
           </p:cNvPr>
@@ -11518,10 +11607,10 @@
       </p:sp>
       <p:sp>
         <p:nvSpPr>
-          <p:cNvPr id="2" name="text-151">
-            <a:extLst xmlns:a="http://schemas.openxmlformats.org/drawingml/2006/main">
-              <a:ext uri="{FF2B5EF4-FFF2-40B4-BE49-F238E27FC236}">
-                <a16:creationId xmlns:a16="http://schemas.microsoft.com/office/drawing/2014/main" id="{C801EC04-523D-4211-B682-9E8E52BF379F}"/>
+          <p:cNvPr id="2" name="text-152">
+            <a:extLst xmlns:a="http://schemas.openxmlformats.org/drawingml/2006/main">
+              <a:ext uri="{FF2B5EF4-FFF2-40B4-BE49-F238E27FC236}">
+                <a16:creationId xmlns:a16="http://schemas.microsoft.com/office/drawing/2014/main" id="{D6212C4E-ABF4-43EF-8024-CC2AA7422BBB}"/>
               </a:ext>
             </a:extLst>
           </p:cNvPr>
@@ -11584,21 +11673,21 @@
       </p:sp>
       <p:sp>
         <p:nvSpPr>
-          <p:cNvPr id="3" name="text-152">
-            <a:extLst xmlns:a="http://schemas.openxmlformats.org/drawingml/2006/main">
-              <a:ext uri="{FF2B5EF4-FFF2-40B4-BE49-F238E27FC236}">
-                <a16:creationId xmlns:a16="http://schemas.microsoft.com/office/drawing/2014/main" id="{BBE17EA1-CADC-48EC-B327-ACE98461881F}"/>
-              </a:ext>
-            </a:extLst>
-          </p:cNvPr>
-          <p:cNvSpPr>
-            <a:spLocks xmlns:a="http://schemas.openxmlformats.org/drawingml/2006/main" noGrp="1"/>
-          </p:cNvSpPr>
-          <p:nvPr/>
-        </p:nvSpPr>
-        <p:spPr>
-          <a:xfrm xmlns:a="http://schemas.openxmlformats.org/drawingml/2006/main">
-            <a:off x="857250" y="1819275"/>
+          <p:cNvPr id="3" name="text-153">
+            <a:extLst xmlns:a="http://schemas.openxmlformats.org/drawingml/2006/main">
+              <a:ext uri="{FF2B5EF4-FFF2-40B4-BE49-F238E27FC236}">
+                <a16:creationId xmlns:a16="http://schemas.microsoft.com/office/drawing/2014/main" id="{EBB85C79-3862-45FE-B64C-B883BAC1555C}"/>
+              </a:ext>
+            </a:extLst>
+          </p:cNvPr>
+          <p:cNvSpPr>
+            <a:spLocks xmlns:a="http://schemas.openxmlformats.org/drawingml/2006/main" noGrp="1"/>
+          </p:cNvSpPr>
+          <p:nvPr/>
+        </p:nvSpPr>
+        <p:spPr>
+          <a:xfrm xmlns:a="http://schemas.openxmlformats.org/drawingml/2006/main">
+            <a:off x="857250" y="1466850"/>
             <a:ext cx="10287000" cy="1209675"/>
           </a:xfrm>
           <a:prstGeom xmlns:a="http://schemas.openxmlformats.org/drawingml/2006/main" prst="rect">
@@ -11673,22 +11762,22 @@
       </p:sp>
       <p:sp>
         <p:nvSpPr>
-          <p:cNvPr id="4" name="text-153">
-            <a:extLst xmlns:a="http://schemas.openxmlformats.org/drawingml/2006/main">
-              <a:ext uri="{FF2B5EF4-FFF2-40B4-BE49-F238E27FC236}">
-                <a16:creationId xmlns:a16="http://schemas.microsoft.com/office/drawing/2014/main" id="{1DB65841-4CA2-43F6-8B37-DB5768EA47A4}"/>
-              </a:ext>
-            </a:extLst>
-          </p:cNvPr>
-          <p:cNvSpPr>
-            <a:spLocks xmlns:a="http://schemas.openxmlformats.org/drawingml/2006/main" noGrp="1"/>
-          </p:cNvSpPr>
-          <p:nvPr/>
-        </p:nvSpPr>
-        <p:spPr>
-          <a:xfrm xmlns:a="http://schemas.openxmlformats.org/drawingml/2006/main">
-            <a:off x="857250" y="3581400"/>
-            <a:ext cx="10287000" cy="666750"/>
+          <p:cNvPr id="4" name="text-154">
+            <a:extLst xmlns:a="http://schemas.openxmlformats.org/drawingml/2006/main">
+              <a:ext uri="{FF2B5EF4-FFF2-40B4-BE49-F238E27FC236}">
+                <a16:creationId xmlns:a16="http://schemas.microsoft.com/office/drawing/2014/main" id="{32A8F631-C182-431A-A170-9ECF8204C42F}"/>
+              </a:ext>
+            </a:extLst>
+          </p:cNvPr>
+          <p:cNvSpPr>
+            <a:spLocks xmlns:a="http://schemas.openxmlformats.org/drawingml/2006/main" noGrp="1"/>
+          </p:cNvSpPr>
+          <p:nvPr/>
+        </p:nvSpPr>
+        <p:spPr>
+          <a:xfrm xmlns:a="http://schemas.openxmlformats.org/drawingml/2006/main">
+            <a:off x="857250" y="2990850"/>
+            <a:ext cx="10287000" cy="857250"/>
           </a:xfrm>
           <a:prstGeom xmlns:a="http://schemas.openxmlformats.org/drawingml/2006/main" prst="rect">
             <a:avLst/>
@@ -11702,7 +11791,7 @@
           <a:bodyPr xmlns:a="http://schemas.openxmlformats.org/drawingml/2006/main" wrap="square" lIns="0" tIns="0" rIns="0" bIns="0" anchor="ctr"/>
           <a:lstStyle xmlns:a="http://schemas.openxmlformats.org/drawingml/2006/main">
             <a:defPPr algn="l">
-              <a:defRPr sz="2400" b="0">
+              <a:defRPr sz="2100" b="0">
                 <a:solidFill>
                   <a:srgbClr val="231F20"/>
                 </a:solidFill>
@@ -11714,7 +11803,7 @@
           </a:lstStyle>
           <a:p xmlns:a="http://schemas.openxmlformats.org/drawingml/2006/main">
             <a:pPr algn="l">
-              <a:defRPr sz="2400" b="0">
+              <a:defRPr sz="2100" b="0">
                 <a:solidFill>
                   <a:srgbClr val="231F20"/>
                 </a:solidFill>
@@ -11724,7 +11813,7 @@
               </a:defRPr>
             </a:pPr>
             <a:r>
-              <a:rPr sz="2400" b="0">
+              <a:rPr sz="2100" b="0">
                 <a:solidFill>
                   <a:srgbClr val="231F20"/>
                 </a:solidFill>
@@ -11732,29 +11821,52 @@
                 <a:ea typeface="Meiryo"/>
                 <a:cs typeface="Meiryo"/>
               </a:rPr>
-              <a:t>接続の選び方を、実機での比較から説明した</a:t>
+              <a:t>試したゲーム条件では、転送回路の追加や</a:t>
+            </a:r>
+          </a:p>
+          <a:p xmlns:a="http://schemas.openxmlformats.org/drawingml/2006/main">
+            <a:pPr algn="l">
+              <a:defRPr sz="2100" b="0">
+                <a:solidFill>
+                  <a:srgbClr val="231F20"/>
+                </a:solidFill>
+                <a:latin typeface="Meiryo"/>
+                <a:ea typeface="Meiryo"/>
+                <a:cs typeface="Meiryo"/>
+              </a:defRPr>
+            </a:pPr>
+            <a:r>
+              <a:rPr sz="2100" b="0">
+                <a:solidFill>
+                  <a:srgbClr val="231F20"/>
+                </a:solidFill>
+                <a:latin typeface="Meiryo"/>
+                <a:ea typeface="Meiryo"/>
+                <a:cs typeface="Meiryo"/>
+              </a:rPr>
+              <a:t>描画用メモリの増量だけでは、大きく速くならなかった</a:t>
             </a:r>
           </a:p>
         </p:txBody>
       </p:sp>
       <p:sp>
         <p:nvSpPr>
-          <p:cNvPr id="5" name="text-154">
-            <a:extLst xmlns:a="http://schemas.openxmlformats.org/drawingml/2006/main">
-              <a:ext uri="{FF2B5EF4-FFF2-40B4-BE49-F238E27FC236}">
-                <a16:creationId xmlns:a16="http://schemas.microsoft.com/office/drawing/2014/main" id="{8EB100C6-269F-4515-AC8F-9FE22AB24BAA}"/>
-              </a:ext>
-            </a:extLst>
-          </p:cNvPr>
-          <p:cNvSpPr>
-            <a:spLocks xmlns:a="http://schemas.openxmlformats.org/drawingml/2006/main" noGrp="1"/>
-          </p:cNvSpPr>
-          <p:nvPr/>
-        </p:nvSpPr>
-        <p:spPr>
-          <a:xfrm xmlns:a="http://schemas.openxmlformats.org/drawingml/2006/main">
-            <a:off x="857250" y="4724400"/>
-            <a:ext cx="10287000" cy="1104900"/>
+          <p:cNvPr id="5" name="text-155">
+            <a:extLst xmlns:a="http://schemas.openxmlformats.org/drawingml/2006/main">
+              <a:ext uri="{FF2B5EF4-FFF2-40B4-BE49-F238E27FC236}">
+                <a16:creationId xmlns:a16="http://schemas.microsoft.com/office/drawing/2014/main" id="{009912A1-A61A-462E-91BB-447C2FA7E304}"/>
+              </a:ext>
+            </a:extLst>
+          </p:cNvPr>
+          <p:cNvSpPr>
+            <a:spLocks xmlns:a="http://schemas.openxmlformats.org/drawingml/2006/main" noGrp="1"/>
+          </p:cNvSpPr>
+          <p:nvPr/>
+        </p:nvSpPr>
+        <p:spPr>
+          <a:xfrm xmlns:a="http://schemas.openxmlformats.org/drawingml/2006/main">
+            <a:off x="857250" y="4191000"/>
+            <a:ext cx="10287000" cy="523875"/>
           </a:xfrm>
           <a:prstGeom xmlns:a="http://schemas.openxmlformats.org/drawingml/2006/main" prst="rect">
             <a:avLst/>
@@ -11798,12 +11910,55 @@
                 <a:ea typeface="Meiryo"/>
                 <a:cs typeface="Meiryo"/>
               </a:rPr>
-              <a:t>公開するもの</a:t>
-            </a:r>
-          </a:p>
+              <a:t>接続設計・ソースコード・試験条件を公開</a:t>
+            </a:r>
+          </a:p>
+        </p:txBody>
+      </p:sp>
+      <p:sp>
+        <p:nvSpPr>
+          <p:cNvPr id="6" name="text-156">
+            <a:extLst xmlns:a="http://schemas.openxmlformats.org/drawingml/2006/main">
+              <a:ext uri="{FF2B5EF4-FFF2-40B4-BE49-F238E27FC236}">
+                <a16:creationId xmlns:a16="http://schemas.microsoft.com/office/drawing/2014/main" id="{2AF675EE-D333-400A-9DF2-5AD95A1314E1}"/>
+              </a:ext>
+            </a:extLst>
+          </p:cNvPr>
+          <p:cNvSpPr>
+            <a:spLocks xmlns:a="http://schemas.openxmlformats.org/drawingml/2006/main" noGrp="1"/>
+          </p:cNvSpPr>
+          <p:nvPr/>
+        </p:nvSpPr>
+        <p:spPr>
+          <a:xfrm xmlns:a="http://schemas.openxmlformats.org/drawingml/2006/main">
+            <a:off x="857250" y="5095875"/>
+            <a:ext cx="10287000" cy="1000125"/>
+          </a:xfrm>
+          <a:prstGeom xmlns:a="http://schemas.openxmlformats.org/drawingml/2006/main" prst="rect">
+            <a:avLst/>
+          </a:prstGeom>
+          <a:noFill xmlns:a="http://schemas.openxmlformats.org/drawingml/2006/main"/>
+          <a:ln xmlns:a="http://schemas.openxmlformats.org/drawingml/2006/main" w="0">
+            <a:noFill/>
+          </a:ln>
+        </p:spPr>
+        <p:txBody>
+          <a:bodyPr xmlns:a="http://schemas.openxmlformats.org/drawingml/2006/main" wrap="square" lIns="0" tIns="0" rIns="0" bIns="0" anchor="ctr"/>
+          <a:lstStyle xmlns:a="http://schemas.openxmlformats.org/drawingml/2006/main">
+            <a:defPPr algn="l">
+              <a:defRPr sz="2325" b="1">
+                <a:solidFill>
+                  <a:srgbClr val="231F20"/>
+                </a:solidFill>
+                <a:latin typeface="Meiryo"/>
+                <a:ea typeface="Meiryo"/>
+                <a:cs typeface="Meiryo"/>
+              </a:defRPr>
+            </a:defPPr>
+          </a:lstStyle>
           <a:p xmlns:a="http://schemas.openxmlformats.org/drawingml/2006/main">
             <a:pPr algn="l">
-              <a:defRPr sz="2250" b="0">
+              <a:defRPr sz="2325" b="1">
                 <a:solidFill>
                   <a:srgbClr val="231F20"/>
                 </a:solidFill>
@@ -11813,7 +11968,7 @@
               </a:defRPr>
             </a:pPr>
             <a:r>
-              <a:rPr sz="2250" b="0">
+              <a:rPr sz="2325" b="1">
                 <a:solidFill>
                   <a:srgbClr val="231F20"/>
                 </a:solidFill>
@@ -11821,7 +11976,30 @@
                 <a:ea typeface="Meiryo"/>
                 <a:cs typeface="Meiryo"/>
               </a:rPr>
-              <a:t>接続設計・ソースコード・試験条件</a:t>
+              <a:t>最終発表：専用コントローラーを接続し、</a:t>
+            </a:r>
+          </a:p>
+          <a:p xmlns:a="http://schemas.openxmlformats.org/drawingml/2006/main">
+            <a:pPr algn="l">
+              <a:defRPr sz="2325" b="1">
+                <a:solidFill>
+                  <a:srgbClr val="231F20"/>
+                </a:solidFill>
+                <a:latin typeface="Meiryo"/>
+                <a:ea typeface="Meiryo"/>
+                <a:cs typeface="Meiryo"/>
+              </a:defRPr>
+            </a:pPr>
+            <a:r>
+              <a:rPr sz="2325" b="1">
+                <a:solidFill>
+                  <a:srgbClr val="231F20"/>
+                </a:solidFill>
+                <a:latin typeface="Meiryo"/>
+                <a:ea typeface="Meiryo"/>
+                <a:cs typeface="Meiryo"/>
+              </a:rPr>
+              <a:t>ボタンによるゲーム操作を検証する</a:t>
             </a:r>
           </a:p>
         </p:txBody>
@@ -11829,7 +12007,7 @@
     </p:spTree>
     <p:extLst>
       <p:ext uri="{BB962C8B-B14F-4D97-AF65-F5344CB8AC3E}">
-        <p14:creationId xmlns:p14="http://schemas.microsoft.com/office/powerpoint/2010/main" val="1228957111"/>
+        <p14:creationId xmlns:p14="http://schemas.microsoft.com/office/powerpoint/2010/main" val="288111047"/>
       </p:ext>
     </p:extLst>
   </p:cSld>

</xml_diff>

<commit_message>
Refocus research documents on console integration
Move OpenGL batching and partial redraw, Nexys Video board adaptation,
and DVI aspect-ratio details into the technical appendix while preserving
their figures and measurements.

Align the thesis, abstract, and slides around connection design and
validation, use full-frame results for connection comparisons, and update
cross-references and generated documents. Expand explanatory figures and
keep the publication manifest synchronized.
</commit_message>
<xml_diff>
--- a/docs/presentation/中間発表_主要事項.pptx
+++ b/docs/presentation/中間発表_主要事項.pptx
@@ -2,20 +2,20 @@
 <file path=ppt/presentation.xml><?xml version="1.0" encoding="utf-8"?>
 <p:presentation xmlns:p="http://schemas.openxmlformats.org/presentationml/2006/main">
   <p:sldMasterIdLst>
-    <p:sldMasterId xmlns:r="http://schemas.openxmlformats.org/officeDocument/2006/relationships" id="2147483648" r:id="R0f78d91987ab4744"/>
+    <p:sldMasterId xmlns:r="http://schemas.openxmlformats.org/officeDocument/2006/relationships" id="2147483648" r:id="Rbbbd8343724444ca"/>
   </p:sldMasterIdLst>
   <p:notesMasterIdLst>
-    <p:notesMasterId xmlns:r="http://schemas.openxmlformats.org/officeDocument/2006/relationships" r:id="R67701b03eedd4467"/>
+    <p:notesMasterId xmlns:r="http://schemas.openxmlformats.org/officeDocument/2006/relationships" r:id="R53c7ecb896324d68"/>
   </p:notesMasterIdLst>
   <p:sldIdLst>
-    <p:sldId xmlns:r="http://schemas.openxmlformats.org/officeDocument/2006/relationships" id="256" r:id="R020f4b782dd04e1a"/>
-    <p:sldId xmlns:r="http://schemas.openxmlformats.org/officeDocument/2006/relationships" id="257" r:id="R0627dc9ff8ae4302"/>
-    <p:sldId xmlns:r="http://schemas.openxmlformats.org/officeDocument/2006/relationships" id="258" r:id="Ra5a425279f104e87"/>
-    <p:sldId xmlns:r="http://schemas.openxmlformats.org/officeDocument/2006/relationships" id="259" r:id="R595ca7e1e5084d8d"/>
-    <p:sldId xmlns:r="http://schemas.openxmlformats.org/officeDocument/2006/relationships" id="260" r:id="Re3db1ff116264378"/>
-    <p:sldId xmlns:r="http://schemas.openxmlformats.org/officeDocument/2006/relationships" id="261" r:id="Rb0fb2395a48b4620"/>
-    <p:sldId xmlns:r="http://schemas.openxmlformats.org/officeDocument/2006/relationships" id="262" r:id="Rbf49a971e98b4c90"/>
-    <p:sldId xmlns:r="http://schemas.openxmlformats.org/officeDocument/2006/relationships" id="263" r:id="Rfb1e42385d6e4eba"/>
+    <p:sldId xmlns:r="http://schemas.openxmlformats.org/officeDocument/2006/relationships" id="256" r:id="Rb81c84c157484b26"/>
+    <p:sldId xmlns:r="http://schemas.openxmlformats.org/officeDocument/2006/relationships" id="257" r:id="R8690009005f8488d"/>
+    <p:sldId xmlns:r="http://schemas.openxmlformats.org/officeDocument/2006/relationships" id="258" r:id="R46f95abbd8a342c1"/>
+    <p:sldId xmlns:r="http://schemas.openxmlformats.org/officeDocument/2006/relationships" id="259" r:id="R45371b4c6213432d"/>
+    <p:sldId xmlns:r="http://schemas.openxmlformats.org/officeDocument/2006/relationships" id="260" r:id="Rf1375968163047df"/>
+    <p:sldId xmlns:r="http://schemas.openxmlformats.org/officeDocument/2006/relationships" id="261" r:id="R25cf43d1084e48bb"/>
+    <p:sldId xmlns:r="http://schemas.openxmlformats.org/officeDocument/2006/relationships" id="262" r:id="R0c701d26f9074388"/>
+    <p:sldId xmlns:r="http://schemas.openxmlformats.org/officeDocument/2006/relationships" id="263" r:id="R4367e6d753bd4631"/>
   </p:sldIdLst>
   <p:sldSz cx="12192000" cy="6858000"/>
   <p:notesSz cx="6858000" cy="9144000"/>
@@ -464,7 +464,7 @@
           </a:p>
           <a:p xmlns:a="http://schemas.openxmlformats.org/drawingml/2006/main">
             <a:r>
-              <a:t>根拠：docs/thesis/本文.md 第6〜11章、第13章、第16章。実験記録 E6、E7。製品 https://github.com/SoshiroFujimori/wally-game-console/tree/261832d48832dd6e26c4971ab8893ce61200688b 。</a:t>
+              <a:t>根拠：docs/thesis/本文.md 第5〜10章、第12章、第15章。実験記録 E6、E7。製品 https://github.com/SoshiroFujimori/wally-game-console/tree/261832d48832dd6e26c4971ab8893ce61200688b 。</a:t>
             </a:r>
           </a:p>
         </p:txBody>
@@ -549,7 +549,7 @@
           </a:p>
           <a:p xmlns:a="http://schemas.openxmlformats.org/drawingml/2006/main">
             <a:r>
-              <a:t>根拠：docs/thesis/本文.md 第6〜11章、第13章、第16章。実験記録 E6、E7。製品 https://github.com/SoshiroFujimori/wally-game-console/tree/261832d48832dd6e26c4971ab8893ce61200688b 。</a:t>
+              <a:t>根拠：docs/thesis/本文.md 第5〜10章、第12章、第15章。実験記録 E6、E7。製品 https://github.com/SoshiroFujimori/wally-game-console/tree/261832d48832dd6e26c4971ab8893ce61200688b 。</a:t>
             </a:r>
           </a:p>
         </p:txBody>
@@ -634,7 +634,7 @@
           </a:p>
           <a:p xmlns:a="http://schemas.openxmlformats.org/drawingml/2006/main">
             <a:r>
-              <a:t>根拠：docs/thesis/本文.md 第6〜11章、第13章、第16章。実験記録 E6、E7。製品 https://github.com/SoshiroFujimori/wally-game-console/tree/261832d48832dd6e26c4971ab8893ce61200688b 。</a:t>
+              <a:t>根拠：docs/thesis/本文.md 第5〜10章、第12章、第15章。実験記録 E6、E7。製品 https://github.com/SoshiroFujimori/wally-game-console/tree/261832d48832dd6e26c4971ab8893ce61200688b 。</a:t>
             </a:r>
           </a:p>
         </p:txBody>
@@ -714,12 +714,12 @@
           </a:p>
           <a:p xmlns:a="http://schemas.openxmlformats.org/drawingml/2006/main">
             <a:r>
-              <a:t>CPUはSDカードから読み込んだゲームを実行します。一回の処理でボールの位置を更新し、位置や色を描画命令にしてメモリへ置きます。接続回路から命令を受けたRasterIXが画像を作り、表示回路が読み出します。これを繰り返すと動いて見えます。計測ではCPUの命令準備が大きな負担でした。そこで、同じ設定の図形をまとめ、変わった部分だけを描き直すようにしました。</a:t>
-            </a:r>
-          </a:p>
-          <a:p xmlns:a="http://schemas.openxmlformats.org/drawingml/2006/main">
-            <a:r>
-              <a:t>根拠：docs/thesis/本文.md 第6〜11章、第13章、第16章。実験記録 E6、E7。製品 https://github.com/SoshiroFujimori/wally-game-console/tree/261832d48832dd6e26c4971ab8893ce61200688b 。</a:t>
+              <a:t>CPUはSDカードから読み込んだゲームを実行します。一回の処理でボールの位置を更新し、位置や色を描画命令にしてメモリへ置きます。接続回路から命令を受けたRasterIXが画像を作り、表示回路が読み出します。これを繰り返すと動いて見えます。位置の数値、描画命令、画素の色は別々のデータです。命令を送る接続と、できた画像を表示する接続を、それぞれ用意しました。</a:t>
+            </a:r>
+          </a:p>
+          <a:p xmlns:a="http://schemas.openxmlformats.org/drawingml/2006/main">
+            <a:r>
+              <a:t>根拠：docs/thesis/本文.md 第5〜10章、第12章、第15章。実験記録 E6、E7。製品 https://github.com/SoshiroFujimori/wally-game-console/tree/261832d48832dd6e26c4971ab8893ce61200688b 。</a:t>
             </a:r>
           </a:p>
         </p:txBody>
@@ -804,7 +804,7 @@
           </a:p>
           <a:p xmlns:a="http://schemas.openxmlformats.org/drawingml/2006/main">
             <a:r>
-              <a:t>根拠：E6、第13.10〜13.13節。1語方式は4相ハンドシェイク。初期状態、全体描画、180フレームを3回、各試行平均の中央値。CPU 20 MHz、RasterIX 100 MHz。</a:t>
+              <a:t>根拠：E6、第12.5〜12.8節。1語方式は4相ハンドシェイク。初期状態、全体描画、180フレームを3回、各試行平均の中央値。CPU 20 MHz、RasterIX 100 MHz。</a:t>
             </a:r>
           </a:p>
         </p:txBody>
@@ -889,7 +889,7 @@
           </a:p>
           <a:p xmlns:a="http://schemas.openxmlformats.org/drawingml/2006/main">
             <a:r>
-              <a:t>根拠：docs/thesis/本文.md 第6〜11章、第13章、第16章。実験記録 E6、E7。製品 https://github.com/SoshiroFujimori/wally-game-console/tree/261832d48832dd6e26c4971ab8893ce61200688b 。</a:t>
+              <a:t>根拠：docs/thesis/本文.md 第5〜10章、第12章、第15章。実験記録 E6、E7。製品 https://github.com/SoshiroFujimori/wally-game-console/tree/261832d48832dd6e26c4971ab8893ce61200688b 。</a:t>
             </a:r>
           </a:p>
         </p:txBody>
@@ -969,12 +969,12 @@
           </a:p>
           <a:p xmlns:a="http://schemas.openxmlformats.org/drawingml/2006/main">
             <a:r>
-              <a:t>640×480画素で、通常版の5分間の自動プレイと、別に30秒の実機映像を確認しました。接続を比較した三方式では、選んだ27条件の最終画像が全画素で期待画像と一致しました。すべての途中画像まで確認したわけではありません。大きなテクスチャの描画と映像認識には未解決の条件が残っています。専用コントローラーは今回の成果に含めず、最終発表に向けて接続と操作を検証します。</a:t>
-            </a:r>
-          </a:p>
-          <a:p xmlns:a="http://schemas.openxmlformats.org/drawingml/2006/main">
-            <a:r>
-              <a:t>根拠：E6、第13.11節と13.15〜13.16節。画像：docs/thesis/figs/fifo-study-game.png。</a:t>
+              <a:t>640×480画素で、通常版の5分間の自動プレイと、別に30秒の実機映像を確認しました。接続を比較した三方式では、毎回全体を描く条件にそろえ、三つの開始状態の計9枚で、最終画像が全画素で期待画像と一致しました。すべての途中画像まで確認したわけではありません。大きなテクスチャの描画と映像認識には未解決の条件が残っています。専用コントローラーは今回の成果に含めず、最終発表に向けて接続と操作を検証します。</a:t>
+            </a:r>
+          </a:p>
+          <a:p xmlns:a="http://schemas.openxmlformats.org/drawingml/2006/main">
+            <a:r>
+              <a:t>根拠：E6、第12.6節と12.10〜12.11節。通常ゲームの連続動作と、全体描画にそろえた接続比較は別の実行条件。画像：docs/thesis/figs/fifo-study-game.png。</a:t>
             </a:r>
           </a:p>
         </p:txBody>
@@ -1054,12 +1054,12 @@
           </a:p>
           <a:p xmlns:a="http://schemas.openxmlformats.org/drawingml/2006/main">
             <a:r>
-              <a:t>Wallyへ描画・表示機能を追加し、二次元ゲームを動かす接続設計を示しました。命令を専用回路で転送する方式と、描画用メモリを増やす方式も実機で比較しました。試した条件では、前者はコピー処理を含めると速くならず、後者の改善も小さい結果でした。設計と試験条件を公開し、学習者が同様の拡張を検討するための参照例とします。最終発表では、専用コントローラーを接続し、ボタンによるゲーム操作を検証します。</a:t>
-            </a:r>
-          </a:p>
-          <a:p xmlns:a="http://schemas.openxmlformats.org/drawingml/2006/main">
-            <a:r>
-              <a:t>根拠：docs/thesis/本文.md 第6〜11章、第13章、第16章。実験記録 E6、E7。製品 https://github.com/SoshiroFujimori/wally-game-console/tree/261832d48832dd6e26c4971ab8893ce61200688b 。</a:t>
+              <a:t>Wallyへ描画・表示機能を追加し、二次元ゲームを動かす接続設計を示しました。命令を専用回路で転送する方式と、描画用メモリを増やす方式も実機で比較しました。毎回全体を描く条件では、前者はコピー処理を含めると速くならず、後者の改善も小さい結果でした。設計と試験条件を公開し、学習者が同様の拡張を検討するための参照例とします。最終発表では、専用コントローラーを接続し、ボタンによるゲーム操作を検証します。</a:t>
+            </a:r>
+          </a:p>
+          <a:p xmlns:a="http://schemas.openxmlformats.org/drawingml/2006/main">
+            <a:r>
+              <a:t>根拠：docs/thesis/本文.md 第5〜10章、第12章、第15章。実験記録 E6、E7。製品 https://github.com/SoshiroFujimori/wally-game-console/tree/261832d48832dd6e26c4971ab8893ce61200688b 。</a:t>
             </a:r>
           </a:p>
         </p:txBody>
@@ -1106,7 +1106,7 @@
           <p:cNvPr id="3" name="Title">
             <a:extLst xmlns:a="http://schemas.openxmlformats.org/drawingml/2006/main">
               <a:ext uri="{FF2B5EF4-FFF2-40B4-BE49-F238E27FC236}">
-                <a16:creationId xmlns:a16="http://schemas.microsoft.com/office/drawing/2014/main" id="{B4C62657-22C4-4594-BEF0-8453C76EA30F}"/>
+                <a16:creationId xmlns:a16="http://schemas.microsoft.com/office/drawing/2014/main" id="{85478C9D-7077-4ED9-A713-08D529C86678}"/>
               </a:ext>
             </a:extLst>
           </p:cNvPr>
@@ -1263,7 +1263,7 @@
           <p:cNvPr id="2" name="Subtitle">
             <a:extLst xmlns:a="http://schemas.openxmlformats.org/drawingml/2006/main">
               <a:ext uri="{FF2B5EF4-FFF2-40B4-BE49-F238E27FC236}">
-                <a16:creationId xmlns:a16="http://schemas.microsoft.com/office/drawing/2014/main" id="{DE774234-3A9B-444D-91A5-FC5C6B6289ED}"/>
+                <a16:creationId xmlns:a16="http://schemas.microsoft.com/office/drawing/2014/main" id="{0B137804-5F12-4D23-A236-7ADEB0F59005}"/>
               </a:ext>
             </a:extLst>
           </p:cNvPr>
@@ -1437,7 +1437,7 @@
           <p:cNvPr id="2" name="Section title">
             <a:extLst xmlns:a="http://schemas.openxmlformats.org/drawingml/2006/main">
               <a:ext uri="{FF2B5EF4-FFF2-40B4-BE49-F238E27FC236}">
-                <a16:creationId xmlns:a16="http://schemas.microsoft.com/office/drawing/2014/main" id="{AB6749E0-95DA-4EC3-877D-432CC94BCB62}"/>
+                <a16:creationId xmlns:a16="http://schemas.microsoft.com/office/drawing/2014/main" id="{160F1A9E-7A03-4EE0-BD13-18B9AD931014}"/>
               </a:ext>
             </a:extLst>
           </p:cNvPr>
@@ -1611,7 +1611,7 @@
           <p:cNvPr id="3" name="Title">
             <a:extLst xmlns:a="http://schemas.openxmlformats.org/drawingml/2006/main">
               <a:ext uri="{FF2B5EF4-FFF2-40B4-BE49-F238E27FC236}">
-                <a16:creationId xmlns:a16="http://schemas.microsoft.com/office/drawing/2014/main" id="{9399E3C0-3116-49BE-B28C-D8B17C174AF9}"/>
+                <a16:creationId xmlns:a16="http://schemas.microsoft.com/office/drawing/2014/main" id="{636ED216-0B17-45D2-B89A-DF4594C7F1AD}"/>
               </a:ext>
             </a:extLst>
           </p:cNvPr>
@@ -1768,7 +1768,7 @@
           <p:cNvPr id="2" name="Body">
             <a:extLst xmlns:a="http://schemas.openxmlformats.org/drawingml/2006/main">
               <a:ext uri="{FF2B5EF4-FFF2-40B4-BE49-F238E27FC236}">
-                <a16:creationId xmlns:a16="http://schemas.microsoft.com/office/drawing/2014/main" id="{16D73D6E-5551-46AE-8583-2D6A93A261ED}"/>
+                <a16:creationId xmlns:a16="http://schemas.microsoft.com/office/drawing/2014/main" id="{4E6B4EAC-87B2-4630-8CD6-FEC5672911A2}"/>
               </a:ext>
             </a:extLst>
           </p:cNvPr>
@@ -1942,7 +1942,7 @@
           <p:cNvPr id="4" name="Title">
             <a:extLst xmlns:a="http://schemas.openxmlformats.org/drawingml/2006/main">
               <a:ext uri="{FF2B5EF4-FFF2-40B4-BE49-F238E27FC236}">
-                <a16:creationId xmlns:a16="http://schemas.microsoft.com/office/drawing/2014/main" id="{26CFC281-07C0-445A-9916-147D6CD3C3D0}"/>
+                <a16:creationId xmlns:a16="http://schemas.microsoft.com/office/drawing/2014/main" id="{C9456E3E-642E-43CC-A054-AA032FBC4DDB}"/>
               </a:ext>
             </a:extLst>
           </p:cNvPr>
@@ -2099,7 +2099,7 @@
           <p:cNvPr id="2" name="Left column">
             <a:extLst xmlns:a="http://schemas.openxmlformats.org/drawingml/2006/main">
               <a:ext uri="{FF2B5EF4-FFF2-40B4-BE49-F238E27FC236}">
-                <a16:creationId xmlns:a16="http://schemas.microsoft.com/office/drawing/2014/main" id="{C28266EF-2A34-4BFC-BD3E-D7C8CE43CCCC}"/>
+                <a16:creationId xmlns:a16="http://schemas.microsoft.com/office/drawing/2014/main" id="{C4019A6F-6A78-4CB8-8706-7A253C418DED}"/>
               </a:ext>
             </a:extLst>
           </p:cNvPr>
@@ -2256,7 +2256,7 @@
           <p:cNvPr id="3" name="Right column">
             <a:extLst xmlns:a="http://schemas.openxmlformats.org/drawingml/2006/main">
               <a:ext uri="{FF2B5EF4-FFF2-40B4-BE49-F238E27FC236}">
-                <a16:creationId xmlns:a16="http://schemas.microsoft.com/office/drawing/2014/main" id="{82B16F02-8AD4-4C53-A6D1-60B90DF4D735}"/>
+                <a16:creationId xmlns:a16="http://schemas.microsoft.com/office/drawing/2014/main" id="{A5AC4197-C4C5-401A-86B4-2A0211F00AF0}"/>
               </a:ext>
             </a:extLst>
           </p:cNvPr>
@@ -2430,7 +2430,7 @@
           <p:cNvPr id="3" name="Title">
             <a:extLst xmlns:a="http://schemas.openxmlformats.org/drawingml/2006/main">
               <a:ext uri="{FF2B5EF4-FFF2-40B4-BE49-F238E27FC236}">
-                <a16:creationId xmlns:a16="http://schemas.microsoft.com/office/drawing/2014/main" id="{0B65F3A4-EA9E-42D0-AF75-9701D10EBFEA}"/>
+                <a16:creationId xmlns:a16="http://schemas.microsoft.com/office/drawing/2014/main" id="{830D3B12-B284-4131-995A-115A3700EB1F}"/>
               </a:ext>
             </a:extLst>
           </p:cNvPr>
@@ -2587,7 +2587,7 @@
           <p:cNvPr id="2" name="Left column">
             <a:extLst xmlns:a="http://schemas.openxmlformats.org/drawingml/2006/main">
               <a:ext uri="{FF2B5EF4-FFF2-40B4-BE49-F238E27FC236}">
-                <a16:creationId xmlns:a16="http://schemas.microsoft.com/office/drawing/2014/main" id="{5E451818-910F-4335-863B-C19DBD1F80C7}"/>
+                <a16:creationId xmlns:a16="http://schemas.microsoft.com/office/drawing/2014/main" id="{B335C610-8E12-48D5-8E16-5380C0EBE99F}"/>
               </a:ext>
             </a:extLst>
           </p:cNvPr>
@@ -2782,12 +2782,12 @@
   </p:cSld>
   <p:clrMap bg1="lt1" tx1="dk1" bg2="lt2" tx2="dk2" accent1="accent1" accent2="accent2" accent3="accent3" accent4="accent4" accent5="accent5" accent6="accent6" hlink="hlink" folHlink="folHlink"/>
   <p:sldLayoutIdLst>
-    <p:sldLayoutId xmlns:r="http://schemas.openxmlformats.org/officeDocument/2006/relationships" id="2147483649" r:id="R816e691821794932"/>
-    <p:sldLayoutId xmlns:r="http://schemas.openxmlformats.org/officeDocument/2006/relationships" id="2147483650" r:id="Re16e8c83ecad4c3f"/>
-    <p:sldLayoutId xmlns:r="http://schemas.openxmlformats.org/officeDocument/2006/relationships" id="2147483651" r:id="R22aa12cb15a24406"/>
-    <p:sldLayoutId xmlns:r="http://schemas.openxmlformats.org/officeDocument/2006/relationships" id="2147483652" r:id="Rbb0be728faf24d05"/>
-    <p:sldLayoutId xmlns:r="http://schemas.openxmlformats.org/officeDocument/2006/relationships" id="2147483653" r:id="Rdd135fd5973e4ade"/>
-    <p:sldLayoutId xmlns:r="http://schemas.openxmlformats.org/officeDocument/2006/relationships" id="2147483654" r:id="R2ce53f2a01564967"/>
+    <p:sldLayoutId xmlns:r="http://schemas.openxmlformats.org/officeDocument/2006/relationships" id="2147483649" r:id="R5c5b1171f1f140bd"/>
+    <p:sldLayoutId xmlns:r="http://schemas.openxmlformats.org/officeDocument/2006/relationships" id="2147483650" r:id="R004938a12606403c"/>
+    <p:sldLayoutId xmlns:r="http://schemas.openxmlformats.org/officeDocument/2006/relationships" id="2147483651" r:id="Rfa530819cb5b47e1"/>
+    <p:sldLayoutId xmlns:r="http://schemas.openxmlformats.org/officeDocument/2006/relationships" id="2147483652" r:id="R3e5e385d886e48b7"/>
+    <p:sldLayoutId xmlns:r="http://schemas.openxmlformats.org/officeDocument/2006/relationships" id="2147483653" r:id="R2a6454d79ba54f9d"/>
+    <p:sldLayoutId xmlns:r="http://schemas.openxmlformats.org/officeDocument/2006/relationships" id="2147483654" r:id="R5153fcda86da42e4"/>
   </p:sldLayoutIdLst>
   <p:txStyles>
     <p:titleStyle>
@@ -3338,7 +3338,7 @@
           <p:cNvPr id="6" name="text-1">
             <a:extLst xmlns:a="http://schemas.openxmlformats.org/drawingml/2006/main">
               <a:ext uri="{FF2B5EF4-FFF2-40B4-BE49-F238E27FC236}">
-                <a16:creationId xmlns:a16="http://schemas.microsoft.com/office/drawing/2014/main" id="{3B53737B-9B56-49BC-959F-7D7FEC493565}"/>
+                <a16:creationId xmlns:a16="http://schemas.microsoft.com/office/drawing/2014/main" id="{16F54AF5-07A8-4668-A0C9-931A2B6FF9B1}"/>
               </a:ext>
             </a:extLst>
           </p:cNvPr>
@@ -3404,7 +3404,7 @@
           <p:cNvPr id="2" name="text-2">
             <a:extLst xmlns:a="http://schemas.openxmlformats.org/drawingml/2006/main">
               <a:ext uri="{FF2B5EF4-FFF2-40B4-BE49-F238E27FC236}">
-                <a16:creationId xmlns:a16="http://schemas.microsoft.com/office/drawing/2014/main" id="{F477BF8E-16E1-4598-BC94-D5939BC1F334}"/>
+                <a16:creationId xmlns:a16="http://schemas.microsoft.com/office/drawing/2014/main" id="{7FA92F81-A7F5-42A2-ADCF-CBA7A3322D7C}"/>
               </a:ext>
             </a:extLst>
           </p:cNvPr>
@@ -3470,7 +3470,7 @@
           <p:cNvPr id="3" name="text-3">
             <a:extLst xmlns:a="http://schemas.openxmlformats.org/drawingml/2006/main">
               <a:ext uri="{FF2B5EF4-FFF2-40B4-BE49-F238E27FC236}">
-                <a16:creationId xmlns:a16="http://schemas.microsoft.com/office/drawing/2014/main" id="{3451ADF5-5011-4DB5-AEB9-66F67470427D}"/>
+                <a16:creationId xmlns:a16="http://schemas.microsoft.com/office/drawing/2014/main" id="{FAC886D0-58D1-45E9-A961-0962ED6B47A8}"/>
               </a:ext>
             </a:extLst>
           </p:cNvPr>
@@ -3559,7 +3559,7 @@
           <p:cNvPr id="4" name="text-4">
             <a:extLst xmlns:a="http://schemas.openxmlformats.org/drawingml/2006/main">
               <a:ext uri="{FF2B5EF4-FFF2-40B4-BE49-F238E27FC236}">
-                <a16:creationId xmlns:a16="http://schemas.microsoft.com/office/drawing/2014/main" id="{555120D7-A3FC-4BD3-B99B-03C5D1E35703}"/>
+                <a16:creationId xmlns:a16="http://schemas.microsoft.com/office/drawing/2014/main" id="{26ADEE64-904F-4AB4-A881-8CD224A29C03}"/>
               </a:ext>
             </a:extLst>
           </p:cNvPr>
@@ -3625,7 +3625,7 @@
           <p:cNvPr id="5" name="text-5">
             <a:extLst xmlns:a="http://schemas.openxmlformats.org/drawingml/2006/main">
               <a:ext uri="{FF2B5EF4-FFF2-40B4-BE49-F238E27FC236}">
-                <a16:creationId xmlns:a16="http://schemas.microsoft.com/office/drawing/2014/main" id="{721FCF5E-B5C1-4CE5-BC0C-19AFBF25FFE4}"/>
+                <a16:creationId xmlns:a16="http://schemas.microsoft.com/office/drawing/2014/main" id="{FDF8A897-F569-4D98-A81B-3EFE437D9245}"/>
               </a:ext>
             </a:extLst>
           </p:cNvPr>
@@ -3689,7 +3689,7 @@
     </p:spTree>
     <p:extLst>
       <p:ext uri="{BB962C8B-B14F-4D97-AF65-F5344CB8AC3E}">
-        <p14:creationId xmlns:p14="http://schemas.microsoft.com/office/powerpoint/2010/main" val="1789090923"/>
+        <p14:creationId xmlns:p14="http://schemas.microsoft.com/office/powerpoint/2010/main" val="157090371"/>
       </p:ext>
     </p:extLst>
   </p:cSld>
@@ -3720,7 +3720,7 @@
           <p:cNvPr id="28" name="text-6">
             <a:extLst xmlns:a="http://schemas.openxmlformats.org/drawingml/2006/main">
               <a:ext uri="{FF2B5EF4-FFF2-40B4-BE49-F238E27FC236}">
-                <a16:creationId xmlns:a16="http://schemas.microsoft.com/office/drawing/2014/main" id="{59893F04-BEB1-4DF0-A2D4-5525F93CD33D}"/>
+                <a16:creationId xmlns:a16="http://schemas.microsoft.com/office/drawing/2014/main" id="{F2C8D9B1-7618-4A33-ABF6-0F9621F16FB9}"/>
               </a:ext>
             </a:extLst>
           </p:cNvPr>
@@ -3786,7 +3786,7 @@
           <p:cNvPr id="2" name="text-7">
             <a:extLst xmlns:a="http://schemas.openxmlformats.org/drawingml/2006/main">
               <a:ext uri="{FF2B5EF4-FFF2-40B4-BE49-F238E27FC236}">
-                <a16:creationId xmlns:a16="http://schemas.microsoft.com/office/drawing/2014/main" id="{0481EEEC-4FAB-46A9-BAE7-516FB4F503C6}"/>
+                <a16:creationId xmlns:a16="http://schemas.microsoft.com/office/drawing/2014/main" id="{8EA03B32-9F3E-4F83-A3D0-7A3500FDEA84}"/>
               </a:ext>
             </a:extLst>
           </p:cNvPr>
@@ -3852,7 +3852,7 @@
           <p:cNvPr id="3" name="circuit-8">
             <a:extLst xmlns:a="http://schemas.openxmlformats.org/drawingml/2006/main">
               <a:ext uri="{FF2B5EF4-FFF2-40B4-BE49-F238E27FC236}">
-                <a16:creationId xmlns:a16="http://schemas.microsoft.com/office/drawing/2014/main" id="{19CB58CB-3699-4B8C-B6D8-E58BD2FBF8FC}"/>
+                <a16:creationId xmlns:a16="http://schemas.microsoft.com/office/drawing/2014/main" id="{FAF5D3EA-7894-42BD-9EF7-F1A370B7D44C}"/>
               </a:ext>
             </a:extLst>
           </p:cNvPr>
@@ -3884,7 +3884,7 @@
           <p:cNvPr id="4" name="text-9">
             <a:extLst xmlns:a="http://schemas.openxmlformats.org/drawingml/2006/main">
               <a:ext uri="{FF2B5EF4-FFF2-40B4-BE49-F238E27FC236}">
-                <a16:creationId xmlns:a16="http://schemas.microsoft.com/office/drawing/2014/main" id="{C8D4E9C4-3B31-4496-85B8-E65FEE34D11D}"/>
+                <a16:creationId xmlns:a16="http://schemas.microsoft.com/office/drawing/2014/main" id="{FBCD2EB3-CE24-4BAF-837E-225BCD80ABAB}"/>
               </a:ext>
             </a:extLst>
           </p:cNvPr>
@@ -3950,7 +3950,7 @@
           <p:cNvPr id="5" name="circuit-10">
             <a:extLst xmlns:a="http://schemas.openxmlformats.org/drawingml/2006/main">
               <a:ext uri="{FF2B5EF4-FFF2-40B4-BE49-F238E27FC236}">
-                <a16:creationId xmlns:a16="http://schemas.microsoft.com/office/drawing/2014/main" id="{19982CAF-B93F-4C1B-9DD4-CC338ED61A12}"/>
+                <a16:creationId xmlns:a16="http://schemas.microsoft.com/office/drawing/2014/main" id="{55A66019-F9B6-408D-85DC-146A3C189200}"/>
               </a:ext>
             </a:extLst>
           </p:cNvPr>
@@ -3982,7 +3982,7 @@
           <p:cNvPr id="6" name="text-11">
             <a:extLst xmlns:a="http://schemas.openxmlformats.org/drawingml/2006/main">
               <a:ext uri="{FF2B5EF4-FFF2-40B4-BE49-F238E27FC236}">
-                <a16:creationId xmlns:a16="http://schemas.microsoft.com/office/drawing/2014/main" id="{AD8981ED-D48F-4446-B890-D6538EAFADC9}"/>
+                <a16:creationId xmlns:a16="http://schemas.microsoft.com/office/drawing/2014/main" id="{EDCF921A-0932-4936-8B8F-A84D47AD42F7}"/>
               </a:ext>
             </a:extLst>
           </p:cNvPr>
@@ -4048,7 +4048,7 @@
           <p:cNvPr id="7" name="wire-12">
             <a:extLst xmlns:a="http://schemas.openxmlformats.org/drawingml/2006/main">
               <a:ext uri="{FF2B5EF4-FFF2-40B4-BE49-F238E27FC236}">
-                <a16:creationId xmlns:a16="http://schemas.microsoft.com/office/drawing/2014/main" id="{34668B9E-1A4C-4746-BFF0-E4B1D093D9C1}"/>
+                <a16:creationId xmlns:a16="http://schemas.microsoft.com/office/drawing/2014/main" id="{FCEAD2B4-BA61-4A7C-8B86-51F1CE74A725}"/>
               </a:ext>
             </a:extLst>
           </p:cNvPr>
@@ -4087,7 +4087,7 @@
           <p:cNvPr id="8" name="circuit-13">
             <a:extLst xmlns:a="http://schemas.openxmlformats.org/drawingml/2006/main">
               <a:ext uri="{FF2B5EF4-FFF2-40B4-BE49-F238E27FC236}">
-                <a16:creationId xmlns:a16="http://schemas.microsoft.com/office/drawing/2014/main" id="{CD5075E7-D07A-4506-BFB1-004D6C8C9FA9}"/>
+                <a16:creationId xmlns:a16="http://schemas.microsoft.com/office/drawing/2014/main" id="{89467821-BFB1-4946-A4EC-948A59FE369D}"/>
               </a:ext>
             </a:extLst>
           </p:cNvPr>
@@ -4119,7 +4119,7 @@
           <p:cNvPr id="9" name="text-14">
             <a:extLst xmlns:a="http://schemas.openxmlformats.org/drawingml/2006/main">
               <a:ext uri="{FF2B5EF4-FFF2-40B4-BE49-F238E27FC236}">
-                <a16:creationId xmlns:a16="http://schemas.microsoft.com/office/drawing/2014/main" id="{3F9F91B9-3B5D-4A9F-A190-525E2453CE26}"/>
+                <a16:creationId xmlns:a16="http://schemas.microsoft.com/office/drawing/2014/main" id="{145ABB00-5A75-491D-A893-3486E8EB98C6}"/>
               </a:ext>
             </a:extLst>
           </p:cNvPr>
@@ -4185,7 +4185,7 @@
           <p:cNvPr id="10" name="wire-15">
             <a:extLst xmlns:a="http://schemas.openxmlformats.org/drawingml/2006/main">
               <a:ext uri="{FF2B5EF4-FFF2-40B4-BE49-F238E27FC236}">
-                <a16:creationId xmlns:a16="http://schemas.microsoft.com/office/drawing/2014/main" id="{4A81F6E9-54CD-4436-993C-D967FD2B7336}"/>
+                <a16:creationId xmlns:a16="http://schemas.microsoft.com/office/drawing/2014/main" id="{5F905DAA-7788-415D-A318-E4B47499A41D}"/>
               </a:ext>
             </a:extLst>
           </p:cNvPr>
@@ -4224,7 +4224,7 @@
           <p:cNvPr id="11" name="circuit-16">
             <a:extLst xmlns:a="http://schemas.openxmlformats.org/drawingml/2006/main">
               <a:ext uri="{FF2B5EF4-FFF2-40B4-BE49-F238E27FC236}">
-                <a16:creationId xmlns:a16="http://schemas.microsoft.com/office/drawing/2014/main" id="{D1B61E4B-7E55-4A60-9A47-0711AA2888EF}"/>
+                <a16:creationId xmlns:a16="http://schemas.microsoft.com/office/drawing/2014/main" id="{B3E50FD1-EB7C-438D-B872-66919CA54650}"/>
               </a:ext>
             </a:extLst>
           </p:cNvPr>
@@ -4256,7 +4256,7 @@
           <p:cNvPr id="12" name="text-17">
             <a:extLst xmlns:a="http://schemas.openxmlformats.org/drawingml/2006/main">
               <a:ext uri="{FF2B5EF4-FFF2-40B4-BE49-F238E27FC236}">
-                <a16:creationId xmlns:a16="http://schemas.microsoft.com/office/drawing/2014/main" id="{6F665B3D-5AFA-46F4-8831-92D74AABA530}"/>
+                <a16:creationId xmlns:a16="http://schemas.microsoft.com/office/drawing/2014/main" id="{E36ED939-9E2E-4708-9866-329F6F66C46D}"/>
               </a:ext>
             </a:extLst>
           </p:cNvPr>
@@ -4322,7 +4322,7 @@
           <p:cNvPr id="13" name="wire-18">
             <a:extLst xmlns:a="http://schemas.openxmlformats.org/drawingml/2006/main">
               <a:ext uri="{FF2B5EF4-FFF2-40B4-BE49-F238E27FC236}">
-                <a16:creationId xmlns:a16="http://schemas.microsoft.com/office/drawing/2014/main" id="{0FE6B6FE-BDB4-4C96-8064-748BE3423561}"/>
+                <a16:creationId xmlns:a16="http://schemas.microsoft.com/office/drawing/2014/main" id="{B6B979BC-3DB6-4089-A473-47808D5B89C6}"/>
               </a:ext>
             </a:extLst>
           </p:cNvPr>
@@ -4361,7 +4361,7 @@
           <p:cNvPr id="14" name="circuit-19">
             <a:extLst xmlns:a="http://schemas.openxmlformats.org/drawingml/2006/main">
               <a:ext uri="{FF2B5EF4-FFF2-40B4-BE49-F238E27FC236}">
-                <a16:creationId xmlns:a16="http://schemas.microsoft.com/office/drawing/2014/main" id="{4ED8C7BB-2649-4A86-99DA-7F3BB0AECDC6}"/>
+                <a16:creationId xmlns:a16="http://schemas.microsoft.com/office/drawing/2014/main" id="{562D1E6C-3E91-46C7-A8F1-5E929FFDF7CE}"/>
               </a:ext>
             </a:extLst>
           </p:cNvPr>
@@ -4393,7 +4393,7 @@
           <p:cNvPr id="15" name="text-20">
             <a:extLst xmlns:a="http://schemas.openxmlformats.org/drawingml/2006/main">
               <a:ext uri="{FF2B5EF4-FFF2-40B4-BE49-F238E27FC236}">
-                <a16:creationId xmlns:a16="http://schemas.microsoft.com/office/drawing/2014/main" id="{84D9EFD0-C0D7-4EA8-ACED-3EC8D6BD7DDA}"/>
+                <a16:creationId xmlns:a16="http://schemas.microsoft.com/office/drawing/2014/main" id="{F8EEDA16-3247-447C-B3FE-F120F2F1B267}"/>
               </a:ext>
             </a:extLst>
           </p:cNvPr>
@@ -4459,7 +4459,7 @@
           <p:cNvPr id="16" name="and-gate-21">
             <a:extLst xmlns:a="http://schemas.openxmlformats.org/drawingml/2006/main">
               <a:ext uri="{FF2B5EF4-FFF2-40B4-BE49-F238E27FC236}">
-                <a16:creationId xmlns:a16="http://schemas.microsoft.com/office/drawing/2014/main" id="{F6A9D9EE-6847-4DC2-974A-060F3C0FF73D}"/>
+                <a16:creationId xmlns:a16="http://schemas.microsoft.com/office/drawing/2014/main" id="{D2B3AA27-7EA5-4940-9D72-B33631B5E644}"/>
               </a:ext>
             </a:extLst>
           </p:cNvPr>
@@ -4509,7 +4509,7 @@
           <p:cNvPr id="17" name="wire-22">
             <a:extLst xmlns:a="http://schemas.openxmlformats.org/drawingml/2006/main">
               <a:ext uri="{FF2B5EF4-FFF2-40B4-BE49-F238E27FC236}">
-                <a16:creationId xmlns:a16="http://schemas.microsoft.com/office/drawing/2014/main" id="{897CD172-30CE-45A7-845F-27093E936404}"/>
+                <a16:creationId xmlns:a16="http://schemas.microsoft.com/office/drawing/2014/main" id="{0F8A381A-C249-4A17-889A-668F6169238D}"/>
               </a:ext>
             </a:extLst>
           </p:cNvPr>
@@ -4548,7 +4548,7 @@
           <p:cNvPr id="18" name="wire-23">
             <a:extLst xmlns:a="http://schemas.openxmlformats.org/drawingml/2006/main">
               <a:ext uri="{FF2B5EF4-FFF2-40B4-BE49-F238E27FC236}">
-                <a16:creationId xmlns:a16="http://schemas.microsoft.com/office/drawing/2014/main" id="{5388F295-91D4-4507-B009-660142958717}"/>
+                <a16:creationId xmlns:a16="http://schemas.microsoft.com/office/drawing/2014/main" id="{2A736FC0-2EF1-42BB-BEB5-BF4539960DB4}"/>
               </a:ext>
             </a:extLst>
           </p:cNvPr>
@@ -4587,7 +4587,7 @@
           <p:cNvPr id="19" name="wire-24">
             <a:extLst xmlns:a="http://schemas.openxmlformats.org/drawingml/2006/main">
               <a:ext uri="{FF2B5EF4-FFF2-40B4-BE49-F238E27FC236}">
-                <a16:creationId xmlns:a16="http://schemas.microsoft.com/office/drawing/2014/main" id="{3F0B3275-3A1A-4C33-AD2C-23270C718A08}"/>
+                <a16:creationId xmlns:a16="http://schemas.microsoft.com/office/drawing/2014/main" id="{0F7E930A-B5C8-410A-8F98-240C6A198D37}"/>
               </a:ext>
             </a:extLst>
           </p:cNvPr>
@@ -4626,7 +4626,7 @@
           <p:cNvPr id="20" name="and-gate-25">
             <a:extLst xmlns:a="http://schemas.openxmlformats.org/drawingml/2006/main">
               <a:ext uri="{FF2B5EF4-FFF2-40B4-BE49-F238E27FC236}">
-                <a16:creationId xmlns:a16="http://schemas.microsoft.com/office/drawing/2014/main" id="{52201803-95A0-4D80-9DB5-91CC2F33AF8C}"/>
+                <a16:creationId xmlns:a16="http://schemas.microsoft.com/office/drawing/2014/main" id="{DDBCAA7A-4101-4BDF-B8D0-27CA3E029283}"/>
               </a:ext>
             </a:extLst>
           </p:cNvPr>
@@ -4676,7 +4676,7 @@
           <p:cNvPr id="21" name="wire-26">
             <a:extLst xmlns:a="http://schemas.openxmlformats.org/drawingml/2006/main">
               <a:ext uri="{FF2B5EF4-FFF2-40B4-BE49-F238E27FC236}">
-                <a16:creationId xmlns:a16="http://schemas.microsoft.com/office/drawing/2014/main" id="{B797C2C2-3451-49A9-A5A5-A4043589116C}"/>
+                <a16:creationId xmlns:a16="http://schemas.microsoft.com/office/drawing/2014/main" id="{3602C9C0-A21D-4445-8F6B-6AA2CE6999E1}"/>
               </a:ext>
             </a:extLst>
           </p:cNvPr>
@@ -4715,7 +4715,7 @@
           <p:cNvPr id="22" name="wire-27">
             <a:extLst xmlns:a="http://schemas.openxmlformats.org/drawingml/2006/main">
               <a:ext uri="{FF2B5EF4-FFF2-40B4-BE49-F238E27FC236}">
-                <a16:creationId xmlns:a16="http://schemas.microsoft.com/office/drawing/2014/main" id="{DD612E14-A908-4685-94F4-25E45C34AC21}"/>
+                <a16:creationId xmlns:a16="http://schemas.microsoft.com/office/drawing/2014/main" id="{5EC2B3F0-11FA-4129-A07F-041FA13837A8}"/>
               </a:ext>
             </a:extLst>
           </p:cNvPr>
@@ -4754,7 +4754,7 @@
           <p:cNvPr id="23" name="wire-28">
             <a:extLst xmlns:a="http://schemas.openxmlformats.org/drawingml/2006/main">
               <a:ext uri="{FF2B5EF4-FFF2-40B4-BE49-F238E27FC236}">
-                <a16:creationId xmlns:a16="http://schemas.microsoft.com/office/drawing/2014/main" id="{EFD76EAD-5AE4-481F-B5FD-28AF94DC5C95}"/>
+                <a16:creationId xmlns:a16="http://schemas.microsoft.com/office/drawing/2014/main" id="{281AFA48-5631-4B9C-A962-0E849CA3C43F}"/>
               </a:ext>
             </a:extLst>
           </p:cNvPr>
@@ -4793,7 +4793,7 @@
           <p:cNvPr id="24" name="logic-29">
             <a:extLst xmlns:a="http://schemas.openxmlformats.org/drawingml/2006/main">
               <a:ext uri="{FF2B5EF4-FFF2-40B4-BE49-F238E27FC236}">
-                <a16:creationId xmlns:a16="http://schemas.microsoft.com/office/drawing/2014/main" id="{DA49DA04-46B7-4C77-B48C-01CF74AA64E0}"/>
+                <a16:creationId xmlns:a16="http://schemas.microsoft.com/office/drawing/2014/main" id="{30B72BE8-5F75-404A-A672-3B01C9B8A31F}"/>
               </a:ext>
             </a:extLst>
           </p:cNvPr>
@@ -4838,7 +4838,7 @@
           <p:cNvPr id="25" name="wire-30">
             <a:extLst xmlns:a="http://schemas.openxmlformats.org/drawingml/2006/main">
               <a:ext uri="{FF2B5EF4-FFF2-40B4-BE49-F238E27FC236}">
-                <a16:creationId xmlns:a16="http://schemas.microsoft.com/office/drawing/2014/main" id="{860A11BC-1CE0-4BA0-9590-5506B55CA34A}"/>
+                <a16:creationId xmlns:a16="http://schemas.microsoft.com/office/drawing/2014/main" id="{BE9315F2-9C4E-42BD-A3A8-DCCCD3028E8E}"/>
               </a:ext>
             </a:extLst>
           </p:cNvPr>
@@ -4877,7 +4877,7 @@
           <p:cNvPr id="26" name="wire-31">
             <a:extLst xmlns:a="http://schemas.openxmlformats.org/drawingml/2006/main">
               <a:ext uri="{FF2B5EF4-FFF2-40B4-BE49-F238E27FC236}">
-                <a16:creationId xmlns:a16="http://schemas.microsoft.com/office/drawing/2014/main" id="{8A9FCD2F-87D3-4B24-8C80-B042834F2F00}"/>
+                <a16:creationId xmlns:a16="http://schemas.microsoft.com/office/drawing/2014/main" id="{26026D6B-2AA8-438C-AD69-36A1898563ED}"/>
               </a:ext>
             </a:extLst>
           </p:cNvPr>
@@ -4916,7 +4916,7 @@
           <p:cNvPr id="27" name="text-32">
             <a:extLst xmlns:a="http://schemas.openxmlformats.org/drawingml/2006/main">
               <a:ext uri="{FF2B5EF4-FFF2-40B4-BE49-F238E27FC236}">
-                <a16:creationId xmlns:a16="http://schemas.microsoft.com/office/drawing/2014/main" id="{1127BD84-AA22-43F1-AD15-47B65A49EB62}"/>
+                <a16:creationId xmlns:a16="http://schemas.microsoft.com/office/drawing/2014/main" id="{1C9D6968-27CF-4ED9-BD78-7CFDFAAC18D5}"/>
               </a:ext>
             </a:extLst>
           </p:cNvPr>
@@ -4980,7 +4980,7 @@
     </p:spTree>
     <p:extLst>
       <p:ext uri="{BB962C8B-B14F-4D97-AF65-F5344CB8AC3E}">
-        <p14:creationId xmlns:p14="http://schemas.microsoft.com/office/powerpoint/2010/main" val="2068751094"/>
+        <p14:creationId xmlns:p14="http://schemas.microsoft.com/office/powerpoint/2010/main" val="218126007"/>
       </p:ext>
     </p:extLst>
   </p:cSld>
@@ -5011,7 +5011,7 @@
           <p:cNvPr id="47" name="text-33">
             <a:extLst xmlns:a="http://schemas.openxmlformats.org/drawingml/2006/main">
               <a:ext uri="{FF2B5EF4-FFF2-40B4-BE49-F238E27FC236}">
-                <a16:creationId xmlns:a16="http://schemas.microsoft.com/office/drawing/2014/main" id="{EF3A2FEB-7689-4707-9414-6B44E6BF10EB}"/>
+                <a16:creationId xmlns:a16="http://schemas.microsoft.com/office/drawing/2014/main" id="{90051105-E33E-4190-BBBA-539CA16833F0}"/>
               </a:ext>
             </a:extLst>
           </p:cNvPr>
@@ -5077,7 +5077,7 @@
           <p:cNvPr id="2" name="text-34">
             <a:extLst xmlns:a="http://schemas.openxmlformats.org/drawingml/2006/main">
               <a:ext uri="{FF2B5EF4-FFF2-40B4-BE49-F238E27FC236}">
-                <a16:creationId xmlns:a16="http://schemas.microsoft.com/office/drawing/2014/main" id="{14D40230-DFE5-420C-9BB9-F1ED0FDD2467}"/>
+                <a16:creationId xmlns:a16="http://schemas.microsoft.com/office/drawing/2014/main" id="{ACC26168-FBF3-44C6-B54B-87E866206CF4}"/>
               </a:ext>
             </a:extLst>
           </p:cNvPr>
@@ -5143,7 +5143,7 @@
           <p:cNvPr id="3" name="circuit-35">
             <a:extLst xmlns:a="http://schemas.openxmlformats.org/drawingml/2006/main">
               <a:ext uri="{FF2B5EF4-FFF2-40B4-BE49-F238E27FC236}">
-                <a16:creationId xmlns:a16="http://schemas.microsoft.com/office/drawing/2014/main" id="{81509C60-7078-4DE6-8111-6C23DDA2FBAB}"/>
+                <a16:creationId xmlns:a16="http://schemas.microsoft.com/office/drawing/2014/main" id="{257A3222-B58A-4399-A57B-BA3CFC339A34}"/>
               </a:ext>
             </a:extLst>
           </p:cNvPr>
@@ -5175,7 +5175,7 @@
           <p:cNvPr id="4" name="circuit-36">
             <a:extLst xmlns:a="http://schemas.openxmlformats.org/drawingml/2006/main">
               <a:ext uri="{FF2B5EF4-FFF2-40B4-BE49-F238E27FC236}">
-                <a16:creationId xmlns:a16="http://schemas.microsoft.com/office/drawing/2014/main" id="{6BF73041-F4A5-4B2E-8F3C-3C02508315BC}"/>
+                <a16:creationId xmlns:a16="http://schemas.microsoft.com/office/drawing/2014/main" id="{970F8EE6-020F-42E3-91E4-283EBD3C16BC}"/>
               </a:ext>
             </a:extLst>
           </p:cNvPr>
@@ -5207,7 +5207,7 @@
           <p:cNvPr id="5" name="text-37">
             <a:extLst xmlns:a="http://schemas.openxmlformats.org/drawingml/2006/main">
               <a:ext uri="{FF2B5EF4-FFF2-40B4-BE49-F238E27FC236}">
-                <a16:creationId xmlns:a16="http://schemas.microsoft.com/office/drawing/2014/main" id="{9841C403-4D62-4259-A628-EFA9C9BFBD46}"/>
+                <a16:creationId xmlns:a16="http://schemas.microsoft.com/office/drawing/2014/main" id="{D95408E6-BD9E-481F-BAB7-AE6F335B6F82}"/>
               </a:ext>
             </a:extLst>
           </p:cNvPr>
@@ -5273,7 +5273,7 @@
           <p:cNvPr id="6" name="circuit-38">
             <a:extLst xmlns:a="http://schemas.openxmlformats.org/drawingml/2006/main">
               <a:ext uri="{FF2B5EF4-FFF2-40B4-BE49-F238E27FC236}">
-                <a16:creationId xmlns:a16="http://schemas.microsoft.com/office/drawing/2014/main" id="{C924D272-8E77-4167-870B-D17A3955CA10}"/>
+                <a16:creationId xmlns:a16="http://schemas.microsoft.com/office/drawing/2014/main" id="{EA60743A-318D-4E0F-ADF7-3DD39102BC0B}"/>
               </a:ext>
             </a:extLst>
           </p:cNvPr>
@@ -5305,7 +5305,7 @@
           <p:cNvPr id="7" name="text-39">
             <a:extLst xmlns:a="http://schemas.openxmlformats.org/drawingml/2006/main">
               <a:ext uri="{FF2B5EF4-FFF2-40B4-BE49-F238E27FC236}">
-                <a16:creationId xmlns:a16="http://schemas.microsoft.com/office/drawing/2014/main" id="{ECB9D904-4ACB-481D-92EF-8319414AEB63}"/>
+                <a16:creationId xmlns:a16="http://schemas.microsoft.com/office/drawing/2014/main" id="{FD691EB3-87B0-4FB3-BC71-B46DCF3A5276}"/>
               </a:ext>
             </a:extLst>
           </p:cNvPr>
@@ -5371,7 +5371,7 @@
           <p:cNvPr id="8" name="circuit-40">
             <a:extLst xmlns:a="http://schemas.openxmlformats.org/drawingml/2006/main">
               <a:ext uri="{FF2B5EF4-FFF2-40B4-BE49-F238E27FC236}">
-                <a16:creationId xmlns:a16="http://schemas.microsoft.com/office/drawing/2014/main" id="{DF95BA53-9BEF-4244-AA6F-A575C47ABA5A}"/>
+                <a16:creationId xmlns:a16="http://schemas.microsoft.com/office/drawing/2014/main" id="{B475EA97-FD6A-44E6-85BE-66071A83BB07}"/>
               </a:ext>
             </a:extLst>
           </p:cNvPr>
@@ -5403,7 +5403,7 @@
           <p:cNvPr id="9" name="text-41">
             <a:extLst xmlns:a="http://schemas.openxmlformats.org/drawingml/2006/main">
               <a:ext uri="{FF2B5EF4-FFF2-40B4-BE49-F238E27FC236}">
-                <a16:creationId xmlns:a16="http://schemas.microsoft.com/office/drawing/2014/main" id="{0A8FBAB8-503D-47BC-A875-AF86AF14117D}"/>
+                <a16:creationId xmlns:a16="http://schemas.microsoft.com/office/drawing/2014/main" id="{786711B3-E476-43FF-8ACC-19A5FC677707}"/>
               </a:ext>
             </a:extLst>
           </p:cNvPr>
@@ -5469,7 +5469,7 @@
           <p:cNvPr id="10" name="circuit-42">
             <a:extLst xmlns:a="http://schemas.openxmlformats.org/drawingml/2006/main">
               <a:ext uri="{FF2B5EF4-FFF2-40B4-BE49-F238E27FC236}">
-                <a16:creationId xmlns:a16="http://schemas.microsoft.com/office/drawing/2014/main" id="{F51D2C75-80CE-4413-BA20-BD66D1841A27}"/>
+                <a16:creationId xmlns:a16="http://schemas.microsoft.com/office/drawing/2014/main" id="{02BDC713-1077-4E00-B314-4E01A170B795}"/>
               </a:ext>
             </a:extLst>
           </p:cNvPr>
@@ -5501,7 +5501,7 @@
           <p:cNvPr id="11" name="text-43">
             <a:extLst xmlns:a="http://schemas.openxmlformats.org/drawingml/2006/main">
               <a:ext uri="{FF2B5EF4-FFF2-40B4-BE49-F238E27FC236}">
-                <a16:creationId xmlns:a16="http://schemas.microsoft.com/office/drawing/2014/main" id="{5093F561-DADF-4EED-8B71-BDDBFA284A9E}"/>
+                <a16:creationId xmlns:a16="http://schemas.microsoft.com/office/drawing/2014/main" id="{1813439B-6CD1-4C50-A0FC-3EAC35C7D8D1}"/>
               </a:ext>
             </a:extLst>
           </p:cNvPr>
@@ -5567,7 +5567,7 @@
           <p:cNvPr id="12" name="circuit-44">
             <a:extLst xmlns:a="http://schemas.openxmlformats.org/drawingml/2006/main">
               <a:ext uri="{FF2B5EF4-FFF2-40B4-BE49-F238E27FC236}">
-                <a16:creationId xmlns:a16="http://schemas.microsoft.com/office/drawing/2014/main" id="{66C9E6B6-7C3B-4098-BF86-69470A4BDE77}"/>
+                <a16:creationId xmlns:a16="http://schemas.microsoft.com/office/drawing/2014/main" id="{7A41FDDF-41B7-4251-961C-59ADDCFE770D}"/>
               </a:ext>
             </a:extLst>
           </p:cNvPr>
@@ -5599,7 +5599,7 @@
           <p:cNvPr id="13" name="text-45">
             <a:extLst xmlns:a="http://schemas.openxmlformats.org/drawingml/2006/main">
               <a:ext uri="{FF2B5EF4-FFF2-40B4-BE49-F238E27FC236}">
-                <a16:creationId xmlns:a16="http://schemas.microsoft.com/office/drawing/2014/main" id="{3238DF3E-61D3-43C2-BB13-6FEFD3003929}"/>
+                <a16:creationId xmlns:a16="http://schemas.microsoft.com/office/drawing/2014/main" id="{20D4E46F-13A0-49B4-AC62-ABB7D93A2BF2}"/>
               </a:ext>
             </a:extLst>
           </p:cNvPr>
@@ -5665,7 +5665,7 @@
           <p:cNvPr id="14" name="wire-46">
             <a:extLst xmlns:a="http://schemas.openxmlformats.org/drawingml/2006/main">
               <a:ext uri="{FF2B5EF4-FFF2-40B4-BE49-F238E27FC236}">
-                <a16:creationId xmlns:a16="http://schemas.microsoft.com/office/drawing/2014/main" id="{AFD0873E-C1F3-4C3B-B528-F3D2811D6D8D}"/>
+                <a16:creationId xmlns:a16="http://schemas.microsoft.com/office/drawing/2014/main" id="{877863DE-6BD9-4CAE-BE66-40A43EFD174E}"/>
               </a:ext>
             </a:extLst>
           </p:cNvPr>
@@ -5704,7 +5704,7 @@
           <p:cNvPr id="15" name="circuit-47">
             <a:extLst xmlns:a="http://schemas.openxmlformats.org/drawingml/2006/main">
               <a:ext uri="{FF2B5EF4-FFF2-40B4-BE49-F238E27FC236}">
-                <a16:creationId xmlns:a16="http://schemas.microsoft.com/office/drawing/2014/main" id="{33C87545-FF41-43A6-8514-39E408404125}"/>
+                <a16:creationId xmlns:a16="http://schemas.microsoft.com/office/drawing/2014/main" id="{E7015D89-08FC-48F8-A919-5051022732B5}"/>
               </a:ext>
             </a:extLst>
           </p:cNvPr>
@@ -5736,7 +5736,7 @@
           <p:cNvPr id="16" name="text-48">
             <a:extLst xmlns:a="http://schemas.openxmlformats.org/drawingml/2006/main">
               <a:ext uri="{FF2B5EF4-FFF2-40B4-BE49-F238E27FC236}">
-                <a16:creationId xmlns:a16="http://schemas.microsoft.com/office/drawing/2014/main" id="{1FC04B89-D019-4118-80B5-A9D7E91E4ED7}"/>
+                <a16:creationId xmlns:a16="http://schemas.microsoft.com/office/drawing/2014/main" id="{904630D2-FBCC-4BB1-AAC6-012B8C03D992}"/>
               </a:ext>
             </a:extLst>
           </p:cNvPr>
@@ -5802,7 +5802,7 @@
           <p:cNvPr id="17" name="wire-49">
             <a:extLst xmlns:a="http://schemas.openxmlformats.org/drawingml/2006/main">
               <a:ext uri="{FF2B5EF4-FFF2-40B4-BE49-F238E27FC236}">
-                <a16:creationId xmlns:a16="http://schemas.microsoft.com/office/drawing/2014/main" id="{CD58AA67-4DC0-4996-A9D1-55EAD51BC7BA}"/>
+                <a16:creationId xmlns:a16="http://schemas.microsoft.com/office/drawing/2014/main" id="{A8757415-8DF6-4388-AD91-0F15601476D0}"/>
               </a:ext>
             </a:extLst>
           </p:cNvPr>
@@ -5841,7 +5841,7 @@
           <p:cNvPr id="18" name="circuit-50">
             <a:extLst xmlns:a="http://schemas.openxmlformats.org/drawingml/2006/main">
               <a:ext uri="{FF2B5EF4-FFF2-40B4-BE49-F238E27FC236}">
-                <a16:creationId xmlns:a16="http://schemas.microsoft.com/office/drawing/2014/main" id="{C539C608-CD8E-4631-B00A-AB6411AB1994}"/>
+                <a16:creationId xmlns:a16="http://schemas.microsoft.com/office/drawing/2014/main" id="{3407F24A-E881-40F4-BC9A-2331EAFA01BA}"/>
               </a:ext>
             </a:extLst>
           </p:cNvPr>
@@ -5873,7 +5873,7 @@
           <p:cNvPr id="19" name="text-51">
             <a:extLst xmlns:a="http://schemas.openxmlformats.org/drawingml/2006/main">
               <a:ext uri="{FF2B5EF4-FFF2-40B4-BE49-F238E27FC236}">
-                <a16:creationId xmlns:a16="http://schemas.microsoft.com/office/drawing/2014/main" id="{69F06A67-A2F0-459B-B053-8E1096269F80}"/>
+                <a16:creationId xmlns:a16="http://schemas.microsoft.com/office/drawing/2014/main" id="{EC730C21-59DC-4190-BB21-A9C47C7FB791}"/>
               </a:ext>
             </a:extLst>
           </p:cNvPr>
@@ -5939,7 +5939,7 @@
           <p:cNvPr id="20" name="wire-52">
             <a:extLst xmlns:a="http://schemas.openxmlformats.org/drawingml/2006/main">
               <a:ext uri="{FF2B5EF4-FFF2-40B4-BE49-F238E27FC236}">
-                <a16:creationId xmlns:a16="http://schemas.microsoft.com/office/drawing/2014/main" id="{20887AEB-06F6-4621-A1F9-4A260E745386}"/>
+                <a16:creationId xmlns:a16="http://schemas.microsoft.com/office/drawing/2014/main" id="{89C8A8B7-3F40-4425-A152-7D8CEBD52783}"/>
               </a:ext>
             </a:extLst>
           </p:cNvPr>
@@ -5978,7 +5978,7 @@
           <p:cNvPr id="21" name="logic-53">
             <a:extLst xmlns:a="http://schemas.openxmlformats.org/drawingml/2006/main">
               <a:ext uri="{FF2B5EF4-FFF2-40B4-BE49-F238E27FC236}">
-                <a16:creationId xmlns:a16="http://schemas.microsoft.com/office/drawing/2014/main" id="{5428709B-E16E-4753-AF5F-F66FF8F3F0C7}"/>
+                <a16:creationId xmlns:a16="http://schemas.microsoft.com/office/drawing/2014/main" id="{9301B44C-6C34-43C3-9B82-4161E4BAB5AE}"/>
               </a:ext>
             </a:extLst>
           </p:cNvPr>
@@ -6023,7 +6023,7 @@
           <p:cNvPr id="22" name="circuit-54">
             <a:extLst xmlns:a="http://schemas.openxmlformats.org/drawingml/2006/main">
               <a:ext uri="{FF2B5EF4-FFF2-40B4-BE49-F238E27FC236}">
-                <a16:creationId xmlns:a16="http://schemas.microsoft.com/office/drawing/2014/main" id="{96A09CD1-3722-494B-85E9-2247E064A17C}"/>
+                <a16:creationId xmlns:a16="http://schemas.microsoft.com/office/drawing/2014/main" id="{BADDCCDF-F065-4AF1-B31C-FD0BC4DD9655}"/>
               </a:ext>
             </a:extLst>
           </p:cNvPr>
@@ -6055,7 +6055,7 @@
           <p:cNvPr id="23" name="text-55">
             <a:extLst xmlns:a="http://schemas.openxmlformats.org/drawingml/2006/main">
               <a:ext uri="{FF2B5EF4-FFF2-40B4-BE49-F238E27FC236}">
-                <a16:creationId xmlns:a16="http://schemas.microsoft.com/office/drawing/2014/main" id="{3BCE5604-085D-4409-9B6D-A67B769CB48C}"/>
+                <a16:creationId xmlns:a16="http://schemas.microsoft.com/office/drawing/2014/main" id="{5F1E1097-E6DA-4A36-9704-918ED9DE6E20}"/>
               </a:ext>
             </a:extLst>
           </p:cNvPr>
@@ -6121,7 +6121,7 @@
           <p:cNvPr id="24" name="wire-56">
             <a:extLst xmlns:a="http://schemas.openxmlformats.org/drawingml/2006/main">
               <a:ext uri="{FF2B5EF4-FFF2-40B4-BE49-F238E27FC236}">
-                <a16:creationId xmlns:a16="http://schemas.microsoft.com/office/drawing/2014/main" id="{BFFD0E4E-F170-408F-ADDD-15EAD0B22902}"/>
+                <a16:creationId xmlns:a16="http://schemas.microsoft.com/office/drawing/2014/main" id="{C8185FCD-9F12-4C02-B116-930E218A66CE}"/>
               </a:ext>
             </a:extLst>
           </p:cNvPr>
@@ -6160,7 +6160,7 @@
           <p:cNvPr id="25" name="wire-57">
             <a:extLst xmlns:a="http://schemas.openxmlformats.org/drawingml/2006/main">
               <a:ext uri="{FF2B5EF4-FFF2-40B4-BE49-F238E27FC236}">
-                <a16:creationId xmlns:a16="http://schemas.microsoft.com/office/drawing/2014/main" id="{ACA6E9C7-CA2F-478C-9A54-80A127B763A5}"/>
+                <a16:creationId xmlns:a16="http://schemas.microsoft.com/office/drawing/2014/main" id="{36BA6320-909F-49E5-A2E4-6BC3DF25DBB7}"/>
               </a:ext>
             </a:extLst>
           </p:cNvPr>
@@ -6199,7 +6199,7 @@
           <p:cNvPr id="26" name="circuit-58">
             <a:extLst xmlns:a="http://schemas.openxmlformats.org/drawingml/2006/main">
               <a:ext uri="{FF2B5EF4-FFF2-40B4-BE49-F238E27FC236}">
-                <a16:creationId xmlns:a16="http://schemas.microsoft.com/office/drawing/2014/main" id="{C47F49CC-1234-4E5E-B584-254123E89ABE}"/>
+                <a16:creationId xmlns:a16="http://schemas.microsoft.com/office/drawing/2014/main" id="{1CD55789-9B41-4AD5-8111-6DCA36E7A7B3}"/>
               </a:ext>
             </a:extLst>
           </p:cNvPr>
@@ -6231,7 +6231,7 @@
           <p:cNvPr id="27" name="text-59">
             <a:extLst xmlns:a="http://schemas.openxmlformats.org/drawingml/2006/main">
               <a:ext uri="{FF2B5EF4-FFF2-40B4-BE49-F238E27FC236}">
-                <a16:creationId xmlns:a16="http://schemas.microsoft.com/office/drawing/2014/main" id="{B7BD1F35-A5B2-48A2-B548-8D8465D05438}"/>
+                <a16:creationId xmlns:a16="http://schemas.microsoft.com/office/drawing/2014/main" id="{DDF15DD0-9EAF-49EC-880E-38C92BC1445D}"/>
               </a:ext>
             </a:extLst>
           </p:cNvPr>
@@ -6320,7 +6320,7 @@
           <p:cNvPr id="28" name="wire-60">
             <a:extLst xmlns:a="http://schemas.openxmlformats.org/drawingml/2006/main">
               <a:ext uri="{FF2B5EF4-FFF2-40B4-BE49-F238E27FC236}">
-                <a16:creationId xmlns:a16="http://schemas.microsoft.com/office/drawing/2014/main" id="{FC41B873-5A89-4ACE-9A5C-A6FAEF2341C2}"/>
+                <a16:creationId xmlns:a16="http://schemas.microsoft.com/office/drawing/2014/main" id="{8D59060C-D187-4C10-81B1-53198DAF634F}"/>
               </a:ext>
             </a:extLst>
           </p:cNvPr>
@@ -6359,7 +6359,7 @@
           <p:cNvPr id="29" name="circuit-61">
             <a:extLst xmlns:a="http://schemas.openxmlformats.org/drawingml/2006/main">
               <a:ext uri="{FF2B5EF4-FFF2-40B4-BE49-F238E27FC236}">
-                <a16:creationId xmlns:a16="http://schemas.microsoft.com/office/drawing/2014/main" id="{CF7A1E86-C775-45B1-8C53-8A823D050397}"/>
+                <a16:creationId xmlns:a16="http://schemas.microsoft.com/office/drawing/2014/main" id="{D8E562B5-8F3D-4489-BE5F-2F72A8F8A66F}"/>
               </a:ext>
             </a:extLst>
           </p:cNvPr>
@@ -6391,7 +6391,7 @@
           <p:cNvPr id="30" name="text-62">
             <a:extLst xmlns:a="http://schemas.openxmlformats.org/drawingml/2006/main">
               <a:ext uri="{FF2B5EF4-FFF2-40B4-BE49-F238E27FC236}">
-                <a16:creationId xmlns:a16="http://schemas.microsoft.com/office/drawing/2014/main" id="{797F5DB3-406D-40A9-981E-3ABDDA17287C}"/>
+                <a16:creationId xmlns:a16="http://schemas.microsoft.com/office/drawing/2014/main" id="{6B51C162-02C1-4BB0-9025-65B9EA98FCF7}"/>
               </a:ext>
             </a:extLst>
           </p:cNvPr>
@@ -6457,7 +6457,7 @@
           <p:cNvPr id="31" name="wire-63">
             <a:extLst xmlns:a="http://schemas.openxmlformats.org/drawingml/2006/main">
               <a:ext uri="{FF2B5EF4-FFF2-40B4-BE49-F238E27FC236}">
-                <a16:creationId xmlns:a16="http://schemas.microsoft.com/office/drawing/2014/main" id="{CBD8D724-C277-495A-A91B-09BB0A4B3112}"/>
+                <a16:creationId xmlns:a16="http://schemas.microsoft.com/office/drawing/2014/main" id="{B65D87B7-DE36-485B-9AF5-8EB5B3CCF66C}"/>
               </a:ext>
             </a:extLst>
           </p:cNvPr>
@@ -6496,7 +6496,7 @@
           <p:cNvPr id="32" name="logic-64">
             <a:extLst xmlns:a="http://schemas.openxmlformats.org/drawingml/2006/main">
               <a:ext uri="{FF2B5EF4-FFF2-40B4-BE49-F238E27FC236}">
-                <a16:creationId xmlns:a16="http://schemas.microsoft.com/office/drawing/2014/main" id="{2034F2CF-A733-4BF4-9174-270C86CA5E7D}"/>
+                <a16:creationId xmlns:a16="http://schemas.microsoft.com/office/drawing/2014/main" id="{DB7D8458-2E6C-4E72-BBA7-4CE1A64699E6}"/>
               </a:ext>
             </a:extLst>
           </p:cNvPr>
@@ -6541,7 +6541,7 @@
           <p:cNvPr id="33" name="circuit-65">
             <a:extLst xmlns:a="http://schemas.openxmlformats.org/drawingml/2006/main">
               <a:ext uri="{FF2B5EF4-FFF2-40B4-BE49-F238E27FC236}">
-                <a16:creationId xmlns:a16="http://schemas.microsoft.com/office/drawing/2014/main" id="{5F48AFC3-B7EA-4A17-9D87-493B3CD2AAC4}"/>
+                <a16:creationId xmlns:a16="http://schemas.microsoft.com/office/drawing/2014/main" id="{A55E8EFE-226A-49B2-A01A-E2E99C38E873}"/>
               </a:ext>
             </a:extLst>
           </p:cNvPr>
@@ -6573,7 +6573,7 @@
           <p:cNvPr id="34" name="text-66">
             <a:extLst xmlns:a="http://schemas.openxmlformats.org/drawingml/2006/main">
               <a:ext uri="{FF2B5EF4-FFF2-40B4-BE49-F238E27FC236}">
-                <a16:creationId xmlns:a16="http://schemas.microsoft.com/office/drawing/2014/main" id="{82B2E5FE-C16D-4963-AC62-1D599C530D42}"/>
+                <a16:creationId xmlns:a16="http://schemas.microsoft.com/office/drawing/2014/main" id="{6FE839DC-BAED-4051-9D12-F169CADF50F4}"/>
               </a:ext>
             </a:extLst>
           </p:cNvPr>
@@ -6662,7 +6662,7 @@
           <p:cNvPr id="35" name="wire-67">
             <a:extLst xmlns:a="http://schemas.openxmlformats.org/drawingml/2006/main">
               <a:ext uri="{FF2B5EF4-FFF2-40B4-BE49-F238E27FC236}">
-                <a16:creationId xmlns:a16="http://schemas.microsoft.com/office/drawing/2014/main" id="{70DB5D4B-0854-4AA3-A924-A28D817E918E}"/>
+                <a16:creationId xmlns:a16="http://schemas.microsoft.com/office/drawing/2014/main" id="{EDC18D8C-2A19-496D-ACDD-401E6C1865E9}"/>
               </a:ext>
             </a:extLst>
           </p:cNvPr>
@@ -6701,7 +6701,7 @@
           <p:cNvPr id="36" name="logic-68">
             <a:extLst xmlns:a="http://schemas.openxmlformats.org/drawingml/2006/main">
               <a:ext uri="{FF2B5EF4-FFF2-40B4-BE49-F238E27FC236}">
-                <a16:creationId xmlns:a16="http://schemas.microsoft.com/office/drawing/2014/main" id="{1BA635AE-34DB-4096-9052-D06397797ACB}"/>
+                <a16:creationId xmlns:a16="http://schemas.microsoft.com/office/drawing/2014/main" id="{AFECB2BA-AB6C-43FE-9CDD-23BA78D02584}"/>
               </a:ext>
             </a:extLst>
           </p:cNvPr>
@@ -6746,7 +6746,7 @@
           <p:cNvPr id="37" name="wire-69">
             <a:extLst xmlns:a="http://schemas.openxmlformats.org/drawingml/2006/main">
               <a:ext uri="{FF2B5EF4-FFF2-40B4-BE49-F238E27FC236}">
-                <a16:creationId xmlns:a16="http://schemas.microsoft.com/office/drawing/2014/main" id="{77277122-AA44-46B6-93C2-4EE435A4BDE8}"/>
+                <a16:creationId xmlns:a16="http://schemas.microsoft.com/office/drawing/2014/main" id="{758701A5-63BC-44AC-8858-C1EB70590939}"/>
               </a:ext>
             </a:extLst>
           </p:cNvPr>
@@ -6785,7 +6785,7 @@
           <p:cNvPr id="38" name="wire-70">
             <a:extLst xmlns:a="http://schemas.openxmlformats.org/drawingml/2006/main">
               <a:ext uri="{FF2B5EF4-FFF2-40B4-BE49-F238E27FC236}">
-                <a16:creationId xmlns:a16="http://schemas.microsoft.com/office/drawing/2014/main" id="{FE4D91FF-7AD7-4AE4-9DC6-B845A73ACAD1}"/>
+                <a16:creationId xmlns:a16="http://schemas.microsoft.com/office/drawing/2014/main" id="{28CD32E0-81FE-48D2-A99A-8EA0C27B3DF3}"/>
               </a:ext>
             </a:extLst>
           </p:cNvPr>
@@ -6824,7 +6824,7 @@
           <p:cNvPr id="39" name="wire-71">
             <a:extLst xmlns:a="http://schemas.openxmlformats.org/drawingml/2006/main">
               <a:ext uri="{FF2B5EF4-FFF2-40B4-BE49-F238E27FC236}">
-                <a16:creationId xmlns:a16="http://schemas.microsoft.com/office/drawing/2014/main" id="{717A87F1-89F1-4416-AFCD-C9B7BF9DB20E}"/>
+                <a16:creationId xmlns:a16="http://schemas.microsoft.com/office/drawing/2014/main" id="{472D53EC-A841-492B-AB1D-C88B66FCE8FD}"/>
               </a:ext>
             </a:extLst>
           </p:cNvPr>
@@ -6863,7 +6863,7 @@
           <p:cNvPr id="40" name="wire-72">
             <a:extLst xmlns:a="http://schemas.openxmlformats.org/drawingml/2006/main">
               <a:ext uri="{FF2B5EF4-FFF2-40B4-BE49-F238E27FC236}">
-                <a16:creationId xmlns:a16="http://schemas.microsoft.com/office/drawing/2014/main" id="{0B03AA88-E546-40A6-A03A-BAE9CAB453D9}"/>
+                <a16:creationId xmlns:a16="http://schemas.microsoft.com/office/drawing/2014/main" id="{792C77D9-2046-4E92-A6FC-9B2964FE74EC}"/>
               </a:ext>
             </a:extLst>
           </p:cNvPr>
@@ -6902,7 +6902,7 @@
           <p:cNvPr id="41" name="logic-73">
             <a:extLst xmlns:a="http://schemas.openxmlformats.org/drawingml/2006/main">
               <a:ext uri="{FF2B5EF4-FFF2-40B4-BE49-F238E27FC236}">
-                <a16:creationId xmlns:a16="http://schemas.microsoft.com/office/drawing/2014/main" id="{F43C9107-B8B0-4E1F-AE01-BE99930BB792}"/>
+                <a16:creationId xmlns:a16="http://schemas.microsoft.com/office/drawing/2014/main" id="{5E38A258-5464-47A1-8106-84074A1B82DF}"/>
               </a:ext>
             </a:extLst>
           </p:cNvPr>
@@ -6947,7 +6947,7 @@
           <p:cNvPr id="42" name="text-74">
             <a:extLst xmlns:a="http://schemas.openxmlformats.org/drawingml/2006/main">
               <a:ext uri="{FF2B5EF4-FFF2-40B4-BE49-F238E27FC236}">
-                <a16:creationId xmlns:a16="http://schemas.microsoft.com/office/drawing/2014/main" id="{29001FFD-A6B9-485C-8506-71A51653B050}"/>
+                <a16:creationId xmlns:a16="http://schemas.microsoft.com/office/drawing/2014/main" id="{14D43B27-7C9F-4988-B64E-BF6A97802B6B}"/>
               </a:ext>
             </a:extLst>
           </p:cNvPr>
@@ -7013,7 +7013,7 @@
           <p:cNvPr id="43" name="wire-75">
             <a:extLst xmlns:a="http://schemas.openxmlformats.org/drawingml/2006/main">
               <a:ext uri="{FF2B5EF4-FFF2-40B4-BE49-F238E27FC236}">
-                <a16:creationId xmlns:a16="http://schemas.microsoft.com/office/drawing/2014/main" id="{02DC308F-1460-4334-A561-BA42CB36522F}"/>
+                <a16:creationId xmlns:a16="http://schemas.microsoft.com/office/drawing/2014/main" id="{F6656DB9-34DB-4136-9471-5F8ECF888E5C}"/>
               </a:ext>
             </a:extLst>
           </p:cNvPr>
@@ -7052,7 +7052,7 @@
           <p:cNvPr id="44" name="logic-76">
             <a:extLst xmlns:a="http://schemas.openxmlformats.org/drawingml/2006/main">
               <a:ext uri="{FF2B5EF4-FFF2-40B4-BE49-F238E27FC236}">
-                <a16:creationId xmlns:a16="http://schemas.microsoft.com/office/drawing/2014/main" id="{C8C9AB22-1B16-4FE6-9C6C-B1D69F6E8B9F}"/>
+                <a16:creationId xmlns:a16="http://schemas.microsoft.com/office/drawing/2014/main" id="{3710DE30-9E67-42AA-88D9-D7A3E74DD38E}"/>
               </a:ext>
             </a:extLst>
           </p:cNvPr>
@@ -7097,19 +7097,19 @@
           <p:cNvPr id="45" name="text-77">
             <a:extLst xmlns:a="http://schemas.openxmlformats.org/drawingml/2006/main">
               <a:ext uri="{FF2B5EF4-FFF2-40B4-BE49-F238E27FC236}">
-                <a16:creationId xmlns:a16="http://schemas.microsoft.com/office/drawing/2014/main" id="{E4F136EB-C842-4211-B774-F3E8992A7C7D}"/>
-              </a:ext>
-            </a:extLst>
-          </p:cNvPr>
-          <p:cNvSpPr>
-            <a:spLocks xmlns:a="http://schemas.openxmlformats.org/drawingml/2006/main" noGrp="1"/>
-          </p:cNvSpPr>
-          <p:nvPr/>
-        </p:nvSpPr>
-        <p:spPr>
-          <a:xfrm xmlns:a="http://schemas.openxmlformats.org/drawingml/2006/main">
-            <a:off x="9382125" y="3743325"/>
-            <a:ext cx="1638300" cy="304800"/>
+                <a16:creationId xmlns:a16="http://schemas.microsoft.com/office/drawing/2014/main" id="{5402DB49-7297-4025-87DE-E8CF043BE518}"/>
+              </a:ext>
+            </a:extLst>
+          </p:cNvPr>
+          <p:cNvSpPr>
+            <a:spLocks xmlns:a="http://schemas.openxmlformats.org/drawingml/2006/main" noGrp="1"/>
+          </p:cNvSpPr>
+          <p:nvPr/>
+        </p:nvSpPr>
+        <p:spPr>
+          <a:xfrm xmlns:a="http://schemas.openxmlformats.org/drawingml/2006/main">
+            <a:off x="9410700" y="3790950"/>
+            <a:ext cx="933450" cy="571500"/>
           </a:xfrm>
           <a:prstGeom xmlns:a="http://schemas.openxmlformats.org/drawingml/2006/main" prst="rect">
             <a:avLst/>
@@ -7122,7 +7122,7 @@
         <p:txBody>
           <a:bodyPr xmlns:a="http://schemas.openxmlformats.org/drawingml/2006/main" wrap="square" lIns="0" tIns="0" rIns="0" bIns="0" anchor="ctr"/>
           <a:lstStyle xmlns:a="http://schemas.openxmlformats.org/drawingml/2006/main">
-            <a:defPPr algn="l">
+            <a:defPPr algn="ctr">
               <a:defRPr sz="1500" b="0">
                 <a:solidFill>
                   <a:srgbClr val="1673C3"/>
@@ -7134,7 +7134,7 @@
             </a:defPPr>
           </a:lstStyle>
           <a:p xmlns:a="http://schemas.openxmlformats.org/drawingml/2006/main">
-            <a:pPr algn="l">
+            <a:pPr algn="ctr">
               <a:defRPr sz="1500" b="0">
                 <a:solidFill>
                   <a:srgbClr val="1673C3"/>
@@ -7153,7 +7153,30 @@
                 <a:ea typeface="Meiryo"/>
                 <a:cs typeface="Meiryo"/>
               </a:rPr>
-              <a:t>表示先の指定</a:t>
+              <a:t>表示先の</a:t>
+            </a:r>
+          </a:p>
+          <a:p xmlns:a="http://schemas.openxmlformats.org/drawingml/2006/main">
+            <a:pPr algn="ctr">
+              <a:defRPr sz="1500" b="0">
+                <a:solidFill>
+                  <a:srgbClr val="1673C3"/>
+                </a:solidFill>
+                <a:latin typeface="Meiryo"/>
+                <a:ea typeface="Meiryo"/>
+                <a:cs typeface="Meiryo"/>
+              </a:defRPr>
+            </a:pPr>
+            <a:r>
+              <a:rPr sz="1500" b="0">
+                <a:solidFill>
+                  <a:srgbClr val="1673C3"/>
+                </a:solidFill>
+                <a:latin typeface="Meiryo"/>
+                <a:ea typeface="Meiryo"/>
+                <a:cs typeface="Meiryo"/>
+              </a:rPr>
+              <a:t>指定</a:t>
             </a:r>
           </a:p>
         </p:txBody>
@@ -7163,7 +7186,7 @@
           <p:cNvPr id="46" name="text-78">
             <a:extLst xmlns:a="http://schemas.openxmlformats.org/drawingml/2006/main">
               <a:ext uri="{FF2B5EF4-FFF2-40B4-BE49-F238E27FC236}">
-                <a16:creationId xmlns:a16="http://schemas.microsoft.com/office/drawing/2014/main" id="{936B64A4-8488-4FFD-9E60-8CE3F4BACA27}"/>
+                <a16:creationId xmlns:a16="http://schemas.microsoft.com/office/drawing/2014/main" id="{FD624AFE-44C5-482F-BC5B-07AD594830E1}"/>
               </a:ext>
             </a:extLst>
           </p:cNvPr>
@@ -7227,7 +7250,7 @@
     </p:spTree>
     <p:extLst>
       <p:ext uri="{BB962C8B-B14F-4D97-AF65-F5344CB8AC3E}">
-        <p14:creationId xmlns:p14="http://schemas.microsoft.com/office/powerpoint/2010/main" val="1815262970"/>
+        <p14:creationId xmlns:p14="http://schemas.microsoft.com/office/powerpoint/2010/main" val="172869916"/>
       </p:ext>
     </p:extLst>
   </p:cSld>
@@ -7258,7 +7281,7 @@
           <p:cNvPr id="26" name="text-79">
             <a:extLst xmlns:a="http://schemas.openxmlformats.org/drawingml/2006/main">
               <a:ext uri="{FF2B5EF4-FFF2-40B4-BE49-F238E27FC236}">
-                <a16:creationId xmlns:a16="http://schemas.microsoft.com/office/drawing/2014/main" id="{5E5071CC-3C9F-496A-BAB1-C178C124BB55}"/>
+                <a16:creationId xmlns:a16="http://schemas.microsoft.com/office/drawing/2014/main" id="{8D2F374B-8E5F-4C50-A0A7-FC99BF86A66B}"/>
               </a:ext>
             </a:extLst>
           </p:cNvPr>
@@ -7324,7 +7347,7 @@
           <p:cNvPr id="2" name="text-80">
             <a:extLst xmlns:a="http://schemas.openxmlformats.org/drawingml/2006/main">
               <a:ext uri="{FF2B5EF4-FFF2-40B4-BE49-F238E27FC236}">
-                <a16:creationId xmlns:a16="http://schemas.microsoft.com/office/drawing/2014/main" id="{378C1FAD-693E-4ED2-BA47-0877AAE5793C}"/>
+                <a16:creationId xmlns:a16="http://schemas.microsoft.com/office/drawing/2014/main" id="{CF71AE6A-379C-47E5-BE40-7FDFDDA7B2B3}"/>
               </a:ext>
             </a:extLst>
           </p:cNvPr>
@@ -7390,7 +7413,7 @@
           <p:cNvPr id="3" name="circuit-81">
             <a:extLst xmlns:a="http://schemas.openxmlformats.org/drawingml/2006/main">
               <a:ext uri="{FF2B5EF4-FFF2-40B4-BE49-F238E27FC236}">
-                <a16:creationId xmlns:a16="http://schemas.microsoft.com/office/drawing/2014/main" id="{EE50C894-8895-4B03-94BA-A4D12C9DC4E5}"/>
+                <a16:creationId xmlns:a16="http://schemas.microsoft.com/office/drawing/2014/main" id="{3999FFAA-9B5C-41CC-90E5-EA4CEA415C49}"/>
               </a:ext>
             </a:extLst>
           </p:cNvPr>
@@ -7422,7 +7445,7 @@
           <p:cNvPr id="4" name="text-82">
             <a:extLst xmlns:a="http://schemas.openxmlformats.org/drawingml/2006/main">
               <a:ext uri="{FF2B5EF4-FFF2-40B4-BE49-F238E27FC236}">
-                <a16:creationId xmlns:a16="http://schemas.microsoft.com/office/drawing/2014/main" id="{18CB5927-CB33-4788-B639-9200AD5F4F64}"/>
+                <a16:creationId xmlns:a16="http://schemas.microsoft.com/office/drawing/2014/main" id="{3EBAF4C9-73CA-492B-A9F1-908F44D0977D}"/>
               </a:ext>
             </a:extLst>
           </p:cNvPr>
@@ -7488,7 +7511,7 @@
           <p:cNvPr id="5" name="circuit-83">
             <a:extLst xmlns:a="http://schemas.openxmlformats.org/drawingml/2006/main">
               <a:ext uri="{FF2B5EF4-FFF2-40B4-BE49-F238E27FC236}">
-                <a16:creationId xmlns:a16="http://schemas.microsoft.com/office/drawing/2014/main" id="{2984D5CF-633B-4221-AABD-B8BAC590EE3A}"/>
+                <a16:creationId xmlns:a16="http://schemas.microsoft.com/office/drawing/2014/main" id="{85154BFF-2126-4E68-827C-D612826A0367}"/>
               </a:ext>
             </a:extLst>
           </p:cNvPr>
@@ -7520,7 +7543,7 @@
           <p:cNvPr id="6" name="text-84">
             <a:extLst xmlns:a="http://schemas.openxmlformats.org/drawingml/2006/main">
               <a:ext uri="{FF2B5EF4-FFF2-40B4-BE49-F238E27FC236}">
-                <a16:creationId xmlns:a16="http://schemas.microsoft.com/office/drawing/2014/main" id="{2D5F3999-7048-460A-A141-758A8911F0D9}"/>
+                <a16:creationId xmlns:a16="http://schemas.microsoft.com/office/drawing/2014/main" id="{2D648D1B-3AD2-41DA-ACFB-264206F97F5C}"/>
               </a:ext>
             </a:extLst>
           </p:cNvPr>
@@ -7586,7 +7609,7 @@
           <p:cNvPr id="7" name="circuit-85">
             <a:extLst xmlns:a="http://schemas.openxmlformats.org/drawingml/2006/main">
               <a:ext uri="{FF2B5EF4-FFF2-40B4-BE49-F238E27FC236}">
-                <a16:creationId xmlns:a16="http://schemas.microsoft.com/office/drawing/2014/main" id="{0A0799C3-FFFA-4894-92FC-894598F867E3}"/>
+                <a16:creationId xmlns:a16="http://schemas.microsoft.com/office/drawing/2014/main" id="{8E7D37F9-85C4-431B-A2B5-17AC53E0BB44}"/>
               </a:ext>
             </a:extLst>
           </p:cNvPr>
@@ -7618,7 +7641,7 @@
           <p:cNvPr id="8" name="text-86">
             <a:extLst xmlns:a="http://schemas.openxmlformats.org/drawingml/2006/main">
               <a:ext uri="{FF2B5EF4-FFF2-40B4-BE49-F238E27FC236}">
-                <a16:creationId xmlns:a16="http://schemas.microsoft.com/office/drawing/2014/main" id="{B2B1D937-F6C0-4A2B-9E3F-E77D401365F4}"/>
+                <a16:creationId xmlns:a16="http://schemas.microsoft.com/office/drawing/2014/main" id="{310B3AC9-8005-48B5-B625-E1BA4633F9AE}"/>
               </a:ext>
             </a:extLst>
           </p:cNvPr>
@@ -7684,7 +7707,7 @@
           <p:cNvPr id="9" name="circuit-87">
             <a:extLst xmlns:a="http://schemas.openxmlformats.org/drawingml/2006/main">
               <a:ext uri="{FF2B5EF4-FFF2-40B4-BE49-F238E27FC236}">
-                <a16:creationId xmlns:a16="http://schemas.microsoft.com/office/drawing/2014/main" id="{D89AB0C2-3648-4193-912D-8194B61B839A}"/>
+                <a16:creationId xmlns:a16="http://schemas.microsoft.com/office/drawing/2014/main" id="{02BDA81B-27C2-42F9-AFAF-E989DBF0E513}"/>
               </a:ext>
             </a:extLst>
           </p:cNvPr>
@@ -7716,7 +7739,7 @@
           <p:cNvPr id="10" name="text-88">
             <a:extLst xmlns:a="http://schemas.openxmlformats.org/drawingml/2006/main">
               <a:ext uri="{FF2B5EF4-FFF2-40B4-BE49-F238E27FC236}">
-                <a16:creationId xmlns:a16="http://schemas.microsoft.com/office/drawing/2014/main" id="{E6233557-BCC5-41B2-8A99-03D36B24E789}"/>
+                <a16:creationId xmlns:a16="http://schemas.microsoft.com/office/drawing/2014/main" id="{4F6ADF2D-FC97-4484-84B6-0074905FDCEC}"/>
               </a:ext>
             </a:extLst>
           </p:cNvPr>
@@ -7782,7 +7805,7 @@
           <p:cNvPr id="11" name="wire-89">
             <a:extLst xmlns:a="http://schemas.openxmlformats.org/drawingml/2006/main">
               <a:ext uri="{FF2B5EF4-FFF2-40B4-BE49-F238E27FC236}">
-                <a16:creationId xmlns:a16="http://schemas.microsoft.com/office/drawing/2014/main" id="{2974A33F-9E07-4939-8CB2-4A3C8E13678A}"/>
+                <a16:creationId xmlns:a16="http://schemas.microsoft.com/office/drawing/2014/main" id="{0BA7AAB9-903F-414A-9E44-FC1B73B8045C}"/>
               </a:ext>
             </a:extLst>
           </p:cNvPr>
@@ -7821,7 +7844,7 @@
           <p:cNvPr id="12" name="logic-90">
             <a:extLst xmlns:a="http://schemas.openxmlformats.org/drawingml/2006/main">
               <a:ext uri="{FF2B5EF4-FFF2-40B4-BE49-F238E27FC236}">
-                <a16:creationId xmlns:a16="http://schemas.microsoft.com/office/drawing/2014/main" id="{D84BBE1F-B1B1-4D77-8825-2A0E853C0C8A}"/>
+                <a16:creationId xmlns:a16="http://schemas.microsoft.com/office/drawing/2014/main" id="{52B70F18-1741-4546-A686-424CDFA932BD}"/>
               </a:ext>
             </a:extLst>
           </p:cNvPr>
@@ -7866,7 +7889,7 @@
           <p:cNvPr id="13" name="wire-91">
             <a:extLst xmlns:a="http://schemas.openxmlformats.org/drawingml/2006/main">
               <a:ext uri="{FF2B5EF4-FFF2-40B4-BE49-F238E27FC236}">
-                <a16:creationId xmlns:a16="http://schemas.microsoft.com/office/drawing/2014/main" id="{870CFA7F-B35A-488B-BDB2-A123305BFDFD}"/>
+                <a16:creationId xmlns:a16="http://schemas.microsoft.com/office/drawing/2014/main" id="{2426357E-9D1A-4220-B989-396651277A56}"/>
               </a:ext>
             </a:extLst>
           </p:cNvPr>
@@ -7905,7 +7928,7 @@
           <p:cNvPr id="14" name="logic-92">
             <a:extLst xmlns:a="http://schemas.openxmlformats.org/drawingml/2006/main">
               <a:ext uri="{FF2B5EF4-FFF2-40B4-BE49-F238E27FC236}">
-                <a16:creationId xmlns:a16="http://schemas.microsoft.com/office/drawing/2014/main" id="{5CD782A3-4F49-4D49-9DB3-87A752F3269C}"/>
+                <a16:creationId xmlns:a16="http://schemas.microsoft.com/office/drawing/2014/main" id="{20E62580-5197-4C03-8F46-377563E6F918}"/>
               </a:ext>
             </a:extLst>
           </p:cNvPr>
@@ -7950,7 +7973,7 @@
           <p:cNvPr id="15" name="wire-93">
             <a:extLst xmlns:a="http://schemas.openxmlformats.org/drawingml/2006/main">
               <a:ext uri="{FF2B5EF4-FFF2-40B4-BE49-F238E27FC236}">
-                <a16:creationId xmlns:a16="http://schemas.microsoft.com/office/drawing/2014/main" id="{A77654F6-6E9A-423A-AE7F-D74A13E4FDC1}"/>
+                <a16:creationId xmlns:a16="http://schemas.microsoft.com/office/drawing/2014/main" id="{2A801BAE-FBC3-44ED-BF17-B69A6CB22D4A}"/>
               </a:ext>
             </a:extLst>
           </p:cNvPr>
@@ -7989,7 +8012,7 @@
           <p:cNvPr id="16" name="logic-94">
             <a:extLst xmlns:a="http://schemas.openxmlformats.org/drawingml/2006/main">
               <a:ext uri="{FF2B5EF4-FFF2-40B4-BE49-F238E27FC236}">
-                <a16:creationId xmlns:a16="http://schemas.microsoft.com/office/drawing/2014/main" id="{584A59F3-DB02-492E-AF9E-29A998C30EB4}"/>
+                <a16:creationId xmlns:a16="http://schemas.microsoft.com/office/drawing/2014/main" id="{D2045AD7-A3DE-4B47-9890-13542C0263E9}"/>
               </a:ext>
             </a:extLst>
           </p:cNvPr>
@@ -8034,7 +8057,7 @@
           <p:cNvPr id="17" name="text-95">
             <a:extLst xmlns:a="http://schemas.openxmlformats.org/drawingml/2006/main">
               <a:ext uri="{FF2B5EF4-FFF2-40B4-BE49-F238E27FC236}">
-                <a16:creationId xmlns:a16="http://schemas.microsoft.com/office/drawing/2014/main" id="{C0C27C63-22AA-4360-9D6C-9062B10B49FC}"/>
+                <a16:creationId xmlns:a16="http://schemas.microsoft.com/office/drawing/2014/main" id="{D2B31596-797F-4721-8314-F3C3008284C7}"/>
               </a:ext>
             </a:extLst>
           </p:cNvPr>
@@ -8123,7 +8146,7 @@
           <p:cNvPr id="18" name="text-96">
             <a:extLst xmlns:a="http://schemas.openxmlformats.org/drawingml/2006/main">
               <a:ext uri="{FF2B5EF4-FFF2-40B4-BE49-F238E27FC236}">
-                <a16:creationId xmlns:a16="http://schemas.microsoft.com/office/drawing/2014/main" id="{7134E0A0-A2CE-48BF-A9FA-6CBC20C3215C}"/>
+                <a16:creationId xmlns:a16="http://schemas.microsoft.com/office/drawing/2014/main" id="{7157200F-7480-4B7D-89C9-3C39F8A601CF}"/>
               </a:ext>
             </a:extLst>
           </p:cNvPr>
@@ -8235,7 +8258,7 @@
           <p:cNvPr id="19" name="text-97">
             <a:extLst xmlns:a="http://schemas.openxmlformats.org/drawingml/2006/main">
               <a:ext uri="{FF2B5EF4-FFF2-40B4-BE49-F238E27FC236}">
-                <a16:creationId xmlns:a16="http://schemas.microsoft.com/office/drawing/2014/main" id="{0EA3CC78-3A05-4276-9CC5-A1DEA1883006}"/>
+                <a16:creationId xmlns:a16="http://schemas.microsoft.com/office/drawing/2014/main" id="{8B42789A-AB31-4167-AB88-C7E8F7E2B596}"/>
               </a:ext>
             </a:extLst>
           </p:cNvPr>
@@ -8324,7 +8347,7 @@
           <p:cNvPr id="20" name="circuit-98">
             <a:extLst xmlns:a="http://schemas.openxmlformats.org/drawingml/2006/main">
               <a:ext uri="{FF2B5EF4-FFF2-40B4-BE49-F238E27FC236}">
-                <a16:creationId xmlns:a16="http://schemas.microsoft.com/office/drawing/2014/main" id="{DB407B34-2BDE-42E3-90C6-65504065EDFC}"/>
+                <a16:creationId xmlns:a16="http://schemas.microsoft.com/office/drawing/2014/main" id="{6C654746-AC76-430A-B981-B73DB9F25CF6}"/>
               </a:ext>
             </a:extLst>
           </p:cNvPr>
@@ -8356,7 +8379,7 @@
           <p:cNvPr id="21" name="circuit-99">
             <a:extLst xmlns:a="http://schemas.openxmlformats.org/drawingml/2006/main">
               <a:ext uri="{FF2B5EF4-FFF2-40B4-BE49-F238E27FC236}">
-                <a16:creationId xmlns:a16="http://schemas.microsoft.com/office/drawing/2014/main" id="{372136B0-56C4-4104-875A-8F1288A616BE}"/>
+                <a16:creationId xmlns:a16="http://schemas.microsoft.com/office/drawing/2014/main" id="{815A3381-8171-4D6E-A567-1F4242F6A6BC}"/>
               </a:ext>
             </a:extLst>
           </p:cNvPr>
@@ -8388,7 +8411,7 @@
           <p:cNvPr id="22" name="wire-100">
             <a:extLst xmlns:a="http://schemas.openxmlformats.org/drawingml/2006/main">
               <a:ext uri="{FF2B5EF4-FFF2-40B4-BE49-F238E27FC236}">
-                <a16:creationId xmlns:a16="http://schemas.microsoft.com/office/drawing/2014/main" id="{F74A872A-64FE-4612-9A0C-8BFC65EE15A3}"/>
+                <a16:creationId xmlns:a16="http://schemas.microsoft.com/office/drawing/2014/main" id="{46931CDE-23AE-492B-900A-A83583AD1F1D}"/>
               </a:ext>
             </a:extLst>
           </p:cNvPr>
@@ -8427,7 +8450,7 @@
           <p:cNvPr id="23" name="wire-101">
             <a:extLst xmlns:a="http://schemas.openxmlformats.org/drawingml/2006/main">
               <a:ext uri="{FF2B5EF4-FFF2-40B4-BE49-F238E27FC236}">
-                <a16:creationId xmlns:a16="http://schemas.microsoft.com/office/drawing/2014/main" id="{168454AA-98E7-4D1A-A29D-6C14BD372971}"/>
+                <a16:creationId xmlns:a16="http://schemas.microsoft.com/office/drawing/2014/main" id="{3670CE56-33A7-4CF6-9097-20C4A31F2776}"/>
               </a:ext>
             </a:extLst>
           </p:cNvPr>
@@ -8466,7 +8489,7 @@
           <p:cNvPr id="24" name="text-102">
             <a:extLst xmlns:a="http://schemas.openxmlformats.org/drawingml/2006/main">
               <a:ext uri="{FF2B5EF4-FFF2-40B4-BE49-F238E27FC236}">
-                <a16:creationId xmlns:a16="http://schemas.microsoft.com/office/drawing/2014/main" id="{50ACC1E6-BCA2-4DF0-A52E-A45D82B97E48}"/>
+                <a16:creationId xmlns:a16="http://schemas.microsoft.com/office/drawing/2014/main" id="{B8B6D1BC-AEA6-43AB-BFDD-F8A64B3036F3}"/>
               </a:ext>
             </a:extLst>
           </p:cNvPr>
@@ -8532,7 +8555,7 @@
           <p:cNvPr id="25" name="text-103">
             <a:extLst xmlns:a="http://schemas.openxmlformats.org/drawingml/2006/main">
               <a:ext uri="{FF2B5EF4-FFF2-40B4-BE49-F238E27FC236}">
-                <a16:creationId xmlns:a16="http://schemas.microsoft.com/office/drawing/2014/main" id="{F344C147-27D7-4159-B44E-166BCCF6D947}"/>
+                <a16:creationId xmlns:a16="http://schemas.microsoft.com/office/drawing/2014/main" id="{9272B35B-3283-4330-BDB2-D40207EBF3FC}"/>
               </a:ext>
             </a:extLst>
           </p:cNvPr>
@@ -8588,7 +8611,7 @@
                 <a:ea typeface="Meiryo"/>
                 <a:cs typeface="Meiryo"/>
               </a:rPr>
-              <a:t>同じ設定の図形をまとめ、変わった部分だけ描き直す</a:t>
+              <a:t>CPUは位置を計算し、描画回路は画素の色を作る</a:t>
             </a:r>
           </a:p>
         </p:txBody>
@@ -8596,7 +8619,7 @@
     </p:spTree>
     <p:extLst>
       <p:ext uri="{BB962C8B-B14F-4D97-AF65-F5344CB8AC3E}">
-        <p14:creationId xmlns:p14="http://schemas.microsoft.com/office/powerpoint/2010/main" val="29969453"/>
+        <p14:creationId xmlns:p14="http://schemas.microsoft.com/office/powerpoint/2010/main" val="1532464311"/>
       </p:ext>
     </p:extLst>
   </p:cSld>
@@ -8627,7 +8650,7 @@
           <p:cNvPr id="25" name="text-104">
             <a:extLst xmlns:a="http://schemas.openxmlformats.org/drawingml/2006/main">
               <a:ext uri="{FF2B5EF4-FFF2-40B4-BE49-F238E27FC236}">
-                <a16:creationId xmlns:a16="http://schemas.microsoft.com/office/drawing/2014/main" id="{476E555F-0BEA-489C-A962-CAA8078AAAD8}"/>
+                <a16:creationId xmlns:a16="http://schemas.microsoft.com/office/drawing/2014/main" id="{7C7AC933-8077-4F52-8FC6-6D7CA23402BD}"/>
               </a:ext>
             </a:extLst>
           </p:cNvPr>
@@ -8693,7 +8716,7 @@
           <p:cNvPr id="2" name="text-105">
             <a:extLst xmlns:a="http://schemas.openxmlformats.org/drawingml/2006/main">
               <a:ext uri="{FF2B5EF4-FFF2-40B4-BE49-F238E27FC236}">
-                <a16:creationId xmlns:a16="http://schemas.microsoft.com/office/drawing/2014/main" id="{1AEDB49A-7F71-4EE5-B7E6-A297E71DE80E}"/>
+                <a16:creationId xmlns:a16="http://schemas.microsoft.com/office/drawing/2014/main" id="{C36C4831-DFA2-4ACB-A770-F834D0215FB8}"/>
               </a:ext>
             </a:extLst>
           </p:cNvPr>
@@ -8759,7 +8782,7 @@
           <p:cNvPr id="3" name="circuit-106">
             <a:extLst xmlns:a="http://schemas.openxmlformats.org/drawingml/2006/main">
               <a:ext uri="{FF2B5EF4-FFF2-40B4-BE49-F238E27FC236}">
-                <a16:creationId xmlns:a16="http://schemas.microsoft.com/office/drawing/2014/main" id="{0B532AC3-CE17-42A9-A147-95308DE11325}"/>
+                <a16:creationId xmlns:a16="http://schemas.microsoft.com/office/drawing/2014/main" id="{C5964ADD-C748-4ECD-A6E3-CF9E99D3B015}"/>
               </a:ext>
             </a:extLst>
           </p:cNvPr>
@@ -8791,7 +8814,7 @@
           <p:cNvPr id="4" name="text-107">
             <a:extLst xmlns:a="http://schemas.openxmlformats.org/drawingml/2006/main">
               <a:ext uri="{FF2B5EF4-FFF2-40B4-BE49-F238E27FC236}">
-                <a16:creationId xmlns:a16="http://schemas.microsoft.com/office/drawing/2014/main" id="{B34A5BF8-AAF7-4A76-9E61-1DBC24D0264E}"/>
+                <a16:creationId xmlns:a16="http://schemas.microsoft.com/office/drawing/2014/main" id="{C096A6AE-D6ED-4DFA-87EA-A5460246B5D6}"/>
               </a:ext>
             </a:extLst>
           </p:cNvPr>
@@ -8880,7 +8903,7 @@
           <p:cNvPr id="5" name="circuit-108">
             <a:extLst xmlns:a="http://schemas.openxmlformats.org/drawingml/2006/main">
               <a:ext uri="{FF2B5EF4-FFF2-40B4-BE49-F238E27FC236}">
-                <a16:creationId xmlns:a16="http://schemas.microsoft.com/office/drawing/2014/main" id="{B7B18C24-702E-4410-8536-452AA5A3E772}"/>
+                <a16:creationId xmlns:a16="http://schemas.microsoft.com/office/drawing/2014/main" id="{7DE53A9A-1E98-407F-991E-0012D5DE06B6}"/>
               </a:ext>
             </a:extLst>
           </p:cNvPr>
@@ -8912,7 +8935,7 @@
           <p:cNvPr id="6" name="text-109">
             <a:extLst xmlns:a="http://schemas.openxmlformats.org/drawingml/2006/main">
               <a:ext uri="{FF2B5EF4-FFF2-40B4-BE49-F238E27FC236}">
-                <a16:creationId xmlns:a16="http://schemas.microsoft.com/office/drawing/2014/main" id="{A0401B4B-6898-461A-933E-8F627354167A}"/>
+                <a16:creationId xmlns:a16="http://schemas.microsoft.com/office/drawing/2014/main" id="{A1A4F632-FE78-43A3-BE4F-0A3C0DD6F228}"/>
               </a:ext>
             </a:extLst>
           </p:cNvPr>
@@ -9001,7 +9024,7 @@
           <p:cNvPr id="7" name="circuit-110">
             <a:extLst xmlns:a="http://schemas.openxmlformats.org/drawingml/2006/main">
               <a:ext uri="{FF2B5EF4-FFF2-40B4-BE49-F238E27FC236}">
-                <a16:creationId xmlns:a16="http://schemas.microsoft.com/office/drawing/2014/main" id="{3698B3B7-84A8-4A34-8B2F-B790E6CF9D0C}"/>
+                <a16:creationId xmlns:a16="http://schemas.microsoft.com/office/drawing/2014/main" id="{94AEB361-546D-4302-9DA0-6B4AF9B36CC1}"/>
               </a:ext>
             </a:extLst>
           </p:cNvPr>
@@ -9033,7 +9056,7 @@
           <p:cNvPr id="8" name="text-111">
             <a:extLst xmlns:a="http://schemas.openxmlformats.org/drawingml/2006/main">
               <a:ext uri="{FF2B5EF4-FFF2-40B4-BE49-F238E27FC236}">
-                <a16:creationId xmlns:a16="http://schemas.microsoft.com/office/drawing/2014/main" id="{8C672DB1-F1F5-419D-BB90-6BB29489DBA1}"/>
+                <a16:creationId xmlns:a16="http://schemas.microsoft.com/office/drawing/2014/main" id="{F393BB94-ED17-4AA3-A1C6-8FF1B0DC2720}"/>
               </a:ext>
             </a:extLst>
           </p:cNvPr>
@@ -9122,7 +9145,7 @@
           <p:cNvPr id="9" name="wire-112">
             <a:extLst xmlns:a="http://schemas.openxmlformats.org/drawingml/2006/main">
               <a:ext uri="{FF2B5EF4-FFF2-40B4-BE49-F238E27FC236}">
-                <a16:creationId xmlns:a16="http://schemas.microsoft.com/office/drawing/2014/main" id="{02DF3075-9355-4FB7-B17D-655352612D80}"/>
+                <a16:creationId xmlns:a16="http://schemas.microsoft.com/office/drawing/2014/main" id="{C631FDF4-0916-45DC-837F-9A1494AB346B}"/>
               </a:ext>
             </a:extLst>
           </p:cNvPr>
@@ -9161,7 +9184,7 @@
           <p:cNvPr id="10" name="logic-113">
             <a:extLst xmlns:a="http://schemas.openxmlformats.org/drawingml/2006/main">
               <a:ext uri="{FF2B5EF4-FFF2-40B4-BE49-F238E27FC236}">
-                <a16:creationId xmlns:a16="http://schemas.microsoft.com/office/drawing/2014/main" id="{DB2C5989-AC1D-46C9-BFAC-1298650BCE6E}"/>
+                <a16:creationId xmlns:a16="http://schemas.microsoft.com/office/drawing/2014/main" id="{4BA4D2E7-5322-4E04-8F5D-97202718E621}"/>
               </a:ext>
             </a:extLst>
           </p:cNvPr>
@@ -9206,7 +9229,7 @@
           <p:cNvPr id="11" name="wire-114">
             <a:extLst xmlns:a="http://schemas.openxmlformats.org/drawingml/2006/main">
               <a:ext uri="{FF2B5EF4-FFF2-40B4-BE49-F238E27FC236}">
-                <a16:creationId xmlns:a16="http://schemas.microsoft.com/office/drawing/2014/main" id="{1E665D3A-2C95-4FFA-9FF8-FBFE7E07CB5B}"/>
+                <a16:creationId xmlns:a16="http://schemas.microsoft.com/office/drawing/2014/main" id="{091E1164-3C24-4030-89C9-66D4BC450E2E}"/>
               </a:ext>
             </a:extLst>
           </p:cNvPr>
@@ -9245,7 +9268,7 @@
           <p:cNvPr id="12" name="logic-115">
             <a:extLst xmlns:a="http://schemas.openxmlformats.org/drawingml/2006/main">
               <a:ext uri="{FF2B5EF4-FFF2-40B4-BE49-F238E27FC236}">
-                <a16:creationId xmlns:a16="http://schemas.microsoft.com/office/drawing/2014/main" id="{70BC985A-7D9C-47C8-89CD-541CDF41A725}"/>
+                <a16:creationId xmlns:a16="http://schemas.microsoft.com/office/drawing/2014/main" id="{9B81035E-7FA4-475C-BAA2-498E5139BFA7}"/>
               </a:ext>
             </a:extLst>
           </p:cNvPr>
@@ -9290,7 +9313,7 @@
           <p:cNvPr id="13" name="text-116">
             <a:extLst xmlns:a="http://schemas.openxmlformats.org/drawingml/2006/main">
               <a:ext uri="{FF2B5EF4-FFF2-40B4-BE49-F238E27FC236}">
-                <a16:creationId xmlns:a16="http://schemas.microsoft.com/office/drawing/2014/main" id="{139A4F99-336D-4EB1-A79F-EB14ED662599}"/>
+                <a16:creationId xmlns:a16="http://schemas.microsoft.com/office/drawing/2014/main" id="{9EB4D2A7-B9BD-4581-932A-1B876E2BB795}"/>
               </a:ext>
             </a:extLst>
           </p:cNvPr>
@@ -9356,7 +9379,7 @@
           <p:cNvPr id="14" name="text-117">
             <a:extLst xmlns:a="http://schemas.openxmlformats.org/drawingml/2006/main">
               <a:ext uri="{FF2B5EF4-FFF2-40B4-BE49-F238E27FC236}">
-                <a16:creationId xmlns:a16="http://schemas.microsoft.com/office/drawing/2014/main" id="{A07574CF-9321-49A7-976A-2EB5582219DE}"/>
+                <a16:creationId xmlns:a16="http://schemas.microsoft.com/office/drawing/2014/main" id="{BB73D2C2-CEAC-49D1-913D-D30469EED3DB}"/>
               </a:ext>
             </a:extLst>
           </p:cNvPr>
@@ -9422,7 +9445,7 @@
           <p:cNvPr id="15" name="text-118">
             <a:extLst xmlns:a="http://schemas.openxmlformats.org/drawingml/2006/main">
               <a:ext uri="{FF2B5EF4-FFF2-40B4-BE49-F238E27FC236}">
-                <a16:creationId xmlns:a16="http://schemas.microsoft.com/office/drawing/2014/main" id="{79B3EADF-D90A-4AA8-9C3C-FC75B07B7B11}"/>
+                <a16:creationId xmlns:a16="http://schemas.microsoft.com/office/drawing/2014/main" id="{4F0ECE25-CAA4-4A94-8CF0-0AABFEC88EF1}"/>
               </a:ext>
             </a:extLst>
           </p:cNvPr>
@@ -9488,7 +9511,7 @@
           <p:cNvPr id="16" name="circuit-119">
             <a:extLst xmlns:a="http://schemas.openxmlformats.org/drawingml/2006/main">
               <a:ext uri="{FF2B5EF4-FFF2-40B4-BE49-F238E27FC236}">
-                <a16:creationId xmlns:a16="http://schemas.microsoft.com/office/drawing/2014/main" id="{9D091537-FE85-433A-9E76-A41DAC4E8AA7}"/>
+                <a16:creationId xmlns:a16="http://schemas.microsoft.com/office/drawing/2014/main" id="{A65FC2B3-8738-49CE-97BB-04C1069653D7}"/>
               </a:ext>
             </a:extLst>
           </p:cNvPr>
@@ -9520,7 +9543,7 @@
           <p:cNvPr id="17" name="text-120">
             <a:extLst xmlns:a="http://schemas.openxmlformats.org/drawingml/2006/main">
               <a:ext uri="{FF2B5EF4-FFF2-40B4-BE49-F238E27FC236}">
-                <a16:creationId xmlns:a16="http://schemas.microsoft.com/office/drawing/2014/main" id="{013D2C10-CA38-4480-B532-220039EC32DC}"/>
+                <a16:creationId xmlns:a16="http://schemas.microsoft.com/office/drawing/2014/main" id="{93E034CD-87CF-4636-A1F1-E52D492164E5}"/>
               </a:ext>
             </a:extLst>
           </p:cNvPr>
@@ -9586,7 +9609,7 @@
           <p:cNvPr id="18" name="text-121">
             <a:extLst xmlns:a="http://schemas.openxmlformats.org/drawingml/2006/main">
               <a:ext uri="{FF2B5EF4-FFF2-40B4-BE49-F238E27FC236}">
-                <a16:creationId xmlns:a16="http://schemas.microsoft.com/office/drawing/2014/main" id="{7F6A4D07-D058-461B-9BA4-E713CBE69DCE}"/>
+                <a16:creationId xmlns:a16="http://schemas.microsoft.com/office/drawing/2014/main" id="{01F6A79D-6EB9-4B57-ACEF-7757CB3E8001}"/>
               </a:ext>
             </a:extLst>
           </p:cNvPr>
@@ -9652,7 +9675,7 @@
           <p:cNvPr id="19" name="circuit-122">
             <a:extLst xmlns:a="http://schemas.openxmlformats.org/drawingml/2006/main">
               <a:ext uri="{FF2B5EF4-FFF2-40B4-BE49-F238E27FC236}">
-                <a16:creationId xmlns:a16="http://schemas.microsoft.com/office/drawing/2014/main" id="{B78D1FA6-8AB5-4A89-A5FF-C1CD01EA4406}"/>
+                <a16:creationId xmlns:a16="http://schemas.microsoft.com/office/drawing/2014/main" id="{8686FD7C-0092-4651-BDC3-374F79ACC78C}"/>
               </a:ext>
             </a:extLst>
           </p:cNvPr>
@@ -9684,7 +9707,7 @@
           <p:cNvPr id="20" name="text-123">
             <a:extLst xmlns:a="http://schemas.openxmlformats.org/drawingml/2006/main">
               <a:ext uri="{FF2B5EF4-FFF2-40B4-BE49-F238E27FC236}">
-                <a16:creationId xmlns:a16="http://schemas.microsoft.com/office/drawing/2014/main" id="{314ADDAB-33DF-44ED-BBEC-675FD6E82C7C}"/>
+                <a16:creationId xmlns:a16="http://schemas.microsoft.com/office/drawing/2014/main" id="{5E4EC65C-0E63-45A0-8B00-9D18B99F7EB1}"/>
               </a:ext>
             </a:extLst>
           </p:cNvPr>
@@ -9750,7 +9773,7 @@
           <p:cNvPr id="21" name="text-124">
             <a:extLst xmlns:a="http://schemas.openxmlformats.org/drawingml/2006/main">
               <a:ext uri="{FF2B5EF4-FFF2-40B4-BE49-F238E27FC236}">
-                <a16:creationId xmlns:a16="http://schemas.microsoft.com/office/drawing/2014/main" id="{30D461AD-5C54-472C-9931-F51F94DD6425}"/>
+                <a16:creationId xmlns:a16="http://schemas.microsoft.com/office/drawing/2014/main" id="{DD182184-5C06-4782-9D1C-A7580640E06D}"/>
               </a:ext>
             </a:extLst>
           </p:cNvPr>
@@ -9816,7 +9839,7 @@
           <p:cNvPr id="22" name="circuit-125">
             <a:extLst xmlns:a="http://schemas.openxmlformats.org/drawingml/2006/main">
               <a:ext uri="{FF2B5EF4-FFF2-40B4-BE49-F238E27FC236}">
-                <a16:creationId xmlns:a16="http://schemas.microsoft.com/office/drawing/2014/main" id="{C7177026-80A1-440E-9B76-ED85C0D095A4}"/>
+                <a16:creationId xmlns:a16="http://schemas.microsoft.com/office/drawing/2014/main" id="{DF8F08F4-A066-4093-B18C-F05A327F81ED}"/>
               </a:ext>
             </a:extLst>
           </p:cNvPr>
@@ -9848,7 +9871,7 @@
           <p:cNvPr id="23" name="text-126">
             <a:extLst xmlns:a="http://schemas.openxmlformats.org/drawingml/2006/main">
               <a:ext uri="{FF2B5EF4-FFF2-40B4-BE49-F238E27FC236}">
-                <a16:creationId xmlns:a16="http://schemas.microsoft.com/office/drawing/2014/main" id="{64EE03B6-CD1B-44FD-94CD-5BBC3112A7CF}"/>
+                <a16:creationId xmlns:a16="http://schemas.microsoft.com/office/drawing/2014/main" id="{B6E7DBFC-5F55-4486-A7F6-49F240109E42}"/>
               </a:ext>
             </a:extLst>
           </p:cNvPr>
@@ -9914,7 +9937,7 @@
           <p:cNvPr id="24" name="text-127">
             <a:extLst xmlns:a="http://schemas.openxmlformats.org/drawingml/2006/main">
               <a:ext uri="{FF2B5EF4-FFF2-40B4-BE49-F238E27FC236}">
-                <a16:creationId xmlns:a16="http://schemas.microsoft.com/office/drawing/2014/main" id="{2A465313-E59B-44D7-B886-561C793B837C}"/>
+                <a16:creationId xmlns:a16="http://schemas.microsoft.com/office/drawing/2014/main" id="{5F0AC044-6331-445E-A8B9-90FE4E72D1C9}"/>
               </a:ext>
             </a:extLst>
           </p:cNvPr>
@@ -9978,7 +10001,7 @@
     </p:spTree>
     <p:extLst>
       <p:ext uri="{BB962C8B-B14F-4D97-AF65-F5344CB8AC3E}">
-        <p14:creationId xmlns:p14="http://schemas.microsoft.com/office/powerpoint/2010/main" val="1464704116"/>
+        <p14:creationId xmlns:p14="http://schemas.microsoft.com/office/powerpoint/2010/main" val="1118805030"/>
       </p:ext>
     </p:extLst>
   </p:cSld>
@@ -10009,7 +10032,7 @@
           <p:cNvPr id="18" name="text-128">
             <a:extLst xmlns:a="http://schemas.openxmlformats.org/drawingml/2006/main">
               <a:ext uri="{FF2B5EF4-FFF2-40B4-BE49-F238E27FC236}">
-                <a16:creationId xmlns:a16="http://schemas.microsoft.com/office/drawing/2014/main" id="{53EB9674-7924-47C9-8896-0759E9AC0A06}"/>
+                <a16:creationId xmlns:a16="http://schemas.microsoft.com/office/drawing/2014/main" id="{FDAE753E-FDC8-4ADA-A5A4-DD76526C63AA}"/>
               </a:ext>
             </a:extLst>
           </p:cNvPr>
@@ -10075,7 +10098,7 @@
           <p:cNvPr id="2" name="text-129">
             <a:extLst xmlns:a="http://schemas.openxmlformats.org/drawingml/2006/main">
               <a:ext uri="{FF2B5EF4-FFF2-40B4-BE49-F238E27FC236}">
-                <a16:creationId xmlns:a16="http://schemas.microsoft.com/office/drawing/2014/main" id="{6D9339F9-1ADE-404F-98C7-4EF87212FA9E}"/>
+                <a16:creationId xmlns:a16="http://schemas.microsoft.com/office/drawing/2014/main" id="{E393B2AA-5336-4EAC-84B9-47A874DADB8C}"/>
               </a:ext>
             </a:extLst>
           </p:cNvPr>
@@ -10141,7 +10164,7 @@
           <p:cNvPr id="3" name="text-130">
             <a:extLst xmlns:a="http://schemas.openxmlformats.org/drawingml/2006/main">
               <a:ext uri="{FF2B5EF4-FFF2-40B4-BE49-F238E27FC236}">
-                <a16:creationId xmlns:a16="http://schemas.microsoft.com/office/drawing/2014/main" id="{9576D761-B315-48C2-B00C-618905F2BB0A}"/>
+                <a16:creationId xmlns:a16="http://schemas.microsoft.com/office/drawing/2014/main" id="{0FBA2B06-D1D6-47F8-9A2B-4CFDA538911A}"/>
               </a:ext>
             </a:extLst>
           </p:cNvPr>
@@ -10207,7 +10230,7 @@
           <p:cNvPr id="4" name="text-131">
             <a:extLst xmlns:a="http://schemas.openxmlformats.org/drawingml/2006/main">
               <a:ext uri="{FF2B5EF4-FFF2-40B4-BE49-F238E27FC236}">
-                <a16:creationId xmlns:a16="http://schemas.microsoft.com/office/drawing/2014/main" id="{65B86BCF-8A27-4187-8D38-B4FAAF33DC08}"/>
+                <a16:creationId xmlns:a16="http://schemas.microsoft.com/office/drawing/2014/main" id="{6294289F-4DA6-4954-80C8-EBE8BB066E55}"/>
               </a:ext>
             </a:extLst>
           </p:cNvPr>
@@ -10273,7 +10296,7 @@
           <p:cNvPr id="5" name="circuit-132">
             <a:extLst xmlns:a="http://schemas.openxmlformats.org/drawingml/2006/main">
               <a:ext uri="{FF2B5EF4-FFF2-40B4-BE49-F238E27FC236}">
-                <a16:creationId xmlns:a16="http://schemas.microsoft.com/office/drawing/2014/main" id="{9E02BF4F-74F2-416D-8AF6-7DA84A10BDDC}"/>
+                <a16:creationId xmlns:a16="http://schemas.microsoft.com/office/drawing/2014/main" id="{86CF4E90-BDEC-4E9C-9075-0BA562407E3B}"/>
               </a:ext>
             </a:extLst>
           </p:cNvPr>
@@ -10305,7 +10328,7 @@
           <p:cNvPr id="6" name="text-133">
             <a:extLst xmlns:a="http://schemas.openxmlformats.org/drawingml/2006/main">
               <a:ext uri="{FF2B5EF4-FFF2-40B4-BE49-F238E27FC236}">
-                <a16:creationId xmlns:a16="http://schemas.microsoft.com/office/drawing/2014/main" id="{DAADE196-7872-4824-A14F-B0EB6E821C80}"/>
+                <a16:creationId xmlns:a16="http://schemas.microsoft.com/office/drawing/2014/main" id="{75987A9D-2762-4C10-BDBB-B7C3C289827E}"/>
               </a:ext>
             </a:extLst>
           </p:cNvPr>
@@ -10371,7 +10394,7 @@
           <p:cNvPr id="7" name="circuit-134">
             <a:extLst xmlns:a="http://schemas.openxmlformats.org/drawingml/2006/main">
               <a:ext uri="{FF2B5EF4-FFF2-40B4-BE49-F238E27FC236}">
-                <a16:creationId xmlns:a16="http://schemas.microsoft.com/office/drawing/2014/main" id="{09B5032D-2CC3-4F00-B752-4E021294844E}"/>
+                <a16:creationId xmlns:a16="http://schemas.microsoft.com/office/drawing/2014/main" id="{7ECA7D92-4DAD-4B8D-AA62-724E52344D99}"/>
               </a:ext>
             </a:extLst>
           </p:cNvPr>
@@ -10403,7 +10426,7 @@
           <p:cNvPr id="8" name="text-135">
             <a:extLst xmlns:a="http://schemas.openxmlformats.org/drawingml/2006/main">
               <a:ext uri="{FF2B5EF4-FFF2-40B4-BE49-F238E27FC236}">
-                <a16:creationId xmlns:a16="http://schemas.microsoft.com/office/drawing/2014/main" id="{ACE97902-C858-4DC4-BB48-9018B286DBE7}"/>
+                <a16:creationId xmlns:a16="http://schemas.microsoft.com/office/drawing/2014/main" id="{6856393F-8BB1-43AC-9154-7455780AEBC9}"/>
               </a:ext>
             </a:extLst>
           </p:cNvPr>
@@ -10469,7 +10492,7 @@
           <p:cNvPr id="9" name="circuit-136">
             <a:extLst xmlns:a="http://schemas.openxmlformats.org/drawingml/2006/main">
               <a:ext uri="{FF2B5EF4-FFF2-40B4-BE49-F238E27FC236}">
-                <a16:creationId xmlns:a16="http://schemas.microsoft.com/office/drawing/2014/main" id="{4978ED78-C59A-4A1B-BB40-741DBD95C691}"/>
+                <a16:creationId xmlns:a16="http://schemas.microsoft.com/office/drawing/2014/main" id="{5A1C61DE-30F4-46F1-A4CF-9AD705E714FE}"/>
               </a:ext>
             </a:extLst>
           </p:cNvPr>
@@ -10501,7 +10524,7 @@
           <p:cNvPr id="10" name="text-137">
             <a:extLst xmlns:a="http://schemas.openxmlformats.org/drawingml/2006/main">
               <a:ext uri="{FF2B5EF4-FFF2-40B4-BE49-F238E27FC236}">
-                <a16:creationId xmlns:a16="http://schemas.microsoft.com/office/drawing/2014/main" id="{0E69CBF7-B367-4CD9-A7D3-7145429CE5A1}"/>
+                <a16:creationId xmlns:a16="http://schemas.microsoft.com/office/drawing/2014/main" id="{4B031C8D-A2D7-4B37-8DF8-53AA7BEA5FB9}"/>
               </a:ext>
             </a:extLst>
           </p:cNvPr>
@@ -10567,7 +10590,7 @@
           <p:cNvPr id="11" name="circuit-138">
             <a:extLst xmlns:a="http://schemas.openxmlformats.org/drawingml/2006/main">
               <a:ext uri="{FF2B5EF4-FFF2-40B4-BE49-F238E27FC236}">
-                <a16:creationId xmlns:a16="http://schemas.microsoft.com/office/drawing/2014/main" id="{35518EFC-7351-4021-9B93-6C0F611B659C}"/>
+                <a16:creationId xmlns:a16="http://schemas.microsoft.com/office/drawing/2014/main" id="{72031F5C-3A8B-4E09-92C8-3952079F5071}"/>
               </a:ext>
             </a:extLst>
           </p:cNvPr>
@@ -10599,7 +10622,7 @@
           <p:cNvPr id="12" name="text-139">
             <a:extLst xmlns:a="http://schemas.openxmlformats.org/drawingml/2006/main">
               <a:ext uri="{FF2B5EF4-FFF2-40B4-BE49-F238E27FC236}">
-                <a16:creationId xmlns:a16="http://schemas.microsoft.com/office/drawing/2014/main" id="{04A8987C-F8F7-44B6-B705-875D074156C5}"/>
+                <a16:creationId xmlns:a16="http://schemas.microsoft.com/office/drawing/2014/main" id="{9FD72DEB-B4DA-427B-A327-3C6E85BD351E}"/>
               </a:ext>
             </a:extLst>
           </p:cNvPr>
@@ -10665,7 +10688,7 @@
           <p:cNvPr id="13" name="wire-140">
             <a:extLst xmlns:a="http://schemas.openxmlformats.org/drawingml/2006/main">
               <a:ext uri="{FF2B5EF4-FFF2-40B4-BE49-F238E27FC236}">
-                <a16:creationId xmlns:a16="http://schemas.microsoft.com/office/drawing/2014/main" id="{E9FA8D79-7EA7-4109-9C2F-0B62FE9DC064}"/>
+                <a16:creationId xmlns:a16="http://schemas.microsoft.com/office/drawing/2014/main" id="{3971516F-A131-4177-A137-537297BBBCBC}"/>
               </a:ext>
             </a:extLst>
           </p:cNvPr>
@@ -10704,7 +10727,7 @@
           <p:cNvPr id="14" name="logic-141">
             <a:extLst xmlns:a="http://schemas.openxmlformats.org/drawingml/2006/main">
               <a:ext uri="{FF2B5EF4-FFF2-40B4-BE49-F238E27FC236}">
-                <a16:creationId xmlns:a16="http://schemas.microsoft.com/office/drawing/2014/main" id="{FCAD6AED-57C6-4F44-BCC2-641A877BCF4A}"/>
+                <a16:creationId xmlns:a16="http://schemas.microsoft.com/office/drawing/2014/main" id="{9C5EA6EE-4B2A-4367-91E7-5236DE110D1B}"/>
               </a:ext>
             </a:extLst>
           </p:cNvPr>
@@ -10749,7 +10772,7 @@
           <p:cNvPr id="15" name="text-142">
             <a:extLst xmlns:a="http://schemas.openxmlformats.org/drawingml/2006/main">
               <a:ext uri="{FF2B5EF4-FFF2-40B4-BE49-F238E27FC236}">
-                <a16:creationId xmlns:a16="http://schemas.microsoft.com/office/drawing/2014/main" id="{87C3AFEC-0A5D-4F09-89EC-12A2C031B843}"/>
+                <a16:creationId xmlns:a16="http://schemas.microsoft.com/office/drawing/2014/main" id="{10CF73DF-86BD-43E3-9082-25FF82A41782}"/>
               </a:ext>
             </a:extLst>
           </p:cNvPr>
@@ -10838,7 +10861,7 @@
           <p:cNvPr id="16" name="text-143">
             <a:extLst xmlns:a="http://schemas.openxmlformats.org/drawingml/2006/main">
               <a:ext uri="{FF2B5EF4-FFF2-40B4-BE49-F238E27FC236}">
-                <a16:creationId xmlns:a16="http://schemas.microsoft.com/office/drawing/2014/main" id="{5D882871-2B15-461A-8ABB-35A9B7E5392D}"/>
+                <a16:creationId xmlns:a16="http://schemas.microsoft.com/office/drawing/2014/main" id="{5D42575F-1B9B-4393-A56B-8DCD5D52778F}"/>
               </a:ext>
             </a:extLst>
           </p:cNvPr>
@@ -10927,7 +10950,7 @@
           <p:cNvPr id="17" name="text-144">
             <a:extLst xmlns:a="http://schemas.openxmlformats.org/drawingml/2006/main">
               <a:ext uri="{FF2B5EF4-FFF2-40B4-BE49-F238E27FC236}">
-                <a16:creationId xmlns:a16="http://schemas.microsoft.com/office/drawing/2014/main" id="{E035ECBC-0006-4E77-8ED1-3CD3DC57EAF2}"/>
+                <a16:creationId xmlns:a16="http://schemas.microsoft.com/office/drawing/2014/main" id="{0EB040B9-3563-4ECD-BCCB-AAEADEA9725F}"/>
               </a:ext>
             </a:extLst>
           </p:cNvPr>
@@ -10991,7 +11014,7 @@
     </p:spTree>
     <p:extLst>
       <p:ext uri="{BB962C8B-B14F-4D97-AF65-F5344CB8AC3E}">
-        <p14:creationId xmlns:p14="http://schemas.microsoft.com/office/powerpoint/2010/main" val="242002097"/>
+        <p14:creationId xmlns:p14="http://schemas.microsoft.com/office/powerpoint/2010/main" val="1258230437"/>
       </p:ext>
     </p:extLst>
   </p:cSld>
@@ -11022,7 +11045,7 @@
           <p:cNvPr id="8" name="text-145">
             <a:extLst xmlns:a="http://schemas.openxmlformats.org/drawingml/2006/main">
               <a:ext uri="{FF2B5EF4-FFF2-40B4-BE49-F238E27FC236}">
-                <a16:creationId xmlns:a16="http://schemas.microsoft.com/office/drawing/2014/main" id="{25132563-2EF5-408C-9019-90F97990A184}"/>
+                <a16:creationId xmlns:a16="http://schemas.microsoft.com/office/drawing/2014/main" id="{58E0AC88-AE71-4D4B-9A58-CBBA686DABB0}"/>
               </a:ext>
             </a:extLst>
           </p:cNvPr>
@@ -11088,7 +11111,7 @@
           <p:cNvPr id="2" name="text-146">
             <a:extLst xmlns:a="http://schemas.openxmlformats.org/drawingml/2006/main">
               <a:ext uri="{FF2B5EF4-FFF2-40B4-BE49-F238E27FC236}">
-                <a16:creationId xmlns:a16="http://schemas.microsoft.com/office/drawing/2014/main" id="{25C6EB79-990A-4539-AE18-4858FC88DFB3}"/>
+                <a16:creationId xmlns:a16="http://schemas.microsoft.com/office/drawing/2014/main" id="{5CAB629A-B03B-45E9-B215-25AAC4F20073}"/>
               </a:ext>
             </a:extLst>
           </p:cNvPr>
@@ -11154,7 +11177,7 @@
           <p:cNvPr id="3" name="">
             <a:extLst xmlns:a="http://schemas.openxmlformats.org/drawingml/2006/main">
               <a:ext uri="{FF2B5EF4-FFF2-40B4-BE49-F238E27FC236}">
-                <a16:creationId xmlns:a16="http://schemas.microsoft.com/office/drawing/2014/main" id="{AB02E750-0328-43A1-8439-094721D2BCE5}"/>
+                <a16:creationId xmlns:a16="http://schemas.microsoft.com/office/drawing/2014/main" id="{A1D8D0B3-31E2-4276-94D8-4D2885837445}"/>
               </a:ext>
             </a:extLst>
           </p:cNvPr>
@@ -11164,7 +11187,7 @@
           <p:nvPr/>
         </p:nvPicPr>
         <p:blipFill>
-          <a:blip xmlns:r="http://schemas.openxmlformats.org/officeDocument/2006/relationships" xmlns:a="http://schemas.openxmlformats.org/drawingml/2006/main" r:embed="R8d83fa87adb74853"/>
+          <a:blip xmlns:r="http://schemas.openxmlformats.org/officeDocument/2006/relationships" xmlns:a="http://schemas.openxmlformats.org/drawingml/2006/main" r:embed="R17e07fd10bb640ce"/>
           <a:stretch xmlns:a="http://schemas.openxmlformats.org/drawingml/2006/main"/>
         </p:blipFill>
         <p:spPr>
@@ -11182,7 +11205,7 @@
           <p:cNvPr id="4" name="text-147">
             <a:extLst xmlns:a="http://schemas.openxmlformats.org/drawingml/2006/main">
               <a:ext uri="{FF2B5EF4-FFF2-40B4-BE49-F238E27FC236}">
-                <a16:creationId xmlns:a16="http://schemas.microsoft.com/office/drawing/2014/main" id="{0F54C650-7DD8-40A7-A4A4-264E452E937D}"/>
+                <a16:creationId xmlns:a16="http://schemas.microsoft.com/office/drawing/2014/main" id="{94CABBFA-838E-4FE7-9557-4FF817EC3C20}"/>
               </a:ext>
             </a:extLst>
           </p:cNvPr>
@@ -11271,7 +11294,7 @@
           <p:cNvPr id="5" name="text-148">
             <a:extLst xmlns:a="http://schemas.openxmlformats.org/drawingml/2006/main">
               <a:ext uri="{FF2B5EF4-FFF2-40B4-BE49-F238E27FC236}">
-                <a16:creationId xmlns:a16="http://schemas.microsoft.com/office/drawing/2014/main" id="{8919EB1B-4B7C-4719-A699-840B76F36281}"/>
+                <a16:creationId xmlns:a16="http://schemas.microsoft.com/office/drawing/2014/main" id="{775A14DA-FF14-4D26-98A4-07499AF8F637}"/>
               </a:ext>
             </a:extLst>
           </p:cNvPr>
@@ -11327,7 +11350,7 @@
                 <a:ea typeface="Meiryo"/>
                 <a:cs typeface="Meiryo"/>
               </a:rPr>
-              <a:t>接続比較では27画面で</a:t>
+              <a:t>接続比較では9画面で</a:t>
             </a:r>
           </a:p>
           <a:p xmlns:a="http://schemas.openxmlformats.org/drawingml/2006/main">
@@ -11360,7 +11383,7 @@
           <p:cNvPr id="6" name="text-149">
             <a:extLst xmlns:a="http://schemas.openxmlformats.org/drawingml/2006/main">
               <a:ext uri="{FF2B5EF4-FFF2-40B4-BE49-F238E27FC236}">
-                <a16:creationId xmlns:a16="http://schemas.microsoft.com/office/drawing/2014/main" id="{7F464D15-F10B-4422-95B5-5E74385CED7E}"/>
+                <a16:creationId xmlns:a16="http://schemas.microsoft.com/office/drawing/2014/main" id="{C7D28028-B407-438F-AB05-355487CDADC6}"/>
               </a:ext>
             </a:extLst>
           </p:cNvPr>
@@ -11449,7 +11472,7 @@
           <p:cNvPr id="7" name="text-150">
             <a:extLst xmlns:a="http://schemas.openxmlformats.org/drawingml/2006/main">
               <a:ext uri="{FF2B5EF4-FFF2-40B4-BE49-F238E27FC236}">
-                <a16:creationId xmlns:a16="http://schemas.microsoft.com/office/drawing/2014/main" id="{031564CA-CCAC-47B3-8B30-5007414359AF}"/>
+                <a16:creationId xmlns:a16="http://schemas.microsoft.com/office/drawing/2014/main" id="{5B3EB882-38E8-4113-8BF6-5D6B628A72C9}"/>
               </a:ext>
             </a:extLst>
           </p:cNvPr>
@@ -11513,7 +11536,7 @@
     </p:spTree>
     <p:extLst>
       <p:ext uri="{BB962C8B-B14F-4D97-AF65-F5344CB8AC3E}">
-        <p14:creationId xmlns:p14="http://schemas.microsoft.com/office/powerpoint/2010/main" val="2091064138"/>
+        <p14:creationId xmlns:p14="http://schemas.microsoft.com/office/powerpoint/2010/main" val="1789385157"/>
       </p:ext>
     </p:extLst>
   </p:cSld>
@@ -11544,7 +11567,7 @@
           <p:cNvPr id="7" name="text-151">
             <a:extLst xmlns:a="http://schemas.openxmlformats.org/drawingml/2006/main">
               <a:ext uri="{FF2B5EF4-FFF2-40B4-BE49-F238E27FC236}">
-                <a16:creationId xmlns:a16="http://schemas.microsoft.com/office/drawing/2014/main" id="{A26B0A78-5355-4B2D-99F0-835C968BF305}"/>
+                <a16:creationId xmlns:a16="http://schemas.microsoft.com/office/drawing/2014/main" id="{D36AD50A-962A-4700-A7D4-60F21150504A}"/>
               </a:ext>
             </a:extLst>
           </p:cNvPr>
@@ -11610,7 +11633,7 @@
           <p:cNvPr id="2" name="text-152">
             <a:extLst xmlns:a="http://schemas.openxmlformats.org/drawingml/2006/main">
               <a:ext uri="{FF2B5EF4-FFF2-40B4-BE49-F238E27FC236}">
-                <a16:creationId xmlns:a16="http://schemas.microsoft.com/office/drawing/2014/main" id="{D6212C4E-ABF4-43EF-8024-CC2AA7422BBB}"/>
+                <a16:creationId xmlns:a16="http://schemas.microsoft.com/office/drawing/2014/main" id="{4C7B0578-FB22-42CC-BC1D-0B20638BB08A}"/>
               </a:ext>
             </a:extLst>
           </p:cNvPr>
@@ -11676,7 +11699,7 @@
           <p:cNvPr id="3" name="text-153">
             <a:extLst xmlns:a="http://schemas.openxmlformats.org/drawingml/2006/main">
               <a:ext uri="{FF2B5EF4-FFF2-40B4-BE49-F238E27FC236}">
-                <a16:creationId xmlns:a16="http://schemas.microsoft.com/office/drawing/2014/main" id="{EBB85C79-3862-45FE-B64C-B883BAC1555C}"/>
+                <a16:creationId xmlns:a16="http://schemas.microsoft.com/office/drawing/2014/main" id="{24EF48EC-55F7-4E25-BCC0-844FAD5177BE}"/>
               </a:ext>
             </a:extLst>
           </p:cNvPr>
@@ -11765,7 +11788,7 @@
           <p:cNvPr id="4" name="text-154">
             <a:extLst xmlns:a="http://schemas.openxmlformats.org/drawingml/2006/main">
               <a:ext uri="{FF2B5EF4-FFF2-40B4-BE49-F238E27FC236}">
-                <a16:creationId xmlns:a16="http://schemas.microsoft.com/office/drawing/2014/main" id="{32A8F631-C182-431A-A170-9ECF8204C42F}"/>
+                <a16:creationId xmlns:a16="http://schemas.microsoft.com/office/drawing/2014/main" id="{F09DC6CF-E95D-49DA-86CC-716F19AEEFC1}"/>
               </a:ext>
             </a:extLst>
           </p:cNvPr>
@@ -11821,7 +11844,7 @@
                 <a:ea typeface="Meiryo"/>
                 <a:cs typeface="Meiryo"/>
               </a:rPr>
-              <a:t>試したゲーム条件では、転送回路の追加や</a:t>
+              <a:t>全体描画の比較では、転送回路の追加や</a:t>
             </a:r>
           </a:p>
           <a:p xmlns:a="http://schemas.openxmlformats.org/drawingml/2006/main">
@@ -11854,7 +11877,7 @@
           <p:cNvPr id="5" name="text-155">
             <a:extLst xmlns:a="http://schemas.openxmlformats.org/drawingml/2006/main">
               <a:ext uri="{FF2B5EF4-FFF2-40B4-BE49-F238E27FC236}">
-                <a16:creationId xmlns:a16="http://schemas.microsoft.com/office/drawing/2014/main" id="{009912A1-A61A-462E-91BB-447C2FA7E304}"/>
+                <a16:creationId xmlns:a16="http://schemas.microsoft.com/office/drawing/2014/main" id="{941BA1D3-51A4-4A4A-AC8A-066A7AF3712C}"/>
               </a:ext>
             </a:extLst>
           </p:cNvPr>
@@ -11920,7 +11943,7 @@
           <p:cNvPr id="6" name="text-156">
             <a:extLst xmlns:a="http://schemas.openxmlformats.org/drawingml/2006/main">
               <a:ext uri="{FF2B5EF4-FFF2-40B4-BE49-F238E27FC236}">
-                <a16:creationId xmlns:a16="http://schemas.microsoft.com/office/drawing/2014/main" id="{2AF675EE-D333-400A-9DF2-5AD95A1314E1}"/>
+                <a16:creationId xmlns:a16="http://schemas.microsoft.com/office/drawing/2014/main" id="{A0D2C7CE-6E17-4132-B709-721773AF7B15}"/>
               </a:ext>
             </a:extLst>
           </p:cNvPr>
@@ -12007,7 +12030,7 @@
     </p:spTree>
     <p:extLst>
       <p:ext uri="{BB962C8B-B14F-4D97-AF65-F5344CB8AC3E}">
-        <p14:creationId xmlns:p14="http://schemas.microsoft.com/office/powerpoint/2010/main" val="288111047"/>
+        <p14:creationId xmlns:p14="http://schemas.microsoft.com/office/powerpoint/2010/main" val="1741310094"/>
       </p:ext>
     </p:extLst>
   </p:cSld>

</xml_diff>

<commit_message>
Focus research documents on console integration
</commit_message>
<xml_diff>
--- a/docs/presentation/中間発表_主要事項.pptx
+++ b/docs/presentation/中間発表_主要事項.pptx
@@ -2,20 +2,20 @@
 <file path=ppt/presentation.xml><?xml version="1.0" encoding="utf-8"?>
 <p:presentation xmlns:p="http://schemas.openxmlformats.org/presentationml/2006/main">
   <p:sldMasterIdLst>
-    <p:sldMasterId xmlns:r="http://schemas.openxmlformats.org/officeDocument/2006/relationships" id="2147483648" r:id="Rbbbd8343724444ca"/>
+    <p:sldMasterId xmlns:r="http://schemas.openxmlformats.org/officeDocument/2006/relationships" id="2147483648" r:id="Rc6af79b7a3f8413d"/>
   </p:sldMasterIdLst>
   <p:notesMasterIdLst>
-    <p:notesMasterId xmlns:r="http://schemas.openxmlformats.org/officeDocument/2006/relationships" r:id="R53c7ecb896324d68"/>
+    <p:notesMasterId xmlns:r="http://schemas.openxmlformats.org/officeDocument/2006/relationships" r:id="R5dfd6a85018d4659"/>
   </p:notesMasterIdLst>
   <p:sldIdLst>
-    <p:sldId xmlns:r="http://schemas.openxmlformats.org/officeDocument/2006/relationships" id="256" r:id="Rb81c84c157484b26"/>
-    <p:sldId xmlns:r="http://schemas.openxmlformats.org/officeDocument/2006/relationships" id="257" r:id="R8690009005f8488d"/>
-    <p:sldId xmlns:r="http://schemas.openxmlformats.org/officeDocument/2006/relationships" id="258" r:id="R46f95abbd8a342c1"/>
-    <p:sldId xmlns:r="http://schemas.openxmlformats.org/officeDocument/2006/relationships" id="259" r:id="R45371b4c6213432d"/>
-    <p:sldId xmlns:r="http://schemas.openxmlformats.org/officeDocument/2006/relationships" id="260" r:id="Rf1375968163047df"/>
-    <p:sldId xmlns:r="http://schemas.openxmlformats.org/officeDocument/2006/relationships" id="261" r:id="R25cf43d1084e48bb"/>
-    <p:sldId xmlns:r="http://schemas.openxmlformats.org/officeDocument/2006/relationships" id="262" r:id="R0c701d26f9074388"/>
-    <p:sldId xmlns:r="http://schemas.openxmlformats.org/officeDocument/2006/relationships" id="263" r:id="R4367e6d753bd4631"/>
+    <p:sldId xmlns:r="http://schemas.openxmlformats.org/officeDocument/2006/relationships" id="256" r:id="Re8aa58e637a24d41"/>
+    <p:sldId xmlns:r="http://schemas.openxmlformats.org/officeDocument/2006/relationships" id="257" r:id="R8c61988a26e04b73"/>
+    <p:sldId xmlns:r="http://schemas.openxmlformats.org/officeDocument/2006/relationships" id="258" r:id="R090bf810aa7340ed"/>
+    <p:sldId xmlns:r="http://schemas.openxmlformats.org/officeDocument/2006/relationships" id="259" r:id="Rab11279a23d14cac"/>
+    <p:sldId xmlns:r="http://schemas.openxmlformats.org/officeDocument/2006/relationships" id="260" r:id="Rdba9894e1998472e"/>
+    <p:sldId xmlns:r="http://schemas.openxmlformats.org/officeDocument/2006/relationships" id="261" r:id="R773ee97d039c467c"/>
+    <p:sldId xmlns:r="http://schemas.openxmlformats.org/officeDocument/2006/relationships" id="262" r:id="Rad1533874f114965"/>
+    <p:sldId xmlns:r="http://schemas.openxmlformats.org/officeDocument/2006/relationships" id="263" r:id="R69c66ad5fe214014"/>
   </p:sldIdLst>
   <p:sldSz cx="12192000" cy="6858000"/>
   <p:notesSz cx="6858000" cy="9144000"/>
@@ -464,7 +464,7 @@
           </a:p>
           <a:p xmlns:a="http://schemas.openxmlformats.org/drawingml/2006/main">
             <a:r>
-              <a:t>根拠：docs/thesis/本文.md 第5〜10章、第12章、第15章。実験記録 E6、E7。製品 https://github.com/SoshiroFujimori/wally-game-console/tree/261832d48832dd6e26c4971ab8893ce61200688b 。</a:t>
+              <a:t>根拠：docs/thesis/本文.md 第5〜10章、第12章、第15章。実験記録 E1、E6。製品 https://github.com/SoshiroFujimori/wally-game-console/tree/261832d48832dd6e26c4971ab8893ce61200688b 。</a:t>
             </a:r>
           </a:p>
         </p:txBody>
@@ -549,7 +549,7 @@
           </a:p>
           <a:p xmlns:a="http://schemas.openxmlformats.org/drawingml/2006/main">
             <a:r>
-              <a:t>根拠：docs/thesis/本文.md 第5〜10章、第12章、第15章。実験記録 E6、E7。製品 https://github.com/SoshiroFujimori/wally-game-console/tree/261832d48832dd6e26c4971ab8893ce61200688b 。</a:t>
+              <a:t>根拠：docs/thesis/本文.md 第5〜10章、第12章、第15章。実験記録 E1、E6。製品 https://github.com/SoshiroFujimori/wally-game-console/tree/261832d48832dd6e26c4971ab8893ce61200688b 。</a:t>
             </a:r>
           </a:p>
         </p:txBody>
@@ -634,7 +634,7 @@
           </a:p>
           <a:p xmlns:a="http://schemas.openxmlformats.org/drawingml/2006/main">
             <a:r>
-              <a:t>根拠：docs/thesis/本文.md 第5〜10章、第12章、第15章。実験記録 E6、E7。製品 https://github.com/SoshiroFujimori/wally-game-console/tree/261832d48832dd6e26c4971ab8893ce61200688b 。</a:t>
+              <a:t>根拠：docs/thesis/本文.md 第5〜10章、第12章、第15章。実験記録 E1、E6。製品 https://github.com/SoshiroFujimori/wally-game-console/tree/261832d48832dd6e26c4971ab8893ce61200688b 。</a:t>
             </a:r>
           </a:p>
         </p:txBody>
@@ -714,12 +714,12 @@
           </a:p>
           <a:p xmlns:a="http://schemas.openxmlformats.org/drawingml/2006/main">
             <a:r>
-              <a:t>CPUはSDカードから読み込んだゲームを実行します。一回の処理でボールの位置を更新し、位置や色を描画命令にしてメモリへ置きます。接続回路から命令を受けたRasterIXが画像を作り、表示回路が読み出します。これを繰り返すと動いて見えます。位置の数値、描画命令、画素の色は別々のデータです。命令を送る接続と、できた画像を表示する接続を、それぞれ用意しました。</a:t>
-            </a:r>
-          </a:p>
-          <a:p xmlns:a="http://schemas.openxmlformats.org/drawingml/2006/main">
-            <a:r>
-              <a:t>根拠：docs/thesis/本文.md 第5〜10章、第12章、第15章。実験記録 E6、E7。製品 https://github.com/SoshiroFujimori/wally-game-console/tree/261832d48832dd6e26c4971ab8893ce61200688b 。</a:t>
+              <a:t>CPUはSDカードから読み込んだゲームを実行します。一回の処理でボールの位置を更新します。位置や色をRasterIX付属のOpenGL互換ライブラリへ渡すと、ライブラリが描画命令をメモリへ用意します。接続回路から命令を受けたRasterIXが画像を作り、表示回路が読み出します。これを繰り返すと動いて見えます。位置の数値、描画命令、画素の色は別々のデータです。命令を送る接続と、できた画像を表示する接続を、それぞれ用意しました。</a:t>
+            </a:r>
+          </a:p>
+          <a:p xmlns:a="http://schemas.openxmlformats.org/drawingml/2006/main">
+            <a:r>
+              <a:t>根拠：docs/thesis/本文.md 第5〜10章、第12章、第15章。実験記録 E1、E6。製品 https://github.com/SoshiroFujimori/wally-game-console/tree/261832d48832dd6e26c4971ab8893ce61200688b 。</a:t>
             </a:r>
           </a:p>
         </p:txBody>
@@ -799,12 +799,12 @@
           </a:p>
           <a:p xmlns:a="http://schemas.openxmlformats.org/drawingml/2006/main">
             <a:r>
-              <a:t>CPUとRasterIXは異なるクロックで動きます。そのため、命令の値と順番を保って渡す接続が必要です。一つの方法は、一語を保持し、相手の受取確認が戻るたびに次を送る方法です。採用したFIFOは、命令を順番に預かる待ち行列です。空きがあれば、CPUは次の命令へ進めます。同じゲームで比べたところ、この図の三方式では512語FIFOの送信待ちが最も短くなりました。この数字はゲーム全体ではなく、書き込みを待たされた時間です。</a:t>
-            </a:r>
-          </a:p>
-          <a:p xmlns:a="http://schemas.openxmlformats.org/drawingml/2006/main">
-            <a:r>
-              <a:t>根拠：E6、第12.5〜12.8節。1語方式は4相ハンドシェイク。初期状態、全体描画、180フレームを3回、各試行平均の中央値。CPU 20 MHz、RasterIX 100 MHz。</a:t>
+              <a:t>CPUは番地を指定して数値を書きます。RasterIXは順番に並ぶ命令を受け取ります。この二つの渡し方をつなぐ回路を設計しました。途中のFIFOは、先に入れた値から渡す保存場所です。また、CPU側は20 MHz、描画側は100 MHzなので、それぞれの時計で受け渡しを管理する既存の非同期FIFOを使いました。空きがなければCPUの書き込みを待たせます。本研究で作ったのは、既存FIFOの内部ではなく、その前後の接続です。</a:t>
+            </a:r>
+          </a:p>
+          <a:p xmlns:a="http://schemas.openxmlformats.org/drawingml/2006/main">
+            <a:r>
+              <a:t>根拠：docs/thesis/本文.md 第5〜10章、第12章、第15章。実験記録 E1、E6。製品 https://github.com/SoshiroFujimori/wally-game-console/tree/261832d48832dd6e26c4971ab8893ce61200688b 。</a:t>
             </a:r>
           </a:p>
         </p:txBody>
@@ -889,7 +889,7 @@
           </a:p>
           <a:p xmlns:a="http://schemas.openxmlformats.org/drawingml/2006/main">
             <a:r>
-              <a:t>根拠：docs/thesis/本文.md 第5〜10章、第12章、第15章。実験記録 E6、E7。製品 https://github.com/SoshiroFujimori/wally-game-console/tree/261832d48832dd6e26c4971ab8893ce61200688b 。</a:t>
+              <a:t>根拠：docs/thesis/本文.md 第5〜10章、第12章、第15章。実験記録 E1、E6。製品 https://github.com/SoshiroFujimori/wally-game-console/tree/261832d48832dd6e26c4971ab8893ce61200688b 。</a:t>
             </a:r>
           </a:p>
         </p:txBody>
@@ -969,12 +969,12 @@
           </a:p>
           <a:p xmlns:a="http://schemas.openxmlformats.org/drawingml/2006/main">
             <a:r>
-              <a:t>640×480画素で、通常版の5分間の自動プレイと、別に30秒の実機映像を確認しました。接続を比較した三方式では、毎回全体を描く条件にそろえ、三つの開始状態の計9枚で、最終画像が全画素で期待画像と一致しました。すべての途中画像まで確認したわけではありません。大きなテクスチャの描画と映像認識には未解決の条件が残っています。専用コントローラーは今回の成果に含めず、最終発表に向けて接続と操作を検証します。</a:t>
-            </a:r>
-          </a:p>
-          <a:p xmlns:a="http://schemas.openxmlformats.org/drawingml/2006/main">
-            <a:r>
-              <a:t>根拠：E6、第12.6節と12.10〜12.11節。通常ゲームの連続動作と、全体描画にそろえた接続比較は別の実行条件。画像：docs/thesis/figs/fifo-study-game.png。</a:t>
+              <a:t>640×480画素のブロック崩しで、画像確認用プログラムの三条件と再起動後の一条件の画像が、すべての画素で期待画像と一致しました。また、5分間の自動プレイの実行記録と、別の実行で記録した30秒間の映像を確認しました。動作確認には、描画処理を軽くする実装を含む完成版を使っています。映像を受信できない場合もあり、その条件の解明は課題です。</a:t>
+            </a:r>
+          </a:p>
+          <a:p xmlns:a="http://schemas.openxmlformats.org/drawingml/2006/main">
+            <a:r>
+              <a:t>根拠：E6、論文12.4〜12.6節。通常構成の画像4条件と継続実行、映像は別の試験。画像確認の開始状態・描画方法はqualification.jsonのwhole_frame_checksに記録。動画の記録枚数はゲームのFPSを示さない。画像：docs/thesis/figs/fifo-study-game.png。</a:t>
             </a:r>
           </a:p>
         </p:txBody>
@@ -1054,12 +1054,12 @@
           </a:p>
           <a:p xmlns:a="http://schemas.openxmlformats.org/drawingml/2006/main">
             <a:r>
-              <a:t>Wallyへ描画・表示機能を追加し、二次元ゲームを動かす接続設計を示しました。命令を専用回路で転送する方式と、描画用メモリを増やす方式も実機で比較しました。毎回全体を描く条件では、前者はコピー処理を含めると速くならず、後者の改善も小さい結果でした。設計と試験条件を公開し、学習者が同様の拡張を検討するための参照例とします。最終発表では、専用コントローラーを接続し、ボタンによるゲーム操作を検証します。</a:t>
-            </a:r>
-          </a:p>
-          <a:p xmlns:a="http://schemas.openxmlformats.org/drawingml/2006/main">
-            <a:r>
-              <a:t>根拠：docs/thesis/本文.md 第5〜10章、第12章、第15章。実験記録 E6、E7。製品 https://github.com/SoshiroFujimori/wally-game-console/tree/261832d48832dd6e26c4971ab8893ce61200688b 。</a:t>
+              <a:t>Wallyに描画と表示の機能を追加し、ブロック崩しを動かす構成を実機で確認しました。既存のCPUと描画回路を利用し、命令の接続、画像を置くメモリの設定、表示画像の切り替えを実装しました。接続設計と試験条件を公開することで、Wallyに周辺機能を追加する人が参照できる例とします。学習効果を測った結果ではありません。最終発表では専用コントローラーを接続し、ボタンによる操作を検証します。</a:t>
+            </a:r>
+          </a:p>
+          <a:p xmlns:a="http://schemas.openxmlformats.org/drawingml/2006/main">
+            <a:r>
+              <a:t>根拠：docs/thesis/本文.md 第5〜10章、第12章、第15章。実験記録 E1、E6。製品 https://github.com/SoshiroFujimori/wally-game-console/tree/261832d48832dd6e26c4971ab8893ce61200688b 。</a:t>
             </a:r>
           </a:p>
         </p:txBody>
@@ -1106,7 +1106,7 @@
           <p:cNvPr id="3" name="Title">
             <a:extLst xmlns:a="http://schemas.openxmlformats.org/drawingml/2006/main">
               <a:ext uri="{FF2B5EF4-FFF2-40B4-BE49-F238E27FC236}">
-                <a16:creationId xmlns:a16="http://schemas.microsoft.com/office/drawing/2014/main" id="{85478C9D-7077-4ED9-A713-08D529C86678}"/>
+                <a16:creationId xmlns:a16="http://schemas.microsoft.com/office/drawing/2014/main" id="{52C09C4B-43CE-439F-B503-19E8FBDC259A}"/>
               </a:ext>
             </a:extLst>
           </p:cNvPr>
@@ -1263,7 +1263,7 @@
           <p:cNvPr id="2" name="Subtitle">
             <a:extLst xmlns:a="http://schemas.openxmlformats.org/drawingml/2006/main">
               <a:ext uri="{FF2B5EF4-FFF2-40B4-BE49-F238E27FC236}">
-                <a16:creationId xmlns:a16="http://schemas.microsoft.com/office/drawing/2014/main" id="{0B137804-5F12-4D23-A236-7ADEB0F59005}"/>
+                <a16:creationId xmlns:a16="http://schemas.microsoft.com/office/drawing/2014/main" id="{2D8D20E9-7A96-4630-8DD1-65E6E258463F}"/>
               </a:ext>
             </a:extLst>
           </p:cNvPr>
@@ -1437,7 +1437,7 @@
           <p:cNvPr id="2" name="Section title">
             <a:extLst xmlns:a="http://schemas.openxmlformats.org/drawingml/2006/main">
               <a:ext uri="{FF2B5EF4-FFF2-40B4-BE49-F238E27FC236}">
-                <a16:creationId xmlns:a16="http://schemas.microsoft.com/office/drawing/2014/main" id="{160F1A9E-7A03-4EE0-BD13-18B9AD931014}"/>
+                <a16:creationId xmlns:a16="http://schemas.microsoft.com/office/drawing/2014/main" id="{B151B1D7-1CCA-486F-8051-DF88B63CD7A5}"/>
               </a:ext>
             </a:extLst>
           </p:cNvPr>
@@ -1611,7 +1611,7 @@
           <p:cNvPr id="3" name="Title">
             <a:extLst xmlns:a="http://schemas.openxmlformats.org/drawingml/2006/main">
               <a:ext uri="{FF2B5EF4-FFF2-40B4-BE49-F238E27FC236}">
-                <a16:creationId xmlns:a16="http://schemas.microsoft.com/office/drawing/2014/main" id="{636ED216-0B17-45D2-B89A-DF4594C7F1AD}"/>
+                <a16:creationId xmlns:a16="http://schemas.microsoft.com/office/drawing/2014/main" id="{9DBD0909-6181-48D2-9486-D5FAE79EE5ED}"/>
               </a:ext>
             </a:extLst>
           </p:cNvPr>
@@ -1768,7 +1768,7 @@
           <p:cNvPr id="2" name="Body">
             <a:extLst xmlns:a="http://schemas.openxmlformats.org/drawingml/2006/main">
               <a:ext uri="{FF2B5EF4-FFF2-40B4-BE49-F238E27FC236}">
-                <a16:creationId xmlns:a16="http://schemas.microsoft.com/office/drawing/2014/main" id="{4E6B4EAC-87B2-4630-8CD6-FEC5672911A2}"/>
+                <a16:creationId xmlns:a16="http://schemas.microsoft.com/office/drawing/2014/main" id="{919299D3-6899-456D-8CA5-69C9E37F7EEE}"/>
               </a:ext>
             </a:extLst>
           </p:cNvPr>
@@ -1942,7 +1942,7 @@
           <p:cNvPr id="4" name="Title">
             <a:extLst xmlns:a="http://schemas.openxmlformats.org/drawingml/2006/main">
               <a:ext uri="{FF2B5EF4-FFF2-40B4-BE49-F238E27FC236}">
-                <a16:creationId xmlns:a16="http://schemas.microsoft.com/office/drawing/2014/main" id="{C9456E3E-642E-43CC-A054-AA032FBC4DDB}"/>
+                <a16:creationId xmlns:a16="http://schemas.microsoft.com/office/drawing/2014/main" id="{49194196-4FD8-4BF1-A640-64B56574E6D8}"/>
               </a:ext>
             </a:extLst>
           </p:cNvPr>
@@ -2099,7 +2099,7 @@
           <p:cNvPr id="2" name="Left column">
             <a:extLst xmlns:a="http://schemas.openxmlformats.org/drawingml/2006/main">
               <a:ext uri="{FF2B5EF4-FFF2-40B4-BE49-F238E27FC236}">
-                <a16:creationId xmlns:a16="http://schemas.microsoft.com/office/drawing/2014/main" id="{C4019A6F-6A78-4CB8-8706-7A253C418DED}"/>
+                <a16:creationId xmlns:a16="http://schemas.microsoft.com/office/drawing/2014/main" id="{43AEBC45-C500-4D9B-B807-B778EA0B3F75}"/>
               </a:ext>
             </a:extLst>
           </p:cNvPr>
@@ -2256,7 +2256,7 @@
           <p:cNvPr id="3" name="Right column">
             <a:extLst xmlns:a="http://schemas.openxmlformats.org/drawingml/2006/main">
               <a:ext uri="{FF2B5EF4-FFF2-40B4-BE49-F238E27FC236}">
-                <a16:creationId xmlns:a16="http://schemas.microsoft.com/office/drawing/2014/main" id="{A5AC4197-C4C5-401A-86B4-2A0211F00AF0}"/>
+                <a16:creationId xmlns:a16="http://schemas.microsoft.com/office/drawing/2014/main" id="{32AC7E27-B838-4284-AB2A-2253ACBD38CA}"/>
               </a:ext>
             </a:extLst>
           </p:cNvPr>
@@ -2430,7 +2430,7 @@
           <p:cNvPr id="3" name="Title">
             <a:extLst xmlns:a="http://schemas.openxmlformats.org/drawingml/2006/main">
               <a:ext uri="{FF2B5EF4-FFF2-40B4-BE49-F238E27FC236}">
-                <a16:creationId xmlns:a16="http://schemas.microsoft.com/office/drawing/2014/main" id="{830D3B12-B284-4131-995A-115A3700EB1F}"/>
+                <a16:creationId xmlns:a16="http://schemas.microsoft.com/office/drawing/2014/main" id="{4915FA0C-3059-4F67-B77D-03A5BD2A9BD8}"/>
               </a:ext>
             </a:extLst>
           </p:cNvPr>
@@ -2587,7 +2587,7 @@
           <p:cNvPr id="2" name="Left column">
             <a:extLst xmlns:a="http://schemas.openxmlformats.org/drawingml/2006/main">
               <a:ext uri="{FF2B5EF4-FFF2-40B4-BE49-F238E27FC236}">
-                <a16:creationId xmlns:a16="http://schemas.microsoft.com/office/drawing/2014/main" id="{B335C610-8E12-48D5-8E16-5380C0EBE99F}"/>
+                <a16:creationId xmlns:a16="http://schemas.microsoft.com/office/drawing/2014/main" id="{0DDB8F25-C2B4-4F15-9C7A-0531923C2C4C}"/>
               </a:ext>
             </a:extLst>
           </p:cNvPr>
@@ -2782,12 +2782,12 @@
   </p:cSld>
   <p:clrMap bg1="lt1" tx1="dk1" bg2="lt2" tx2="dk2" accent1="accent1" accent2="accent2" accent3="accent3" accent4="accent4" accent5="accent5" accent6="accent6" hlink="hlink" folHlink="folHlink"/>
   <p:sldLayoutIdLst>
-    <p:sldLayoutId xmlns:r="http://schemas.openxmlformats.org/officeDocument/2006/relationships" id="2147483649" r:id="R5c5b1171f1f140bd"/>
-    <p:sldLayoutId xmlns:r="http://schemas.openxmlformats.org/officeDocument/2006/relationships" id="2147483650" r:id="R004938a12606403c"/>
-    <p:sldLayoutId xmlns:r="http://schemas.openxmlformats.org/officeDocument/2006/relationships" id="2147483651" r:id="Rfa530819cb5b47e1"/>
-    <p:sldLayoutId xmlns:r="http://schemas.openxmlformats.org/officeDocument/2006/relationships" id="2147483652" r:id="R3e5e385d886e48b7"/>
-    <p:sldLayoutId xmlns:r="http://schemas.openxmlformats.org/officeDocument/2006/relationships" id="2147483653" r:id="R2a6454d79ba54f9d"/>
-    <p:sldLayoutId xmlns:r="http://schemas.openxmlformats.org/officeDocument/2006/relationships" id="2147483654" r:id="R5153fcda86da42e4"/>
+    <p:sldLayoutId xmlns:r="http://schemas.openxmlformats.org/officeDocument/2006/relationships" id="2147483649" r:id="Ra19f2925058a4bfc"/>
+    <p:sldLayoutId xmlns:r="http://schemas.openxmlformats.org/officeDocument/2006/relationships" id="2147483650" r:id="R8c1512a6c83041bb"/>
+    <p:sldLayoutId xmlns:r="http://schemas.openxmlformats.org/officeDocument/2006/relationships" id="2147483651" r:id="R04ab971275d34284"/>
+    <p:sldLayoutId xmlns:r="http://schemas.openxmlformats.org/officeDocument/2006/relationships" id="2147483652" r:id="R4366644d301a401d"/>
+    <p:sldLayoutId xmlns:r="http://schemas.openxmlformats.org/officeDocument/2006/relationships" id="2147483653" r:id="R2c3ca293ea054972"/>
+    <p:sldLayoutId xmlns:r="http://schemas.openxmlformats.org/officeDocument/2006/relationships" id="2147483654" r:id="R8164927795904250"/>
   </p:sldLayoutIdLst>
   <p:txStyles>
     <p:titleStyle>
@@ -3338,7 +3338,7 @@
           <p:cNvPr id="6" name="text-1">
             <a:extLst xmlns:a="http://schemas.openxmlformats.org/drawingml/2006/main">
               <a:ext uri="{FF2B5EF4-FFF2-40B4-BE49-F238E27FC236}">
-                <a16:creationId xmlns:a16="http://schemas.microsoft.com/office/drawing/2014/main" id="{16F54AF5-07A8-4668-A0C9-931A2B6FF9B1}"/>
+                <a16:creationId xmlns:a16="http://schemas.microsoft.com/office/drawing/2014/main" id="{372EE456-DEA1-4068-A17A-D0F1266EE803}"/>
               </a:ext>
             </a:extLst>
           </p:cNvPr>
@@ -3404,7 +3404,7 @@
           <p:cNvPr id="2" name="text-2">
             <a:extLst xmlns:a="http://schemas.openxmlformats.org/drawingml/2006/main">
               <a:ext uri="{FF2B5EF4-FFF2-40B4-BE49-F238E27FC236}">
-                <a16:creationId xmlns:a16="http://schemas.microsoft.com/office/drawing/2014/main" id="{7FA92F81-A7F5-42A2-ADCF-CBA7A3322D7C}"/>
+                <a16:creationId xmlns:a16="http://schemas.microsoft.com/office/drawing/2014/main" id="{EF126B38-4ADF-4E36-842A-C30FD39EE800}"/>
               </a:ext>
             </a:extLst>
           </p:cNvPr>
@@ -3470,7 +3470,7 @@
           <p:cNvPr id="3" name="text-3">
             <a:extLst xmlns:a="http://schemas.openxmlformats.org/drawingml/2006/main">
               <a:ext uri="{FF2B5EF4-FFF2-40B4-BE49-F238E27FC236}">
-                <a16:creationId xmlns:a16="http://schemas.microsoft.com/office/drawing/2014/main" id="{FAC886D0-58D1-45E9-A961-0962ED6B47A8}"/>
+                <a16:creationId xmlns:a16="http://schemas.microsoft.com/office/drawing/2014/main" id="{F07A086F-8F23-4D4C-A484-7AE59433C34B}"/>
               </a:ext>
             </a:extLst>
           </p:cNvPr>
@@ -3559,7 +3559,7 @@
           <p:cNvPr id="4" name="text-4">
             <a:extLst xmlns:a="http://schemas.openxmlformats.org/drawingml/2006/main">
               <a:ext uri="{FF2B5EF4-FFF2-40B4-BE49-F238E27FC236}">
-                <a16:creationId xmlns:a16="http://schemas.microsoft.com/office/drawing/2014/main" id="{26ADEE64-904F-4AB4-A881-8CD224A29C03}"/>
+                <a16:creationId xmlns:a16="http://schemas.microsoft.com/office/drawing/2014/main" id="{D1A09447-0D2A-49AA-B0A6-C769B247BA10}"/>
               </a:ext>
             </a:extLst>
           </p:cNvPr>
@@ -3625,7 +3625,7 @@
           <p:cNvPr id="5" name="text-5">
             <a:extLst xmlns:a="http://schemas.openxmlformats.org/drawingml/2006/main">
               <a:ext uri="{FF2B5EF4-FFF2-40B4-BE49-F238E27FC236}">
-                <a16:creationId xmlns:a16="http://schemas.microsoft.com/office/drawing/2014/main" id="{FDF8A897-F569-4D98-A81B-3EFE437D9245}"/>
+                <a16:creationId xmlns:a16="http://schemas.microsoft.com/office/drawing/2014/main" id="{CC3DAFB5-AD78-45ED-AF9D-209C628CDFE0}"/>
               </a:ext>
             </a:extLst>
           </p:cNvPr>
@@ -3689,7 +3689,7 @@
     </p:spTree>
     <p:extLst>
       <p:ext uri="{BB962C8B-B14F-4D97-AF65-F5344CB8AC3E}">
-        <p14:creationId xmlns:p14="http://schemas.microsoft.com/office/powerpoint/2010/main" val="157090371"/>
+        <p14:creationId xmlns:p14="http://schemas.microsoft.com/office/powerpoint/2010/main" val="73464915"/>
       </p:ext>
     </p:extLst>
   </p:cSld>
@@ -3720,7 +3720,7 @@
           <p:cNvPr id="28" name="text-6">
             <a:extLst xmlns:a="http://schemas.openxmlformats.org/drawingml/2006/main">
               <a:ext uri="{FF2B5EF4-FFF2-40B4-BE49-F238E27FC236}">
-                <a16:creationId xmlns:a16="http://schemas.microsoft.com/office/drawing/2014/main" id="{F2C8D9B1-7618-4A33-ABF6-0F9621F16FB9}"/>
+                <a16:creationId xmlns:a16="http://schemas.microsoft.com/office/drawing/2014/main" id="{3863FDA3-1E15-4983-8184-6E42F3C18973}"/>
               </a:ext>
             </a:extLst>
           </p:cNvPr>
@@ -3786,7 +3786,7 @@
           <p:cNvPr id="2" name="text-7">
             <a:extLst xmlns:a="http://schemas.openxmlformats.org/drawingml/2006/main">
               <a:ext uri="{FF2B5EF4-FFF2-40B4-BE49-F238E27FC236}">
-                <a16:creationId xmlns:a16="http://schemas.microsoft.com/office/drawing/2014/main" id="{8EA03B32-9F3E-4F83-A3D0-7A3500FDEA84}"/>
+                <a16:creationId xmlns:a16="http://schemas.microsoft.com/office/drawing/2014/main" id="{1490CF67-6A48-4322-9B74-9CD7B52B89D5}"/>
               </a:ext>
             </a:extLst>
           </p:cNvPr>
@@ -3852,7 +3852,7 @@
           <p:cNvPr id="3" name="circuit-8">
             <a:extLst xmlns:a="http://schemas.openxmlformats.org/drawingml/2006/main">
               <a:ext uri="{FF2B5EF4-FFF2-40B4-BE49-F238E27FC236}">
-                <a16:creationId xmlns:a16="http://schemas.microsoft.com/office/drawing/2014/main" id="{FAF5D3EA-7894-42BD-9EF7-F1A370B7D44C}"/>
+                <a16:creationId xmlns:a16="http://schemas.microsoft.com/office/drawing/2014/main" id="{05373992-33C6-4DF4-A5C6-AE04011C3609}"/>
               </a:ext>
             </a:extLst>
           </p:cNvPr>
@@ -3884,7 +3884,7 @@
           <p:cNvPr id="4" name="text-9">
             <a:extLst xmlns:a="http://schemas.openxmlformats.org/drawingml/2006/main">
               <a:ext uri="{FF2B5EF4-FFF2-40B4-BE49-F238E27FC236}">
-                <a16:creationId xmlns:a16="http://schemas.microsoft.com/office/drawing/2014/main" id="{FBCD2EB3-CE24-4BAF-837E-225BCD80ABAB}"/>
+                <a16:creationId xmlns:a16="http://schemas.microsoft.com/office/drawing/2014/main" id="{5C31CC03-61C6-4807-BAA5-44637F0E5CB6}"/>
               </a:ext>
             </a:extLst>
           </p:cNvPr>
@@ -3950,7 +3950,7 @@
           <p:cNvPr id="5" name="circuit-10">
             <a:extLst xmlns:a="http://schemas.openxmlformats.org/drawingml/2006/main">
               <a:ext uri="{FF2B5EF4-FFF2-40B4-BE49-F238E27FC236}">
-                <a16:creationId xmlns:a16="http://schemas.microsoft.com/office/drawing/2014/main" id="{55A66019-F9B6-408D-85DC-146A3C189200}"/>
+                <a16:creationId xmlns:a16="http://schemas.microsoft.com/office/drawing/2014/main" id="{FAB0BF58-B7FE-436D-BD83-9448E1684D85}"/>
               </a:ext>
             </a:extLst>
           </p:cNvPr>
@@ -3982,7 +3982,7 @@
           <p:cNvPr id="6" name="text-11">
             <a:extLst xmlns:a="http://schemas.openxmlformats.org/drawingml/2006/main">
               <a:ext uri="{FF2B5EF4-FFF2-40B4-BE49-F238E27FC236}">
-                <a16:creationId xmlns:a16="http://schemas.microsoft.com/office/drawing/2014/main" id="{EDCF921A-0932-4936-8B8F-A84D47AD42F7}"/>
+                <a16:creationId xmlns:a16="http://schemas.microsoft.com/office/drawing/2014/main" id="{05391A28-4894-45CE-9A37-F52ED58CC9D5}"/>
               </a:ext>
             </a:extLst>
           </p:cNvPr>
@@ -4048,7 +4048,7 @@
           <p:cNvPr id="7" name="wire-12">
             <a:extLst xmlns:a="http://schemas.openxmlformats.org/drawingml/2006/main">
               <a:ext uri="{FF2B5EF4-FFF2-40B4-BE49-F238E27FC236}">
-                <a16:creationId xmlns:a16="http://schemas.microsoft.com/office/drawing/2014/main" id="{FCEAD2B4-BA61-4A7C-8B86-51F1CE74A725}"/>
+                <a16:creationId xmlns:a16="http://schemas.microsoft.com/office/drawing/2014/main" id="{92FCA9D6-FDE8-40EF-AFBE-33D1EC83C6C7}"/>
               </a:ext>
             </a:extLst>
           </p:cNvPr>
@@ -4087,7 +4087,7 @@
           <p:cNvPr id="8" name="circuit-13">
             <a:extLst xmlns:a="http://schemas.openxmlformats.org/drawingml/2006/main">
               <a:ext uri="{FF2B5EF4-FFF2-40B4-BE49-F238E27FC236}">
-                <a16:creationId xmlns:a16="http://schemas.microsoft.com/office/drawing/2014/main" id="{89467821-BFB1-4946-A4EC-948A59FE369D}"/>
+                <a16:creationId xmlns:a16="http://schemas.microsoft.com/office/drawing/2014/main" id="{953495DB-EC61-403B-BF84-138C437B7007}"/>
               </a:ext>
             </a:extLst>
           </p:cNvPr>
@@ -4119,7 +4119,7 @@
           <p:cNvPr id="9" name="text-14">
             <a:extLst xmlns:a="http://schemas.openxmlformats.org/drawingml/2006/main">
               <a:ext uri="{FF2B5EF4-FFF2-40B4-BE49-F238E27FC236}">
-                <a16:creationId xmlns:a16="http://schemas.microsoft.com/office/drawing/2014/main" id="{145ABB00-5A75-491D-A893-3486E8EB98C6}"/>
+                <a16:creationId xmlns:a16="http://schemas.microsoft.com/office/drawing/2014/main" id="{0151820F-14B2-4B33-A29F-6DFC573C01E1}"/>
               </a:ext>
             </a:extLst>
           </p:cNvPr>
@@ -4185,7 +4185,7 @@
           <p:cNvPr id="10" name="wire-15">
             <a:extLst xmlns:a="http://schemas.openxmlformats.org/drawingml/2006/main">
               <a:ext uri="{FF2B5EF4-FFF2-40B4-BE49-F238E27FC236}">
-                <a16:creationId xmlns:a16="http://schemas.microsoft.com/office/drawing/2014/main" id="{5F905DAA-7788-415D-A318-E4B47499A41D}"/>
+                <a16:creationId xmlns:a16="http://schemas.microsoft.com/office/drawing/2014/main" id="{047347E6-7A7C-41B7-87F3-C5E92AF79AA2}"/>
               </a:ext>
             </a:extLst>
           </p:cNvPr>
@@ -4224,7 +4224,7 @@
           <p:cNvPr id="11" name="circuit-16">
             <a:extLst xmlns:a="http://schemas.openxmlformats.org/drawingml/2006/main">
               <a:ext uri="{FF2B5EF4-FFF2-40B4-BE49-F238E27FC236}">
-                <a16:creationId xmlns:a16="http://schemas.microsoft.com/office/drawing/2014/main" id="{B3E50FD1-EB7C-438D-B872-66919CA54650}"/>
+                <a16:creationId xmlns:a16="http://schemas.microsoft.com/office/drawing/2014/main" id="{F65977CD-0281-453F-A239-7A66CEA77E07}"/>
               </a:ext>
             </a:extLst>
           </p:cNvPr>
@@ -4256,7 +4256,7 @@
           <p:cNvPr id="12" name="text-17">
             <a:extLst xmlns:a="http://schemas.openxmlformats.org/drawingml/2006/main">
               <a:ext uri="{FF2B5EF4-FFF2-40B4-BE49-F238E27FC236}">
-                <a16:creationId xmlns:a16="http://schemas.microsoft.com/office/drawing/2014/main" id="{E36ED939-9E2E-4708-9866-329F6F66C46D}"/>
+                <a16:creationId xmlns:a16="http://schemas.microsoft.com/office/drawing/2014/main" id="{1A488734-5C85-4FCD-AACF-181DA9C7F012}"/>
               </a:ext>
             </a:extLst>
           </p:cNvPr>
@@ -4322,7 +4322,7 @@
           <p:cNvPr id="13" name="wire-18">
             <a:extLst xmlns:a="http://schemas.openxmlformats.org/drawingml/2006/main">
               <a:ext uri="{FF2B5EF4-FFF2-40B4-BE49-F238E27FC236}">
-                <a16:creationId xmlns:a16="http://schemas.microsoft.com/office/drawing/2014/main" id="{B6B979BC-3DB6-4089-A473-47808D5B89C6}"/>
+                <a16:creationId xmlns:a16="http://schemas.microsoft.com/office/drawing/2014/main" id="{49F61818-50D0-48CB-8A6F-F91D1349AFFB}"/>
               </a:ext>
             </a:extLst>
           </p:cNvPr>
@@ -4361,7 +4361,7 @@
           <p:cNvPr id="14" name="circuit-19">
             <a:extLst xmlns:a="http://schemas.openxmlformats.org/drawingml/2006/main">
               <a:ext uri="{FF2B5EF4-FFF2-40B4-BE49-F238E27FC236}">
-                <a16:creationId xmlns:a16="http://schemas.microsoft.com/office/drawing/2014/main" id="{562D1E6C-3E91-46C7-A8F1-5E929FFDF7CE}"/>
+                <a16:creationId xmlns:a16="http://schemas.microsoft.com/office/drawing/2014/main" id="{3996FD2A-6BFA-4AE1-BFA3-ADBB06390786}"/>
               </a:ext>
             </a:extLst>
           </p:cNvPr>
@@ -4393,7 +4393,7 @@
           <p:cNvPr id="15" name="text-20">
             <a:extLst xmlns:a="http://schemas.openxmlformats.org/drawingml/2006/main">
               <a:ext uri="{FF2B5EF4-FFF2-40B4-BE49-F238E27FC236}">
-                <a16:creationId xmlns:a16="http://schemas.microsoft.com/office/drawing/2014/main" id="{F8EEDA16-3247-447C-B3FE-F120F2F1B267}"/>
+                <a16:creationId xmlns:a16="http://schemas.microsoft.com/office/drawing/2014/main" id="{8B2BAFFE-7B43-4AAB-BD58-AB017DF64CBB}"/>
               </a:ext>
             </a:extLst>
           </p:cNvPr>
@@ -4459,7 +4459,7 @@
           <p:cNvPr id="16" name="and-gate-21">
             <a:extLst xmlns:a="http://schemas.openxmlformats.org/drawingml/2006/main">
               <a:ext uri="{FF2B5EF4-FFF2-40B4-BE49-F238E27FC236}">
-                <a16:creationId xmlns:a16="http://schemas.microsoft.com/office/drawing/2014/main" id="{D2B3AA27-7EA5-4940-9D72-B33631B5E644}"/>
+                <a16:creationId xmlns:a16="http://schemas.microsoft.com/office/drawing/2014/main" id="{DB9AC41B-8BF9-4BFF-839C-7A011FECBF31}"/>
               </a:ext>
             </a:extLst>
           </p:cNvPr>
@@ -4509,7 +4509,7 @@
           <p:cNvPr id="17" name="wire-22">
             <a:extLst xmlns:a="http://schemas.openxmlformats.org/drawingml/2006/main">
               <a:ext uri="{FF2B5EF4-FFF2-40B4-BE49-F238E27FC236}">
-                <a16:creationId xmlns:a16="http://schemas.microsoft.com/office/drawing/2014/main" id="{0F8A381A-C249-4A17-889A-668F6169238D}"/>
+                <a16:creationId xmlns:a16="http://schemas.microsoft.com/office/drawing/2014/main" id="{D583666B-47F9-4349-A60B-584F98ED3B9D}"/>
               </a:ext>
             </a:extLst>
           </p:cNvPr>
@@ -4548,7 +4548,7 @@
           <p:cNvPr id="18" name="wire-23">
             <a:extLst xmlns:a="http://schemas.openxmlformats.org/drawingml/2006/main">
               <a:ext uri="{FF2B5EF4-FFF2-40B4-BE49-F238E27FC236}">
-                <a16:creationId xmlns:a16="http://schemas.microsoft.com/office/drawing/2014/main" id="{2A736FC0-2EF1-42BB-BEB5-BF4539960DB4}"/>
+                <a16:creationId xmlns:a16="http://schemas.microsoft.com/office/drawing/2014/main" id="{FCF2B3CE-7954-411B-85E8-2D882B800DC6}"/>
               </a:ext>
             </a:extLst>
           </p:cNvPr>
@@ -4587,7 +4587,7 @@
           <p:cNvPr id="19" name="wire-24">
             <a:extLst xmlns:a="http://schemas.openxmlformats.org/drawingml/2006/main">
               <a:ext uri="{FF2B5EF4-FFF2-40B4-BE49-F238E27FC236}">
-                <a16:creationId xmlns:a16="http://schemas.microsoft.com/office/drawing/2014/main" id="{0F7E930A-B5C8-410A-8F98-240C6A198D37}"/>
+                <a16:creationId xmlns:a16="http://schemas.microsoft.com/office/drawing/2014/main" id="{F259A039-78D8-48C2-A2C1-AC84F5B48599}"/>
               </a:ext>
             </a:extLst>
           </p:cNvPr>
@@ -4626,7 +4626,7 @@
           <p:cNvPr id="20" name="and-gate-25">
             <a:extLst xmlns:a="http://schemas.openxmlformats.org/drawingml/2006/main">
               <a:ext uri="{FF2B5EF4-FFF2-40B4-BE49-F238E27FC236}">
-                <a16:creationId xmlns:a16="http://schemas.microsoft.com/office/drawing/2014/main" id="{DDBCAA7A-4101-4BDF-B8D0-27CA3E029283}"/>
+                <a16:creationId xmlns:a16="http://schemas.microsoft.com/office/drawing/2014/main" id="{78A04EC9-5213-4B28-B2A1-0729328CC286}"/>
               </a:ext>
             </a:extLst>
           </p:cNvPr>
@@ -4676,7 +4676,7 @@
           <p:cNvPr id="21" name="wire-26">
             <a:extLst xmlns:a="http://schemas.openxmlformats.org/drawingml/2006/main">
               <a:ext uri="{FF2B5EF4-FFF2-40B4-BE49-F238E27FC236}">
-                <a16:creationId xmlns:a16="http://schemas.microsoft.com/office/drawing/2014/main" id="{3602C9C0-A21D-4445-8F6B-6AA2CE6999E1}"/>
+                <a16:creationId xmlns:a16="http://schemas.microsoft.com/office/drawing/2014/main" id="{CA6DA666-6745-46E7-8BEF-7E222CEDF028}"/>
               </a:ext>
             </a:extLst>
           </p:cNvPr>
@@ -4715,7 +4715,7 @@
           <p:cNvPr id="22" name="wire-27">
             <a:extLst xmlns:a="http://schemas.openxmlformats.org/drawingml/2006/main">
               <a:ext uri="{FF2B5EF4-FFF2-40B4-BE49-F238E27FC236}">
-                <a16:creationId xmlns:a16="http://schemas.microsoft.com/office/drawing/2014/main" id="{5EC2B3F0-11FA-4129-A07F-041FA13837A8}"/>
+                <a16:creationId xmlns:a16="http://schemas.microsoft.com/office/drawing/2014/main" id="{88A590A2-7432-4954-9E6C-4F317FF77D9B}"/>
               </a:ext>
             </a:extLst>
           </p:cNvPr>
@@ -4754,7 +4754,7 @@
           <p:cNvPr id="23" name="wire-28">
             <a:extLst xmlns:a="http://schemas.openxmlformats.org/drawingml/2006/main">
               <a:ext uri="{FF2B5EF4-FFF2-40B4-BE49-F238E27FC236}">
-                <a16:creationId xmlns:a16="http://schemas.microsoft.com/office/drawing/2014/main" id="{281AFA48-5631-4B9C-A962-0E849CA3C43F}"/>
+                <a16:creationId xmlns:a16="http://schemas.microsoft.com/office/drawing/2014/main" id="{05557752-FBAC-4E05-8A1E-492D0D9DD963}"/>
               </a:ext>
             </a:extLst>
           </p:cNvPr>
@@ -4793,7 +4793,7 @@
           <p:cNvPr id="24" name="logic-29">
             <a:extLst xmlns:a="http://schemas.openxmlformats.org/drawingml/2006/main">
               <a:ext uri="{FF2B5EF4-FFF2-40B4-BE49-F238E27FC236}">
-                <a16:creationId xmlns:a16="http://schemas.microsoft.com/office/drawing/2014/main" id="{30B72BE8-5F75-404A-A672-3B01C9B8A31F}"/>
+                <a16:creationId xmlns:a16="http://schemas.microsoft.com/office/drawing/2014/main" id="{72FCE0EC-0C1B-407F-B3BD-A7678A3FDEDE}"/>
               </a:ext>
             </a:extLst>
           </p:cNvPr>
@@ -4838,7 +4838,7 @@
           <p:cNvPr id="25" name="wire-30">
             <a:extLst xmlns:a="http://schemas.openxmlformats.org/drawingml/2006/main">
               <a:ext uri="{FF2B5EF4-FFF2-40B4-BE49-F238E27FC236}">
-                <a16:creationId xmlns:a16="http://schemas.microsoft.com/office/drawing/2014/main" id="{BE9315F2-9C4E-42BD-A3A8-DCCCD3028E8E}"/>
+                <a16:creationId xmlns:a16="http://schemas.microsoft.com/office/drawing/2014/main" id="{A70D2938-EB1F-453D-8412-A05260683A57}"/>
               </a:ext>
             </a:extLst>
           </p:cNvPr>
@@ -4877,7 +4877,7 @@
           <p:cNvPr id="26" name="wire-31">
             <a:extLst xmlns:a="http://schemas.openxmlformats.org/drawingml/2006/main">
               <a:ext uri="{FF2B5EF4-FFF2-40B4-BE49-F238E27FC236}">
-                <a16:creationId xmlns:a16="http://schemas.microsoft.com/office/drawing/2014/main" id="{26026D6B-2AA8-438C-AD69-36A1898563ED}"/>
+                <a16:creationId xmlns:a16="http://schemas.microsoft.com/office/drawing/2014/main" id="{02AC4277-3990-4E36-B386-B63A5DB5BBA1}"/>
               </a:ext>
             </a:extLst>
           </p:cNvPr>
@@ -4916,7 +4916,7 @@
           <p:cNvPr id="27" name="text-32">
             <a:extLst xmlns:a="http://schemas.openxmlformats.org/drawingml/2006/main">
               <a:ext uri="{FF2B5EF4-FFF2-40B4-BE49-F238E27FC236}">
-                <a16:creationId xmlns:a16="http://schemas.microsoft.com/office/drawing/2014/main" id="{1C9D6968-27CF-4ED9-BD78-7CFDFAAC18D5}"/>
+                <a16:creationId xmlns:a16="http://schemas.microsoft.com/office/drawing/2014/main" id="{1CAB55F3-FFAB-45F7-BED5-D136AE7A123B}"/>
               </a:ext>
             </a:extLst>
           </p:cNvPr>
@@ -4980,7 +4980,7 @@
     </p:spTree>
     <p:extLst>
       <p:ext uri="{BB962C8B-B14F-4D97-AF65-F5344CB8AC3E}">
-        <p14:creationId xmlns:p14="http://schemas.microsoft.com/office/powerpoint/2010/main" val="218126007"/>
+        <p14:creationId xmlns:p14="http://schemas.microsoft.com/office/powerpoint/2010/main" val="520636860"/>
       </p:ext>
     </p:extLst>
   </p:cSld>
@@ -5011,7 +5011,7 @@
           <p:cNvPr id="47" name="text-33">
             <a:extLst xmlns:a="http://schemas.openxmlformats.org/drawingml/2006/main">
               <a:ext uri="{FF2B5EF4-FFF2-40B4-BE49-F238E27FC236}">
-                <a16:creationId xmlns:a16="http://schemas.microsoft.com/office/drawing/2014/main" id="{90051105-E33E-4190-BBBA-539CA16833F0}"/>
+                <a16:creationId xmlns:a16="http://schemas.microsoft.com/office/drawing/2014/main" id="{DE0F1A8D-9AA3-43C1-A816-CCC884548520}"/>
               </a:ext>
             </a:extLst>
           </p:cNvPr>
@@ -5077,7 +5077,7 @@
           <p:cNvPr id="2" name="text-34">
             <a:extLst xmlns:a="http://schemas.openxmlformats.org/drawingml/2006/main">
               <a:ext uri="{FF2B5EF4-FFF2-40B4-BE49-F238E27FC236}">
-                <a16:creationId xmlns:a16="http://schemas.microsoft.com/office/drawing/2014/main" id="{ACC26168-FBF3-44C6-B54B-87E866206CF4}"/>
+                <a16:creationId xmlns:a16="http://schemas.microsoft.com/office/drawing/2014/main" id="{8D7A5100-7F03-4689-B842-F03DA0D3EAF2}"/>
               </a:ext>
             </a:extLst>
           </p:cNvPr>
@@ -5143,7 +5143,7 @@
           <p:cNvPr id="3" name="circuit-35">
             <a:extLst xmlns:a="http://schemas.openxmlformats.org/drawingml/2006/main">
               <a:ext uri="{FF2B5EF4-FFF2-40B4-BE49-F238E27FC236}">
-                <a16:creationId xmlns:a16="http://schemas.microsoft.com/office/drawing/2014/main" id="{257A3222-B58A-4399-A57B-BA3CFC339A34}"/>
+                <a16:creationId xmlns:a16="http://schemas.microsoft.com/office/drawing/2014/main" id="{B75B7D27-F37E-4802-8329-0D15245667D3}"/>
               </a:ext>
             </a:extLst>
           </p:cNvPr>
@@ -5175,7 +5175,7 @@
           <p:cNvPr id="4" name="circuit-36">
             <a:extLst xmlns:a="http://schemas.openxmlformats.org/drawingml/2006/main">
               <a:ext uri="{FF2B5EF4-FFF2-40B4-BE49-F238E27FC236}">
-                <a16:creationId xmlns:a16="http://schemas.microsoft.com/office/drawing/2014/main" id="{970F8EE6-020F-42E3-91E4-283EBD3C16BC}"/>
+                <a16:creationId xmlns:a16="http://schemas.microsoft.com/office/drawing/2014/main" id="{036F085C-6A3D-4E2F-8B37-276DF089E7A8}"/>
               </a:ext>
             </a:extLst>
           </p:cNvPr>
@@ -5207,7 +5207,7 @@
           <p:cNvPr id="5" name="text-37">
             <a:extLst xmlns:a="http://schemas.openxmlformats.org/drawingml/2006/main">
               <a:ext uri="{FF2B5EF4-FFF2-40B4-BE49-F238E27FC236}">
-                <a16:creationId xmlns:a16="http://schemas.microsoft.com/office/drawing/2014/main" id="{D95408E6-BD9E-481F-BAB7-AE6F335B6F82}"/>
+                <a16:creationId xmlns:a16="http://schemas.microsoft.com/office/drawing/2014/main" id="{828901AC-987B-4E10-B49A-7E7F0D0D651C}"/>
               </a:ext>
             </a:extLst>
           </p:cNvPr>
@@ -5273,7 +5273,7 @@
           <p:cNvPr id="6" name="circuit-38">
             <a:extLst xmlns:a="http://schemas.openxmlformats.org/drawingml/2006/main">
               <a:ext uri="{FF2B5EF4-FFF2-40B4-BE49-F238E27FC236}">
-                <a16:creationId xmlns:a16="http://schemas.microsoft.com/office/drawing/2014/main" id="{EA60743A-318D-4E0F-ADF7-3DD39102BC0B}"/>
+                <a16:creationId xmlns:a16="http://schemas.microsoft.com/office/drawing/2014/main" id="{2739B40C-BB31-42FC-A1C6-11180FF1895E}"/>
               </a:ext>
             </a:extLst>
           </p:cNvPr>
@@ -5305,7 +5305,7 @@
           <p:cNvPr id="7" name="text-39">
             <a:extLst xmlns:a="http://schemas.openxmlformats.org/drawingml/2006/main">
               <a:ext uri="{FF2B5EF4-FFF2-40B4-BE49-F238E27FC236}">
-                <a16:creationId xmlns:a16="http://schemas.microsoft.com/office/drawing/2014/main" id="{FD691EB3-87B0-4FB3-BC71-B46DCF3A5276}"/>
+                <a16:creationId xmlns:a16="http://schemas.microsoft.com/office/drawing/2014/main" id="{BF32214B-05CC-4946-AC36-9D4F3B8683EC}"/>
               </a:ext>
             </a:extLst>
           </p:cNvPr>
@@ -5371,7 +5371,7 @@
           <p:cNvPr id="8" name="circuit-40">
             <a:extLst xmlns:a="http://schemas.openxmlformats.org/drawingml/2006/main">
               <a:ext uri="{FF2B5EF4-FFF2-40B4-BE49-F238E27FC236}">
-                <a16:creationId xmlns:a16="http://schemas.microsoft.com/office/drawing/2014/main" id="{B475EA97-FD6A-44E6-85BE-66071A83BB07}"/>
+                <a16:creationId xmlns:a16="http://schemas.microsoft.com/office/drawing/2014/main" id="{98765259-E442-4199-9CCB-C8696C0A2544}"/>
               </a:ext>
             </a:extLst>
           </p:cNvPr>
@@ -5403,7 +5403,7 @@
           <p:cNvPr id="9" name="text-41">
             <a:extLst xmlns:a="http://schemas.openxmlformats.org/drawingml/2006/main">
               <a:ext uri="{FF2B5EF4-FFF2-40B4-BE49-F238E27FC236}">
-                <a16:creationId xmlns:a16="http://schemas.microsoft.com/office/drawing/2014/main" id="{786711B3-E476-43FF-8ACC-19A5FC677707}"/>
+                <a16:creationId xmlns:a16="http://schemas.microsoft.com/office/drawing/2014/main" id="{BDFC6F0F-3A88-4613-99BD-C23529955BC0}"/>
               </a:ext>
             </a:extLst>
           </p:cNvPr>
@@ -5469,7 +5469,7 @@
           <p:cNvPr id="10" name="circuit-42">
             <a:extLst xmlns:a="http://schemas.openxmlformats.org/drawingml/2006/main">
               <a:ext uri="{FF2B5EF4-FFF2-40B4-BE49-F238E27FC236}">
-                <a16:creationId xmlns:a16="http://schemas.microsoft.com/office/drawing/2014/main" id="{02BDC713-1077-4E00-B314-4E01A170B795}"/>
+                <a16:creationId xmlns:a16="http://schemas.microsoft.com/office/drawing/2014/main" id="{4351597F-E4DA-4836-8A77-7972DCAD3D21}"/>
               </a:ext>
             </a:extLst>
           </p:cNvPr>
@@ -5501,7 +5501,7 @@
           <p:cNvPr id="11" name="text-43">
             <a:extLst xmlns:a="http://schemas.openxmlformats.org/drawingml/2006/main">
               <a:ext uri="{FF2B5EF4-FFF2-40B4-BE49-F238E27FC236}">
-                <a16:creationId xmlns:a16="http://schemas.microsoft.com/office/drawing/2014/main" id="{1813439B-6CD1-4C50-A0FC-3EAC35C7D8D1}"/>
+                <a16:creationId xmlns:a16="http://schemas.microsoft.com/office/drawing/2014/main" id="{552E4753-2A75-4FEA-A4DB-B93AB0F27014}"/>
               </a:ext>
             </a:extLst>
           </p:cNvPr>
@@ -5567,7 +5567,7 @@
           <p:cNvPr id="12" name="circuit-44">
             <a:extLst xmlns:a="http://schemas.openxmlformats.org/drawingml/2006/main">
               <a:ext uri="{FF2B5EF4-FFF2-40B4-BE49-F238E27FC236}">
-                <a16:creationId xmlns:a16="http://schemas.microsoft.com/office/drawing/2014/main" id="{7A41FDDF-41B7-4251-961C-59ADDCFE770D}"/>
+                <a16:creationId xmlns:a16="http://schemas.microsoft.com/office/drawing/2014/main" id="{2F672333-A628-4E94-ABF0-6DC93F8D1102}"/>
               </a:ext>
             </a:extLst>
           </p:cNvPr>
@@ -5599,7 +5599,7 @@
           <p:cNvPr id="13" name="text-45">
             <a:extLst xmlns:a="http://schemas.openxmlformats.org/drawingml/2006/main">
               <a:ext uri="{FF2B5EF4-FFF2-40B4-BE49-F238E27FC236}">
-                <a16:creationId xmlns:a16="http://schemas.microsoft.com/office/drawing/2014/main" id="{20D4E46F-13A0-49B4-AC62-ABB7D93A2BF2}"/>
+                <a16:creationId xmlns:a16="http://schemas.microsoft.com/office/drawing/2014/main" id="{09125A18-5138-46C9-835A-D05A12C41D4E}"/>
               </a:ext>
             </a:extLst>
           </p:cNvPr>
@@ -5665,7 +5665,7 @@
           <p:cNvPr id="14" name="wire-46">
             <a:extLst xmlns:a="http://schemas.openxmlformats.org/drawingml/2006/main">
               <a:ext uri="{FF2B5EF4-FFF2-40B4-BE49-F238E27FC236}">
-                <a16:creationId xmlns:a16="http://schemas.microsoft.com/office/drawing/2014/main" id="{877863DE-6BD9-4CAE-BE66-40A43EFD174E}"/>
+                <a16:creationId xmlns:a16="http://schemas.microsoft.com/office/drawing/2014/main" id="{47B013C5-4D17-439E-8E88-239951796D2B}"/>
               </a:ext>
             </a:extLst>
           </p:cNvPr>
@@ -5704,7 +5704,7 @@
           <p:cNvPr id="15" name="circuit-47">
             <a:extLst xmlns:a="http://schemas.openxmlformats.org/drawingml/2006/main">
               <a:ext uri="{FF2B5EF4-FFF2-40B4-BE49-F238E27FC236}">
-                <a16:creationId xmlns:a16="http://schemas.microsoft.com/office/drawing/2014/main" id="{E7015D89-08FC-48F8-A919-5051022732B5}"/>
+                <a16:creationId xmlns:a16="http://schemas.microsoft.com/office/drawing/2014/main" id="{483E5157-1671-4EA3-A844-52D537668332}"/>
               </a:ext>
             </a:extLst>
           </p:cNvPr>
@@ -5736,7 +5736,7 @@
           <p:cNvPr id="16" name="text-48">
             <a:extLst xmlns:a="http://schemas.openxmlformats.org/drawingml/2006/main">
               <a:ext uri="{FF2B5EF4-FFF2-40B4-BE49-F238E27FC236}">
-                <a16:creationId xmlns:a16="http://schemas.microsoft.com/office/drawing/2014/main" id="{904630D2-FBCC-4BB1-AAC6-012B8C03D992}"/>
+                <a16:creationId xmlns:a16="http://schemas.microsoft.com/office/drawing/2014/main" id="{680EB88D-63CB-4FCE-9CF0-BA2EDC5FB9D3}"/>
               </a:ext>
             </a:extLst>
           </p:cNvPr>
@@ -5802,7 +5802,7 @@
           <p:cNvPr id="17" name="wire-49">
             <a:extLst xmlns:a="http://schemas.openxmlformats.org/drawingml/2006/main">
               <a:ext uri="{FF2B5EF4-FFF2-40B4-BE49-F238E27FC236}">
-                <a16:creationId xmlns:a16="http://schemas.microsoft.com/office/drawing/2014/main" id="{A8757415-8DF6-4388-AD91-0F15601476D0}"/>
+                <a16:creationId xmlns:a16="http://schemas.microsoft.com/office/drawing/2014/main" id="{4A376101-EAC0-4740-A357-1074DA2FE0CD}"/>
               </a:ext>
             </a:extLst>
           </p:cNvPr>
@@ -5841,7 +5841,7 @@
           <p:cNvPr id="18" name="circuit-50">
             <a:extLst xmlns:a="http://schemas.openxmlformats.org/drawingml/2006/main">
               <a:ext uri="{FF2B5EF4-FFF2-40B4-BE49-F238E27FC236}">
-                <a16:creationId xmlns:a16="http://schemas.microsoft.com/office/drawing/2014/main" id="{3407F24A-E881-40F4-BC9A-2331EAFA01BA}"/>
+                <a16:creationId xmlns:a16="http://schemas.microsoft.com/office/drawing/2014/main" id="{01DF810F-AF72-45C3-99B6-E92F8EACD0F5}"/>
               </a:ext>
             </a:extLst>
           </p:cNvPr>
@@ -5873,7 +5873,7 @@
           <p:cNvPr id="19" name="text-51">
             <a:extLst xmlns:a="http://schemas.openxmlformats.org/drawingml/2006/main">
               <a:ext uri="{FF2B5EF4-FFF2-40B4-BE49-F238E27FC236}">
-                <a16:creationId xmlns:a16="http://schemas.microsoft.com/office/drawing/2014/main" id="{EC730C21-59DC-4190-BB21-A9C47C7FB791}"/>
+                <a16:creationId xmlns:a16="http://schemas.microsoft.com/office/drawing/2014/main" id="{E125EF5A-C3A4-4A4D-B957-77F6AFF13EE3}"/>
               </a:ext>
             </a:extLst>
           </p:cNvPr>
@@ -5939,7 +5939,7 @@
           <p:cNvPr id="20" name="wire-52">
             <a:extLst xmlns:a="http://schemas.openxmlformats.org/drawingml/2006/main">
               <a:ext uri="{FF2B5EF4-FFF2-40B4-BE49-F238E27FC236}">
-                <a16:creationId xmlns:a16="http://schemas.microsoft.com/office/drawing/2014/main" id="{89C8A8B7-3F40-4425-A152-7D8CEBD52783}"/>
+                <a16:creationId xmlns:a16="http://schemas.microsoft.com/office/drawing/2014/main" id="{6074213E-5C8C-4A70-80A0-EC326187AB99}"/>
               </a:ext>
             </a:extLst>
           </p:cNvPr>
@@ -5978,7 +5978,7 @@
           <p:cNvPr id="21" name="logic-53">
             <a:extLst xmlns:a="http://schemas.openxmlformats.org/drawingml/2006/main">
               <a:ext uri="{FF2B5EF4-FFF2-40B4-BE49-F238E27FC236}">
-                <a16:creationId xmlns:a16="http://schemas.microsoft.com/office/drawing/2014/main" id="{9301B44C-6C34-43C3-9B82-4161E4BAB5AE}"/>
+                <a16:creationId xmlns:a16="http://schemas.microsoft.com/office/drawing/2014/main" id="{7A5E6A53-86F0-44C0-8BB5-98EB59D08601}"/>
               </a:ext>
             </a:extLst>
           </p:cNvPr>
@@ -6023,7 +6023,7 @@
           <p:cNvPr id="22" name="circuit-54">
             <a:extLst xmlns:a="http://schemas.openxmlformats.org/drawingml/2006/main">
               <a:ext uri="{FF2B5EF4-FFF2-40B4-BE49-F238E27FC236}">
-                <a16:creationId xmlns:a16="http://schemas.microsoft.com/office/drawing/2014/main" id="{BADDCCDF-F065-4AF1-B31C-FD0BC4DD9655}"/>
+                <a16:creationId xmlns:a16="http://schemas.microsoft.com/office/drawing/2014/main" id="{892A185C-68EF-447A-B80C-A2F45060A62B}"/>
               </a:ext>
             </a:extLst>
           </p:cNvPr>
@@ -6055,7 +6055,7 @@
           <p:cNvPr id="23" name="text-55">
             <a:extLst xmlns:a="http://schemas.openxmlformats.org/drawingml/2006/main">
               <a:ext uri="{FF2B5EF4-FFF2-40B4-BE49-F238E27FC236}">
-                <a16:creationId xmlns:a16="http://schemas.microsoft.com/office/drawing/2014/main" id="{5F1E1097-E6DA-4A36-9704-918ED9DE6E20}"/>
+                <a16:creationId xmlns:a16="http://schemas.microsoft.com/office/drawing/2014/main" id="{FFAC963B-7E38-4D1D-BD51-E79C88EA7BBF}"/>
               </a:ext>
             </a:extLst>
           </p:cNvPr>
@@ -6121,7 +6121,7 @@
           <p:cNvPr id="24" name="wire-56">
             <a:extLst xmlns:a="http://schemas.openxmlformats.org/drawingml/2006/main">
               <a:ext uri="{FF2B5EF4-FFF2-40B4-BE49-F238E27FC236}">
-                <a16:creationId xmlns:a16="http://schemas.microsoft.com/office/drawing/2014/main" id="{C8185FCD-9F12-4C02-B116-930E218A66CE}"/>
+                <a16:creationId xmlns:a16="http://schemas.microsoft.com/office/drawing/2014/main" id="{DD5DD714-1B4B-43A4-92D3-0A7D7EEF7F5A}"/>
               </a:ext>
             </a:extLst>
           </p:cNvPr>
@@ -6160,7 +6160,7 @@
           <p:cNvPr id="25" name="wire-57">
             <a:extLst xmlns:a="http://schemas.openxmlformats.org/drawingml/2006/main">
               <a:ext uri="{FF2B5EF4-FFF2-40B4-BE49-F238E27FC236}">
-                <a16:creationId xmlns:a16="http://schemas.microsoft.com/office/drawing/2014/main" id="{36BA6320-909F-49E5-A2E4-6BC3DF25DBB7}"/>
+                <a16:creationId xmlns:a16="http://schemas.microsoft.com/office/drawing/2014/main" id="{9D743BE4-B443-4CEB-953E-FDB2D3772E30}"/>
               </a:ext>
             </a:extLst>
           </p:cNvPr>
@@ -6199,7 +6199,7 @@
           <p:cNvPr id="26" name="circuit-58">
             <a:extLst xmlns:a="http://schemas.openxmlformats.org/drawingml/2006/main">
               <a:ext uri="{FF2B5EF4-FFF2-40B4-BE49-F238E27FC236}">
-                <a16:creationId xmlns:a16="http://schemas.microsoft.com/office/drawing/2014/main" id="{1CD55789-9B41-4AD5-8111-6DCA36E7A7B3}"/>
+                <a16:creationId xmlns:a16="http://schemas.microsoft.com/office/drawing/2014/main" id="{0EF43E5B-D860-41C1-8DDF-966422080BD8}"/>
               </a:ext>
             </a:extLst>
           </p:cNvPr>
@@ -6231,7 +6231,7 @@
           <p:cNvPr id="27" name="text-59">
             <a:extLst xmlns:a="http://schemas.openxmlformats.org/drawingml/2006/main">
               <a:ext uri="{FF2B5EF4-FFF2-40B4-BE49-F238E27FC236}">
-                <a16:creationId xmlns:a16="http://schemas.microsoft.com/office/drawing/2014/main" id="{DDF15DD0-9EAF-49EC-880E-38C92BC1445D}"/>
+                <a16:creationId xmlns:a16="http://schemas.microsoft.com/office/drawing/2014/main" id="{98D8FE9F-7C91-4888-9ABC-59443A4248D4}"/>
               </a:ext>
             </a:extLst>
           </p:cNvPr>
@@ -6320,7 +6320,7 @@
           <p:cNvPr id="28" name="wire-60">
             <a:extLst xmlns:a="http://schemas.openxmlformats.org/drawingml/2006/main">
               <a:ext uri="{FF2B5EF4-FFF2-40B4-BE49-F238E27FC236}">
-                <a16:creationId xmlns:a16="http://schemas.microsoft.com/office/drawing/2014/main" id="{8D59060C-D187-4C10-81B1-53198DAF634F}"/>
+                <a16:creationId xmlns:a16="http://schemas.microsoft.com/office/drawing/2014/main" id="{2726F8E0-2B9B-4A96-A89D-06A3C23837E7}"/>
               </a:ext>
             </a:extLst>
           </p:cNvPr>
@@ -6359,7 +6359,7 @@
           <p:cNvPr id="29" name="circuit-61">
             <a:extLst xmlns:a="http://schemas.openxmlformats.org/drawingml/2006/main">
               <a:ext uri="{FF2B5EF4-FFF2-40B4-BE49-F238E27FC236}">
-                <a16:creationId xmlns:a16="http://schemas.microsoft.com/office/drawing/2014/main" id="{D8E562B5-8F3D-4489-BE5F-2F72A8F8A66F}"/>
+                <a16:creationId xmlns:a16="http://schemas.microsoft.com/office/drawing/2014/main" id="{FFF7D510-1A91-4CBF-AF62-8030149086D1}"/>
               </a:ext>
             </a:extLst>
           </p:cNvPr>
@@ -6391,7 +6391,7 @@
           <p:cNvPr id="30" name="text-62">
             <a:extLst xmlns:a="http://schemas.openxmlformats.org/drawingml/2006/main">
               <a:ext uri="{FF2B5EF4-FFF2-40B4-BE49-F238E27FC236}">
-                <a16:creationId xmlns:a16="http://schemas.microsoft.com/office/drawing/2014/main" id="{6B51C162-02C1-4BB0-9025-65B9EA98FCF7}"/>
+                <a16:creationId xmlns:a16="http://schemas.microsoft.com/office/drawing/2014/main" id="{28A027E8-9CF3-4817-A896-231C357A4CAA}"/>
               </a:ext>
             </a:extLst>
           </p:cNvPr>
@@ -6457,7 +6457,7 @@
           <p:cNvPr id="31" name="wire-63">
             <a:extLst xmlns:a="http://schemas.openxmlformats.org/drawingml/2006/main">
               <a:ext uri="{FF2B5EF4-FFF2-40B4-BE49-F238E27FC236}">
-                <a16:creationId xmlns:a16="http://schemas.microsoft.com/office/drawing/2014/main" id="{B65D87B7-DE36-485B-9AF5-8EB5B3CCF66C}"/>
+                <a16:creationId xmlns:a16="http://schemas.microsoft.com/office/drawing/2014/main" id="{1DA7F7B6-D5A2-4E64-8274-944135A167E1}"/>
               </a:ext>
             </a:extLst>
           </p:cNvPr>
@@ -6496,7 +6496,7 @@
           <p:cNvPr id="32" name="logic-64">
             <a:extLst xmlns:a="http://schemas.openxmlformats.org/drawingml/2006/main">
               <a:ext uri="{FF2B5EF4-FFF2-40B4-BE49-F238E27FC236}">
-                <a16:creationId xmlns:a16="http://schemas.microsoft.com/office/drawing/2014/main" id="{DB7D8458-2E6C-4E72-BBA7-4CE1A64699E6}"/>
+                <a16:creationId xmlns:a16="http://schemas.microsoft.com/office/drawing/2014/main" id="{E502F4A1-F332-4775-9E9F-9B99D49F4B86}"/>
               </a:ext>
             </a:extLst>
           </p:cNvPr>
@@ -6541,7 +6541,7 @@
           <p:cNvPr id="33" name="circuit-65">
             <a:extLst xmlns:a="http://schemas.openxmlformats.org/drawingml/2006/main">
               <a:ext uri="{FF2B5EF4-FFF2-40B4-BE49-F238E27FC236}">
-                <a16:creationId xmlns:a16="http://schemas.microsoft.com/office/drawing/2014/main" id="{A55E8EFE-226A-49B2-A01A-E2E99C38E873}"/>
+                <a16:creationId xmlns:a16="http://schemas.microsoft.com/office/drawing/2014/main" id="{4AFDADAA-FE7A-47CE-BEF3-CE5585FD35CE}"/>
               </a:ext>
             </a:extLst>
           </p:cNvPr>
@@ -6573,7 +6573,7 @@
           <p:cNvPr id="34" name="text-66">
             <a:extLst xmlns:a="http://schemas.openxmlformats.org/drawingml/2006/main">
               <a:ext uri="{FF2B5EF4-FFF2-40B4-BE49-F238E27FC236}">
-                <a16:creationId xmlns:a16="http://schemas.microsoft.com/office/drawing/2014/main" id="{6FE839DC-BAED-4051-9D12-F169CADF50F4}"/>
+                <a16:creationId xmlns:a16="http://schemas.microsoft.com/office/drawing/2014/main" id="{C8D16CD4-54FB-4741-A575-A582391A4151}"/>
               </a:ext>
             </a:extLst>
           </p:cNvPr>
@@ -6662,7 +6662,7 @@
           <p:cNvPr id="35" name="wire-67">
             <a:extLst xmlns:a="http://schemas.openxmlformats.org/drawingml/2006/main">
               <a:ext uri="{FF2B5EF4-FFF2-40B4-BE49-F238E27FC236}">
-                <a16:creationId xmlns:a16="http://schemas.microsoft.com/office/drawing/2014/main" id="{EDC18D8C-2A19-496D-ACDD-401E6C1865E9}"/>
+                <a16:creationId xmlns:a16="http://schemas.microsoft.com/office/drawing/2014/main" id="{96D8855F-AB58-4414-B2BC-77DBAAF62A8C}"/>
               </a:ext>
             </a:extLst>
           </p:cNvPr>
@@ -6701,7 +6701,7 @@
           <p:cNvPr id="36" name="logic-68">
             <a:extLst xmlns:a="http://schemas.openxmlformats.org/drawingml/2006/main">
               <a:ext uri="{FF2B5EF4-FFF2-40B4-BE49-F238E27FC236}">
-                <a16:creationId xmlns:a16="http://schemas.microsoft.com/office/drawing/2014/main" id="{AFECB2BA-AB6C-43FE-9CDD-23BA78D02584}"/>
+                <a16:creationId xmlns:a16="http://schemas.microsoft.com/office/drawing/2014/main" id="{4A812763-56C0-476D-88D3-E206F6577870}"/>
               </a:ext>
             </a:extLst>
           </p:cNvPr>
@@ -6746,7 +6746,7 @@
           <p:cNvPr id="37" name="wire-69">
             <a:extLst xmlns:a="http://schemas.openxmlformats.org/drawingml/2006/main">
               <a:ext uri="{FF2B5EF4-FFF2-40B4-BE49-F238E27FC236}">
-                <a16:creationId xmlns:a16="http://schemas.microsoft.com/office/drawing/2014/main" id="{758701A5-63BC-44AC-8858-C1EB70590939}"/>
+                <a16:creationId xmlns:a16="http://schemas.microsoft.com/office/drawing/2014/main" id="{A56D373D-83E5-47BE-817F-BBF5E487712A}"/>
               </a:ext>
             </a:extLst>
           </p:cNvPr>
@@ -6785,7 +6785,7 @@
           <p:cNvPr id="38" name="wire-70">
             <a:extLst xmlns:a="http://schemas.openxmlformats.org/drawingml/2006/main">
               <a:ext uri="{FF2B5EF4-FFF2-40B4-BE49-F238E27FC236}">
-                <a16:creationId xmlns:a16="http://schemas.microsoft.com/office/drawing/2014/main" id="{28CD32E0-81FE-48D2-A99A-8EA0C27B3DF3}"/>
+                <a16:creationId xmlns:a16="http://schemas.microsoft.com/office/drawing/2014/main" id="{CED2FC9A-3609-4732-B4B8-05A13388D520}"/>
               </a:ext>
             </a:extLst>
           </p:cNvPr>
@@ -6824,7 +6824,7 @@
           <p:cNvPr id="39" name="wire-71">
             <a:extLst xmlns:a="http://schemas.openxmlformats.org/drawingml/2006/main">
               <a:ext uri="{FF2B5EF4-FFF2-40B4-BE49-F238E27FC236}">
-                <a16:creationId xmlns:a16="http://schemas.microsoft.com/office/drawing/2014/main" id="{472D53EC-A841-492B-AB1D-C88B66FCE8FD}"/>
+                <a16:creationId xmlns:a16="http://schemas.microsoft.com/office/drawing/2014/main" id="{37A19555-FA0A-41FD-B5D3-33926F3396BF}"/>
               </a:ext>
             </a:extLst>
           </p:cNvPr>
@@ -6863,7 +6863,7 @@
           <p:cNvPr id="40" name="wire-72">
             <a:extLst xmlns:a="http://schemas.openxmlformats.org/drawingml/2006/main">
               <a:ext uri="{FF2B5EF4-FFF2-40B4-BE49-F238E27FC236}">
-                <a16:creationId xmlns:a16="http://schemas.microsoft.com/office/drawing/2014/main" id="{792C77D9-2046-4E92-A6FC-9B2964FE74EC}"/>
+                <a16:creationId xmlns:a16="http://schemas.microsoft.com/office/drawing/2014/main" id="{9703782F-20D7-4061-BFE6-CDD8FD4FD168}"/>
               </a:ext>
             </a:extLst>
           </p:cNvPr>
@@ -6902,7 +6902,7 @@
           <p:cNvPr id="41" name="logic-73">
             <a:extLst xmlns:a="http://schemas.openxmlformats.org/drawingml/2006/main">
               <a:ext uri="{FF2B5EF4-FFF2-40B4-BE49-F238E27FC236}">
-                <a16:creationId xmlns:a16="http://schemas.microsoft.com/office/drawing/2014/main" id="{5E38A258-5464-47A1-8106-84074A1B82DF}"/>
+                <a16:creationId xmlns:a16="http://schemas.microsoft.com/office/drawing/2014/main" id="{C2E4C551-E4FB-40E7-B729-A21B384A7371}"/>
               </a:ext>
             </a:extLst>
           </p:cNvPr>
@@ -6947,7 +6947,7 @@
           <p:cNvPr id="42" name="text-74">
             <a:extLst xmlns:a="http://schemas.openxmlformats.org/drawingml/2006/main">
               <a:ext uri="{FF2B5EF4-FFF2-40B4-BE49-F238E27FC236}">
-                <a16:creationId xmlns:a16="http://schemas.microsoft.com/office/drawing/2014/main" id="{14D43B27-7C9F-4988-B64E-BF6A97802B6B}"/>
+                <a16:creationId xmlns:a16="http://schemas.microsoft.com/office/drawing/2014/main" id="{E507B445-7656-49A5-B860-648B8DA63689}"/>
               </a:ext>
             </a:extLst>
           </p:cNvPr>
@@ -7013,7 +7013,7 @@
           <p:cNvPr id="43" name="wire-75">
             <a:extLst xmlns:a="http://schemas.openxmlformats.org/drawingml/2006/main">
               <a:ext uri="{FF2B5EF4-FFF2-40B4-BE49-F238E27FC236}">
-                <a16:creationId xmlns:a16="http://schemas.microsoft.com/office/drawing/2014/main" id="{F6656DB9-34DB-4136-9471-5F8ECF888E5C}"/>
+                <a16:creationId xmlns:a16="http://schemas.microsoft.com/office/drawing/2014/main" id="{9AEF0866-2EDC-44C3-AB0E-ABAD51DEBD18}"/>
               </a:ext>
             </a:extLst>
           </p:cNvPr>
@@ -7052,7 +7052,7 @@
           <p:cNvPr id="44" name="logic-76">
             <a:extLst xmlns:a="http://schemas.openxmlformats.org/drawingml/2006/main">
               <a:ext uri="{FF2B5EF4-FFF2-40B4-BE49-F238E27FC236}">
-                <a16:creationId xmlns:a16="http://schemas.microsoft.com/office/drawing/2014/main" id="{3710DE30-9E67-42AA-88D9-D7A3E74DD38E}"/>
+                <a16:creationId xmlns:a16="http://schemas.microsoft.com/office/drawing/2014/main" id="{E79B14BE-9C11-4149-83E6-8C5D430BC74F}"/>
               </a:ext>
             </a:extLst>
           </p:cNvPr>
@@ -7097,7 +7097,7 @@
           <p:cNvPr id="45" name="text-77">
             <a:extLst xmlns:a="http://schemas.openxmlformats.org/drawingml/2006/main">
               <a:ext uri="{FF2B5EF4-FFF2-40B4-BE49-F238E27FC236}">
-                <a16:creationId xmlns:a16="http://schemas.microsoft.com/office/drawing/2014/main" id="{5402DB49-7297-4025-87DE-E8CF043BE518}"/>
+                <a16:creationId xmlns:a16="http://schemas.microsoft.com/office/drawing/2014/main" id="{6CF007BD-0D0E-49EA-9CC1-F587F5E47952}"/>
               </a:ext>
             </a:extLst>
           </p:cNvPr>
@@ -7186,7 +7186,7 @@
           <p:cNvPr id="46" name="text-78">
             <a:extLst xmlns:a="http://schemas.openxmlformats.org/drawingml/2006/main">
               <a:ext uri="{FF2B5EF4-FFF2-40B4-BE49-F238E27FC236}">
-                <a16:creationId xmlns:a16="http://schemas.microsoft.com/office/drawing/2014/main" id="{FD624AFE-44C5-482F-BC5B-07AD594830E1}"/>
+                <a16:creationId xmlns:a16="http://schemas.microsoft.com/office/drawing/2014/main" id="{5AD64B5D-6CAA-41DB-AA20-D119141CEFA8}"/>
               </a:ext>
             </a:extLst>
           </p:cNvPr>
@@ -7250,7 +7250,7 @@
     </p:spTree>
     <p:extLst>
       <p:ext uri="{BB962C8B-B14F-4D97-AF65-F5344CB8AC3E}">
-        <p14:creationId xmlns:p14="http://schemas.microsoft.com/office/powerpoint/2010/main" val="172869916"/>
+        <p14:creationId xmlns:p14="http://schemas.microsoft.com/office/powerpoint/2010/main" val="1588118666"/>
       </p:ext>
     </p:extLst>
   </p:cSld>
@@ -7281,7 +7281,7 @@
           <p:cNvPr id="26" name="text-79">
             <a:extLst xmlns:a="http://schemas.openxmlformats.org/drawingml/2006/main">
               <a:ext uri="{FF2B5EF4-FFF2-40B4-BE49-F238E27FC236}">
-                <a16:creationId xmlns:a16="http://schemas.microsoft.com/office/drawing/2014/main" id="{8D2F374B-8E5F-4C50-A0A7-FC99BF86A66B}"/>
+                <a16:creationId xmlns:a16="http://schemas.microsoft.com/office/drawing/2014/main" id="{2CEC843C-7AF1-4EB0-8A41-1E2C83701C83}"/>
               </a:ext>
             </a:extLst>
           </p:cNvPr>
@@ -7347,7 +7347,7 @@
           <p:cNvPr id="2" name="text-80">
             <a:extLst xmlns:a="http://schemas.openxmlformats.org/drawingml/2006/main">
               <a:ext uri="{FF2B5EF4-FFF2-40B4-BE49-F238E27FC236}">
-                <a16:creationId xmlns:a16="http://schemas.microsoft.com/office/drawing/2014/main" id="{CF71AE6A-379C-47E5-BE40-7FDFDDA7B2B3}"/>
+                <a16:creationId xmlns:a16="http://schemas.microsoft.com/office/drawing/2014/main" id="{49558AD8-F9DE-4FCA-B723-D5FC52143C75}"/>
               </a:ext>
             </a:extLst>
           </p:cNvPr>
@@ -7413,7 +7413,7 @@
           <p:cNvPr id="3" name="circuit-81">
             <a:extLst xmlns:a="http://schemas.openxmlformats.org/drawingml/2006/main">
               <a:ext uri="{FF2B5EF4-FFF2-40B4-BE49-F238E27FC236}">
-                <a16:creationId xmlns:a16="http://schemas.microsoft.com/office/drawing/2014/main" id="{3999FFAA-9B5C-41CC-90E5-EA4CEA415C49}"/>
+                <a16:creationId xmlns:a16="http://schemas.microsoft.com/office/drawing/2014/main" id="{978E1FF2-F1F5-4217-AAAD-9A927F82FF66}"/>
               </a:ext>
             </a:extLst>
           </p:cNvPr>
@@ -7445,7 +7445,7 @@
           <p:cNvPr id="4" name="text-82">
             <a:extLst xmlns:a="http://schemas.openxmlformats.org/drawingml/2006/main">
               <a:ext uri="{FF2B5EF4-FFF2-40B4-BE49-F238E27FC236}">
-                <a16:creationId xmlns:a16="http://schemas.microsoft.com/office/drawing/2014/main" id="{3EBAF4C9-73CA-492B-A9F1-908F44D0977D}"/>
+                <a16:creationId xmlns:a16="http://schemas.microsoft.com/office/drawing/2014/main" id="{2C6B8BAB-65FA-4080-87ED-6AF953F65345}"/>
               </a:ext>
             </a:extLst>
           </p:cNvPr>
@@ -7511,7 +7511,7 @@
           <p:cNvPr id="5" name="circuit-83">
             <a:extLst xmlns:a="http://schemas.openxmlformats.org/drawingml/2006/main">
               <a:ext uri="{FF2B5EF4-FFF2-40B4-BE49-F238E27FC236}">
-                <a16:creationId xmlns:a16="http://schemas.microsoft.com/office/drawing/2014/main" id="{85154BFF-2126-4E68-827C-D612826A0367}"/>
+                <a16:creationId xmlns:a16="http://schemas.microsoft.com/office/drawing/2014/main" id="{06A60284-33F5-494A-828F-D2DA63D2832E}"/>
               </a:ext>
             </a:extLst>
           </p:cNvPr>
@@ -7543,7 +7543,7 @@
           <p:cNvPr id="6" name="text-84">
             <a:extLst xmlns:a="http://schemas.openxmlformats.org/drawingml/2006/main">
               <a:ext uri="{FF2B5EF4-FFF2-40B4-BE49-F238E27FC236}">
-                <a16:creationId xmlns:a16="http://schemas.microsoft.com/office/drawing/2014/main" id="{2D648D1B-3AD2-41DA-ACFB-264206F97F5C}"/>
+                <a16:creationId xmlns:a16="http://schemas.microsoft.com/office/drawing/2014/main" id="{ECAEDDDB-0E24-4F58-B95D-D0D6C63A5779}"/>
               </a:ext>
             </a:extLst>
           </p:cNvPr>
@@ -7609,7 +7609,7 @@
           <p:cNvPr id="7" name="circuit-85">
             <a:extLst xmlns:a="http://schemas.openxmlformats.org/drawingml/2006/main">
               <a:ext uri="{FF2B5EF4-FFF2-40B4-BE49-F238E27FC236}">
-                <a16:creationId xmlns:a16="http://schemas.microsoft.com/office/drawing/2014/main" id="{8E7D37F9-85C4-431B-A2B5-17AC53E0BB44}"/>
+                <a16:creationId xmlns:a16="http://schemas.microsoft.com/office/drawing/2014/main" id="{A6A43697-112B-44C2-B617-4988032B6F9D}"/>
               </a:ext>
             </a:extLst>
           </p:cNvPr>
@@ -7641,7 +7641,7 @@
           <p:cNvPr id="8" name="text-86">
             <a:extLst xmlns:a="http://schemas.openxmlformats.org/drawingml/2006/main">
               <a:ext uri="{FF2B5EF4-FFF2-40B4-BE49-F238E27FC236}">
-                <a16:creationId xmlns:a16="http://schemas.microsoft.com/office/drawing/2014/main" id="{310B3AC9-8005-48B5-B625-E1BA4633F9AE}"/>
+                <a16:creationId xmlns:a16="http://schemas.microsoft.com/office/drawing/2014/main" id="{1A7533A3-0DDA-40B2-B97D-666DF0F5CA49}"/>
               </a:ext>
             </a:extLst>
           </p:cNvPr>
@@ -7707,7 +7707,7 @@
           <p:cNvPr id="9" name="circuit-87">
             <a:extLst xmlns:a="http://schemas.openxmlformats.org/drawingml/2006/main">
               <a:ext uri="{FF2B5EF4-FFF2-40B4-BE49-F238E27FC236}">
-                <a16:creationId xmlns:a16="http://schemas.microsoft.com/office/drawing/2014/main" id="{02BDA81B-27C2-42F9-AFAF-E989DBF0E513}"/>
+                <a16:creationId xmlns:a16="http://schemas.microsoft.com/office/drawing/2014/main" id="{9ED800DD-833D-4E43-9485-88347B078180}"/>
               </a:ext>
             </a:extLst>
           </p:cNvPr>
@@ -7739,7 +7739,7 @@
           <p:cNvPr id="10" name="text-88">
             <a:extLst xmlns:a="http://schemas.openxmlformats.org/drawingml/2006/main">
               <a:ext uri="{FF2B5EF4-FFF2-40B4-BE49-F238E27FC236}">
-                <a16:creationId xmlns:a16="http://schemas.microsoft.com/office/drawing/2014/main" id="{4F6ADF2D-FC97-4484-84B6-0074905FDCEC}"/>
+                <a16:creationId xmlns:a16="http://schemas.microsoft.com/office/drawing/2014/main" id="{08A01343-A90B-435E-BC43-BF423422A4C0}"/>
               </a:ext>
             </a:extLst>
           </p:cNvPr>
@@ -7805,7 +7805,7 @@
           <p:cNvPr id="11" name="wire-89">
             <a:extLst xmlns:a="http://schemas.openxmlformats.org/drawingml/2006/main">
               <a:ext uri="{FF2B5EF4-FFF2-40B4-BE49-F238E27FC236}">
-                <a16:creationId xmlns:a16="http://schemas.microsoft.com/office/drawing/2014/main" id="{0BA7AAB9-903F-414A-9E44-FC1B73B8045C}"/>
+                <a16:creationId xmlns:a16="http://schemas.microsoft.com/office/drawing/2014/main" id="{8F6398AF-343F-4A99-8283-2B98F303CFF9}"/>
               </a:ext>
             </a:extLst>
           </p:cNvPr>
@@ -7844,7 +7844,7 @@
           <p:cNvPr id="12" name="logic-90">
             <a:extLst xmlns:a="http://schemas.openxmlformats.org/drawingml/2006/main">
               <a:ext uri="{FF2B5EF4-FFF2-40B4-BE49-F238E27FC236}">
-                <a16:creationId xmlns:a16="http://schemas.microsoft.com/office/drawing/2014/main" id="{52B70F18-1741-4546-A686-424CDFA932BD}"/>
+                <a16:creationId xmlns:a16="http://schemas.microsoft.com/office/drawing/2014/main" id="{60F88848-36A3-4060-875B-2609B1F512E7}"/>
               </a:ext>
             </a:extLst>
           </p:cNvPr>
@@ -7889,7 +7889,7 @@
           <p:cNvPr id="13" name="wire-91">
             <a:extLst xmlns:a="http://schemas.openxmlformats.org/drawingml/2006/main">
               <a:ext uri="{FF2B5EF4-FFF2-40B4-BE49-F238E27FC236}">
-                <a16:creationId xmlns:a16="http://schemas.microsoft.com/office/drawing/2014/main" id="{2426357E-9D1A-4220-B989-396651277A56}"/>
+                <a16:creationId xmlns:a16="http://schemas.microsoft.com/office/drawing/2014/main" id="{62933A74-5F44-4BB2-8A91-6B12F53A2FEE}"/>
               </a:ext>
             </a:extLst>
           </p:cNvPr>
@@ -7928,7 +7928,7 @@
           <p:cNvPr id="14" name="logic-92">
             <a:extLst xmlns:a="http://schemas.openxmlformats.org/drawingml/2006/main">
               <a:ext uri="{FF2B5EF4-FFF2-40B4-BE49-F238E27FC236}">
-                <a16:creationId xmlns:a16="http://schemas.microsoft.com/office/drawing/2014/main" id="{20E62580-5197-4C03-8F46-377563E6F918}"/>
+                <a16:creationId xmlns:a16="http://schemas.microsoft.com/office/drawing/2014/main" id="{8E812F4A-EFBB-49C7-A875-992E25314938}"/>
               </a:ext>
             </a:extLst>
           </p:cNvPr>
@@ -7973,7 +7973,7 @@
           <p:cNvPr id="15" name="wire-93">
             <a:extLst xmlns:a="http://schemas.openxmlformats.org/drawingml/2006/main">
               <a:ext uri="{FF2B5EF4-FFF2-40B4-BE49-F238E27FC236}">
-                <a16:creationId xmlns:a16="http://schemas.microsoft.com/office/drawing/2014/main" id="{2A801BAE-FBC3-44ED-BF17-B69A6CB22D4A}"/>
+                <a16:creationId xmlns:a16="http://schemas.microsoft.com/office/drawing/2014/main" id="{8FCB49FB-FEAF-4E9B-BBD9-2FF6D281B5CF}"/>
               </a:ext>
             </a:extLst>
           </p:cNvPr>
@@ -8012,7 +8012,7 @@
           <p:cNvPr id="16" name="logic-94">
             <a:extLst xmlns:a="http://schemas.openxmlformats.org/drawingml/2006/main">
               <a:ext uri="{FF2B5EF4-FFF2-40B4-BE49-F238E27FC236}">
-                <a16:creationId xmlns:a16="http://schemas.microsoft.com/office/drawing/2014/main" id="{D2045AD7-A3DE-4B47-9890-13542C0263E9}"/>
+                <a16:creationId xmlns:a16="http://schemas.microsoft.com/office/drawing/2014/main" id="{79784863-1F5C-4CE2-9B57-AD215FF7927C}"/>
               </a:ext>
             </a:extLst>
           </p:cNvPr>
@@ -8057,7 +8057,7 @@
           <p:cNvPr id="17" name="text-95">
             <a:extLst xmlns:a="http://schemas.openxmlformats.org/drawingml/2006/main">
               <a:ext uri="{FF2B5EF4-FFF2-40B4-BE49-F238E27FC236}">
-                <a16:creationId xmlns:a16="http://schemas.microsoft.com/office/drawing/2014/main" id="{D2B31596-797F-4721-8314-F3C3008284C7}"/>
+                <a16:creationId xmlns:a16="http://schemas.microsoft.com/office/drawing/2014/main" id="{E9351406-D0B7-4C5F-9D71-669798016345}"/>
               </a:ext>
             </a:extLst>
           </p:cNvPr>
@@ -8146,7 +8146,7 @@
           <p:cNvPr id="18" name="text-96">
             <a:extLst xmlns:a="http://schemas.openxmlformats.org/drawingml/2006/main">
               <a:ext uri="{FF2B5EF4-FFF2-40B4-BE49-F238E27FC236}">
-                <a16:creationId xmlns:a16="http://schemas.microsoft.com/office/drawing/2014/main" id="{7157200F-7480-4B7D-89C9-3C39F8A601CF}"/>
+                <a16:creationId xmlns:a16="http://schemas.microsoft.com/office/drawing/2014/main" id="{D66BA80A-7DFF-4A31-809E-9D94DE4FBD95}"/>
               </a:ext>
             </a:extLst>
           </p:cNvPr>
@@ -8202,7 +8202,7 @@
                 <a:ea typeface="Meiryo"/>
                 <a:cs typeface="Meiryo"/>
               </a:rPr>
-              <a:t>位置・大きさ・色を</a:t>
+              <a:t>OpenGL互換</a:t>
             </a:r>
           </a:p>
           <a:p xmlns:a="http://schemas.openxmlformats.org/drawingml/2006/main">
@@ -8225,7 +8225,7 @@
                 <a:ea typeface="Meiryo"/>
                 <a:cs typeface="Meiryo"/>
               </a:rPr>
-              <a:t>数値列にして</a:t>
+              <a:t>ライブラリが命令を</a:t>
             </a:r>
           </a:p>
           <a:p xmlns:a="http://schemas.openxmlformats.org/drawingml/2006/main">
@@ -8248,7 +8248,7 @@
                 <a:ea typeface="Meiryo"/>
                 <a:cs typeface="Meiryo"/>
               </a:rPr>
-              <a:t>メモリに保存</a:t>
+              <a:t>メモリに用意</a:t>
             </a:r>
           </a:p>
         </p:txBody>
@@ -8258,7 +8258,7 @@
           <p:cNvPr id="19" name="text-97">
             <a:extLst xmlns:a="http://schemas.openxmlformats.org/drawingml/2006/main">
               <a:ext uri="{FF2B5EF4-FFF2-40B4-BE49-F238E27FC236}">
-                <a16:creationId xmlns:a16="http://schemas.microsoft.com/office/drawing/2014/main" id="{8B42789A-AB31-4167-AB88-C7E8F7E2B596}"/>
+                <a16:creationId xmlns:a16="http://schemas.microsoft.com/office/drawing/2014/main" id="{C6EB3435-B13C-43FB-B339-3E2564808CAD}"/>
               </a:ext>
             </a:extLst>
           </p:cNvPr>
@@ -8347,7 +8347,7 @@
           <p:cNvPr id="20" name="circuit-98">
             <a:extLst xmlns:a="http://schemas.openxmlformats.org/drawingml/2006/main">
               <a:ext uri="{FF2B5EF4-FFF2-40B4-BE49-F238E27FC236}">
-                <a16:creationId xmlns:a16="http://schemas.microsoft.com/office/drawing/2014/main" id="{6C654746-AC76-430A-B981-B73DB9F25CF6}"/>
+                <a16:creationId xmlns:a16="http://schemas.microsoft.com/office/drawing/2014/main" id="{EEA2A087-CE3B-42CF-9C0E-BA42BA254F71}"/>
               </a:ext>
             </a:extLst>
           </p:cNvPr>
@@ -8379,7 +8379,7 @@
           <p:cNvPr id="21" name="circuit-99">
             <a:extLst xmlns:a="http://schemas.openxmlformats.org/drawingml/2006/main">
               <a:ext uri="{FF2B5EF4-FFF2-40B4-BE49-F238E27FC236}">
-                <a16:creationId xmlns:a16="http://schemas.microsoft.com/office/drawing/2014/main" id="{815A3381-8171-4D6E-A567-1F4242F6A6BC}"/>
+                <a16:creationId xmlns:a16="http://schemas.microsoft.com/office/drawing/2014/main" id="{D2748C8D-4A69-4441-9BC5-CEEF7BB301C7}"/>
               </a:ext>
             </a:extLst>
           </p:cNvPr>
@@ -8411,7 +8411,7 @@
           <p:cNvPr id="22" name="wire-100">
             <a:extLst xmlns:a="http://schemas.openxmlformats.org/drawingml/2006/main">
               <a:ext uri="{FF2B5EF4-FFF2-40B4-BE49-F238E27FC236}">
-                <a16:creationId xmlns:a16="http://schemas.microsoft.com/office/drawing/2014/main" id="{46931CDE-23AE-492B-900A-A83583AD1F1D}"/>
+                <a16:creationId xmlns:a16="http://schemas.microsoft.com/office/drawing/2014/main" id="{E45C1318-88DD-4A34-8704-CE03610A757F}"/>
               </a:ext>
             </a:extLst>
           </p:cNvPr>
@@ -8450,7 +8450,7 @@
           <p:cNvPr id="23" name="wire-101">
             <a:extLst xmlns:a="http://schemas.openxmlformats.org/drawingml/2006/main">
               <a:ext uri="{FF2B5EF4-FFF2-40B4-BE49-F238E27FC236}">
-                <a16:creationId xmlns:a16="http://schemas.microsoft.com/office/drawing/2014/main" id="{3670CE56-33A7-4CF6-9097-20C4A31F2776}"/>
+                <a16:creationId xmlns:a16="http://schemas.microsoft.com/office/drawing/2014/main" id="{B3CF5F44-BF42-4452-AF41-004887747A0F}"/>
               </a:ext>
             </a:extLst>
           </p:cNvPr>
@@ -8489,7 +8489,7 @@
           <p:cNvPr id="24" name="text-102">
             <a:extLst xmlns:a="http://schemas.openxmlformats.org/drawingml/2006/main">
               <a:ext uri="{FF2B5EF4-FFF2-40B4-BE49-F238E27FC236}">
-                <a16:creationId xmlns:a16="http://schemas.microsoft.com/office/drawing/2014/main" id="{B8B6D1BC-AEA6-43AB-BFDD-F8A64B3036F3}"/>
+                <a16:creationId xmlns:a16="http://schemas.microsoft.com/office/drawing/2014/main" id="{BF21BC09-CD08-471F-8967-D14E667D9316}"/>
               </a:ext>
             </a:extLst>
           </p:cNvPr>
@@ -8555,7 +8555,7 @@
           <p:cNvPr id="25" name="text-103">
             <a:extLst xmlns:a="http://schemas.openxmlformats.org/drawingml/2006/main">
               <a:ext uri="{FF2B5EF4-FFF2-40B4-BE49-F238E27FC236}">
-                <a16:creationId xmlns:a16="http://schemas.microsoft.com/office/drawing/2014/main" id="{9272B35B-3283-4330-BDB2-D40207EBF3FC}"/>
+                <a16:creationId xmlns:a16="http://schemas.microsoft.com/office/drawing/2014/main" id="{4276F575-7073-4702-A2A0-25E5CF8AEDAA}"/>
               </a:ext>
             </a:extLst>
           </p:cNvPr>
@@ -8619,7 +8619,7 @@
     </p:spTree>
     <p:extLst>
       <p:ext uri="{BB962C8B-B14F-4D97-AF65-F5344CB8AC3E}">
-        <p14:creationId xmlns:p14="http://schemas.microsoft.com/office/powerpoint/2010/main" val="1532464311"/>
+        <p14:creationId xmlns:p14="http://schemas.microsoft.com/office/powerpoint/2010/main" val="574694599"/>
       </p:ext>
     </p:extLst>
   </p:cSld>
@@ -8647,10 +8647,10 @@
       </p:grpSpPr>
       <p:sp>
         <p:nvSpPr>
-          <p:cNvPr id="25" name="text-104">
-            <a:extLst xmlns:a="http://schemas.openxmlformats.org/drawingml/2006/main">
-              <a:ext uri="{FF2B5EF4-FFF2-40B4-BE49-F238E27FC236}">
-                <a16:creationId xmlns:a16="http://schemas.microsoft.com/office/drawing/2014/main" id="{7C7AC933-8077-4F52-8FC6-6D7CA23402BD}"/>
+          <p:cNvPr id="18" name="text-104">
+            <a:extLst xmlns:a="http://schemas.openxmlformats.org/drawingml/2006/main">
+              <a:ext uri="{FF2B5EF4-FFF2-40B4-BE49-F238E27FC236}">
+                <a16:creationId xmlns:a16="http://schemas.microsoft.com/office/drawing/2014/main" id="{55A6CC84-C8B0-4160-93D8-01BEFBE0D451}"/>
               </a:ext>
             </a:extLst>
           </p:cNvPr>
@@ -8706,7 +8706,7 @@
                 <a:ea typeface="Meiryo"/>
                 <a:cs typeface="Meiryo"/>
               </a:rPr>
-              <a:t>命令を預けて、CPUの待ちを減らす</a:t>
+              <a:t>CPUから描画回路へ命令を渡す</a:t>
             </a:r>
           </a:p>
         </p:txBody>
@@ -8716,7 +8716,7 @@
           <p:cNvPr id="2" name="text-105">
             <a:extLst xmlns:a="http://schemas.openxmlformats.org/drawingml/2006/main">
               <a:ext uri="{FF2B5EF4-FFF2-40B4-BE49-F238E27FC236}">
-                <a16:creationId xmlns:a16="http://schemas.microsoft.com/office/drawing/2014/main" id="{C36C4831-DFA2-4ACB-A770-F834D0215FB8}"/>
+                <a16:creationId xmlns:a16="http://schemas.microsoft.com/office/drawing/2014/main" id="{EA0DB09B-F9B9-48B7-9DF2-1AC3DC1C838B}"/>
               </a:ext>
             </a:extLst>
           </p:cNvPr>
@@ -8782,18 +8782,18 @@
           <p:cNvPr id="3" name="circuit-106">
             <a:extLst xmlns:a="http://schemas.openxmlformats.org/drawingml/2006/main">
               <a:ext uri="{FF2B5EF4-FFF2-40B4-BE49-F238E27FC236}">
-                <a16:creationId xmlns:a16="http://schemas.microsoft.com/office/drawing/2014/main" id="{C5964ADD-C748-4ECD-A6E3-CF9E99D3B015}"/>
-              </a:ext>
-            </a:extLst>
-          </p:cNvPr>
-          <p:cNvSpPr>
-            <a:spLocks xmlns:a="http://schemas.openxmlformats.org/drawingml/2006/main" noGrp="1"/>
-          </p:cNvSpPr>
-          <p:nvPr/>
-        </p:nvSpPr>
-        <p:spPr>
-          <a:xfrm xmlns:a="http://schemas.openxmlformats.org/drawingml/2006/main">
-            <a:off x="819150" y="1695450"/>
+                <a16:creationId xmlns:a16="http://schemas.microsoft.com/office/drawing/2014/main" id="{2EF1A8D4-78F7-4E8A-B0EE-95170EC0B481}"/>
+              </a:ext>
+            </a:extLst>
+          </p:cNvPr>
+          <p:cNvSpPr>
+            <a:spLocks xmlns:a="http://schemas.openxmlformats.org/drawingml/2006/main" noGrp="1"/>
+          </p:cNvSpPr>
+          <p:nvPr/>
+        </p:nvSpPr>
+        <p:spPr>
+          <a:xfrm xmlns:a="http://schemas.openxmlformats.org/drawingml/2006/main">
+            <a:off x="819150" y="1676400"/>
             <a:ext cx="2381250" cy="1047750"/>
           </a:xfrm>
           <a:prstGeom xmlns:a="http://schemas.openxmlformats.org/drawingml/2006/main" prst="rect">
@@ -8814,18 +8814,18 @@
           <p:cNvPr id="4" name="text-107">
             <a:extLst xmlns:a="http://schemas.openxmlformats.org/drawingml/2006/main">
               <a:ext uri="{FF2B5EF4-FFF2-40B4-BE49-F238E27FC236}">
-                <a16:creationId xmlns:a16="http://schemas.microsoft.com/office/drawing/2014/main" id="{C096A6AE-D6ED-4DFA-87EA-A5460246B5D6}"/>
-              </a:ext>
-            </a:extLst>
-          </p:cNvPr>
-          <p:cNvSpPr>
-            <a:spLocks xmlns:a="http://schemas.openxmlformats.org/drawingml/2006/main" noGrp="1"/>
-          </p:cNvSpPr>
-          <p:nvPr/>
-        </p:nvSpPr>
-        <p:spPr>
-          <a:xfrm xmlns:a="http://schemas.openxmlformats.org/drawingml/2006/main">
-            <a:off x="933450" y="1752600"/>
+                <a16:creationId xmlns:a16="http://schemas.microsoft.com/office/drawing/2014/main" id="{4A060B5F-E5F5-4D18-938A-396700BA3196}"/>
+              </a:ext>
+            </a:extLst>
+          </p:cNvPr>
+          <p:cNvSpPr>
+            <a:spLocks xmlns:a="http://schemas.openxmlformats.org/drawingml/2006/main" noGrp="1"/>
+          </p:cNvSpPr>
+          <p:nvPr/>
+        </p:nvSpPr>
+        <p:spPr>
+          <a:xfrm xmlns:a="http://schemas.openxmlformats.org/drawingml/2006/main">
+            <a:off x="933450" y="1733550"/>
             <a:ext cx="2152650" cy="933450"/>
           </a:xfrm>
           <a:prstGeom xmlns:a="http://schemas.openxmlformats.org/drawingml/2006/main" prst="rect">
@@ -8903,18 +8903,18 @@
           <p:cNvPr id="5" name="circuit-108">
             <a:extLst xmlns:a="http://schemas.openxmlformats.org/drawingml/2006/main">
               <a:ext uri="{FF2B5EF4-FFF2-40B4-BE49-F238E27FC236}">
-                <a16:creationId xmlns:a16="http://schemas.microsoft.com/office/drawing/2014/main" id="{7DE53A9A-1E98-407F-991E-0012D5DE06B6}"/>
-              </a:ext>
-            </a:extLst>
-          </p:cNvPr>
-          <p:cNvSpPr>
-            <a:spLocks xmlns:a="http://schemas.openxmlformats.org/drawingml/2006/main" noGrp="1"/>
-          </p:cNvSpPr>
-          <p:nvPr/>
-        </p:nvSpPr>
-        <p:spPr>
-          <a:xfrm xmlns:a="http://schemas.openxmlformats.org/drawingml/2006/main">
-            <a:off x="4295775" y="1695450"/>
+                <a16:creationId xmlns:a16="http://schemas.microsoft.com/office/drawing/2014/main" id="{D9D9C3C8-8F64-43FE-B099-FF358670652D}"/>
+              </a:ext>
+            </a:extLst>
+          </p:cNvPr>
+          <p:cNvSpPr>
+            <a:spLocks xmlns:a="http://schemas.openxmlformats.org/drawingml/2006/main" noGrp="1"/>
+          </p:cNvSpPr>
+          <p:nvPr/>
+        </p:nvSpPr>
+        <p:spPr>
+          <a:xfrm xmlns:a="http://schemas.openxmlformats.org/drawingml/2006/main">
+            <a:off x="4295775" y="1676400"/>
             <a:ext cx="3524250" cy="1047750"/>
           </a:xfrm>
           <a:prstGeom xmlns:a="http://schemas.openxmlformats.org/drawingml/2006/main" prst="rect">
@@ -8935,18 +8935,18 @@
           <p:cNvPr id="6" name="text-109">
             <a:extLst xmlns:a="http://schemas.openxmlformats.org/drawingml/2006/main">
               <a:ext uri="{FF2B5EF4-FFF2-40B4-BE49-F238E27FC236}">
-                <a16:creationId xmlns:a16="http://schemas.microsoft.com/office/drawing/2014/main" id="{A1A4F632-FE78-43A3-BE4F-0A3C0DD6F228}"/>
-              </a:ext>
-            </a:extLst>
-          </p:cNvPr>
-          <p:cNvSpPr>
-            <a:spLocks xmlns:a="http://schemas.openxmlformats.org/drawingml/2006/main" noGrp="1"/>
-          </p:cNvSpPr>
-          <p:nvPr/>
-        </p:nvSpPr>
-        <p:spPr>
-          <a:xfrm xmlns:a="http://schemas.openxmlformats.org/drawingml/2006/main">
-            <a:off x="4410075" y="1752600"/>
+                <a16:creationId xmlns:a16="http://schemas.microsoft.com/office/drawing/2014/main" id="{B5442C4B-D603-4D0C-926B-00D8B3E2BEAB}"/>
+              </a:ext>
+            </a:extLst>
+          </p:cNvPr>
+          <p:cNvSpPr>
+            <a:spLocks xmlns:a="http://schemas.openxmlformats.org/drawingml/2006/main" noGrp="1"/>
+          </p:cNvSpPr>
+          <p:nvPr/>
+        </p:nvSpPr>
+        <p:spPr>
+          <a:xfrm xmlns:a="http://schemas.openxmlformats.org/drawingml/2006/main">
+            <a:off x="4410075" y="1733550"/>
             <a:ext cx="3295650" cy="933450"/>
           </a:xfrm>
           <a:prstGeom xmlns:a="http://schemas.openxmlformats.org/drawingml/2006/main" prst="rect">
@@ -8991,7 +8991,7 @@
                 <a:ea typeface="Meiryo"/>
                 <a:cs typeface="Meiryo"/>
               </a:rPr>
-              <a:t>FIFO</a:t>
+              <a:t>接続回路とFIFO</a:t>
             </a:r>
           </a:p>
           <a:p xmlns:a="http://schemas.openxmlformats.org/drawingml/2006/main">
@@ -9024,18 +9024,18 @@
           <p:cNvPr id="7" name="circuit-110">
             <a:extLst xmlns:a="http://schemas.openxmlformats.org/drawingml/2006/main">
               <a:ext uri="{FF2B5EF4-FFF2-40B4-BE49-F238E27FC236}">
-                <a16:creationId xmlns:a16="http://schemas.microsoft.com/office/drawing/2014/main" id="{94AEB361-546D-4302-9DA0-6B4AF9B36CC1}"/>
-              </a:ext>
-            </a:extLst>
-          </p:cNvPr>
-          <p:cNvSpPr>
-            <a:spLocks xmlns:a="http://schemas.openxmlformats.org/drawingml/2006/main" noGrp="1"/>
-          </p:cNvSpPr>
-          <p:nvPr/>
-        </p:nvSpPr>
-        <p:spPr>
-          <a:xfrm xmlns:a="http://schemas.openxmlformats.org/drawingml/2006/main">
-            <a:off x="8915400" y="1695450"/>
+                <a16:creationId xmlns:a16="http://schemas.microsoft.com/office/drawing/2014/main" id="{F44290F1-3D12-4DF0-BB54-06C3060453BF}"/>
+              </a:ext>
+            </a:extLst>
+          </p:cNvPr>
+          <p:cNvSpPr>
+            <a:spLocks xmlns:a="http://schemas.openxmlformats.org/drawingml/2006/main" noGrp="1"/>
+          </p:cNvSpPr>
+          <p:nvPr/>
+        </p:nvSpPr>
+        <p:spPr>
+          <a:xfrm xmlns:a="http://schemas.openxmlformats.org/drawingml/2006/main">
+            <a:off x="8915400" y="1676400"/>
             <a:ext cx="2381250" cy="1047750"/>
           </a:xfrm>
           <a:prstGeom xmlns:a="http://schemas.openxmlformats.org/drawingml/2006/main" prst="rect">
@@ -9056,18 +9056,18 @@
           <p:cNvPr id="8" name="text-111">
             <a:extLst xmlns:a="http://schemas.openxmlformats.org/drawingml/2006/main">
               <a:ext uri="{FF2B5EF4-FFF2-40B4-BE49-F238E27FC236}">
-                <a16:creationId xmlns:a16="http://schemas.microsoft.com/office/drawing/2014/main" id="{F393BB94-ED17-4AA3-A1C6-8FF1B0DC2720}"/>
-              </a:ext>
-            </a:extLst>
-          </p:cNvPr>
-          <p:cNvSpPr>
-            <a:spLocks xmlns:a="http://schemas.openxmlformats.org/drawingml/2006/main" noGrp="1"/>
-          </p:cNvSpPr>
-          <p:nvPr/>
-        </p:nvSpPr>
-        <p:spPr>
-          <a:xfrm xmlns:a="http://schemas.openxmlformats.org/drawingml/2006/main">
-            <a:off x="9029700" y="1752600"/>
+                <a16:creationId xmlns:a16="http://schemas.microsoft.com/office/drawing/2014/main" id="{FCF019ED-79BB-4945-96B3-056553E3CBC7}"/>
+              </a:ext>
+            </a:extLst>
+          </p:cNvPr>
+          <p:cNvSpPr>
+            <a:spLocks xmlns:a="http://schemas.openxmlformats.org/drawingml/2006/main" noGrp="1"/>
+          </p:cNvSpPr>
+          <p:nvPr/>
+        </p:nvSpPr>
+        <p:spPr>
+          <a:xfrm xmlns:a="http://schemas.openxmlformats.org/drawingml/2006/main">
+            <a:off x="9029700" y="1733550"/>
             <a:ext cx="2152650" cy="933450"/>
           </a:xfrm>
           <a:prstGeom xmlns:a="http://schemas.openxmlformats.org/drawingml/2006/main" prst="rect">
@@ -9145,18 +9145,18 @@
           <p:cNvPr id="9" name="wire-112">
             <a:extLst xmlns:a="http://schemas.openxmlformats.org/drawingml/2006/main">
               <a:ext uri="{FF2B5EF4-FFF2-40B4-BE49-F238E27FC236}">
-                <a16:creationId xmlns:a16="http://schemas.microsoft.com/office/drawing/2014/main" id="{C631FDF4-0916-45DC-837F-9A1494AB346B}"/>
-              </a:ext>
-            </a:extLst>
-          </p:cNvPr>
-          <p:cNvSpPr>
-            <a:spLocks xmlns:a="http://schemas.openxmlformats.org/drawingml/2006/main" noGrp="1"/>
-          </p:cNvSpPr>
-          <p:nvPr/>
-        </p:nvSpPr>
-        <p:spPr>
-          <a:xfrm xmlns:a="http://schemas.openxmlformats.org/drawingml/2006/main">
-            <a:off x="3200400" y="2209800"/>
+                <a16:creationId xmlns:a16="http://schemas.microsoft.com/office/drawing/2014/main" id="{09D6E3CF-7902-491E-8175-0C370F5EBAE1}"/>
+              </a:ext>
+            </a:extLst>
+          </p:cNvPr>
+          <p:cNvSpPr>
+            <a:spLocks xmlns:a="http://schemas.openxmlformats.org/drawingml/2006/main" noGrp="1"/>
+          </p:cNvSpPr>
+          <p:nvPr/>
+        </p:nvSpPr>
+        <p:spPr>
+          <a:xfrm xmlns:a="http://schemas.openxmlformats.org/drawingml/2006/main">
+            <a:off x="3200400" y="2190750"/>
             <a:ext cx="1095375" cy="9525"/>
           </a:xfrm>
           <a:custGeom xmlns:a="http://schemas.openxmlformats.org/drawingml/2006/main">
@@ -9184,18 +9184,18 @@
           <p:cNvPr id="10" name="logic-113">
             <a:extLst xmlns:a="http://schemas.openxmlformats.org/drawingml/2006/main">
               <a:ext uri="{FF2B5EF4-FFF2-40B4-BE49-F238E27FC236}">
-                <a16:creationId xmlns:a16="http://schemas.microsoft.com/office/drawing/2014/main" id="{4BA4D2E7-5322-4E04-8F5D-97202718E621}"/>
-              </a:ext>
-            </a:extLst>
-          </p:cNvPr>
-          <p:cNvSpPr>
-            <a:spLocks xmlns:a="http://schemas.openxmlformats.org/drawingml/2006/main" noGrp="1"/>
-          </p:cNvSpPr>
-          <p:nvPr/>
-        </p:nvSpPr>
-        <p:spPr>
-          <a:xfrm xmlns:a="http://schemas.openxmlformats.org/drawingml/2006/main">
-            <a:off x="4181475" y="2162175"/>
+                <a16:creationId xmlns:a16="http://schemas.microsoft.com/office/drawing/2014/main" id="{4B8B4786-6E34-488A-89A7-588772712A6C}"/>
+              </a:ext>
+            </a:extLst>
+          </p:cNvPr>
+          <p:cNvSpPr>
+            <a:spLocks xmlns:a="http://schemas.openxmlformats.org/drawingml/2006/main" noGrp="1"/>
+          </p:cNvSpPr>
+          <p:nvPr/>
+        </p:nvSpPr>
+        <p:spPr>
+          <a:xfrm xmlns:a="http://schemas.openxmlformats.org/drawingml/2006/main">
+            <a:off x="4181475" y="2143125"/>
             <a:ext cx="114300" cy="95250"/>
           </a:xfrm>
           <a:custGeom xmlns:a="http://schemas.openxmlformats.org/drawingml/2006/main">
@@ -9229,18 +9229,18 @@
           <p:cNvPr id="11" name="wire-114">
             <a:extLst xmlns:a="http://schemas.openxmlformats.org/drawingml/2006/main">
               <a:ext uri="{FF2B5EF4-FFF2-40B4-BE49-F238E27FC236}">
-                <a16:creationId xmlns:a16="http://schemas.microsoft.com/office/drawing/2014/main" id="{091E1164-3C24-4030-89C9-66D4BC450E2E}"/>
-              </a:ext>
-            </a:extLst>
-          </p:cNvPr>
-          <p:cNvSpPr>
-            <a:spLocks xmlns:a="http://schemas.openxmlformats.org/drawingml/2006/main" noGrp="1"/>
-          </p:cNvSpPr>
-          <p:nvPr/>
-        </p:nvSpPr>
-        <p:spPr>
-          <a:xfrm xmlns:a="http://schemas.openxmlformats.org/drawingml/2006/main">
-            <a:off x="7820025" y="2209800"/>
+                <a16:creationId xmlns:a16="http://schemas.microsoft.com/office/drawing/2014/main" id="{0EDCB925-ED36-417B-ADCB-39EEC10C9F10}"/>
+              </a:ext>
+            </a:extLst>
+          </p:cNvPr>
+          <p:cNvSpPr>
+            <a:spLocks xmlns:a="http://schemas.openxmlformats.org/drawingml/2006/main" noGrp="1"/>
+          </p:cNvSpPr>
+          <p:nvPr/>
+        </p:nvSpPr>
+        <p:spPr>
+          <a:xfrm xmlns:a="http://schemas.openxmlformats.org/drawingml/2006/main">
+            <a:off x="7820025" y="2190750"/>
             <a:ext cx="1095375" cy="9525"/>
           </a:xfrm>
           <a:custGeom xmlns:a="http://schemas.openxmlformats.org/drawingml/2006/main">
@@ -9268,18 +9268,18 @@
           <p:cNvPr id="12" name="logic-115">
             <a:extLst xmlns:a="http://schemas.openxmlformats.org/drawingml/2006/main">
               <a:ext uri="{FF2B5EF4-FFF2-40B4-BE49-F238E27FC236}">
-                <a16:creationId xmlns:a16="http://schemas.microsoft.com/office/drawing/2014/main" id="{9B81035E-7FA4-475C-BAA2-498E5139BFA7}"/>
-              </a:ext>
-            </a:extLst>
-          </p:cNvPr>
-          <p:cNvSpPr>
-            <a:spLocks xmlns:a="http://schemas.openxmlformats.org/drawingml/2006/main" noGrp="1"/>
-          </p:cNvSpPr>
-          <p:nvPr/>
-        </p:nvSpPr>
-        <p:spPr>
-          <a:xfrm xmlns:a="http://schemas.openxmlformats.org/drawingml/2006/main">
-            <a:off x="8801100" y="2162175"/>
+                <a16:creationId xmlns:a16="http://schemas.microsoft.com/office/drawing/2014/main" id="{D3BA43C9-5423-49FC-8FBA-A96E3EA4BD09}"/>
+              </a:ext>
+            </a:extLst>
+          </p:cNvPr>
+          <p:cNvSpPr>
+            <a:spLocks xmlns:a="http://schemas.openxmlformats.org/drawingml/2006/main" noGrp="1"/>
+          </p:cNvSpPr>
+          <p:nvPr/>
+        </p:nvSpPr>
+        <p:spPr>
+          <a:xfrm xmlns:a="http://schemas.openxmlformats.org/drawingml/2006/main">
+            <a:off x="8801100" y="2143125"/>
             <a:ext cx="114300" cy="95250"/>
           </a:xfrm>
           <a:custGeom xmlns:a="http://schemas.openxmlformats.org/drawingml/2006/main">
@@ -9313,19 +9313,19 @@
           <p:cNvPr id="13" name="text-116">
             <a:extLst xmlns:a="http://schemas.openxmlformats.org/drawingml/2006/main">
               <a:ext uri="{FF2B5EF4-FFF2-40B4-BE49-F238E27FC236}">
-                <a16:creationId xmlns:a16="http://schemas.microsoft.com/office/drawing/2014/main" id="{9EB4D2A7-B9BD-4581-932A-1B876E2BB795}"/>
-              </a:ext>
-            </a:extLst>
-          </p:cNvPr>
-          <p:cNvSpPr>
-            <a:spLocks xmlns:a="http://schemas.openxmlformats.org/drawingml/2006/main" noGrp="1"/>
-          </p:cNvSpPr>
-          <p:nvPr/>
-        </p:nvSpPr>
-        <p:spPr>
-          <a:xfrm xmlns:a="http://schemas.openxmlformats.org/drawingml/2006/main">
-            <a:off x="2305050" y="2943225"/>
-            <a:ext cx="7886700" cy="476250"/>
+                <a16:creationId xmlns:a16="http://schemas.microsoft.com/office/drawing/2014/main" id="{4BEBACA9-608B-4AB2-886B-5338F6090458}"/>
+              </a:ext>
+            </a:extLst>
+          </p:cNvPr>
+          <p:cNvSpPr>
+            <a:spLocks xmlns:a="http://schemas.openxmlformats.org/drawingml/2006/main" noGrp="1"/>
+          </p:cNvSpPr>
+          <p:nvPr/>
+        </p:nvSpPr>
+        <p:spPr>
+          <a:xfrm xmlns:a="http://schemas.openxmlformats.org/drawingml/2006/main">
+            <a:off x="828675" y="3038475"/>
+            <a:ext cx="4667250" cy="476250"/>
           </a:xfrm>
           <a:prstGeom xmlns:a="http://schemas.openxmlformats.org/drawingml/2006/main" prst="rect">
             <a:avLst/>
@@ -9338,8 +9338,8 @@
         <p:txBody>
           <a:bodyPr xmlns:a="http://schemas.openxmlformats.org/drawingml/2006/main" wrap="square" lIns="0" tIns="0" rIns="0" bIns="0" anchor="ctr"/>
           <a:lstStyle xmlns:a="http://schemas.openxmlformats.org/drawingml/2006/main">
-            <a:defPPr algn="ctr">
-              <a:defRPr sz="2250" b="0">
+            <a:defPPr algn="l">
+              <a:defRPr sz="2100" b="0">
                 <a:solidFill>
                   <a:srgbClr val="231F20"/>
                 </a:solidFill>
@@ -9350,8 +9350,8 @@
             </a:defPPr>
           </a:lstStyle>
           <a:p xmlns:a="http://schemas.openxmlformats.org/drawingml/2006/main">
-            <a:pPr algn="ctr">
-              <a:defRPr sz="2250" b="0">
+            <a:pPr algn="l">
+              <a:defRPr sz="2100" b="0">
                 <a:solidFill>
                   <a:srgbClr val="231F20"/>
                 </a:solidFill>
@@ -9361,7 +9361,7 @@
               </a:defRPr>
             </a:pPr>
             <a:r>
-              <a:rPr sz="2250" b="0">
+              <a:rPr sz="2100" b="0">
                 <a:solidFill>
                   <a:srgbClr val="231F20"/>
                 </a:solidFill>
@@ -9369,7 +9369,7 @@
                 <a:ea typeface="Meiryo"/>
                 <a:cs typeface="Meiryo"/>
               </a:rPr>
-              <a:t>空きがあれば、CPUは次の命令へ進める</a:t>
+              <a:t>CPUは番地を指定して書く</a:t>
             </a:r>
           </a:p>
         </p:txBody>
@@ -9379,19 +9379,19 @@
           <p:cNvPr id="14" name="text-117">
             <a:extLst xmlns:a="http://schemas.openxmlformats.org/drawingml/2006/main">
               <a:ext uri="{FF2B5EF4-FFF2-40B4-BE49-F238E27FC236}">
-                <a16:creationId xmlns:a16="http://schemas.microsoft.com/office/drawing/2014/main" id="{BB73D2C2-CEAC-49D1-913D-D30469EED3DB}"/>
-              </a:ext>
-            </a:extLst>
-          </p:cNvPr>
-          <p:cNvSpPr>
-            <a:spLocks xmlns:a="http://schemas.openxmlformats.org/drawingml/2006/main" noGrp="1"/>
-          </p:cNvSpPr>
-          <p:nvPr/>
-        </p:nvSpPr>
-        <p:spPr>
-          <a:xfrm xmlns:a="http://schemas.openxmlformats.org/drawingml/2006/main">
-            <a:off x="857250" y="3857625"/>
-            <a:ext cx="10477500" cy="457200"/>
+                <a16:creationId xmlns:a16="http://schemas.microsoft.com/office/drawing/2014/main" id="{90C61B28-001E-4D9D-834A-E123768B2E51}"/>
+              </a:ext>
+            </a:extLst>
+          </p:cNvPr>
+          <p:cNvSpPr>
+            <a:spLocks xmlns:a="http://schemas.openxmlformats.org/drawingml/2006/main" noGrp="1"/>
+          </p:cNvSpPr>
+          <p:nvPr/>
+        </p:nvSpPr>
+        <p:spPr>
+          <a:xfrm xmlns:a="http://schemas.openxmlformats.org/drawingml/2006/main">
+            <a:off x="6553200" y="3038475"/>
+            <a:ext cx="4762500" cy="476250"/>
           </a:xfrm>
           <a:prstGeom xmlns:a="http://schemas.openxmlformats.org/drawingml/2006/main" prst="rect">
             <a:avLst/>
@@ -9405,7 +9405,7 @@
           <a:bodyPr xmlns:a="http://schemas.openxmlformats.org/drawingml/2006/main" wrap="square" lIns="0" tIns="0" rIns="0" bIns="0" anchor="ctr"/>
           <a:lstStyle xmlns:a="http://schemas.openxmlformats.org/drawingml/2006/main">
             <a:defPPr algn="l">
-              <a:defRPr sz="2250" b="1">
+              <a:defRPr sz="2100" b="0">
                 <a:solidFill>
                   <a:srgbClr val="231F20"/>
                 </a:solidFill>
@@ -9417,7 +9417,7 @@
           </a:lstStyle>
           <a:p xmlns:a="http://schemas.openxmlformats.org/drawingml/2006/main">
             <a:pPr algn="l">
-              <a:defRPr sz="2250" b="1">
+              <a:defRPr sz="2100" b="0">
                 <a:solidFill>
                   <a:srgbClr val="231F20"/>
                 </a:solidFill>
@@ -9427,7 +9427,7 @@
               </a:defRPr>
             </a:pPr>
             <a:r>
-              <a:rPr sz="2250" b="1">
+              <a:rPr sz="2100" b="0">
                 <a:solidFill>
                   <a:srgbClr val="231F20"/>
                 </a:solidFill>
@@ -9435,7 +9435,7 @@
                 <a:ea typeface="Meiryo"/>
                 <a:cs typeface="Meiryo"/>
               </a:rPr>
-              <a:t>1画面分の命令を送る間の待ち時間</a:t>
+              <a:t>RasterIXは命令を順に受け取る</a:t>
             </a:r>
           </a:p>
         </p:txBody>
@@ -9445,19 +9445,19 @@
           <p:cNvPr id="15" name="text-118">
             <a:extLst xmlns:a="http://schemas.openxmlformats.org/drawingml/2006/main">
               <a:ext uri="{FF2B5EF4-FFF2-40B4-BE49-F238E27FC236}">
-                <a16:creationId xmlns:a16="http://schemas.microsoft.com/office/drawing/2014/main" id="{4F0ECE25-CAA4-4A94-8CF0-0AABFEC88EF1}"/>
-              </a:ext>
-            </a:extLst>
-          </p:cNvPr>
-          <p:cNvSpPr>
-            <a:spLocks xmlns:a="http://schemas.openxmlformats.org/drawingml/2006/main" noGrp="1"/>
-          </p:cNvSpPr>
-          <p:nvPr/>
-        </p:nvSpPr>
-        <p:spPr>
-          <a:xfrm xmlns:a="http://schemas.openxmlformats.org/drawingml/2006/main">
-            <a:off x="990600" y="4514850"/>
-            <a:ext cx="2305050" cy="381000"/>
+                <a16:creationId xmlns:a16="http://schemas.microsoft.com/office/drawing/2014/main" id="{DA7A911C-0901-4B62-9E85-036754E4696A}"/>
+              </a:ext>
+            </a:extLst>
+          </p:cNvPr>
+          <p:cNvSpPr>
+            <a:spLocks xmlns:a="http://schemas.openxmlformats.org/drawingml/2006/main" noGrp="1"/>
+          </p:cNvSpPr>
+          <p:nvPr/>
+        </p:nvSpPr>
+        <p:spPr>
+          <a:xfrm xmlns:a="http://schemas.openxmlformats.org/drawingml/2006/main">
+            <a:off x="828675" y="4114800"/>
+            <a:ext cx="10477500" cy="552450"/>
           </a:xfrm>
           <a:prstGeom xmlns:a="http://schemas.openxmlformats.org/drawingml/2006/main" prst="rect">
             <a:avLst/>
@@ -9470,8 +9470,8 @@
         <p:txBody>
           <a:bodyPr xmlns:a="http://schemas.openxmlformats.org/drawingml/2006/main" wrap="square" lIns="0" tIns="0" rIns="0" bIns="0" anchor="ctr"/>
           <a:lstStyle xmlns:a="http://schemas.openxmlformats.org/drawingml/2006/main">
-            <a:defPPr algn="l">
-              <a:defRPr sz="1950" b="0">
+            <a:defPPr algn="ctr">
+              <a:defRPr sz="2550" b="1">
                 <a:solidFill>
                   <a:srgbClr val="231F20"/>
                 </a:solidFill>
@@ -9482,8 +9482,8 @@
             </a:defPPr>
           </a:lstStyle>
           <a:p xmlns:a="http://schemas.openxmlformats.org/drawingml/2006/main">
-            <a:pPr algn="l">
-              <a:defRPr sz="1950" b="0">
+            <a:pPr algn="ctr">
+              <a:defRPr sz="2550" b="1">
                 <a:solidFill>
                   <a:srgbClr val="231F20"/>
                 </a:solidFill>
@@ -9493,7 +9493,7 @@
               </a:defRPr>
             </a:pPr>
             <a:r>
-              <a:rPr sz="1950" b="0">
+              <a:rPr sz="2550" b="1">
                 <a:solidFill>
                   <a:srgbClr val="231F20"/>
                 </a:solidFill>
@@ -9501,61 +9501,29 @@
                 <a:ea typeface="Meiryo"/>
                 <a:cs typeface="Meiryo"/>
               </a:rPr>
-              <a:t>1語ずつ渡す</a:t>
+              <a:t>接続回路が、両側の受け渡しをつなぐ</a:t>
             </a:r>
           </a:p>
         </p:txBody>
       </p:sp>
       <p:sp>
         <p:nvSpPr>
-          <p:cNvPr id="16" name="circuit-119">
-            <a:extLst xmlns:a="http://schemas.openxmlformats.org/drawingml/2006/main">
-              <a:ext uri="{FF2B5EF4-FFF2-40B4-BE49-F238E27FC236}">
-                <a16:creationId xmlns:a16="http://schemas.microsoft.com/office/drawing/2014/main" id="{A65FC2B3-8738-49CE-97BB-04C1069653D7}"/>
-              </a:ext>
-            </a:extLst>
-          </p:cNvPr>
-          <p:cNvSpPr>
-            <a:spLocks xmlns:a="http://schemas.openxmlformats.org/drawingml/2006/main" noGrp="1"/>
-          </p:cNvSpPr>
-          <p:nvPr/>
-        </p:nvSpPr>
-        <p:spPr>
-          <a:xfrm xmlns:a="http://schemas.openxmlformats.org/drawingml/2006/main">
-            <a:off x="3371850" y="4552950"/>
-            <a:ext cx="5565162" cy="276225"/>
-          </a:xfrm>
-          <a:prstGeom xmlns:a="http://schemas.openxmlformats.org/drawingml/2006/main" prst="rect">
-            <a:avLst/>
-          </a:prstGeom>
-          <a:solidFill xmlns:a="http://schemas.openxmlformats.org/drawingml/2006/main">
-            <a:srgbClr val="77A3DC"/>
-          </a:solidFill>
-          <a:ln xmlns:a="http://schemas.openxmlformats.org/drawingml/2006/main" w="19050">
-            <a:solidFill>
-              <a:srgbClr val="231F20"/>
-            </a:solidFill>
-          </a:ln>
-        </p:spPr>
-      </p:sp>
-      <p:sp>
-        <p:nvSpPr>
-          <p:cNvPr id="17" name="text-120">
-            <a:extLst xmlns:a="http://schemas.openxmlformats.org/drawingml/2006/main">
-              <a:ext uri="{FF2B5EF4-FFF2-40B4-BE49-F238E27FC236}">
-                <a16:creationId xmlns:a16="http://schemas.microsoft.com/office/drawing/2014/main" id="{93E034CD-87CF-4636-A1F1-E52D492164E5}"/>
-              </a:ext>
-            </a:extLst>
-          </p:cNvPr>
-          <p:cNvSpPr>
-            <a:spLocks xmlns:a="http://schemas.openxmlformats.org/drawingml/2006/main" noGrp="1"/>
-          </p:cNvSpPr>
-          <p:nvPr/>
-        </p:nvSpPr>
-        <p:spPr>
-          <a:xfrm xmlns:a="http://schemas.openxmlformats.org/drawingml/2006/main">
-            <a:off x="9248775" y="4514850"/>
-            <a:ext cx="2000250" cy="381000"/>
+          <p:cNvPr id="16" name="text-119">
+            <a:extLst xmlns:a="http://schemas.openxmlformats.org/drawingml/2006/main">
+              <a:ext uri="{FF2B5EF4-FFF2-40B4-BE49-F238E27FC236}">
+                <a16:creationId xmlns:a16="http://schemas.microsoft.com/office/drawing/2014/main" id="{B662DB2F-6E47-49B0-BFCF-0BA3C79B3FDC}"/>
+              </a:ext>
+            </a:extLst>
+          </p:cNvPr>
+          <p:cNvSpPr>
+            <a:spLocks xmlns:a="http://schemas.openxmlformats.org/drawingml/2006/main" noGrp="1"/>
+          </p:cNvSpPr>
+          <p:nvPr/>
+        </p:nvSpPr>
+        <p:spPr>
+          <a:xfrm xmlns:a="http://schemas.openxmlformats.org/drawingml/2006/main">
+            <a:off x="1143000" y="5010150"/>
+            <a:ext cx="10096500" cy="476250"/>
           </a:xfrm>
           <a:prstGeom xmlns:a="http://schemas.openxmlformats.org/drawingml/2006/main" prst="rect">
             <a:avLst/>
@@ -9568,8 +9536,8 @@
         <p:txBody>
           <a:bodyPr xmlns:a="http://schemas.openxmlformats.org/drawingml/2006/main" wrap="square" lIns="0" tIns="0" rIns="0" bIns="0" anchor="ctr"/>
           <a:lstStyle xmlns:a="http://schemas.openxmlformats.org/drawingml/2006/main">
-            <a:defPPr algn="l">
-              <a:defRPr sz="1950" b="0">
+            <a:defPPr algn="ctr">
+              <a:defRPr sz="2250" b="0">
                 <a:solidFill>
                   <a:srgbClr val="231F20"/>
                 </a:solidFill>
@@ -9580,8 +9548,8 @@
             </a:defPPr>
           </a:lstStyle>
           <a:p xmlns:a="http://schemas.openxmlformats.org/drawingml/2006/main">
-            <a:pPr algn="l">
-              <a:defRPr sz="1950" b="0">
+            <a:pPr algn="ctr">
+              <a:defRPr sz="2250" b="0">
                 <a:solidFill>
                   <a:srgbClr val="231F20"/>
                 </a:solidFill>
@@ -9591,7 +9559,7 @@
               </a:defRPr>
             </a:pPr>
             <a:r>
-              <a:rPr sz="1950" b="0">
+              <a:rPr sz="2250" b="0">
                 <a:solidFill>
                   <a:srgbClr val="231F20"/>
                 </a:solidFill>
@@ -9599,29 +9567,29 @@
                 <a:ea typeface="Meiryo"/>
                 <a:cs typeface="Meiryo"/>
               </a:rPr>
-              <a:t>4.393 ms</a:t>
+              <a:t>別々のクロックでも、値と順番を保つ</a:t>
             </a:r>
           </a:p>
         </p:txBody>
       </p:sp>
       <p:sp>
         <p:nvSpPr>
-          <p:cNvPr id="18" name="text-121">
-            <a:extLst xmlns:a="http://schemas.openxmlformats.org/drawingml/2006/main">
-              <a:ext uri="{FF2B5EF4-FFF2-40B4-BE49-F238E27FC236}">
-                <a16:creationId xmlns:a16="http://schemas.microsoft.com/office/drawing/2014/main" id="{01F6A79D-6EB9-4B57-ACEF-7757CB3E8001}"/>
-              </a:ext>
-            </a:extLst>
-          </p:cNvPr>
-          <p:cNvSpPr>
-            <a:spLocks xmlns:a="http://schemas.openxmlformats.org/drawingml/2006/main" noGrp="1"/>
-          </p:cNvSpPr>
-          <p:nvPr/>
-        </p:nvSpPr>
-        <p:spPr>
-          <a:xfrm xmlns:a="http://schemas.openxmlformats.org/drawingml/2006/main">
-            <a:off x="990600" y="5029200"/>
-            <a:ext cx="2305050" cy="381000"/>
+          <p:cNvPr id="17" name="text-120">
+            <a:extLst xmlns:a="http://schemas.openxmlformats.org/drawingml/2006/main">
+              <a:ext uri="{FF2B5EF4-FFF2-40B4-BE49-F238E27FC236}">
+                <a16:creationId xmlns:a16="http://schemas.microsoft.com/office/drawing/2014/main" id="{7B95B59C-1E5E-4E61-ABE2-332403393202}"/>
+              </a:ext>
+            </a:extLst>
+          </p:cNvPr>
+          <p:cNvSpPr>
+            <a:spLocks xmlns:a="http://schemas.openxmlformats.org/drawingml/2006/main" noGrp="1"/>
+          </p:cNvSpPr>
+          <p:nvPr/>
+        </p:nvSpPr>
+        <p:spPr>
+          <a:xfrm xmlns:a="http://schemas.openxmlformats.org/drawingml/2006/main">
+            <a:off x="1143000" y="5715000"/>
+            <a:ext cx="10096500" cy="476250"/>
           </a:xfrm>
           <a:prstGeom xmlns:a="http://schemas.openxmlformats.org/drawingml/2006/main" prst="rect">
             <a:avLst/>
@@ -9634,8 +9602,8 @@
         <p:txBody>
           <a:bodyPr xmlns:a="http://schemas.openxmlformats.org/drawingml/2006/main" wrap="square" lIns="0" tIns="0" rIns="0" bIns="0" anchor="ctr"/>
           <a:lstStyle xmlns:a="http://schemas.openxmlformats.org/drawingml/2006/main">
-            <a:defPPr algn="l">
-              <a:defRPr sz="1950" b="0">
+            <a:defPPr algn="ctr">
+              <a:defRPr sz="2175" b="0">
                 <a:solidFill>
                   <a:srgbClr val="231F20"/>
                 </a:solidFill>
@@ -9646,8 +9614,8 @@
             </a:defPPr>
           </a:lstStyle>
           <a:p xmlns:a="http://schemas.openxmlformats.org/drawingml/2006/main">
-            <a:pPr algn="l">
-              <a:defRPr sz="1950" b="0">
+            <a:pPr algn="ctr">
+              <a:defRPr sz="2175" b="0">
                 <a:solidFill>
                   <a:srgbClr val="231F20"/>
                 </a:solidFill>
@@ -9657,7 +9625,7 @@
               </a:defRPr>
             </a:pPr>
             <a:r>
-              <a:rPr sz="1950" b="0">
+              <a:rPr sz="2175" b="0">
                 <a:solidFill>
                   <a:srgbClr val="231F20"/>
                 </a:solidFill>
@@ -9665,335 +9633,7 @@
                 <a:ea typeface="Meiryo"/>
                 <a:cs typeface="Meiryo"/>
               </a:rPr>
-              <a:t>16語FIFO</a:t>
-            </a:r>
-          </a:p>
-        </p:txBody>
-      </p:sp>
-      <p:sp>
-        <p:nvSpPr>
-          <p:cNvPr id="19" name="circuit-122">
-            <a:extLst xmlns:a="http://schemas.openxmlformats.org/drawingml/2006/main">
-              <a:ext uri="{FF2B5EF4-FFF2-40B4-BE49-F238E27FC236}">
-                <a16:creationId xmlns:a16="http://schemas.microsoft.com/office/drawing/2014/main" id="{8686FD7C-0092-4651-BDC3-374F79ACC78C}"/>
-              </a:ext>
-            </a:extLst>
-          </p:cNvPr>
-          <p:cNvSpPr>
-            <a:spLocks xmlns:a="http://schemas.openxmlformats.org/drawingml/2006/main" noGrp="1"/>
-          </p:cNvSpPr>
-          <p:nvPr/>
-        </p:nvSpPr>
-        <p:spPr>
-          <a:xfrm xmlns:a="http://schemas.openxmlformats.org/drawingml/2006/main">
-            <a:off x="3371850" y="5067300"/>
-            <a:ext cx="2855424" cy="276225"/>
-          </a:xfrm>
-          <a:prstGeom xmlns:a="http://schemas.openxmlformats.org/drawingml/2006/main" prst="rect">
-            <a:avLst/>
-          </a:prstGeom>
-          <a:solidFill xmlns:a="http://schemas.openxmlformats.org/drawingml/2006/main">
-            <a:srgbClr val="77A3DC"/>
-          </a:solidFill>
-          <a:ln xmlns:a="http://schemas.openxmlformats.org/drawingml/2006/main" w="19050">
-            <a:solidFill>
-              <a:srgbClr val="231F20"/>
-            </a:solidFill>
-          </a:ln>
-        </p:spPr>
-      </p:sp>
-      <p:sp>
-        <p:nvSpPr>
-          <p:cNvPr id="20" name="text-123">
-            <a:extLst xmlns:a="http://schemas.openxmlformats.org/drawingml/2006/main">
-              <a:ext uri="{FF2B5EF4-FFF2-40B4-BE49-F238E27FC236}">
-                <a16:creationId xmlns:a16="http://schemas.microsoft.com/office/drawing/2014/main" id="{5E4EC65C-0E63-45A0-8B00-9D18B99F7EB1}"/>
-              </a:ext>
-            </a:extLst>
-          </p:cNvPr>
-          <p:cNvSpPr>
-            <a:spLocks xmlns:a="http://schemas.openxmlformats.org/drawingml/2006/main" noGrp="1"/>
-          </p:cNvSpPr>
-          <p:nvPr/>
-        </p:nvSpPr>
-        <p:spPr>
-          <a:xfrm xmlns:a="http://schemas.openxmlformats.org/drawingml/2006/main">
-            <a:off x="9248775" y="5029200"/>
-            <a:ext cx="2000250" cy="381000"/>
-          </a:xfrm>
-          <a:prstGeom xmlns:a="http://schemas.openxmlformats.org/drawingml/2006/main" prst="rect">
-            <a:avLst/>
-          </a:prstGeom>
-          <a:noFill xmlns:a="http://schemas.openxmlformats.org/drawingml/2006/main"/>
-          <a:ln xmlns:a="http://schemas.openxmlformats.org/drawingml/2006/main" w="0">
-            <a:noFill/>
-          </a:ln>
-        </p:spPr>
-        <p:txBody>
-          <a:bodyPr xmlns:a="http://schemas.openxmlformats.org/drawingml/2006/main" wrap="square" lIns="0" tIns="0" rIns="0" bIns="0" anchor="ctr"/>
-          <a:lstStyle xmlns:a="http://schemas.openxmlformats.org/drawingml/2006/main">
-            <a:defPPr algn="l">
-              <a:defRPr sz="1950" b="0">
-                <a:solidFill>
-                  <a:srgbClr val="231F20"/>
-                </a:solidFill>
-                <a:latin typeface="Meiryo"/>
-                <a:ea typeface="Meiryo"/>
-                <a:cs typeface="Meiryo"/>
-              </a:defRPr>
-            </a:defPPr>
-          </a:lstStyle>
-          <a:p xmlns:a="http://schemas.openxmlformats.org/drawingml/2006/main">
-            <a:pPr algn="l">
-              <a:defRPr sz="1950" b="0">
-                <a:solidFill>
-                  <a:srgbClr val="231F20"/>
-                </a:solidFill>
-                <a:latin typeface="Meiryo"/>
-                <a:ea typeface="Meiryo"/>
-                <a:cs typeface="Meiryo"/>
-              </a:defRPr>
-            </a:pPr>
-            <a:r>
-              <a:rPr sz="1950" b="0">
-                <a:solidFill>
-                  <a:srgbClr val="231F20"/>
-                </a:solidFill>
-                <a:latin typeface="Meiryo"/>
-                <a:ea typeface="Meiryo"/>
-                <a:cs typeface="Meiryo"/>
-              </a:rPr>
-              <a:t>2.254 ms</a:t>
-            </a:r>
-          </a:p>
-        </p:txBody>
-      </p:sp>
-      <p:sp>
-        <p:nvSpPr>
-          <p:cNvPr id="21" name="text-124">
-            <a:extLst xmlns:a="http://schemas.openxmlformats.org/drawingml/2006/main">
-              <a:ext uri="{FF2B5EF4-FFF2-40B4-BE49-F238E27FC236}">
-                <a16:creationId xmlns:a16="http://schemas.microsoft.com/office/drawing/2014/main" id="{DD182184-5C06-4782-9D1C-A7580640E06D}"/>
-              </a:ext>
-            </a:extLst>
-          </p:cNvPr>
-          <p:cNvSpPr>
-            <a:spLocks xmlns:a="http://schemas.openxmlformats.org/drawingml/2006/main" noGrp="1"/>
-          </p:cNvSpPr>
-          <p:nvPr/>
-        </p:nvSpPr>
-        <p:spPr>
-          <a:xfrm xmlns:a="http://schemas.openxmlformats.org/drawingml/2006/main">
-            <a:off x="990600" y="5543550"/>
-            <a:ext cx="2305050" cy="381000"/>
-          </a:xfrm>
-          <a:prstGeom xmlns:a="http://schemas.openxmlformats.org/drawingml/2006/main" prst="rect">
-            <a:avLst/>
-          </a:prstGeom>
-          <a:noFill xmlns:a="http://schemas.openxmlformats.org/drawingml/2006/main"/>
-          <a:ln xmlns:a="http://schemas.openxmlformats.org/drawingml/2006/main" w="0">
-            <a:noFill/>
-          </a:ln>
-        </p:spPr>
-        <p:txBody>
-          <a:bodyPr xmlns:a="http://schemas.openxmlformats.org/drawingml/2006/main" wrap="square" lIns="0" tIns="0" rIns="0" bIns="0" anchor="ctr"/>
-          <a:lstStyle xmlns:a="http://schemas.openxmlformats.org/drawingml/2006/main">
-            <a:defPPr algn="l">
-              <a:defRPr sz="1950" b="0">
-                <a:solidFill>
-                  <a:srgbClr val="231F20"/>
-                </a:solidFill>
-                <a:latin typeface="Meiryo"/>
-                <a:ea typeface="Meiryo"/>
-                <a:cs typeface="Meiryo"/>
-              </a:defRPr>
-            </a:defPPr>
-          </a:lstStyle>
-          <a:p xmlns:a="http://schemas.openxmlformats.org/drawingml/2006/main">
-            <a:pPr algn="l">
-              <a:defRPr sz="1950" b="0">
-                <a:solidFill>
-                  <a:srgbClr val="231F20"/>
-                </a:solidFill>
-                <a:latin typeface="Meiryo"/>
-                <a:ea typeface="Meiryo"/>
-                <a:cs typeface="Meiryo"/>
-              </a:defRPr>
-            </a:pPr>
-            <a:r>
-              <a:rPr sz="1950" b="0">
-                <a:solidFill>
-                  <a:srgbClr val="231F20"/>
-                </a:solidFill>
-                <a:latin typeface="Meiryo"/>
-                <a:ea typeface="Meiryo"/>
-                <a:cs typeface="Meiryo"/>
-              </a:rPr>
-              <a:t>512語FIFO</a:t>
-            </a:r>
-          </a:p>
-        </p:txBody>
-      </p:sp>
-      <p:sp>
-        <p:nvSpPr>
-          <p:cNvPr id="22" name="circuit-125">
-            <a:extLst xmlns:a="http://schemas.openxmlformats.org/drawingml/2006/main">
-              <a:ext uri="{FF2B5EF4-FFF2-40B4-BE49-F238E27FC236}">
-                <a16:creationId xmlns:a16="http://schemas.microsoft.com/office/drawing/2014/main" id="{DF8F08F4-A066-4093-B18C-F05A327F81ED}"/>
-              </a:ext>
-            </a:extLst>
-          </p:cNvPr>
-          <p:cNvSpPr>
-            <a:spLocks xmlns:a="http://schemas.openxmlformats.org/drawingml/2006/main" noGrp="1"/>
-          </p:cNvSpPr>
-          <p:nvPr/>
-        </p:nvSpPr>
-        <p:spPr>
-          <a:xfrm xmlns:a="http://schemas.openxmlformats.org/drawingml/2006/main">
-            <a:off x="3371850" y="5581650"/>
-            <a:ext cx="589074" cy="276225"/>
-          </a:xfrm>
-          <a:prstGeom xmlns:a="http://schemas.openxmlformats.org/drawingml/2006/main" prst="rect">
-            <a:avLst/>
-          </a:prstGeom>
-          <a:solidFill xmlns:a="http://schemas.openxmlformats.org/drawingml/2006/main">
-            <a:srgbClr val="77A3DC"/>
-          </a:solidFill>
-          <a:ln xmlns:a="http://schemas.openxmlformats.org/drawingml/2006/main" w="19050">
-            <a:solidFill>
-              <a:srgbClr val="231F20"/>
-            </a:solidFill>
-          </a:ln>
-        </p:spPr>
-      </p:sp>
-      <p:sp>
-        <p:nvSpPr>
-          <p:cNvPr id="23" name="text-126">
-            <a:extLst xmlns:a="http://schemas.openxmlformats.org/drawingml/2006/main">
-              <a:ext uri="{FF2B5EF4-FFF2-40B4-BE49-F238E27FC236}">
-                <a16:creationId xmlns:a16="http://schemas.microsoft.com/office/drawing/2014/main" id="{B6E7DBFC-5F55-4486-A7F6-49F240109E42}"/>
-              </a:ext>
-            </a:extLst>
-          </p:cNvPr>
-          <p:cNvSpPr>
-            <a:spLocks xmlns:a="http://schemas.openxmlformats.org/drawingml/2006/main" noGrp="1"/>
-          </p:cNvSpPr>
-          <p:nvPr/>
-        </p:nvSpPr>
-        <p:spPr>
-          <a:xfrm xmlns:a="http://schemas.openxmlformats.org/drawingml/2006/main">
-            <a:off x="9248775" y="5543550"/>
-            <a:ext cx="2000250" cy="381000"/>
-          </a:xfrm>
-          <a:prstGeom xmlns:a="http://schemas.openxmlformats.org/drawingml/2006/main" prst="rect">
-            <a:avLst/>
-          </a:prstGeom>
-          <a:noFill xmlns:a="http://schemas.openxmlformats.org/drawingml/2006/main"/>
-          <a:ln xmlns:a="http://schemas.openxmlformats.org/drawingml/2006/main" w="0">
-            <a:noFill/>
-          </a:ln>
-        </p:spPr>
-        <p:txBody>
-          <a:bodyPr xmlns:a="http://schemas.openxmlformats.org/drawingml/2006/main" wrap="square" lIns="0" tIns="0" rIns="0" bIns="0" anchor="ctr"/>
-          <a:lstStyle xmlns:a="http://schemas.openxmlformats.org/drawingml/2006/main">
-            <a:defPPr algn="l">
-              <a:defRPr sz="1950" b="0">
-                <a:solidFill>
-                  <a:srgbClr val="231F20"/>
-                </a:solidFill>
-                <a:latin typeface="Meiryo"/>
-                <a:ea typeface="Meiryo"/>
-                <a:cs typeface="Meiryo"/>
-              </a:defRPr>
-            </a:defPPr>
-          </a:lstStyle>
-          <a:p xmlns:a="http://schemas.openxmlformats.org/drawingml/2006/main">
-            <a:pPr algn="l">
-              <a:defRPr sz="1950" b="0">
-                <a:solidFill>
-                  <a:srgbClr val="231F20"/>
-                </a:solidFill>
-                <a:latin typeface="Meiryo"/>
-                <a:ea typeface="Meiryo"/>
-                <a:cs typeface="Meiryo"/>
-              </a:defRPr>
-            </a:pPr>
-            <a:r>
-              <a:rPr sz="1950" b="0">
-                <a:solidFill>
-                  <a:srgbClr val="231F20"/>
-                </a:solidFill>
-                <a:latin typeface="Meiryo"/>
-                <a:ea typeface="Meiryo"/>
-                <a:cs typeface="Meiryo"/>
-              </a:rPr>
-              <a:t>0.465 ms</a:t>
-            </a:r>
-          </a:p>
-        </p:txBody>
-      </p:sp>
-      <p:sp>
-        <p:nvSpPr>
-          <p:cNvPr id="24" name="text-127">
-            <a:extLst xmlns:a="http://schemas.openxmlformats.org/drawingml/2006/main">
-              <a:ext uri="{FF2B5EF4-FFF2-40B4-BE49-F238E27FC236}">
-                <a16:creationId xmlns:a16="http://schemas.microsoft.com/office/drawing/2014/main" id="{5F0AC044-6331-445E-A8B9-90FE4E72D1C9}"/>
-              </a:ext>
-            </a:extLst>
-          </p:cNvPr>
-          <p:cNvSpPr>
-            <a:spLocks xmlns:a="http://schemas.openxmlformats.org/drawingml/2006/main" noGrp="1"/>
-          </p:cNvSpPr>
-          <p:nvPr/>
-        </p:nvSpPr>
-        <p:spPr>
-          <a:xfrm xmlns:a="http://schemas.openxmlformats.org/drawingml/2006/main">
-            <a:off x="990600" y="6172200"/>
-            <a:ext cx="9715500" cy="323850"/>
-          </a:xfrm>
-          <a:prstGeom xmlns:a="http://schemas.openxmlformats.org/drawingml/2006/main" prst="rect">
-            <a:avLst/>
-          </a:prstGeom>
-          <a:noFill xmlns:a="http://schemas.openxmlformats.org/drawingml/2006/main"/>
-          <a:ln xmlns:a="http://schemas.openxmlformats.org/drawingml/2006/main" w="0">
-            <a:noFill/>
-          </a:ln>
-        </p:spPr>
-        <p:txBody>
-          <a:bodyPr xmlns:a="http://schemas.openxmlformats.org/drawingml/2006/main" wrap="square" lIns="0" tIns="0" rIns="0" bIns="0" anchor="ctr"/>
-          <a:lstStyle xmlns:a="http://schemas.openxmlformats.org/drawingml/2006/main">
-            <a:defPPr algn="l">
-              <a:defRPr sz="1500" b="0">
-                <a:solidFill>
-                  <a:srgbClr val="231F20"/>
-                </a:solidFill>
-                <a:latin typeface="Meiryo"/>
-                <a:ea typeface="Meiryo"/>
-                <a:cs typeface="Meiryo"/>
-              </a:defRPr>
-            </a:defPPr>
-          </a:lstStyle>
-          <a:p xmlns:a="http://schemas.openxmlformats.org/drawingml/2006/main">
-            <a:pPr algn="l">
-              <a:defRPr sz="1500" b="0">
-                <a:solidFill>
-                  <a:srgbClr val="231F20"/>
-                </a:solidFill>
-                <a:latin typeface="Meiryo"/>
-                <a:ea typeface="Meiryo"/>
-                <a:cs typeface="Meiryo"/>
-              </a:defRPr>
-            </a:pPr>
-            <a:r>
-              <a:rPr sz="1500" b="0">
-                <a:solidFill>
-                  <a:srgbClr val="231F20"/>
-                </a:solidFill>
-                <a:latin typeface="Meiryo"/>
-                <a:ea typeface="Meiryo"/>
-                <a:cs typeface="Meiryo"/>
-              </a:rPr>
-              <a:t>全体描画・同じ初期状態／各方式180フレーム × 3回</a:t>
+              <a:t>保存できない間は、CPUの書き込みを待たせる</a:t>
             </a:r>
           </a:p>
         </p:txBody>
@@ -10001,7 +9641,7 @@
     </p:spTree>
     <p:extLst>
       <p:ext uri="{BB962C8B-B14F-4D97-AF65-F5344CB8AC3E}">
-        <p14:creationId xmlns:p14="http://schemas.microsoft.com/office/powerpoint/2010/main" val="1118805030"/>
+        <p14:creationId xmlns:p14="http://schemas.microsoft.com/office/powerpoint/2010/main" val="1598251846"/>
       </p:ext>
     </p:extLst>
   </p:cSld>
@@ -10029,10 +9669,10 @@
       </p:grpSpPr>
       <p:sp>
         <p:nvSpPr>
-          <p:cNvPr id="18" name="text-128">
-            <a:extLst xmlns:a="http://schemas.openxmlformats.org/drawingml/2006/main">
-              <a:ext uri="{FF2B5EF4-FFF2-40B4-BE49-F238E27FC236}">
-                <a16:creationId xmlns:a16="http://schemas.microsoft.com/office/drawing/2014/main" id="{FDAE753E-FDC8-4ADA-A5A4-DD76526C63AA}"/>
+          <p:cNvPr id="18" name="text-121">
+            <a:extLst xmlns:a="http://schemas.openxmlformats.org/drawingml/2006/main">
+              <a:ext uri="{FF2B5EF4-FFF2-40B4-BE49-F238E27FC236}">
+                <a16:creationId xmlns:a16="http://schemas.microsoft.com/office/drawing/2014/main" id="{14FEF62A-7799-4172-8F00-E87DFE67DDD8}"/>
               </a:ext>
             </a:extLst>
           </p:cNvPr>
@@ -10095,10 +9735,10 @@
       </p:sp>
       <p:sp>
         <p:nvSpPr>
-          <p:cNvPr id="2" name="text-129">
-            <a:extLst xmlns:a="http://schemas.openxmlformats.org/drawingml/2006/main">
-              <a:ext uri="{FF2B5EF4-FFF2-40B4-BE49-F238E27FC236}">
-                <a16:creationId xmlns:a16="http://schemas.microsoft.com/office/drawing/2014/main" id="{E393B2AA-5336-4EAC-84B9-47A874DADB8C}"/>
+          <p:cNvPr id="2" name="text-122">
+            <a:extLst xmlns:a="http://schemas.openxmlformats.org/drawingml/2006/main">
+              <a:ext uri="{FF2B5EF4-FFF2-40B4-BE49-F238E27FC236}">
+                <a16:creationId xmlns:a16="http://schemas.microsoft.com/office/drawing/2014/main" id="{ED94A16D-AF38-4D30-A4B3-247FD39DFB25}"/>
               </a:ext>
             </a:extLst>
           </p:cNvPr>
@@ -10161,10 +9801,10 @@
       </p:sp>
       <p:sp>
         <p:nvSpPr>
-          <p:cNvPr id="3" name="text-130">
-            <a:extLst xmlns:a="http://schemas.openxmlformats.org/drawingml/2006/main">
-              <a:ext uri="{FF2B5EF4-FFF2-40B4-BE49-F238E27FC236}">
-                <a16:creationId xmlns:a16="http://schemas.microsoft.com/office/drawing/2014/main" id="{0FBA2B06-D1D6-47F8-9A2B-4CFDA538911A}"/>
+          <p:cNvPr id="3" name="text-123">
+            <a:extLst xmlns:a="http://schemas.openxmlformats.org/drawingml/2006/main">
+              <a:ext uri="{FF2B5EF4-FFF2-40B4-BE49-F238E27FC236}">
+                <a16:creationId xmlns:a16="http://schemas.microsoft.com/office/drawing/2014/main" id="{D6CFF447-1521-458D-9E42-4FFB167193AA}"/>
               </a:ext>
             </a:extLst>
           </p:cNvPr>
@@ -10227,10 +9867,10 @@
       </p:sp>
       <p:sp>
         <p:nvSpPr>
-          <p:cNvPr id="4" name="text-131">
-            <a:extLst xmlns:a="http://schemas.openxmlformats.org/drawingml/2006/main">
-              <a:ext uri="{FF2B5EF4-FFF2-40B4-BE49-F238E27FC236}">
-                <a16:creationId xmlns:a16="http://schemas.microsoft.com/office/drawing/2014/main" id="{6294289F-4DA6-4954-80C8-EBE8BB066E55}"/>
+          <p:cNvPr id="4" name="text-124">
+            <a:extLst xmlns:a="http://schemas.openxmlformats.org/drawingml/2006/main">
+              <a:ext uri="{FF2B5EF4-FFF2-40B4-BE49-F238E27FC236}">
+                <a16:creationId xmlns:a16="http://schemas.microsoft.com/office/drawing/2014/main" id="{20C1135E-38C9-4B1B-9A0C-AF50B8765837}"/>
               </a:ext>
             </a:extLst>
           </p:cNvPr>
@@ -10293,10 +9933,10 @@
       </p:sp>
       <p:sp>
         <p:nvSpPr>
-          <p:cNvPr id="5" name="circuit-132">
-            <a:extLst xmlns:a="http://schemas.openxmlformats.org/drawingml/2006/main">
-              <a:ext uri="{FF2B5EF4-FFF2-40B4-BE49-F238E27FC236}">
-                <a16:creationId xmlns:a16="http://schemas.microsoft.com/office/drawing/2014/main" id="{86CF4E90-BDEC-4E9C-9075-0BA562407E3B}"/>
+          <p:cNvPr id="5" name="circuit-125">
+            <a:extLst xmlns:a="http://schemas.openxmlformats.org/drawingml/2006/main">
+              <a:ext uri="{FF2B5EF4-FFF2-40B4-BE49-F238E27FC236}">
+                <a16:creationId xmlns:a16="http://schemas.microsoft.com/office/drawing/2014/main" id="{A99D169F-BAE5-4AE9-85FB-B9A4DA45FFEA}"/>
               </a:ext>
             </a:extLst>
           </p:cNvPr>
@@ -10325,10 +9965,10 @@
       </p:sp>
       <p:sp>
         <p:nvSpPr>
-          <p:cNvPr id="6" name="text-133">
-            <a:extLst xmlns:a="http://schemas.openxmlformats.org/drawingml/2006/main">
-              <a:ext uri="{FF2B5EF4-FFF2-40B4-BE49-F238E27FC236}">
-                <a16:creationId xmlns:a16="http://schemas.microsoft.com/office/drawing/2014/main" id="{75987A9D-2762-4C10-BDBB-B7C3C289827E}"/>
+          <p:cNvPr id="6" name="text-126">
+            <a:extLst xmlns:a="http://schemas.openxmlformats.org/drawingml/2006/main">
+              <a:ext uri="{FF2B5EF4-FFF2-40B4-BE49-F238E27FC236}">
+                <a16:creationId xmlns:a16="http://schemas.microsoft.com/office/drawing/2014/main" id="{3A9035A6-0163-418B-9734-D8869AB1DCA9}"/>
               </a:ext>
             </a:extLst>
           </p:cNvPr>
@@ -10391,10 +10031,10 @@
       </p:sp>
       <p:sp>
         <p:nvSpPr>
-          <p:cNvPr id="7" name="circuit-134">
-            <a:extLst xmlns:a="http://schemas.openxmlformats.org/drawingml/2006/main">
-              <a:ext uri="{FF2B5EF4-FFF2-40B4-BE49-F238E27FC236}">
-                <a16:creationId xmlns:a16="http://schemas.microsoft.com/office/drawing/2014/main" id="{7ECA7D92-4DAD-4B8D-AA62-724E52344D99}"/>
+          <p:cNvPr id="7" name="circuit-127">
+            <a:extLst xmlns:a="http://schemas.openxmlformats.org/drawingml/2006/main">
+              <a:ext uri="{FF2B5EF4-FFF2-40B4-BE49-F238E27FC236}">
+                <a16:creationId xmlns:a16="http://schemas.microsoft.com/office/drawing/2014/main" id="{826C0515-CE7B-4FB8-86E8-831ED6D42D19}"/>
               </a:ext>
             </a:extLst>
           </p:cNvPr>
@@ -10423,10 +10063,10 @@
       </p:sp>
       <p:sp>
         <p:nvSpPr>
-          <p:cNvPr id="8" name="text-135">
-            <a:extLst xmlns:a="http://schemas.openxmlformats.org/drawingml/2006/main">
-              <a:ext uri="{FF2B5EF4-FFF2-40B4-BE49-F238E27FC236}">
-                <a16:creationId xmlns:a16="http://schemas.microsoft.com/office/drawing/2014/main" id="{6856393F-8BB1-43AC-9154-7455780AEBC9}"/>
+          <p:cNvPr id="8" name="text-128">
+            <a:extLst xmlns:a="http://schemas.openxmlformats.org/drawingml/2006/main">
+              <a:ext uri="{FF2B5EF4-FFF2-40B4-BE49-F238E27FC236}">
+                <a16:creationId xmlns:a16="http://schemas.microsoft.com/office/drawing/2014/main" id="{1247612D-C315-4431-AB7F-FDB2E4BEB1DB}"/>
               </a:ext>
             </a:extLst>
           </p:cNvPr>
@@ -10489,10 +10129,10 @@
       </p:sp>
       <p:sp>
         <p:nvSpPr>
-          <p:cNvPr id="9" name="circuit-136">
-            <a:extLst xmlns:a="http://schemas.openxmlformats.org/drawingml/2006/main">
-              <a:ext uri="{FF2B5EF4-FFF2-40B4-BE49-F238E27FC236}">
-                <a16:creationId xmlns:a16="http://schemas.microsoft.com/office/drawing/2014/main" id="{5A1C61DE-30F4-46F1-A4CF-9AD705E714FE}"/>
+          <p:cNvPr id="9" name="circuit-129">
+            <a:extLst xmlns:a="http://schemas.openxmlformats.org/drawingml/2006/main">
+              <a:ext uri="{FF2B5EF4-FFF2-40B4-BE49-F238E27FC236}">
+                <a16:creationId xmlns:a16="http://schemas.microsoft.com/office/drawing/2014/main" id="{369D0823-DD78-4F8F-AD43-8EA0F1E4C3F2}"/>
               </a:ext>
             </a:extLst>
           </p:cNvPr>
@@ -10521,10 +10161,10 @@
       </p:sp>
       <p:sp>
         <p:nvSpPr>
-          <p:cNvPr id="10" name="text-137">
-            <a:extLst xmlns:a="http://schemas.openxmlformats.org/drawingml/2006/main">
-              <a:ext uri="{FF2B5EF4-FFF2-40B4-BE49-F238E27FC236}">
-                <a16:creationId xmlns:a16="http://schemas.microsoft.com/office/drawing/2014/main" id="{4B031C8D-A2D7-4B37-8DF8-53AA7BEA5FB9}"/>
+          <p:cNvPr id="10" name="text-130">
+            <a:extLst xmlns:a="http://schemas.openxmlformats.org/drawingml/2006/main">
+              <a:ext uri="{FF2B5EF4-FFF2-40B4-BE49-F238E27FC236}">
+                <a16:creationId xmlns:a16="http://schemas.microsoft.com/office/drawing/2014/main" id="{ED9453F3-7DEB-4FBB-9797-D3BB299ECD46}"/>
               </a:ext>
             </a:extLst>
           </p:cNvPr>
@@ -10587,10 +10227,10 @@
       </p:sp>
       <p:sp>
         <p:nvSpPr>
-          <p:cNvPr id="11" name="circuit-138">
-            <a:extLst xmlns:a="http://schemas.openxmlformats.org/drawingml/2006/main">
-              <a:ext uri="{FF2B5EF4-FFF2-40B4-BE49-F238E27FC236}">
-                <a16:creationId xmlns:a16="http://schemas.microsoft.com/office/drawing/2014/main" id="{72031F5C-3A8B-4E09-92C8-3952079F5071}"/>
+          <p:cNvPr id="11" name="circuit-131">
+            <a:extLst xmlns:a="http://schemas.openxmlformats.org/drawingml/2006/main">
+              <a:ext uri="{FF2B5EF4-FFF2-40B4-BE49-F238E27FC236}">
+                <a16:creationId xmlns:a16="http://schemas.microsoft.com/office/drawing/2014/main" id="{5AD9B8F9-BA08-453C-891D-676C61B04E32}"/>
               </a:ext>
             </a:extLst>
           </p:cNvPr>
@@ -10619,10 +10259,10 @@
       </p:sp>
       <p:sp>
         <p:nvSpPr>
-          <p:cNvPr id="12" name="text-139">
-            <a:extLst xmlns:a="http://schemas.openxmlformats.org/drawingml/2006/main">
-              <a:ext uri="{FF2B5EF4-FFF2-40B4-BE49-F238E27FC236}">
-                <a16:creationId xmlns:a16="http://schemas.microsoft.com/office/drawing/2014/main" id="{9FD72DEB-B4DA-427B-A327-3C6E85BD351E}"/>
+          <p:cNvPr id="12" name="text-132">
+            <a:extLst xmlns:a="http://schemas.openxmlformats.org/drawingml/2006/main">
+              <a:ext uri="{FF2B5EF4-FFF2-40B4-BE49-F238E27FC236}">
+                <a16:creationId xmlns:a16="http://schemas.microsoft.com/office/drawing/2014/main" id="{2EA22AA8-CDA5-4581-9143-68761A68CA79}"/>
               </a:ext>
             </a:extLst>
           </p:cNvPr>
@@ -10685,10 +10325,10 @@
       </p:sp>
       <p:sp>
         <p:nvSpPr>
-          <p:cNvPr id="13" name="wire-140">
-            <a:extLst xmlns:a="http://schemas.openxmlformats.org/drawingml/2006/main">
-              <a:ext uri="{FF2B5EF4-FFF2-40B4-BE49-F238E27FC236}">
-                <a16:creationId xmlns:a16="http://schemas.microsoft.com/office/drawing/2014/main" id="{3971516F-A131-4177-A137-537297BBBCBC}"/>
+          <p:cNvPr id="13" name="wire-133">
+            <a:extLst xmlns:a="http://schemas.openxmlformats.org/drawingml/2006/main">
+              <a:ext uri="{FF2B5EF4-FFF2-40B4-BE49-F238E27FC236}">
+                <a16:creationId xmlns:a16="http://schemas.microsoft.com/office/drawing/2014/main" id="{AB6DDFBD-46F5-41AF-BE21-9CBD276704A0}"/>
               </a:ext>
             </a:extLst>
           </p:cNvPr>
@@ -10724,10 +10364,10 @@
       </p:sp>
       <p:sp>
         <p:nvSpPr>
-          <p:cNvPr id="14" name="logic-141">
-            <a:extLst xmlns:a="http://schemas.openxmlformats.org/drawingml/2006/main">
-              <a:ext uri="{FF2B5EF4-FFF2-40B4-BE49-F238E27FC236}">
-                <a16:creationId xmlns:a16="http://schemas.microsoft.com/office/drawing/2014/main" id="{9C5EA6EE-4B2A-4367-91E7-5236DE110D1B}"/>
+          <p:cNvPr id="14" name="logic-134">
+            <a:extLst xmlns:a="http://schemas.openxmlformats.org/drawingml/2006/main">
+              <a:ext uri="{FF2B5EF4-FFF2-40B4-BE49-F238E27FC236}">
+                <a16:creationId xmlns:a16="http://schemas.microsoft.com/office/drawing/2014/main" id="{ACC9D468-065A-4568-A574-A4D602067077}"/>
               </a:ext>
             </a:extLst>
           </p:cNvPr>
@@ -10769,10 +10409,10 @@
       </p:sp>
       <p:sp>
         <p:nvSpPr>
-          <p:cNvPr id="15" name="text-142">
-            <a:extLst xmlns:a="http://schemas.openxmlformats.org/drawingml/2006/main">
-              <a:ext uri="{FF2B5EF4-FFF2-40B4-BE49-F238E27FC236}">
-                <a16:creationId xmlns:a16="http://schemas.microsoft.com/office/drawing/2014/main" id="{10CF73DF-86BD-43E3-9082-25FF82A41782}"/>
+          <p:cNvPr id="15" name="text-135">
+            <a:extLst xmlns:a="http://schemas.openxmlformats.org/drawingml/2006/main">
+              <a:ext uri="{FF2B5EF4-FFF2-40B4-BE49-F238E27FC236}">
+                <a16:creationId xmlns:a16="http://schemas.microsoft.com/office/drawing/2014/main" id="{901EF70B-CD5D-4C72-9B4E-C11C155D12B8}"/>
               </a:ext>
             </a:extLst>
           </p:cNvPr>
@@ -10858,10 +10498,10 @@
       </p:sp>
       <p:sp>
         <p:nvSpPr>
-          <p:cNvPr id="16" name="text-143">
-            <a:extLst xmlns:a="http://schemas.openxmlformats.org/drawingml/2006/main">
-              <a:ext uri="{FF2B5EF4-FFF2-40B4-BE49-F238E27FC236}">
-                <a16:creationId xmlns:a16="http://schemas.microsoft.com/office/drawing/2014/main" id="{5D42575F-1B9B-4393-A56B-8DCD5D52778F}"/>
+          <p:cNvPr id="16" name="text-136">
+            <a:extLst xmlns:a="http://schemas.openxmlformats.org/drawingml/2006/main">
+              <a:ext uri="{FF2B5EF4-FFF2-40B4-BE49-F238E27FC236}">
+                <a16:creationId xmlns:a16="http://schemas.microsoft.com/office/drawing/2014/main" id="{478E8FA2-69D2-4DD4-B246-B7C220479BB3}"/>
               </a:ext>
             </a:extLst>
           </p:cNvPr>
@@ -10947,10 +10587,10 @@
       </p:sp>
       <p:sp>
         <p:nvSpPr>
-          <p:cNvPr id="17" name="text-144">
-            <a:extLst xmlns:a="http://schemas.openxmlformats.org/drawingml/2006/main">
-              <a:ext uri="{FF2B5EF4-FFF2-40B4-BE49-F238E27FC236}">
-                <a16:creationId xmlns:a16="http://schemas.microsoft.com/office/drawing/2014/main" id="{0EB040B9-3563-4ECD-BCCB-AAEADEA9725F}"/>
+          <p:cNvPr id="17" name="text-137">
+            <a:extLst xmlns:a="http://schemas.openxmlformats.org/drawingml/2006/main">
+              <a:ext uri="{FF2B5EF4-FFF2-40B4-BE49-F238E27FC236}">
+                <a16:creationId xmlns:a16="http://schemas.microsoft.com/office/drawing/2014/main" id="{7A7CA47D-2D68-4BBA-8EAF-50EA9C4DCA9E}"/>
               </a:ext>
             </a:extLst>
           </p:cNvPr>
@@ -11014,7 +10654,7 @@
     </p:spTree>
     <p:extLst>
       <p:ext uri="{BB962C8B-B14F-4D97-AF65-F5344CB8AC3E}">
-        <p14:creationId xmlns:p14="http://schemas.microsoft.com/office/powerpoint/2010/main" val="1258230437"/>
+        <p14:creationId xmlns:p14="http://schemas.microsoft.com/office/powerpoint/2010/main" val="755213471"/>
       </p:ext>
     </p:extLst>
   </p:cSld>
@@ -11042,10 +10682,10 @@
       </p:grpSpPr>
       <p:sp>
         <p:nvSpPr>
-          <p:cNvPr id="8" name="text-145">
-            <a:extLst xmlns:a="http://schemas.openxmlformats.org/drawingml/2006/main">
-              <a:ext uri="{FF2B5EF4-FFF2-40B4-BE49-F238E27FC236}">
-                <a16:creationId xmlns:a16="http://schemas.microsoft.com/office/drawing/2014/main" id="{58E0AC88-AE71-4D4B-9A58-CBBA686DABB0}"/>
+          <p:cNvPr id="8" name="text-138">
+            <a:extLst xmlns:a="http://schemas.openxmlformats.org/drawingml/2006/main">
+              <a:ext uri="{FF2B5EF4-FFF2-40B4-BE49-F238E27FC236}">
+                <a16:creationId xmlns:a16="http://schemas.microsoft.com/office/drawing/2014/main" id="{E8EEC773-CB75-4E83-801F-76DFD2AEDE7E}"/>
               </a:ext>
             </a:extLst>
           </p:cNvPr>
@@ -11108,10 +10748,10 @@
       </p:sp>
       <p:sp>
         <p:nvSpPr>
-          <p:cNvPr id="2" name="text-146">
-            <a:extLst xmlns:a="http://schemas.openxmlformats.org/drawingml/2006/main">
-              <a:ext uri="{FF2B5EF4-FFF2-40B4-BE49-F238E27FC236}">
-                <a16:creationId xmlns:a16="http://schemas.microsoft.com/office/drawing/2014/main" id="{5CAB629A-B03B-45E9-B215-25AAC4F20073}"/>
+          <p:cNvPr id="2" name="text-139">
+            <a:extLst xmlns:a="http://schemas.openxmlformats.org/drawingml/2006/main">
+              <a:ext uri="{FF2B5EF4-FFF2-40B4-BE49-F238E27FC236}">
+                <a16:creationId xmlns:a16="http://schemas.microsoft.com/office/drawing/2014/main" id="{F4F9F378-15E7-4500-899D-DEBB41E16AD3}"/>
               </a:ext>
             </a:extLst>
           </p:cNvPr>
@@ -11177,7 +10817,7 @@
           <p:cNvPr id="3" name="">
             <a:extLst xmlns:a="http://schemas.openxmlformats.org/drawingml/2006/main">
               <a:ext uri="{FF2B5EF4-FFF2-40B4-BE49-F238E27FC236}">
-                <a16:creationId xmlns:a16="http://schemas.microsoft.com/office/drawing/2014/main" id="{A1D8D0B3-31E2-4276-94D8-4D2885837445}"/>
+                <a16:creationId xmlns:a16="http://schemas.microsoft.com/office/drawing/2014/main" id="{F678B0D2-6690-48CE-A679-AD0457194783}"/>
               </a:ext>
             </a:extLst>
           </p:cNvPr>
@@ -11187,12 +10827,12 @@
           <p:nvPr/>
         </p:nvPicPr>
         <p:blipFill>
-          <a:blip xmlns:r="http://schemas.openxmlformats.org/officeDocument/2006/relationships" xmlns:a="http://schemas.openxmlformats.org/drawingml/2006/main" r:embed="R17e07fd10bb640ce"/>
+          <a:blip xmlns:r="http://schemas.openxmlformats.org/officeDocument/2006/relationships" xmlns:a="http://schemas.openxmlformats.org/drawingml/2006/main" r:embed="Reeb6a7f99ce04796"/>
           <a:stretch xmlns:a="http://schemas.openxmlformats.org/drawingml/2006/main"/>
         </p:blipFill>
         <p:spPr>
           <a:xfrm xmlns:a="http://schemas.openxmlformats.org/drawingml/2006/main">
-            <a:off x="609600" y="1840111"/>
+            <a:off x="609600" y="1754386"/>
             <a:ext cx="6191250" cy="3482578"/>
           </a:xfrm>
           <a:prstGeom xmlns:a="http://schemas.openxmlformats.org/drawingml/2006/main" prst="rect">
@@ -11202,22 +10842,22 @@
       </p:pic>
       <p:sp>
         <p:nvSpPr>
-          <p:cNvPr id="4" name="text-147">
-            <a:extLst xmlns:a="http://schemas.openxmlformats.org/drawingml/2006/main">
-              <a:ext uri="{FF2B5EF4-FFF2-40B4-BE49-F238E27FC236}">
-                <a16:creationId xmlns:a16="http://schemas.microsoft.com/office/drawing/2014/main" id="{94CABBFA-838E-4FE7-9557-4FF817EC3C20}"/>
-              </a:ext>
-            </a:extLst>
-          </p:cNvPr>
-          <p:cNvSpPr>
-            <a:spLocks xmlns:a="http://schemas.openxmlformats.org/drawingml/2006/main" noGrp="1"/>
-          </p:cNvSpPr>
-          <p:nvPr/>
-        </p:nvSpPr>
-        <p:spPr>
-          <a:xfrm xmlns:a="http://schemas.openxmlformats.org/drawingml/2006/main">
-            <a:off x="7277100" y="2038350"/>
-            <a:ext cx="4238625" cy="1114425"/>
+          <p:cNvPr id="4" name="text-140">
+            <a:extLst xmlns:a="http://schemas.openxmlformats.org/drawingml/2006/main">
+              <a:ext uri="{FF2B5EF4-FFF2-40B4-BE49-F238E27FC236}">
+                <a16:creationId xmlns:a16="http://schemas.microsoft.com/office/drawing/2014/main" id="{42D57D3B-4D45-4B27-8274-E2CA64196139}"/>
+              </a:ext>
+            </a:extLst>
+          </p:cNvPr>
+          <p:cNvSpPr>
+            <a:spLocks xmlns:a="http://schemas.openxmlformats.org/drawingml/2006/main" noGrp="1"/>
+          </p:cNvSpPr>
+          <p:nvPr/>
+        </p:nvSpPr>
+        <p:spPr>
+          <a:xfrm xmlns:a="http://schemas.openxmlformats.org/drawingml/2006/main">
+            <a:off x="7153275" y="1752600"/>
+            <a:ext cx="4429125" cy="1314450"/>
           </a:xfrm>
           <a:prstGeom xmlns:a="http://schemas.openxmlformats.org/drawingml/2006/main" prst="rect">
             <a:avLst/>
@@ -11231,7 +10871,7 @@
           <a:bodyPr xmlns:a="http://schemas.openxmlformats.org/drawingml/2006/main" wrap="square" lIns="0" tIns="0" rIns="0" bIns="0" anchor="ctr"/>
           <a:lstStyle xmlns:a="http://schemas.openxmlformats.org/drawingml/2006/main">
             <a:defPPr algn="l">
-              <a:defRPr sz="2475" b="1">
+              <a:defRPr sz="2250" b="1">
                 <a:solidFill>
                   <a:srgbClr val="231F20"/>
                 </a:solidFill>
@@ -11243,7 +10883,7 @@
           </a:lstStyle>
           <a:p xmlns:a="http://schemas.openxmlformats.org/drawingml/2006/main">
             <a:pPr algn="l">
-              <a:defRPr sz="2475" b="1">
+              <a:defRPr sz="2250" b="1">
                 <a:solidFill>
                   <a:srgbClr val="231F20"/>
                 </a:solidFill>
@@ -11253,7 +10893,7 @@
               </a:defRPr>
             </a:pPr>
             <a:r>
-              <a:rPr sz="2475" b="1">
+              <a:rPr sz="2250" b="1">
                 <a:solidFill>
                   <a:srgbClr val="231F20"/>
                 </a:solidFill>
@@ -11266,7 +10906,7 @@
           </a:p>
           <a:p xmlns:a="http://schemas.openxmlformats.org/drawingml/2006/main">
             <a:pPr algn="l">
-              <a:defRPr sz="2475" b="1">
+              <a:defRPr sz="2250" b="1">
                 <a:solidFill>
                   <a:srgbClr val="231F20"/>
                 </a:solidFill>
@@ -11276,7 +10916,7 @@
               </a:defRPr>
             </a:pPr>
             <a:r>
-              <a:rPr sz="2475" b="1">
+              <a:rPr sz="2250" b="1">
                 <a:solidFill>
                   <a:srgbClr val="231F20"/>
                 </a:solidFill>
@@ -11284,29 +10924,52 @@
                 <a:ea typeface="Meiryo"/>
                 <a:cs typeface="Meiryo"/>
               </a:rPr>
-              <a:t>5分間の自動プレイ</a:t>
+              <a:t>4条件で全画素が</a:t>
+            </a:r>
+          </a:p>
+          <a:p xmlns:a="http://schemas.openxmlformats.org/drawingml/2006/main">
+            <a:pPr algn="l">
+              <a:defRPr sz="2250" b="1">
+                <a:solidFill>
+                  <a:srgbClr val="231F20"/>
+                </a:solidFill>
+                <a:latin typeface="Meiryo"/>
+                <a:ea typeface="Meiryo"/>
+                <a:cs typeface="Meiryo"/>
+              </a:defRPr>
+            </a:pPr>
+            <a:r>
+              <a:rPr sz="2250" b="1">
+                <a:solidFill>
+                  <a:srgbClr val="231F20"/>
+                </a:solidFill>
+                <a:latin typeface="Meiryo"/>
+                <a:ea typeface="Meiryo"/>
+                <a:cs typeface="Meiryo"/>
+              </a:rPr>
+              <a:t>期待画像と一致</a:t>
             </a:r>
           </a:p>
         </p:txBody>
       </p:sp>
       <p:sp>
         <p:nvSpPr>
-          <p:cNvPr id="5" name="text-148">
-            <a:extLst xmlns:a="http://schemas.openxmlformats.org/drawingml/2006/main">
-              <a:ext uri="{FF2B5EF4-FFF2-40B4-BE49-F238E27FC236}">
-                <a16:creationId xmlns:a16="http://schemas.microsoft.com/office/drawing/2014/main" id="{775A14DA-FF14-4D26-98A4-07499AF8F637}"/>
-              </a:ext>
-            </a:extLst>
-          </p:cNvPr>
-          <p:cNvSpPr>
-            <a:spLocks xmlns:a="http://schemas.openxmlformats.org/drawingml/2006/main" noGrp="1"/>
-          </p:cNvSpPr>
-          <p:nvPr/>
-        </p:nvSpPr>
-        <p:spPr>
-          <a:xfrm xmlns:a="http://schemas.openxmlformats.org/drawingml/2006/main">
-            <a:off x="7277100" y="3476625"/>
-            <a:ext cx="4238625" cy="1028700"/>
+          <p:cNvPr id="5" name="text-141">
+            <a:extLst xmlns:a="http://schemas.openxmlformats.org/drawingml/2006/main">
+              <a:ext uri="{FF2B5EF4-FFF2-40B4-BE49-F238E27FC236}">
+                <a16:creationId xmlns:a16="http://schemas.microsoft.com/office/drawing/2014/main" id="{DC759AC9-8628-492B-9EDC-A9487F2A4ACB}"/>
+              </a:ext>
+            </a:extLst>
+          </p:cNvPr>
+          <p:cNvSpPr>
+            <a:spLocks xmlns:a="http://schemas.openxmlformats.org/drawingml/2006/main" noGrp="1"/>
+          </p:cNvSpPr>
+          <p:nvPr/>
+        </p:nvSpPr>
+        <p:spPr>
+          <a:xfrm xmlns:a="http://schemas.openxmlformats.org/drawingml/2006/main">
+            <a:off x="7153275" y="3333750"/>
+            <a:ext cx="4429125" cy="1066800"/>
           </a:xfrm>
           <a:prstGeom xmlns:a="http://schemas.openxmlformats.org/drawingml/2006/main" prst="rect">
             <a:avLst/>
@@ -11320,7 +10983,7 @@
           <a:bodyPr xmlns:a="http://schemas.openxmlformats.org/drawingml/2006/main" wrap="square" lIns="0" tIns="0" rIns="0" bIns="0" anchor="ctr"/>
           <a:lstStyle xmlns:a="http://schemas.openxmlformats.org/drawingml/2006/main">
             <a:defPPr algn="l">
-              <a:defRPr sz="2175" b="0">
+              <a:defRPr sz="2250" b="0">
                 <a:solidFill>
                   <a:srgbClr val="231F20"/>
                 </a:solidFill>
@@ -11332,7 +10995,7 @@
           </a:lstStyle>
           <a:p xmlns:a="http://schemas.openxmlformats.org/drawingml/2006/main">
             <a:pPr algn="l">
-              <a:defRPr sz="2175" b="0">
+              <a:defRPr sz="2250" b="0">
                 <a:solidFill>
                   <a:srgbClr val="231F20"/>
                 </a:solidFill>
@@ -11342,7 +11005,7 @@
               </a:defRPr>
             </a:pPr>
             <a:r>
-              <a:rPr sz="2175" b="0">
+              <a:rPr sz="2250" b="0">
                 <a:solidFill>
                   <a:srgbClr val="231F20"/>
                 </a:solidFill>
@@ -11350,12 +11013,12 @@
                 <a:ea typeface="Meiryo"/>
                 <a:cs typeface="Meiryo"/>
               </a:rPr>
-              <a:t>接続比較では9画面で</a:t>
+              <a:t>5分間の自動プレイ</a:t>
             </a:r>
           </a:p>
           <a:p xmlns:a="http://schemas.openxmlformats.org/drawingml/2006/main">
             <a:pPr algn="l">
-              <a:defRPr sz="2175" b="0">
+              <a:defRPr sz="2250" b="0">
                 <a:solidFill>
                   <a:srgbClr val="231F20"/>
                 </a:solidFill>
@@ -11365,7 +11028,7 @@
               </a:defRPr>
             </a:pPr>
             <a:r>
-              <a:rPr sz="2175" b="0">
+              <a:rPr sz="2250" b="0">
                 <a:solidFill>
                   <a:srgbClr val="231F20"/>
                 </a:solidFill>
@@ -11373,29 +11036,29 @@
                 <a:ea typeface="Meiryo"/>
                 <a:cs typeface="Meiryo"/>
               </a:rPr>
-              <a:t>全画素が正解画像と一致</a:t>
+              <a:t>別に30秒間の映像を確認</a:t>
             </a:r>
           </a:p>
         </p:txBody>
       </p:sp>
       <p:sp>
         <p:nvSpPr>
-          <p:cNvPr id="6" name="text-149">
-            <a:extLst xmlns:a="http://schemas.openxmlformats.org/drawingml/2006/main">
-              <a:ext uri="{FF2B5EF4-FFF2-40B4-BE49-F238E27FC236}">
-                <a16:creationId xmlns:a16="http://schemas.microsoft.com/office/drawing/2014/main" id="{C7D28028-B407-438F-AB05-355487CDADC6}"/>
-              </a:ext>
-            </a:extLst>
-          </p:cNvPr>
-          <p:cNvSpPr>
-            <a:spLocks xmlns:a="http://schemas.openxmlformats.org/drawingml/2006/main" noGrp="1"/>
-          </p:cNvSpPr>
-          <p:nvPr/>
-        </p:nvSpPr>
-        <p:spPr>
-          <a:xfrm xmlns:a="http://schemas.openxmlformats.org/drawingml/2006/main">
-            <a:off x="7277100" y="4857750"/>
-            <a:ext cx="4238625" cy="857250"/>
+          <p:cNvPr id="6" name="text-142">
+            <a:extLst xmlns:a="http://schemas.openxmlformats.org/drawingml/2006/main">
+              <a:ext uri="{FF2B5EF4-FFF2-40B4-BE49-F238E27FC236}">
+                <a16:creationId xmlns:a16="http://schemas.microsoft.com/office/drawing/2014/main" id="{B7856C06-3207-4DA6-B78E-E9E1E6D77F38}"/>
+              </a:ext>
+            </a:extLst>
+          </p:cNvPr>
+          <p:cNvSpPr>
+            <a:spLocks xmlns:a="http://schemas.openxmlformats.org/drawingml/2006/main" noGrp="1"/>
+          </p:cNvSpPr>
+          <p:nvPr/>
+        </p:nvSpPr>
+        <p:spPr>
+          <a:xfrm xmlns:a="http://schemas.openxmlformats.org/drawingml/2006/main">
+            <a:off x="7153275" y="4867275"/>
+            <a:ext cx="4429125" cy="762000"/>
           </a:xfrm>
           <a:prstGeom xmlns:a="http://schemas.openxmlformats.org/drawingml/2006/main" prst="rect">
             <a:avLst/>
@@ -11409,7 +11072,7 @@
           <a:bodyPr xmlns:a="http://schemas.openxmlformats.org/drawingml/2006/main" wrap="square" lIns="0" tIns="0" rIns="0" bIns="0" anchor="ctr"/>
           <a:lstStyle xmlns:a="http://schemas.openxmlformats.org/drawingml/2006/main">
             <a:defPPr algn="l">
-              <a:defRPr sz="1950" b="0">
+              <a:defRPr sz="1875" b="0">
                 <a:solidFill>
                   <a:srgbClr val="231F20"/>
                 </a:solidFill>
@@ -11421,7 +11084,7 @@
           </a:lstStyle>
           <a:p xmlns:a="http://schemas.openxmlformats.org/drawingml/2006/main">
             <a:pPr algn="l">
-              <a:defRPr sz="1950" b="0">
+              <a:defRPr sz="1875" b="0">
                 <a:solidFill>
                   <a:srgbClr val="231F20"/>
                 </a:solidFill>
@@ -11431,7 +11094,7 @@
               </a:defRPr>
             </a:pPr>
             <a:r>
-              <a:rPr sz="1950" b="0">
+              <a:rPr sz="1875" b="0">
                 <a:solidFill>
                   <a:srgbClr val="231F20"/>
                 </a:solidFill>
@@ -11439,12 +11102,12 @@
                 <a:ea typeface="Meiryo"/>
                 <a:cs typeface="Meiryo"/>
               </a:rPr>
-              <a:t>専用コントローラーは</a:t>
+              <a:t>動作確認には描画処理を</a:t>
             </a:r>
           </a:p>
           <a:p xmlns:a="http://schemas.openxmlformats.org/drawingml/2006/main">
             <a:pPr algn="l">
-              <a:defRPr sz="1950" b="0">
+              <a:defRPr sz="1875" b="0">
                 <a:solidFill>
                   <a:srgbClr val="231F20"/>
                 </a:solidFill>
@@ -11454,7 +11117,7 @@
               </a:defRPr>
             </a:pPr>
             <a:r>
-              <a:rPr sz="1950" b="0">
+              <a:rPr sz="1875" b="0">
                 <a:solidFill>
                   <a:srgbClr val="231F20"/>
                 </a:solidFill>
@@ -11462,28 +11125,28 @@
                 <a:ea typeface="Meiryo"/>
                 <a:cs typeface="Meiryo"/>
               </a:rPr>
-              <a:t>最終発表に向けて接続・検証</a:t>
+              <a:t>軽くした完成版を使用</a:t>
             </a:r>
           </a:p>
         </p:txBody>
       </p:sp>
       <p:sp>
         <p:nvSpPr>
-          <p:cNvPr id="7" name="text-150">
-            <a:extLst xmlns:a="http://schemas.openxmlformats.org/drawingml/2006/main">
-              <a:ext uri="{FF2B5EF4-FFF2-40B4-BE49-F238E27FC236}">
-                <a16:creationId xmlns:a16="http://schemas.microsoft.com/office/drawing/2014/main" id="{5B3EB882-38E8-4113-8BF6-5D6B628A72C9}"/>
-              </a:ext>
-            </a:extLst>
-          </p:cNvPr>
-          <p:cNvSpPr>
-            <a:spLocks xmlns:a="http://schemas.openxmlformats.org/drawingml/2006/main" noGrp="1"/>
-          </p:cNvSpPr>
-          <p:nvPr/>
-        </p:nvSpPr>
-        <p:spPr>
-          <a:xfrm xmlns:a="http://schemas.openxmlformats.org/drawingml/2006/main">
-            <a:off x="685800" y="5962650"/>
+          <p:cNvPr id="7" name="text-143">
+            <a:extLst xmlns:a="http://schemas.openxmlformats.org/drawingml/2006/main">
+              <a:ext uri="{FF2B5EF4-FFF2-40B4-BE49-F238E27FC236}">
+                <a16:creationId xmlns:a16="http://schemas.microsoft.com/office/drawing/2014/main" id="{5CB33655-C04A-49D3-9E7F-9F5C21C2CB9A}"/>
+              </a:ext>
+            </a:extLst>
+          </p:cNvPr>
+          <p:cNvSpPr>
+            <a:spLocks xmlns:a="http://schemas.openxmlformats.org/drawingml/2006/main" noGrp="1"/>
+          </p:cNvSpPr>
+          <p:nvPr/>
+        </p:nvSpPr>
+        <p:spPr>
+          <a:xfrm xmlns:a="http://schemas.openxmlformats.org/drawingml/2006/main">
+            <a:off x="685800" y="6010275"/>
             <a:ext cx="10858500" cy="381000"/>
           </a:xfrm>
           <a:prstGeom xmlns:a="http://schemas.openxmlformats.org/drawingml/2006/main" prst="rect">
@@ -11528,7 +11191,7 @@
                 <a:ea typeface="Meiryo"/>
                 <a:cs typeface="Meiryo"/>
               </a:rPr>
-              <a:t>大きいテクスチャと、映像認識には未解決の条件がある</a:t>
+              <a:t>課題：映像を受信できない場合の条件を調べる</a:t>
             </a:r>
           </a:p>
         </p:txBody>
@@ -11536,7 +11199,7 @@
     </p:spTree>
     <p:extLst>
       <p:ext uri="{BB962C8B-B14F-4D97-AF65-F5344CB8AC3E}">
-        <p14:creationId xmlns:p14="http://schemas.microsoft.com/office/powerpoint/2010/main" val="1789385157"/>
+        <p14:creationId xmlns:p14="http://schemas.microsoft.com/office/powerpoint/2010/main" val="869636482"/>
       </p:ext>
     </p:extLst>
   </p:cSld>
@@ -11564,10 +11227,10 @@
       </p:grpSpPr>
       <p:sp>
         <p:nvSpPr>
-          <p:cNvPr id="7" name="text-151">
-            <a:extLst xmlns:a="http://schemas.openxmlformats.org/drawingml/2006/main">
-              <a:ext uri="{FF2B5EF4-FFF2-40B4-BE49-F238E27FC236}">
-                <a16:creationId xmlns:a16="http://schemas.microsoft.com/office/drawing/2014/main" id="{D36AD50A-962A-4700-A7D4-60F21150504A}"/>
+          <p:cNvPr id="7" name="text-144">
+            <a:extLst xmlns:a="http://schemas.openxmlformats.org/drawingml/2006/main">
+              <a:ext uri="{FF2B5EF4-FFF2-40B4-BE49-F238E27FC236}">
+                <a16:creationId xmlns:a16="http://schemas.microsoft.com/office/drawing/2014/main" id="{B0D0A147-AE82-4B23-BC28-F2DEC814EC52}"/>
               </a:ext>
             </a:extLst>
           </p:cNvPr>
@@ -11630,10 +11293,10 @@
       </p:sp>
       <p:sp>
         <p:nvSpPr>
-          <p:cNvPr id="2" name="text-152">
-            <a:extLst xmlns:a="http://schemas.openxmlformats.org/drawingml/2006/main">
-              <a:ext uri="{FF2B5EF4-FFF2-40B4-BE49-F238E27FC236}">
-                <a16:creationId xmlns:a16="http://schemas.microsoft.com/office/drawing/2014/main" id="{4C7B0578-FB22-42CC-BC1D-0B20638BB08A}"/>
+          <p:cNvPr id="2" name="text-145">
+            <a:extLst xmlns:a="http://schemas.openxmlformats.org/drawingml/2006/main">
+              <a:ext uri="{FF2B5EF4-FFF2-40B4-BE49-F238E27FC236}">
+                <a16:creationId xmlns:a16="http://schemas.microsoft.com/office/drawing/2014/main" id="{E49C70AA-5A2B-4619-827E-93948CC9DE10}"/>
               </a:ext>
             </a:extLst>
           </p:cNvPr>
@@ -11696,22 +11359,22 @@
       </p:sp>
       <p:sp>
         <p:nvSpPr>
-          <p:cNvPr id="3" name="text-153">
-            <a:extLst xmlns:a="http://schemas.openxmlformats.org/drawingml/2006/main">
-              <a:ext uri="{FF2B5EF4-FFF2-40B4-BE49-F238E27FC236}">
-                <a16:creationId xmlns:a16="http://schemas.microsoft.com/office/drawing/2014/main" id="{24EF48EC-55F7-4E25-BCC0-844FAD5177BE}"/>
-              </a:ext>
-            </a:extLst>
-          </p:cNvPr>
-          <p:cNvSpPr>
-            <a:spLocks xmlns:a="http://schemas.openxmlformats.org/drawingml/2006/main" noGrp="1"/>
-          </p:cNvSpPr>
-          <p:nvPr/>
-        </p:nvSpPr>
-        <p:spPr>
-          <a:xfrm xmlns:a="http://schemas.openxmlformats.org/drawingml/2006/main">
-            <a:off x="857250" y="1466850"/>
-            <a:ext cx="10287000" cy="1209675"/>
+          <p:cNvPr id="3" name="text-146">
+            <a:extLst xmlns:a="http://schemas.openxmlformats.org/drawingml/2006/main">
+              <a:ext uri="{FF2B5EF4-FFF2-40B4-BE49-F238E27FC236}">
+                <a16:creationId xmlns:a16="http://schemas.microsoft.com/office/drawing/2014/main" id="{C339FA2D-631C-4B96-95C6-C6A061FE3C67}"/>
+              </a:ext>
+            </a:extLst>
+          </p:cNvPr>
+          <p:cNvSpPr>
+            <a:spLocks xmlns:a="http://schemas.openxmlformats.org/drawingml/2006/main" noGrp="1"/>
+          </p:cNvSpPr>
+          <p:nvPr/>
+        </p:nvSpPr>
+        <p:spPr>
+          <a:xfrm xmlns:a="http://schemas.openxmlformats.org/drawingml/2006/main">
+            <a:off x="857250" y="1524000"/>
+            <a:ext cx="10382250" cy="1209675"/>
           </a:xfrm>
           <a:prstGeom xmlns:a="http://schemas.openxmlformats.org/drawingml/2006/main" prst="rect">
             <a:avLst/>
@@ -11725,7 +11388,7 @@
           <a:bodyPr xmlns:a="http://schemas.openxmlformats.org/drawingml/2006/main" wrap="square" lIns="0" tIns="0" rIns="0" bIns="0" anchor="ctr"/>
           <a:lstStyle xmlns:a="http://schemas.openxmlformats.org/drawingml/2006/main">
             <a:defPPr algn="l">
-              <a:defRPr sz="3225" b="1">
+              <a:defRPr sz="3075" b="1">
                 <a:solidFill>
                   <a:srgbClr val="231F20"/>
                 </a:solidFill>
@@ -11737,7 +11400,7 @@
           </a:lstStyle>
           <a:p xmlns:a="http://schemas.openxmlformats.org/drawingml/2006/main">
             <a:pPr algn="l">
-              <a:defRPr sz="3225" b="1">
+              <a:defRPr sz="3075" b="1">
                 <a:solidFill>
                   <a:srgbClr val="231F20"/>
                 </a:solidFill>
@@ -11747,7 +11410,7 @@
               </a:defRPr>
             </a:pPr>
             <a:r>
-              <a:rPr sz="3225" b="1">
+              <a:rPr sz="3075" b="1">
                 <a:solidFill>
                   <a:srgbClr val="231F20"/>
                 </a:solidFill>
@@ -11755,12 +11418,12 @@
                 <a:ea typeface="Meiryo"/>
                 <a:cs typeface="Meiryo"/>
               </a:rPr>
-              <a:t>CPUに描画・表示機能を追加し、</a:t>
+              <a:t>Wallyに描画・表示機能を加え、</a:t>
             </a:r>
           </a:p>
           <a:p xmlns:a="http://schemas.openxmlformats.org/drawingml/2006/main">
             <a:pPr algn="l">
-              <a:defRPr sz="3225" b="1">
+              <a:defRPr sz="3075" b="1">
                 <a:solidFill>
                   <a:srgbClr val="231F20"/>
                 </a:solidFill>
@@ -11770,7 +11433,7 @@
               </a:defRPr>
             </a:pPr>
             <a:r>
-              <a:rPr sz="3225" b="1">
+              <a:rPr sz="3075" b="1">
                 <a:solidFill>
                   <a:srgbClr val="231F20"/>
                 </a:solidFill>
@@ -11778,29 +11441,29 @@
                 <a:ea typeface="Meiryo"/>
                 <a:cs typeface="Meiryo"/>
               </a:rPr>
-              <a:t>二次元ゲームを実行できた</a:t>
+              <a:t>ブロック崩しの動作を実機で確認した</a:t>
             </a:r>
           </a:p>
         </p:txBody>
       </p:sp>
       <p:sp>
         <p:nvSpPr>
-          <p:cNvPr id="4" name="text-154">
-            <a:extLst xmlns:a="http://schemas.openxmlformats.org/drawingml/2006/main">
-              <a:ext uri="{FF2B5EF4-FFF2-40B4-BE49-F238E27FC236}">
-                <a16:creationId xmlns:a16="http://schemas.microsoft.com/office/drawing/2014/main" id="{F09DC6CF-E95D-49DA-86CC-716F19AEEFC1}"/>
-              </a:ext>
-            </a:extLst>
-          </p:cNvPr>
-          <p:cNvSpPr>
-            <a:spLocks xmlns:a="http://schemas.openxmlformats.org/drawingml/2006/main" noGrp="1"/>
-          </p:cNvSpPr>
-          <p:nvPr/>
-        </p:nvSpPr>
-        <p:spPr>
-          <a:xfrm xmlns:a="http://schemas.openxmlformats.org/drawingml/2006/main">
-            <a:off x="857250" y="2990850"/>
-            <a:ext cx="10287000" cy="857250"/>
+          <p:cNvPr id="4" name="text-147">
+            <a:extLst xmlns:a="http://schemas.openxmlformats.org/drawingml/2006/main">
+              <a:ext uri="{FF2B5EF4-FFF2-40B4-BE49-F238E27FC236}">
+                <a16:creationId xmlns:a16="http://schemas.microsoft.com/office/drawing/2014/main" id="{5DD75380-9DB8-4A29-BDDA-EB0106A76255}"/>
+              </a:ext>
+            </a:extLst>
+          </p:cNvPr>
+          <p:cNvSpPr>
+            <a:spLocks xmlns:a="http://schemas.openxmlformats.org/drawingml/2006/main" noGrp="1"/>
+          </p:cNvSpPr>
+          <p:nvPr/>
+        </p:nvSpPr>
+        <p:spPr>
+          <a:xfrm xmlns:a="http://schemas.openxmlformats.org/drawingml/2006/main">
+            <a:off x="857250" y="3209925"/>
+            <a:ext cx="10477500" cy="571500"/>
           </a:xfrm>
           <a:prstGeom xmlns:a="http://schemas.openxmlformats.org/drawingml/2006/main" prst="rect">
             <a:avLst/>
@@ -11814,7 +11477,7 @@
           <a:bodyPr xmlns:a="http://schemas.openxmlformats.org/drawingml/2006/main" wrap="square" lIns="0" tIns="0" rIns="0" bIns="0" anchor="ctr"/>
           <a:lstStyle xmlns:a="http://schemas.openxmlformats.org/drawingml/2006/main">
             <a:defPPr algn="l">
-              <a:defRPr sz="2100" b="0">
+              <a:defRPr sz="2175" b="0">
                 <a:solidFill>
                   <a:srgbClr val="231F20"/>
                 </a:solidFill>
@@ -11826,7 +11489,7 @@
           </a:lstStyle>
           <a:p xmlns:a="http://schemas.openxmlformats.org/drawingml/2006/main">
             <a:pPr algn="l">
-              <a:defRPr sz="2100" b="0">
+              <a:defRPr sz="2175" b="0">
                 <a:solidFill>
                   <a:srgbClr val="231F20"/>
                 </a:solidFill>
@@ -11836,7 +11499,7 @@
               </a:defRPr>
             </a:pPr>
             <a:r>
-              <a:rPr sz="2100" b="0">
+              <a:rPr sz="2175" b="0">
                 <a:solidFill>
                   <a:srgbClr val="231F20"/>
                 </a:solidFill>
@@ -11844,52 +11507,29 @@
                 <a:ea typeface="Meiryo"/>
                 <a:cs typeface="Meiryo"/>
               </a:rPr>
-              <a:t>全体描画の比較では、転送回路の追加や</a:t>
-            </a:r>
-          </a:p>
-          <a:p xmlns:a="http://schemas.openxmlformats.org/drawingml/2006/main">
-            <a:pPr algn="l">
-              <a:defRPr sz="2100" b="0">
-                <a:solidFill>
-                  <a:srgbClr val="231F20"/>
-                </a:solidFill>
-                <a:latin typeface="Meiryo"/>
-                <a:ea typeface="Meiryo"/>
-                <a:cs typeface="Meiryo"/>
-              </a:defRPr>
-            </a:pPr>
-            <a:r>
-              <a:rPr sz="2100" b="0">
-                <a:solidFill>
-                  <a:srgbClr val="231F20"/>
-                </a:solidFill>
-                <a:latin typeface="Meiryo"/>
-                <a:ea typeface="Meiryo"/>
-                <a:cs typeface="Meiryo"/>
-              </a:rPr>
-              <a:t>描画用メモリの増量だけでは、大きく速くならなかった</a:t>
+              <a:t>命令の接続・画像用メモリ・表示の切り替えを実装</a:t>
             </a:r>
           </a:p>
         </p:txBody>
       </p:sp>
       <p:sp>
         <p:nvSpPr>
-          <p:cNvPr id="5" name="text-155">
-            <a:extLst xmlns:a="http://schemas.openxmlformats.org/drawingml/2006/main">
-              <a:ext uri="{FF2B5EF4-FFF2-40B4-BE49-F238E27FC236}">
-                <a16:creationId xmlns:a16="http://schemas.microsoft.com/office/drawing/2014/main" id="{941BA1D3-51A4-4A4A-AC8A-066A7AF3712C}"/>
-              </a:ext>
-            </a:extLst>
-          </p:cNvPr>
-          <p:cNvSpPr>
-            <a:spLocks xmlns:a="http://schemas.openxmlformats.org/drawingml/2006/main" noGrp="1"/>
-          </p:cNvSpPr>
-          <p:nvPr/>
-        </p:nvSpPr>
-        <p:spPr>
-          <a:xfrm xmlns:a="http://schemas.openxmlformats.org/drawingml/2006/main">
-            <a:off x="857250" y="4191000"/>
-            <a:ext cx="10287000" cy="523875"/>
+          <p:cNvPr id="5" name="text-148">
+            <a:extLst xmlns:a="http://schemas.openxmlformats.org/drawingml/2006/main">
+              <a:ext uri="{FF2B5EF4-FFF2-40B4-BE49-F238E27FC236}">
+                <a16:creationId xmlns:a16="http://schemas.microsoft.com/office/drawing/2014/main" id="{906EE0CA-D276-495A-AD2D-3CA294773CCD}"/>
+              </a:ext>
+            </a:extLst>
+          </p:cNvPr>
+          <p:cNvSpPr>
+            <a:spLocks xmlns:a="http://schemas.openxmlformats.org/drawingml/2006/main" noGrp="1"/>
+          </p:cNvSpPr>
+          <p:nvPr/>
+        </p:nvSpPr>
+        <p:spPr>
+          <a:xfrm xmlns:a="http://schemas.openxmlformats.org/drawingml/2006/main">
+            <a:off x="857250" y="4076700"/>
+            <a:ext cx="10382250" cy="952500"/>
           </a:xfrm>
           <a:prstGeom xmlns:a="http://schemas.openxmlformats.org/drawingml/2006/main" prst="rect">
             <a:avLst/>
@@ -11933,29 +11573,52 @@
                 <a:ea typeface="Meiryo"/>
                 <a:cs typeface="Meiryo"/>
               </a:rPr>
-              <a:t>接続設計・ソースコード・試験条件を公開</a:t>
+              <a:t>接続設計と試験条件を公開し、</a:t>
+            </a:r>
+          </a:p>
+          <a:p xmlns:a="http://schemas.openxmlformats.org/drawingml/2006/main">
+            <a:pPr algn="l">
+              <a:defRPr sz="2250" b="0">
+                <a:solidFill>
+                  <a:srgbClr val="231F20"/>
+                </a:solidFill>
+                <a:latin typeface="Meiryo"/>
+                <a:ea typeface="Meiryo"/>
+                <a:cs typeface="Meiryo"/>
+              </a:defRPr>
+            </a:pPr>
+            <a:r>
+              <a:rPr sz="2250" b="0">
+                <a:solidFill>
+                  <a:srgbClr val="231F20"/>
+                </a:solidFill>
+                <a:latin typeface="Meiryo"/>
+                <a:ea typeface="Meiryo"/>
+                <a:cs typeface="Meiryo"/>
+              </a:rPr>
+              <a:t>Wallyを拡張する人が参照できる形にまとめた</a:t>
             </a:r>
           </a:p>
         </p:txBody>
       </p:sp>
       <p:sp>
         <p:nvSpPr>
-          <p:cNvPr id="6" name="text-156">
-            <a:extLst xmlns:a="http://schemas.openxmlformats.org/drawingml/2006/main">
-              <a:ext uri="{FF2B5EF4-FFF2-40B4-BE49-F238E27FC236}">
-                <a16:creationId xmlns:a16="http://schemas.microsoft.com/office/drawing/2014/main" id="{A0D2C7CE-6E17-4132-B709-721773AF7B15}"/>
-              </a:ext>
-            </a:extLst>
-          </p:cNvPr>
-          <p:cNvSpPr>
-            <a:spLocks xmlns:a="http://schemas.openxmlformats.org/drawingml/2006/main" noGrp="1"/>
-          </p:cNvSpPr>
-          <p:nvPr/>
-        </p:nvSpPr>
-        <p:spPr>
-          <a:xfrm xmlns:a="http://schemas.openxmlformats.org/drawingml/2006/main">
-            <a:off x="857250" y="5095875"/>
-            <a:ext cx="10287000" cy="1000125"/>
+          <p:cNvPr id="6" name="text-149">
+            <a:extLst xmlns:a="http://schemas.openxmlformats.org/drawingml/2006/main">
+              <a:ext uri="{FF2B5EF4-FFF2-40B4-BE49-F238E27FC236}">
+                <a16:creationId xmlns:a16="http://schemas.microsoft.com/office/drawing/2014/main" id="{1A3CE8DB-55C9-4E70-811C-E0DE0A06933E}"/>
+              </a:ext>
+            </a:extLst>
+          </p:cNvPr>
+          <p:cNvSpPr>
+            <a:spLocks xmlns:a="http://schemas.openxmlformats.org/drawingml/2006/main" noGrp="1"/>
+          </p:cNvSpPr>
+          <p:nvPr/>
+        </p:nvSpPr>
+        <p:spPr>
+          <a:xfrm xmlns:a="http://schemas.openxmlformats.org/drawingml/2006/main">
+            <a:off x="857250" y="5553075"/>
+            <a:ext cx="10477500" cy="571500"/>
           </a:xfrm>
           <a:prstGeom xmlns:a="http://schemas.openxmlformats.org/drawingml/2006/main" prst="rect">
             <a:avLst/>
@@ -11969,7 +11632,7 @@
           <a:bodyPr xmlns:a="http://schemas.openxmlformats.org/drawingml/2006/main" wrap="square" lIns="0" tIns="0" rIns="0" bIns="0" anchor="ctr"/>
           <a:lstStyle xmlns:a="http://schemas.openxmlformats.org/drawingml/2006/main">
             <a:defPPr algn="l">
-              <a:defRPr sz="2325" b="1">
+              <a:defRPr sz="2250" b="1">
                 <a:solidFill>
                   <a:srgbClr val="231F20"/>
                 </a:solidFill>
@@ -11981,7 +11644,7 @@
           </a:lstStyle>
           <a:p xmlns:a="http://schemas.openxmlformats.org/drawingml/2006/main">
             <a:pPr algn="l">
-              <a:defRPr sz="2325" b="1">
+              <a:defRPr sz="2250" b="1">
                 <a:solidFill>
                   <a:srgbClr val="231F20"/>
                 </a:solidFill>
@@ -11991,7 +11654,7 @@
               </a:defRPr>
             </a:pPr>
             <a:r>
-              <a:rPr sz="2325" b="1">
+              <a:rPr sz="2250" b="1">
                 <a:solidFill>
                   <a:srgbClr val="231F20"/>
                 </a:solidFill>
@@ -11999,30 +11662,7 @@
                 <a:ea typeface="Meiryo"/>
                 <a:cs typeface="Meiryo"/>
               </a:rPr>
-              <a:t>最終発表：専用コントローラーを接続し、</a:t>
-            </a:r>
-          </a:p>
-          <a:p xmlns:a="http://schemas.openxmlformats.org/drawingml/2006/main">
-            <a:pPr algn="l">
-              <a:defRPr sz="2325" b="1">
-                <a:solidFill>
-                  <a:srgbClr val="231F20"/>
-                </a:solidFill>
-                <a:latin typeface="Meiryo"/>
-                <a:ea typeface="Meiryo"/>
-                <a:cs typeface="Meiryo"/>
-              </a:defRPr>
-            </a:pPr>
-            <a:r>
-              <a:rPr sz="2325" b="1">
-                <a:solidFill>
-                  <a:srgbClr val="231F20"/>
-                </a:solidFill>
-                <a:latin typeface="Meiryo"/>
-                <a:ea typeface="Meiryo"/>
-                <a:cs typeface="Meiryo"/>
-              </a:rPr>
-              <a:t>ボタンによるゲーム操作を検証する</a:t>
+              <a:t>最終発表：専用コントローラーによる操作を検証</a:t>
             </a:r>
           </a:p>
         </p:txBody>
@@ -12030,7 +11670,7 @@
     </p:spTree>
     <p:extLst>
       <p:ext uri="{BB962C8B-B14F-4D97-AF65-F5344CB8AC3E}">
-        <p14:creationId xmlns:p14="http://schemas.microsoft.com/office/powerpoint/2010/main" val="1741310094"/>
+        <p14:creationId xmlns:p14="http://schemas.microsoft.com/office/powerpoint/2010/main" val="1086139068"/>
       </p:ext>
     </p:extLst>
   </p:cSld>

</xml_diff>